<commit_message>
Add Session 2 solution-reveal deck and backup-deck appendices
Expand the hands-on deck with Z3 API and counterexample walkthroughs
(15 -> 20 slides), add an instructor-only session2-solutions deck kept
under instructor/ so zipping slides/ never leaks it, and append authored
workshop appendices to the extracted memory-model and k-induction decks
via extend_backup_decks.py. README run order, delivery plan, and the
overflow.c expected-verdict note updated; .gitignore added.
</commit_message>
<xml_diff>
--- a/slides/session2/01-session2-hands-on.pptx
+++ b/slides/session2/01-session2-hands-on.pptx
@@ -20,6 +20,11 @@
     <p:sldId id="268" r:id="rId19"/>
     <p:sldId id="269" r:id="rId20"/>
     <p:sldId id="270" r:id="rId21"/>
+    <p:sldId id="271" r:id="rId22"/>
+    <p:sldId id="272" r:id="rId23"/>
+    <p:sldId id="273" r:id="rId24"/>
+    <p:sldId id="274" r:id="rId25"/>
+    <p:sldId id="275" r:id="rId26"/>
   </p:sldIdLst>
   <p:sldSz cx="12191695" cy="6858000" type="screen4x3"/>
   <p:notesSz cx="6858000" cy="9144000"/>
@@ -3249,7 +3254,7 @@
                   <a:srgbClr val="5A0A7A"/>
                 </a:solidFill>
               </a:rPr>
-              <a:t>Lab 3 — Specifications (35 min)</a:t>
+              <a:t>Lab 2 — Bug hunting (40 min)</a:t>
             </a:r>
           </a:p>
         </p:txBody>
@@ -3262,8 +3267,8 @@
         </p:nvSpPr>
         <p:spPr>
           <a:xfrm>
-            <a:off x="731520" y="1828800"/>
-            <a:ext cx="10789920" cy="4754880"/>
+            <a:off x="731520" y="1371600"/>
+            <a:ext cx="10789920" cy="5212080"/>
           </a:xfrm>
           <a:prstGeom prst="rect">
             <a:avLst/>
@@ -3282,72 +3287,297 @@
               </a:spcAft>
             </a:pPr>
             <a:r>
-              <a:rPr sz="2800">
-                <a:solidFill>
-                  <a:srgbClr val="212121"/>
-                </a:solidFill>
-              </a:rPr>
-              <a:t>triangle.c verifies SUCCESSFUL as shipped.</a:t>
-            </a:r>
-          </a:p>
-          <a:p>
-            <a:pPr>
-              <a:spcAft>
-                <a:spcPts val="800"/>
-              </a:spcAft>
-            </a:pPr>
-            <a:r>
-              <a:rPr sz="2800">
-                <a:solidFill>
-                  <a:srgbClr val="212121"/>
-                </a:solidFill>
-              </a:rPr>
-              <a:t>Does that mean it's correct?</a:t>
-            </a:r>
-          </a:p>
-          <a:p>
-            <a:pPr>
-              <a:spcAft>
-                <a:spcPts val="800"/>
-              </a:spcAft>
-            </a:pPr>
-            <a:r>
-              <a:rPr sz="2800">
-                <a:solidFill>
-                  <a:srgbClr val="212121"/>
-                </a:solidFill>
-              </a:rPr>
-              <a:t>Write the two TODO properties and find out.</a:t>
-            </a:r>
-          </a:p>
-          <a:p>
-            <a:pPr>
-              <a:spcAft>
-                <a:spcPts val="800"/>
-              </a:spcAft>
-            </a:pPr>
-            <a:r>
-              <a:rPr sz="2800">
-                <a:solidFill>
-                  <a:srgbClr val="212121"/>
-                </a:solidFill>
-              </a:rPr>
-              <a:t/>
-            </a:r>
-          </a:p>
-          <a:p>
-            <a:pPr>
-              <a:spcAft>
-                <a:spcPts val="800"/>
-              </a:spcAft>
-            </a:pPr>
-            <a:r>
-              <a:rPr sz="2800">
-                <a:solidFill>
-                  <a:srgbClr val="212121"/>
-                </a:solidFill>
-              </a:rPr>
-              <a:t>The tool checks what you specify — with a weak spec, green is cheap.</a:t>
+              <a:rPr sz="2200">
+                <a:solidFill>
+                  <a:srgbClr val="212121"/>
+                </a:solidFill>
+              </a:rPr>
+              <a:t>predict → verify → READ THE COUNTEREXAMPLE → fix → re-verify</a:t>
+            </a:r>
+          </a:p>
+        </p:txBody>
+      </p:sp>
+      <p:graphicFrame>
+        <p:nvGraphicFramePr>
+          <p:cNvPr id="4" name="Table 3"/>
+          <p:cNvGraphicFramePr>
+            <a:graphicFrameLocks noGrp="1"/>
+          </p:cNvGraphicFramePr>
+          <p:nvPr/>
+        </p:nvGraphicFramePr>
+        <p:xfrm>
+          <a:off x="731520" y="2103120"/>
+          <a:ext cx="7498080" cy="1828800"/>
+        </p:xfrm>
+        <a:graphic>
+          <a:graphicData uri="http://schemas.openxmlformats.org/drawingml/2006/table">
+            <a:tbl>
+              <a:tblPr firstRow="1" bandRow="1">
+                <a:tableStyleId>{5C22544A-7EE6-4342-B048-85BDC9FD1C3A}</a:tableStyleId>
+              </a:tblPr>
+              <a:tblGrid>
+                <a:gridCol w="731520"/>
+                <a:gridCol w="4754880"/>
+                <a:gridCol w="2011680"/>
+              </a:tblGrid>
+              <a:tr h="365760">
+                <a:tc>
+                  <a:txBody>
+                    <a:bodyPr/>
+                    <a:lstStyle/>
+                    <a:p>
+                      <a:r>
+                        <a:rPr sz="1800" b="1"/>
+                        <a:t>#</a:t>
+                      </a:r>
+                    </a:p>
+                  </a:txBody>
+                  <a:tcPr/>
+                </a:tc>
+                <a:tc>
+                  <a:txBody>
+                    <a:bodyPr/>
+                    <a:lstStyle/>
+                    <a:p>
+                      <a:r>
+                        <a:rPr sz="1800" b="1"/>
+                        <a:t>File</a:t>
+                      </a:r>
+                    </a:p>
+                  </a:txBody>
+                  <a:tcPr/>
+                </a:tc>
+                <a:tc>
+                  <a:txBody>
+                    <a:bodyPr/>
+                    <a:lstStyle/>
+                    <a:p>
+                      <a:r>
+                        <a:rPr sz="1800" b="1"/>
+                        <a:t>By</a:t>
+                      </a:r>
+                    </a:p>
+                  </a:txBody>
+                  <a:tcPr/>
+                </a:tc>
+              </a:tr>
+              <a:tr h="365760">
+                <a:tc>
+                  <a:txBody>
+                    <a:bodyPr/>
+                    <a:lstStyle/>
+                    <a:p>
+                      <a:r>
+                        <a:rPr sz="1800"/>
+                        <a:t>1</a:t>
+                      </a:r>
+                    </a:p>
+                  </a:txBody>
+                  <a:tcPr/>
+                </a:tc>
+                <a:tc>
+                  <a:txBody>
+                    <a:bodyPr/>
+                    <a:lstStyle/>
+                    <a:p>
+                      <a:r>
+                        <a:rPr sz="1800"/>
+                        <a:t>overflow.c</a:t>
+                      </a:r>
+                    </a:p>
+                  </a:txBody>
+                  <a:tcPr/>
+                </a:tc>
+                <a:tc>
+                  <a:txBody>
+                    <a:bodyPr/>
+                    <a:lstStyle/>
+                    <a:p>
+                      <a:r>
+                        <a:rPr sz="1800"/>
+                        <a:t>—</a:t>
+                      </a:r>
+                    </a:p>
+                  </a:txBody>
+                  <a:tcPr/>
+                </a:tc>
+              </a:tr>
+              <a:tr h="365760">
+                <a:tc>
+                  <a:txBody>
+                    <a:bodyPr/>
+                    <a:lstStyle/>
+                    <a:p>
+                      <a:r>
+                        <a:rPr sz="1800"/>
+                        <a:t>2</a:t>
+                      </a:r>
+                    </a:p>
+                  </a:txBody>
+                  <a:tcPr/>
+                </a:tc>
+                <a:tc>
+                  <a:txBody>
+                    <a:bodyPr/>
+                    <a:lstStyle/>
+                    <a:p>
+                      <a:r>
+                        <a:rPr sz="1800"/>
+                        <a:t>leak.c</a:t>
+                      </a:r>
+                    </a:p>
+                  </a:txBody>
+                  <a:tcPr/>
+                </a:tc>
+                <a:tc>
+                  <a:txBody>
+                    <a:bodyPr/>
+                    <a:lstStyle/>
+                    <a:p>
+                      <a:r>
+                        <a:rPr sz="1800"/>
+                        <a:t>19:05</a:t>
+                      </a:r>
+                    </a:p>
+                  </a:txBody>
+                  <a:tcPr/>
+                </a:tc>
+              </a:tr>
+              <a:tr h="365760">
+                <a:tc>
+                  <a:txBody>
+                    <a:bodyPr/>
+                    <a:lstStyle/>
+                    <a:p>
+                      <a:r>
+                        <a:rPr sz="1800"/>
+                        <a:t>3</a:t>
+                      </a:r>
+                    </a:p>
+                  </a:txBody>
+                  <a:tcPr/>
+                </a:tc>
+                <a:tc>
+                  <a:txBody>
+                    <a:bodyPr/>
+                    <a:lstStyle/>
+                    <a:p>
+                      <a:r>
+                        <a:rPr sz="1800"/>
+                        <a:t>vla.c  (two bugs!)</a:t>
+                      </a:r>
+                    </a:p>
+                  </a:txBody>
+                  <a:tcPr/>
+                </a:tc>
+                <a:tc>
+                  <a:txBody>
+                    <a:bodyPr/>
+                    <a:lstStyle/>
+                    <a:p>
+                      <a:r>
+                        <a:rPr sz="1800"/>
+                        <a:t>19:20</a:t>
+                      </a:r>
+                    </a:p>
+                  </a:txBody>
+                  <a:tcPr/>
+                </a:tc>
+              </a:tr>
+              <a:tr h="365760">
+                <a:tc>
+                  <a:txBody>
+                    <a:bodyPr/>
+                    <a:lstStyle/>
+                    <a:p>
+                      <a:r>
+                        <a:rPr sz="1800"/>
+                        <a:t>4</a:t>
+                      </a:r>
+                    </a:p>
+                  </a:txBody>
+                  <a:tcPr/>
+                </a:tc>
+                <a:tc>
+                  <a:txBody>
+                    <a:bodyPr/>
+                    <a:lstStyle/>
+                    <a:p>
+                      <a:r>
+                        <a:rPr sz="1800"/>
+                        <a:t>getpassword.c</a:t>
+                      </a:r>
+                    </a:p>
+                  </a:txBody>
+                  <a:tcPr/>
+                </a:tc>
+                <a:tc>
+                  <a:txBody>
+                    <a:bodyPr/>
+                    <a:lstStyle/>
+                    <a:p>
+                      <a:r>
+                        <a:rPr sz="1800"/>
+                        <a:t>stretch</a:t>
+                      </a:r>
+                    </a:p>
+                  </a:txBody>
+                  <a:tcPr/>
+                </a:tc>
+              </a:tr>
+            </a:tbl>
+          </a:graphicData>
+        </a:graphic>
+      </p:graphicFrame>
+      <p:sp>
+        <p:nvSpPr>
+          <p:cNvPr id="5" name="TextBox 4"/>
+          <p:cNvSpPr txBox="1"/>
+          <p:nvPr/>
+        </p:nvSpPr>
+        <p:spPr>
+          <a:xfrm>
+            <a:off x="731520" y="4754880"/>
+            <a:ext cx="10789920" cy="1828799"/>
+          </a:xfrm>
+          <a:prstGeom prst="rect">
+            <a:avLst/>
+          </a:prstGeom>
+          <a:noFill/>
+        </p:spPr>
+        <p:txBody>
+          <a:bodyPr wrap="square">
+            <a:spAutoFit/>
+          </a:bodyPr>
+          <a:lstStyle/>
+          <a:p>
+            <a:pPr>
+              <a:spcAft>
+                <a:spcPts val="800"/>
+              </a:spcAft>
+            </a:pPr>
+            <a:r>
+              <a:rPr sz="2000">
+                <a:solidFill>
+                  <a:srgbClr val="212121"/>
+                </a:solidFill>
+              </a:rPr>
+              <a:t>Done = VERIFICATION SUCCESSFUL on your fixed file, same flags.</a:t>
+            </a:r>
+          </a:p>
+          <a:p>
+            <a:pPr>
+              <a:spcAft>
+                <a:spcPts val="800"/>
+              </a:spcAft>
+            </a:pPr>
+            <a:r>
+              <a:rPr sz="2000">
+                <a:solidFill>
+                  <a:srgbClr val="212121"/>
+                </a:solidFill>
+              </a:rPr>
+              <a:t>Finished early? You are now a TA — help the pair next to you.</a:t>
             </a:r>
           </a:p>
         </p:txBody>
@@ -3398,7 +3628,7 @@
                   <a:srgbClr val="5A0A7A"/>
                 </a:solidFill>
               </a:rPr>
-              <a:t>Your specification toolkit</a:t>
+              <a:t>How to read a counterexample</a:t>
             </a:r>
           </a:p>
         </p:txBody>
@@ -3427,6 +3657,21 @@
           <a:p>
             <a:pPr>
               <a:spcAft>
+                <a:spcPts val="800"/>
+              </a:spcAft>
+            </a:pPr>
+            <a:r>
+              <a:rPr sz="2200">
+                <a:solidFill>
+                  <a:srgbClr val="212121"/>
+                </a:solidFill>
+              </a:rPr>
+              <a:t>Real output — esbmc getpassword.c --unwind 8:</a:t>
+            </a:r>
+          </a:p>
+          <a:p>
+            <a:pPr>
+              <a:spcAft>
                 <a:spcPts val="0"/>
               </a:spcAft>
             </a:pPr>
@@ -3437,7 +3682,7 @@
                 </a:solidFill>
                 <a:latin typeface="Courier New"/>
               </a:rPr>
-              <a:t>int nondet_int(void);              /* any possible int */</a:t>
+              <a:t>State 1 file getpassword.c line 18 function getPassword thread 0</a:t>
             </a:r>
           </a:p>
           <a:p>
@@ -3453,7 +3698,7 @@
                 </a:solidFill>
                 <a:latin typeface="Courier New"/>
               </a:rPr>
-              <a:t>void __ESBMC_assume(_Bool);</a:t>
+              <a:t>  buf = { 0, 0, 0, 0 }              ← the state so far</a:t>
             </a:r>
           </a:p>
           <a:p>
@@ -3469,60 +3714,91 @@
                 </a:solidFill>
                 <a:latin typeface="Courier New"/>
               </a:rPr>
+              <a:t>State 2 file ...library/io.c line 91 function gets thread 0</a:t>
+            </a:r>
+          </a:p>
+          <a:p>
+            <a:pPr>
+              <a:spcAft>
+                <a:spcPts val="0"/>
+              </a:spcAft>
+            </a:pPr>
+            <a:r>
+              <a:rPr sz="1800">
+                <a:solidFill>
+                  <a:srgbClr val="212121"/>
+                </a:solidFill>
+                <a:latin typeface="Courier New"/>
+              </a:rPr>
+              <a:t>Violated property:</a:t>
+            </a:r>
+          </a:p>
+          <a:p>
+            <a:pPr>
+              <a:spcAft>
+                <a:spcPts val="0"/>
+              </a:spcAft>
+            </a:pPr>
+            <a:r>
+              <a:rPr sz="1800">
+                <a:solidFill>
+                  <a:srgbClr val="212121"/>
+                </a:solidFill>
+                <a:latin typeface="Courier New"/>
+              </a:rPr>
+              <a:t>  dereference failure: array bounds violated   ← what broke</a:t>
+            </a:r>
+          </a:p>
+          <a:p>
+            <a:pPr>
+              <a:spcAft>
+                <a:spcPts val="0"/>
+              </a:spcAft>
+            </a:pPr>
+            <a:r>
+              <a:rPr sz="1800">
+                <a:solidFill>
+                  <a:srgbClr val="212121"/>
+                </a:solidFill>
+                <a:latin typeface="Courier New"/>
+              </a:rPr>
+              <a:t>  CWE: CWE-121, CWE-125, CWE-129, ...           ← the vuln class</a:t>
+            </a:r>
+          </a:p>
+          <a:p>
+            <a:pPr>
+              <a:spcAft>
+                <a:spcPts val="0"/>
+              </a:spcAft>
+            </a:pPr>
+            <a:r>
+              <a:rPr sz="1800">
+                <a:solidFill>
+                  <a:srgbClr val="212121"/>
+                </a:solidFill>
+                <a:latin typeface="Courier New"/>
+              </a:rPr>
+              <a:t>VERIFICATION FAILED</a:t>
+            </a:r>
+          </a:p>
+          <a:p>
+            <a:pPr>
+              <a:spcAft>
+                <a:spcPts val="800"/>
+              </a:spcAft>
+            </a:pPr>
+            <a:r>
+              <a:rPr sz="2200">
+                <a:solidFill>
+                  <a:srgbClr val="212121"/>
+                </a:solidFill>
+              </a:rPr>
               <a:t/>
             </a:r>
           </a:p>
           <a:p>
             <a:pPr>
               <a:spcAft>
-                <a:spcPts val="0"/>
-              </a:spcAft>
-            </a:pPr>
-            <a:r>
-              <a:rPr sz="1800">
-                <a:solidFill>
-                  <a:srgbClr val="212121"/>
-                </a:solidFill>
-                <a:latin typeface="Courier New"/>
-              </a:rPr>
-              <a:t>int x = nondet_int();              /* every value at once */</a:t>
-            </a:r>
-          </a:p>
-          <a:p>
-            <a:pPr>
-              <a:spcAft>
-                <a:spcPts val="0"/>
-              </a:spcAft>
-            </a:pPr>
-            <a:r>
-              <a:rPr sz="1800">
-                <a:solidFill>
-                  <a:srgbClr val="212121"/>
-                </a:solidFill>
-                <a:latin typeface="Courier New"/>
-              </a:rPr>
-              <a:t>__ESBMC_assume(x &gt; 0 &amp;&amp; x &lt; 100);  /* now: every value in 1..99 */</a:t>
-            </a:r>
-          </a:p>
-          <a:p>
-            <a:pPr>
-              <a:spcAft>
-                <a:spcPts val="0"/>
-              </a:spcAft>
-            </a:pPr>
-            <a:r>
-              <a:rPr sz="1800">
-                <a:solidFill>
-                  <a:srgbClr val="212121"/>
-                </a:solidFill>
-                <a:latin typeface="Courier New"/>
-              </a:rPr>
-              <a:t>assert(property(x));               /* must hold for ALL of them */</a:t>
-            </a:r>
-          </a:p>
-          <a:p>
-            <a:pPr>
-              <a:spcAft>
                 <a:spcPts val="800"/>
               </a:spcAft>
             </a:pPr>
@@ -3532,22 +3808,7 @@
                   <a:srgbClr val="212121"/>
                 </a:solidFill>
               </a:rPr>
-              <a:t/>
-            </a:r>
-          </a:p>
-          <a:p>
-            <a:pPr>
-              <a:spcAft>
-                <a:spcPts val="800"/>
-              </a:spcAft>
-            </a:pPr>
-            <a:r>
-              <a:rPr sz="2200">
-                <a:solidFill>
-                  <a:srgbClr val="212121"/>
-                </a:solidFill>
-              </a:rPr>
-              <a:t>One nondet input = all tests of that input at once.</a:t>
+              <a:t>Read bottom-up: what was violated, then scroll up for which values caused it.</a:t>
             </a:r>
           </a:p>
         </p:txBody>
@@ -3598,7 +3859,7 @@
                   <a:srgbClr val="5A0A7A"/>
                 </a:solidFill>
               </a:rPr>
-              <a:t>Lab 3, Part 2 — what did we prove?</a:t>
+              <a:t>Deep dive: overflow.c — the trace</a:t>
             </a:r>
           </a:p>
         </p:txBody>
@@ -3637,7 +3898,7 @@
                 </a:solidFill>
                 <a:latin typeface="Courier New"/>
               </a:rPr>
-              <a:t>esbmc unwind.c --unwind 5      →  ?</a:t>
+              <a:t>State 1 ...  a = { 0, -1 }   ← stack garbage in the array</a:t>
             </a:r>
           </a:p>
           <a:p>
@@ -3653,7 +3914,7 @@
                 </a:solidFill>
                 <a:latin typeface="Courier New"/>
               </a:rPr>
-              <a:t>esbmc unwind.c --unwind 20     →  ?</a:t>
+              <a:t>State 2 ...  i = -1          ← the index the solver chose</a:t>
             </a:r>
           </a:p>
           <a:p>
@@ -3669,7 +3930,55 @@
                 </a:solidFill>
                 <a:latin typeface="Courier New"/>
               </a:rPr>
-              <a:t>esbmc unwind.c --unwind 60     →  ?</a:t>
+              <a:t>State 3 ...  x = -1          ← the branch the solver chose</a:t>
+            </a:r>
+          </a:p>
+          <a:p>
+            <a:pPr>
+              <a:spcAft>
+                <a:spcPts val="0"/>
+              </a:spcAft>
+            </a:pPr>
+            <a:r>
+              <a:rPr sz="1800">
+                <a:solidFill>
+                  <a:srgbClr val="212121"/>
+                </a:solidFill>
+                <a:latin typeface="Courier New"/>
+              </a:rPr>
+              <a:t>Violated property:</a:t>
+            </a:r>
+          </a:p>
+          <a:p>
+            <a:pPr>
+              <a:spcAft>
+                <a:spcPts val="0"/>
+              </a:spcAft>
+            </a:pPr>
+            <a:r>
+              <a:rPr sz="1800">
+                <a:solidFill>
+                  <a:srgbClr val="212121"/>
+                </a:solidFill>
+                <a:latin typeface="Courier New"/>
+              </a:rPr>
+              <a:t>  file overflow.c line 24 ... assertion main</a:t>
+            </a:r>
+          </a:p>
+          <a:p>
+            <a:pPr>
+              <a:spcAft>
+                <a:spcPts val="0"/>
+              </a:spcAft>
+            </a:pPr>
+            <a:r>
+              <a:rPr sz="1800">
+                <a:solidFill>
+                  <a:srgbClr val="212121"/>
+                </a:solidFill>
+                <a:latin typeface="Courier New"/>
+              </a:rPr>
+              <a:t>  !((_Bool)((signed long int)(!(p[1] == 1))))</a:t>
             </a:r>
           </a:p>
           <a:p>
@@ -3688,6 +3997,36 @@
             </a:r>
           </a:p>
           <a:p>
+            <a:pPr lvl="1">
+              <a:spcAft>
+                <a:spcPts val="800"/>
+              </a:spcAft>
+            </a:pPr>
+            <a:r>
+              <a:rPr sz="2000">
+                <a:solidFill>
+                  <a:srgbClr val="212121"/>
+                </a:solidFill>
+              </a:rPr>
+              <a:t>x = -1 takes the else branch; a[i + 1] with i = -1 writes a[0].</a:t>
+            </a:r>
+          </a:p>
+          <a:p>
+            <a:pPr lvl="1">
+              <a:spcAft>
+                <a:spcPts val="800"/>
+              </a:spcAft>
+            </a:pPr>
+            <a:r>
+              <a:rPr sz="2000">
+                <a:solidFill>
+                  <a:srgbClr val="212121"/>
+                </a:solidFill>
+              </a:rPr>
+              <a:t>So a[1] keeps its garbage (-1) and assert(*(p + 1) == 1) dies.</a:t>
+            </a:r>
+          </a:p>
+          <a:p>
             <a:pPr>
               <a:spcAft>
                 <a:spcPts val="800"/>
@@ -3699,37 +4038,7 @@
                   <a:srgbClr val="212121"/>
                 </a:solidFill>
               </a:rPr>
-              <a:t>What is the unwinding assertion telling you at 5 and 20?</a:t>
-            </a:r>
-          </a:p>
-          <a:p>
-            <a:pPr>
-              <a:spcAft>
-                <a:spcPts val="800"/>
-              </a:spcAft>
-            </a:pPr>
-            <a:r>
-              <a:rPr sz="2200">
-                <a:solidFill>
-                  <a:srgbClr val="212121"/>
-                </a:solidFill>
-              </a:rPr>
-              <a:t>At 60 — what exactly is proven, and for which n?</a:t>
-            </a:r>
-          </a:p>
-          <a:p>
-            <a:pPr>
-              <a:spcAft>
-                <a:spcPts val="800"/>
-              </a:spcAft>
-            </a:pPr>
-            <a:r>
-              <a:rPr sz="2200">
-                <a:solidFill>
-                  <a:srgbClr val="212121"/>
-                </a:solidFill>
-              </a:rPr>
-              <a:t>Stretch: --k-induction answers VERIFICATION UNKNOWN. Why is the unbounded question fundamentally harder? (Background deck: 03-k-induction.pptx)</a:t>
+              <a:t>i = -1, x = -1 is a ready-made failing test case — keep it.</a:t>
             </a:r>
           </a:p>
         </p:txBody>
@@ -3780,7 +4089,7 @@
                   <a:srgbClr val="5A0A7A"/>
                 </a:solidFill>
               </a:rPr>
-              <a:t>Lab 4 — Team challenge (30 min)</a:t>
+              <a:t>Deep dive: what broke, and its CWE</a:t>
             </a:r>
           </a:p>
         </p:txBody>
@@ -3818,7 +4127,7 @@
                   <a:srgbClr val="212121"/>
                 </a:solidFill>
               </a:rPr>
-              <a:t>Teams of 3–4. Points on the whiteboard:</a:t>
+              <a:t>Two shapes of violated property:</a:t>
             </a:r>
           </a:p>
           <a:p>
@@ -3833,12 +4142,28 @@
                   <a:srgbClr val="212121"/>
                 </a:solidFill>
               </a:rPr>
-              <a:t>1 pt — verdict predicted correctly in writing, before running</a:t>
+              <a:t>an assertion — names YOUR line:</a:t>
             </a:r>
           </a:p>
           <a:p>
             <a:pPr lvl="1">
               <a:spcAft>
+                <a:spcPts val="0"/>
+              </a:spcAft>
+            </a:pPr>
+            <a:r>
+              <a:rPr sz="1800">
+                <a:solidFill>
+                  <a:srgbClr val="212121"/>
+                </a:solidFill>
+                <a:latin typeface="Courier New"/>
+              </a:rPr>
+              <a:t>  overflow.c line 24 ... assertion main</a:t>
+            </a:r>
+          </a:p>
+          <a:p>
+            <a:pPr lvl="1">
+              <a:spcAft>
                 <a:spcPts val="800"/>
               </a:spcAft>
             </a:pPr>
@@ -3848,7 +4173,54 @@
                   <a:srgbClr val="212121"/>
                 </a:solidFill>
               </a:rPr>
-              <a:t>2 pts — file fixed and re-verified</a:t>
+              <a:t>a built-in check — names the bug kind plus its CWE classes:</a:t>
+            </a:r>
+          </a:p>
+          <a:p>
+            <a:pPr lvl="1">
+              <a:spcAft>
+                <a:spcPts val="0"/>
+              </a:spcAft>
+            </a:pPr>
+            <a:r>
+              <a:rPr sz="1800">
+                <a:solidFill>
+                  <a:srgbClr val="212121"/>
+                </a:solidFill>
+                <a:latin typeface="Courier New"/>
+              </a:rPr>
+              <a:t>  dereference failure: array bounds violated</a:t>
+            </a:r>
+          </a:p>
+          <a:p>
+            <a:pPr lvl="1">
+              <a:spcAft>
+                <a:spcPts val="0"/>
+              </a:spcAft>
+            </a:pPr>
+            <a:r>
+              <a:rPr sz="1800">
+                <a:solidFill>
+                  <a:srgbClr val="212121"/>
+                </a:solidFill>
+                <a:latin typeface="Courier New"/>
+              </a:rPr>
+              <a:t>  CWE: CWE-121, CWE-125, CWE-129, CWE-131, CWE-193, CWE-787</a:t>
+            </a:r>
+          </a:p>
+          <a:p>
+            <a:pPr lvl="2">
+              <a:spcAft>
+                <a:spcPts val="800"/>
+              </a:spcAft>
+            </a:pPr>
+            <a:r>
+              <a:rPr sz="1800">
+                <a:solidFill>
+                  <a:srgbClr val="212121"/>
+                </a:solidFill>
+              </a:rPr>
+              <a:t>  (stack overflow · OOB read · bad index · size miscalc · off-by-one · OOB write)</a:t>
             </a:r>
           </a:p>
           <a:p>
@@ -3878,38 +4250,22 @@
                   <a:srgbClr val="212121"/>
                 </a:solidFill>
               </a:rPr>
-              <a:t>Track A:  race.c — write down the failing interleaving first, then</a:t>
-            </a:r>
-          </a:p>
-          <a:p>
-            <a:pPr>
-              <a:spcAft>
-                <a:spcPts val="0"/>
-              </a:spcAft>
-            </a:pPr>
-            <a:r>
-              <a:rPr sz="1800">
-                <a:solidFill>
-                  <a:srgbClr val="212121"/>
-                </a:solidFill>
-                <a:latin typeface="Courier New"/>
-              </a:rPr>
-              <a:t>esbmc race.c --context-bound 2</a:t>
-            </a:r>
-          </a:p>
-          <a:p>
-            <a:pPr>
-              <a:spcAft>
-                <a:spcPts val="800"/>
-              </a:spcAft>
-            </a:pPr>
-            <a:r>
-              <a:rPr sz="2200">
-                <a:solidFill>
-                  <a:srgbClr val="212121"/>
-                </a:solidFill>
-              </a:rPr>
-              <a:t>Track B:  float.c — primary-school arithmetic. Or is it?</a:t>
+              <a:t>The path may point inside ESBMC's model of the C library (io.c line 91 = the gets model).</a:t>
+            </a:r>
+          </a:p>
+          <a:p>
+            <a:pPr lvl="1">
+              <a:spcAft>
+                <a:spcPts val="800"/>
+              </a:spcAft>
+            </a:pPr>
+            <a:r>
+              <a:rPr sz="2000">
+                <a:solidFill>
+                  <a:srgbClr val="212121"/>
+                </a:solidFill>
+              </a:rPr>
+              <a:t>That names the API you misused — it is not a bug in ESBMC.</a:t>
             </a:r>
           </a:p>
         </p:txBody>
@@ -3940,7 +4296,7 @@
         </p:nvSpPr>
         <p:spPr>
           <a:xfrm>
-            <a:off x="548640" y="365760"/>
+            <a:off x="548640" y="2377440"/>
             <a:ext cx="11064240" cy="1005840"/>
           </a:xfrm>
           <a:prstGeom prst="rect">
@@ -3955,110 +4311,12 @@
           <a:lstStyle/>
           <a:p>
             <a:r>
-              <a:rPr sz="3600" b="1">
+              <a:rPr sz="4400" b="1">
                 <a:solidFill>
                   <a:srgbClr val="5A0A7A"/>
                 </a:solidFill>
               </a:rPr>
-              <a:t>Why machines beat humans at Track A</a:t>
-            </a:r>
-          </a:p>
-        </p:txBody>
-      </p:sp>
-      <p:sp>
-        <p:nvSpPr>
-          <p:cNvPr id="3" name="TextBox 2"/>
-          <p:cNvSpPr txBox="1"/>
-          <p:nvPr/>
-        </p:nvSpPr>
-        <p:spPr>
-          <a:xfrm>
-            <a:off x="731520" y="1463040"/>
-            <a:ext cx="10789920" cy="5120640"/>
-          </a:xfrm>
-          <a:prstGeom prst="rect">
-            <a:avLst/>
-          </a:prstGeom>
-          <a:noFill/>
-        </p:spPr>
-        <p:txBody>
-          <a:bodyPr wrap="square">
-            <a:spAutoFit/>
-          </a:bodyPr>
-          <a:lstStyle/>
-          <a:p>
-            <a:pPr>
-              <a:spcAft>
-                <a:spcPts val="800"/>
-              </a:spcAft>
-            </a:pPr>
-            <a:r>
-              <a:rPr sz="2200">
-                <a:solidFill>
-                  <a:srgbClr val="212121"/>
-                </a:solidFill>
-              </a:rPr>
-              <a:t>Sequentially, race.c is bulletproof — run it a million times, the bug may never show.</a:t>
-            </a:r>
-          </a:p>
-          <a:p>
-            <a:pPr>
-              <a:spcAft>
-                <a:spcPts val="800"/>
-              </a:spcAft>
-            </a:pPr>
-            <a:r>
-              <a:rPr sz="2200">
-                <a:solidFill>
-                  <a:srgbClr val="212121"/>
-                </a:solidFill>
-              </a:rPr>
-              <a:t>Two threads of just 2 and 1 statements already have 3 interleavings; real code has billions.</a:t>
-            </a:r>
-          </a:p>
-          <a:p>
-            <a:pPr>
-              <a:spcAft>
-                <a:spcPts val="800"/>
-              </a:spcAft>
-            </a:pPr>
-            <a:r>
-              <a:rPr sz="2200">
-                <a:solidFill>
-                  <a:srgbClr val="212121"/>
-                </a:solidFill>
-              </a:rPr>
-              <a:t>The model checker enumerates every interleaving up to the context bound — including the one that kills the assertion.</a:t>
-            </a:r>
-          </a:p>
-          <a:p>
-            <a:pPr>
-              <a:spcAft>
-                <a:spcPts val="800"/>
-              </a:spcAft>
-            </a:pPr>
-            <a:r>
-              <a:rPr sz="2200">
-                <a:solidFill>
-                  <a:srgbClr val="212121"/>
-                </a:solidFill>
-              </a:rPr>
-              <a:t/>
-            </a:r>
-          </a:p>
-          <a:p>
-            <a:pPr>
-              <a:spcAft>
-                <a:spcPts val="800"/>
-              </a:spcAft>
-            </a:pPr>
-            <a:r>
-              <a:rPr sz="2200">
-                <a:solidFill>
-                  <a:srgbClr val="212121"/>
-                </a:solidFill>
-              </a:rPr>
-              <a:t>The counterexample you get includes the thread schedule: read it as a story of who ran when.</a:t>
+              <a:t>Break — back at 19:40</a:t>
             </a:r>
           </a:p>
         </p:txBody>
@@ -4109,7 +4367,156 @@
                   <a:srgbClr val="5A0A7A"/>
                 </a:solidFill>
               </a:rPr>
-              <a:t>Debrief</a:t>
+              <a:t>Lab 3 — Specifications (35 min)</a:t>
+            </a:r>
+          </a:p>
+        </p:txBody>
+      </p:sp>
+      <p:sp>
+        <p:nvSpPr>
+          <p:cNvPr id="3" name="TextBox 2"/>
+          <p:cNvSpPr txBox="1"/>
+          <p:nvPr/>
+        </p:nvSpPr>
+        <p:spPr>
+          <a:xfrm>
+            <a:off x="731520" y="1828800"/>
+            <a:ext cx="10789920" cy="4754880"/>
+          </a:xfrm>
+          <a:prstGeom prst="rect">
+            <a:avLst/>
+          </a:prstGeom>
+          <a:noFill/>
+        </p:spPr>
+        <p:txBody>
+          <a:bodyPr wrap="square">
+            <a:spAutoFit/>
+          </a:bodyPr>
+          <a:lstStyle/>
+          <a:p>
+            <a:pPr>
+              <a:spcAft>
+                <a:spcPts val="800"/>
+              </a:spcAft>
+            </a:pPr>
+            <a:r>
+              <a:rPr sz="2800">
+                <a:solidFill>
+                  <a:srgbClr val="212121"/>
+                </a:solidFill>
+              </a:rPr>
+              <a:t>triangle.c verifies SUCCESSFUL as shipped.</a:t>
+            </a:r>
+          </a:p>
+          <a:p>
+            <a:pPr>
+              <a:spcAft>
+                <a:spcPts val="800"/>
+              </a:spcAft>
+            </a:pPr>
+            <a:r>
+              <a:rPr sz="2800">
+                <a:solidFill>
+                  <a:srgbClr val="212121"/>
+                </a:solidFill>
+              </a:rPr>
+              <a:t>Does that mean it's correct?</a:t>
+            </a:r>
+          </a:p>
+          <a:p>
+            <a:pPr>
+              <a:spcAft>
+                <a:spcPts val="800"/>
+              </a:spcAft>
+            </a:pPr>
+            <a:r>
+              <a:rPr sz="2800">
+                <a:solidFill>
+                  <a:srgbClr val="212121"/>
+                </a:solidFill>
+              </a:rPr>
+              <a:t>Write the two TODO properties and find out.</a:t>
+            </a:r>
+          </a:p>
+          <a:p>
+            <a:pPr>
+              <a:spcAft>
+                <a:spcPts val="800"/>
+              </a:spcAft>
+            </a:pPr>
+            <a:r>
+              <a:rPr sz="2800">
+                <a:solidFill>
+                  <a:srgbClr val="212121"/>
+                </a:solidFill>
+              </a:rPr>
+              <a:t/>
+            </a:r>
+          </a:p>
+          <a:p>
+            <a:pPr>
+              <a:spcAft>
+                <a:spcPts val="800"/>
+              </a:spcAft>
+            </a:pPr>
+            <a:r>
+              <a:rPr sz="2800">
+                <a:solidFill>
+                  <a:srgbClr val="212121"/>
+                </a:solidFill>
+              </a:rPr>
+              <a:t>The tool checks what you specify — with a weak spec, green is cheap.</a:t>
+            </a:r>
+          </a:p>
+        </p:txBody>
+      </p:sp>
+    </p:spTree>
+  </p:cSld>
+  <p:clrMapOvr>
+    <a:masterClrMapping/>
+  </p:clrMapOvr>
+</p:sld>
+</file>
+
+<file path=ppt/slides/slide16.xml><?xml version="1.0" encoding="utf-8"?>
+<p:sld xmlns:a="http://schemas.openxmlformats.org/drawingml/2006/main" xmlns:p="http://schemas.openxmlformats.org/presentationml/2006/main" xmlns:r="http://schemas.openxmlformats.org/officeDocument/2006/relationships">
+  <p:cSld>
+    <p:spTree>
+      <p:nvGrpSpPr>
+        <p:cNvPr id="1" name=""/>
+        <p:cNvGrpSpPr/>
+        <p:nvPr/>
+      </p:nvGrpSpPr>
+      <p:grpSpPr/>
+      <p:sp>
+        <p:nvSpPr>
+          <p:cNvPr id="2" name="TextBox 1"/>
+          <p:cNvSpPr txBox="1"/>
+          <p:nvPr/>
+        </p:nvSpPr>
+        <p:spPr>
+          <a:xfrm>
+            <a:off x="548640" y="365760"/>
+            <a:ext cx="11064240" cy="1005840"/>
+          </a:xfrm>
+          <a:prstGeom prst="rect">
+            <a:avLst/>
+          </a:prstGeom>
+          <a:noFill/>
+        </p:spPr>
+        <p:txBody>
+          <a:bodyPr wrap="square">
+            <a:spAutoFit/>
+          </a:bodyPr>
+          <a:lstStyle/>
+          <a:p>
+            <a:r>
+              <a:rPr sz="3600" b="1">
+                <a:solidFill>
+                  <a:srgbClr val="5A0A7A"/>
+                </a:solidFill>
+              </a:rPr>
+              <a:t>Your specification toolkit</a:t>
             </a:r>
           </a:p>
         </p:txBody>
@@ -4138,6 +4545,102 @@
           <a:p>
             <a:pPr>
               <a:spcAft>
+                <a:spcPts val="0"/>
+              </a:spcAft>
+            </a:pPr>
+            <a:r>
+              <a:rPr sz="1800">
+                <a:solidFill>
+                  <a:srgbClr val="212121"/>
+                </a:solidFill>
+                <a:latin typeface="Courier New"/>
+              </a:rPr>
+              <a:t>int nondet_int(void);              /* any possible int */</a:t>
+            </a:r>
+          </a:p>
+          <a:p>
+            <a:pPr>
+              <a:spcAft>
+                <a:spcPts val="0"/>
+              </a:spcAft>
+            </a:pPr>
+            <a:r>
+              <a:rPr sz="1800">
+                <a:solidFill>
+                  <a:srgbClr val="212121"/>
+                </a:solidFill>
+                <a:latin typeface="Courier New"/>
+              </a:rPr>
+              <a:t>void __ESBMC_assume(_Bool);</a:t>
+            </a:r>
+          </a:p>
+          <a:p>
+            <a:pPr>
+              <a:spcAft>
+                <a:spcPts val="0"/>
+              </a:spcAft>
+            </a:pPr>
+            <a:r>
+              <a:rPr sz="1800">
+                <a:solidFill>
+                  <a:srgbClr val="212121"/>
+                </a:solidFill>
+                <a:latin typeface="Courier New"/>
+              </a:rPr>
+              <a:t/>
+            </a:r>
+          </a:p>
+          <a:p>
+            <a:pPr>
+              <a:spcAft>
+                <a:spcPts val="0"/>
+              </a:spcAft>
+            </a:pPr>
+            <a:r>
+              <a:rPr sz="1800">
+                <a:solidFill>
+                  <a:srgbClr val="212121"/>
+                </a:solidFill>
+                <a:latin typeface="Courier New"/>
+              </a:rPr>
+              <a:t>int x = nondet_int();              /* every value at once */</a:t>
+            </a:r>
+          </a:p>
+          <a:p>
+            <a:pPr>
+              <a:spcAft>
+                <a:spcPts val="0"/>
+              </a:spcAft>
+            </a:pPr>
+            <a:r>
+              <a:rPr sz="1800">
+                <a:solidFill>
+                  <a:srgbClr val="212121"/>
+                </a:solidFill>
+                <a:latin typeface="Courier New"/>
+              </a:rPr>
+              <a:t>__ESBMC_assume(x &gt; 0 &amp;&amp; x &lt; 100);  /* now: every value in 1..99 */</a:t>
+            </a:r>
+          </a:p>
+          <a:p>
+            <a:pPr>
+              <a:spcAft>
+                <a:spcPts val="0"/>
+              </a:spcAft>
+            </a:pPr>
+            <a:r>
+              <a:rPr sz="1800">
+                <a:solidFill>
+                  <a:srgbClr val="212121"/>
+                </a:solidFill>
+                <a:latin typeface="Courier New"/>
+              </a:rPr>
+              <a:t>assert(property(x));               /* must hold for ALL of them */</a:t>
+            </a:r>
+          </a:p>
+          <a:p>
+            <a:pPr>
+              <a:spcAft>
                 <a:spcPts val="800"/>
               </a:spcAft>
             </a:pPr>
@@ -4147,7 +4650,7 @@
                   <a:srgbClr val="212121"/>
                 </a:solidFill>
               </a:rPr>
-              <a:t>One thing the tool caught that YOU wouldn't have?</a:t>
+              <a:t/>
             </a:r>
           </a:p>
           <a:p>
@@ -4162,7 +4665,129 @@
                   <a:srgbClr val="212121"/>
                 </a:solidFill>
               </a:rPr>
-              <a:t>The arc you just walked: intuition → concepts → tools → application</a:t>
+              <a:t>One nondet input = all tests of that input at once.</a:t>
+            </a:r>
+          </a:p>
+        </p:txBody>
+      </p:sp>
+    </p:spTree>
+  </p:cSld>
+  <p:clrMapOvr>
+    <a:masterClrMapping/>
+  </p:clrMapOvr>
+</p:sld>
+</file>
+
+<file path=ppt/slides/slide17.xml><?xml version="1.0" encoding="utf-8"?>
+<p:sld xmlns:a="http://schemas.openxmlformats.org/drawingml/2006/main" xmlns:p="http://schemas.openxmlformats.org/presentationml/2006/main" xmlns:r="http://schemas.openxmlformats.org/officeDocument/2006/relationships">
+  <p:cSld>
+    <p:spTree>
+      <p:nvGrpSpPr>
+        <p:cNvPr id="1" name=""/>
+        <p:cNvGrpSpPr/>
+        <p:nvPr/>
+      </p:nvGrpSpPr>
+      <p:grpSpPr/>
+      <p:sp>
+        <p:nvSpPr>
+          <p:cNvPr id="2" name="TextBox 1"/>
+          <p:cNvSpPr txBox="1"/>
+          <p:nvPr/>
+        </p:nvSpPr>
+        <p:spPr>
+          <a:xfrm>
+            <a:off x="548640" y="365760"/>
+            <a:ext cx="11064240" cy="1005840"/>
+          </a:xfrm>
+          <a:prstGeom prst="rect">
+            <a:avLst/>
+          </a:prstGeom>
+          <a:noFill/>
+        </p:spPr>
+        <p:txBody>
+          <a:bodyPr wrap="square">
+            <a:spAutoFit/>
+          </a:bodyPr>
+          <a:lstStyle/>
+          <a:p>
+            <a:r>
+              <a:rPr sz="3600" b="1">
+                <a:solidFill>
+                  <a:srgbClr val="5A0A7A"/>
+                </a:solidFill>
+              </a:rPr>
+              <a:t>Lab 3, Part 2 — what did we prove?</a:t>
+            </a:r>
+          </a:p>
+        </p:txBody>
+      </p:sp>
+      <p:sp>
+        <p:nvSpPr>
+          <p:cNvPr id="3" name="TextBox 2"/>
+          <p:cNvSpPr txBox="1"/>
+          <p:nvPr/>
+        </p:nvSpPr>
+        <p:spPr>
+          <a:xfrm>
+            <a:off x="731520" y="1463040"/>
+            <a:ext cx="10789920" cy="5120640"/>
+          </a:xfrm>
+          <a:prstGeom prst="rect">
+            <a:avLst/>
+          </a:prstGeom>
+          <a:noFill/>
+        </p:spPr>
+        <p:txBody>
+          <a:bodyPr wrap="square">
+            <a:spAutoFit/>
+          </a:bodyPr>
+          <a:lstStyle/>
+          <a:p>
+            <a:pPr>
+              <a:spcAft>
+                <a:spcPts val="0"/>
+              </a:spcAft>
+            </a:pPr>
+            <a:r>
+              <a:rPr sz="1800">
+                <a:solidFill>
+                  <a:srgbClr val="212121"/>
+                </a:solidFill>
+                <a:latin typeface="Courier New"/>
+              </a:rPr>
+              <a:t>esbmc unwind.c --unwind 5      →  ?</a:t>
+            </a:r>
+          </a:p>
+          <a:p>
+            <a:pPr>
+              <a:spcAft>
+                <a:spcPts val="0"/>
+              </a:spcAft>
+            </a:pPr>
+            <a:r>
+              <a:rPr sz="1800">
+                <a:solidFill>
+                  <a:srgbClr val="212121"/>
+                </a:solidFill>
+                <a:latin typeface="Courier New"/>
+              </a:rPr>
+              <a:t>esbmc unwind.c --unwind 20     →  ?</a:t>
+            </a:r>
+          </a:p>
+          <a:p>
+            <a:pPr>
+              <a:spcAft>
+                <a:spcPts val="0"/>
+              </a:spcAft>
+            </a:pPr>
+            <a:r>
+              <a:rPr sz="1800">
+                <a:solidFill>
+                  <a:srgbClr val="212121"/>
+                </a:solidFill>
+                <a:latin typeface="Courier New"/>
+              </a:rPr>
+              <a:t>esbmc unwind.c --unwind 60     →  ?</a:t>
             </a:r>
           </a:p>
           <a:p>
@@ -4192,7 +4817,126 @@
                   <a:srgbClr val="212121"/>
                 </a:solidFill>
               </a:rPr>
-              <a:t>Where next:</a:t>
+              <a:t>What is the unwinding assertion telling you at 5 and 20?</a:t>
+            </a:r>
+          </a:p>
+          <a:p>
+            <a:pPr>
+              <a:spcAft>
+                <a:spcPts val="800"/>
+              </a:spcAft>
+            </a:pPr>
+            <a:r>
+              <a:rPr sz="2200">
+                <a:solidFill>
+                  <a:srgbClr val="212121"/>
+                </a:solidFill>
+              </a:rPr>
+              <a:t>At 60 — what exactly is proven, and for which n?</a:t>
+            </a:r>
+          </a:p>
+          <a:p>
+            <a:pPr>
+              <a:spcAft>
+                <a:spcPts val="800"/>
+              </a:spcAft>
+            </a:pPr>
+            <a:r>
+              <a:rPr sz="2200">
+                <a:solidFill>
+                  <a:srgbClr val="212121"/>
+                </a:solidFill>
+              </a:rPr>
+              <a:t>Stretch: --k-induction answers VERIFICATION UNKNOWN. Why is the unbounded question fundamentally harder? (Background deck: 03-k-induction.pptx)</a:t>
+            </a:r>
+          </a:p>
+        </p:txBody>
+      </p:sp>
+    </p:spTree>
+  </p:cSld>
+  <p:clrMapOvr>
+    <a:masterClrMapping/>
+  </p:clrMapOvr>
+</p:sld>
+</file>
+
+<file path=ppt/slides/slide18.xml><?xml version="1.0" encoding="utf-8"?>
+<p:sld xmlns:a="http://schemas.openxmlformats.org/drawingml/2006/main" xmlns:p="http://schemas.openxmlformats.org/presentationml/2006/main" xmlns:r="http://schemas.openxmlformats.org/officeDocument/2006/relationships">
+  <p:cSld>
+    <p:spTree>
+      <p:nvGrpSpPr>
+        <p:cNvPr id="1" name=""/>
+        <p:cNvGrpSpPr/>
+        <p:nvPr/>
+      </p:nvGrpSpPr>
+      <p:grpSpPr/>
+      <p:sp>
+        <p:nvSpPr>
+          <p:cNvPr id="2" name="TextBox 1"/>
+          <p:cNvSpPr txBox="1"/>
+          <p:nvPr/>
+        </p:nvSpPr>
+        <p:spPr>
+          <a:xfrm>
+            <a:off x="548640" y="365760"/>
+            <a:ext cx="11064240" cy="1005840"/>
+          </a:xfrm>
+          <a:prstGeom prst="rect">
+            <a:avLst/>
+          </a:prstGeom>
+          <a:noFill/>
+        </p:spPr>
+        <p:txBody>
+          <a:bodyPr wrap="square">
+            <a:spAutoFit/>
+          </a:bodyPr>
+          <a:lstStyle/>
+          <a:p>
+            <a:r>
+              <a:rPr sz="3600" b="1">
+                <a:solidFill>
+                  <a:srgbClr val="5A0A7A"/>
+                </a:solidFill>
+              </a:rPr>
+              <a:t>Lab 4 — Team challenge (30 min)</a:t>
+            </a:r>
+          </a:p>
+        </p:txBody>
+      </p:sp>
+      <p:sp>
+        <p:nvSpPr>
+          <p:cNvPr id="3" name="TextBox 2"/>
+          <p:cNvSpPr txBox="1"/>
+          <p:nvPr/>
+        </p:nvSpPr>
+        <p:spPr>
+          <a:xfrm>
+            <a:off x="731520" y="1463040"/>
+            <a:ext cx="10789920" cy="5120640"/>
+          </a:xfrm>
+          <a:prstGeom prst="rect">
+            <a:avLst/>
+          </a:prstGeom>
+          <a:noFill/>
+        </p:spPr>
+        <p:txBody>
+          <a:bodyPr wrap="square">
+            <a:spAutoFit/>
+          </a:bodyPr>
+          <a:lstStyle/>
+          <a:p>
+            <a:pPr>
+              <a:spcAft>
+                <a:spcPts val="800"/>
+              </a:spcAft>
+            </a:pPr>
+            <a:r>
+              <a:rPr sz="2200">
+                <a:solidFill>
+                  <a:srgbClr val="212121"/>
+                </a:solidFill>
+              </a:rPr>
+              <a:t>Teams of 3–4. Points on the whiteboard:</a:t>
             </a:r>
           </a:p>
           <a:p>
@@ -4207,7 +4951,7 @@
                   <a:srgbClr val="212121"/>
                 </a:solidFill>
               </a:rPr>
-              <a:t>SV-COMP benchmarks: sv-comp.sosy-lab.org</a:t>
+              <a:t>1 pt — verdict predicted correctly in writing, before running</a:t>
             </a:r>
           </a:p>
           <a:p>
@@ -4222,37 +4966,7 @@
                   <a:srgbClr val="212121"/>
                 </a:solidFill>
               </a:rPr>
-              <a:t>Full course: COMP63342 Software Security (slides online)</a:t>
-            </a:r>
-          </a:p>
-          <a:p>
-            <a:pPr lvl="1">
-              <a:spcAft>
-                <a:spcPts val="800"/>
-              </a:spcAft>
-            </a:pPr>
-            <a:r>
-              <a:rPr sz="2000">
-                <a:solidFill>
-                  <a:srgbClr val="212121"/>
-                </a:solidFill>
-              </a:rPr>
-              <a:t>ESBMC: esbmc.org · Z3: github.com/Z3Prover/z3</a:t>
-            </a:r>
-          </a:p>
-          <a:p>
-            <a:pPr lvl="1">
-              <a:spcAft>
-                <a:spcPts val="800"/>
-              </a:spcAft>
-            </a:pPr>
-            <a:r>
-              <a:rPr sz="2000">
-                <a:solidFill>
-                  <a:srgbClr val="212121"/>
-                </a:solidFill>
-              </a:rPr>
-              <a:t>The complementary technique: fuzzing (AFL, OSS-Fuzz)</a:t>
+              <a:t>2 pts — file fixed and re-verified</a:t>
             </a:r>
           </a:p>
           <a:p>
@@ -4282,7 +4996,187 @@
                   <a:srgbClr val="212121"/>
                 </a:solidFill>
               </a:rPr>
-              <a:t>Feedback poll: pace / best lab / one improvement. Thank you!</a:t>
+              <a:t>Track A:  race.c — write down the failing interleaving first, then</a:t>
+            </a:r>
+          </a:p>
+          <a:p>
+            <a:pPr>
+              <a:spcAft>
+                <a:spcPts val="0"/>
+              </a:spcAft>
+            </a:pPr>
+            <a:r>
+              <a:rPr sz="1800">
+                <a:solidFill>
+                  <a:srgbClr val="212121"/>
+                </a:solidFill>
+                <a:latin typeface="Courier New"/>
+              </a:rPr>
+              <a:t>esbmc race.c --context-bound 2</a:t>
+            </a:r>
+          </a:p>
+          <a:p>
+            <a:pPr>
+              <a:spcAft>
+                <a:spcPts val="800"/>
+              </a:spcAft>
+            </a:pPr>
+            <a:r>
+              <a:rPr sz="2200">
+                <a:solidFill>
+                  <a:srgbClr val="212121"/>
+                </a:solidFill>
+              </a:rPr>
+              <a:t>Track B:  float.c — primary-school arithmetic. Or is it?</a:t>
+            </a:r>
+          </a:p>
+        </p:txBody>
+      </p:sp>
+    </p:spTree>
+  </p:cSld>
+  <p:clrMapOvr>
+    <a:masterClrMapping/>
+  </p:clrMapOvr>
+</p:sld>
+</file>
+
+<file path=ppt/slides/slide19.xml><?xml version="1.0" encoding="utf-8"?>
+<p:sld xmlns:a="http://schemas.openxmlformats.org/drawingml/2006/main" xmlns:p="http://schemas.openxmlformats.org/presentationml/2006/main" xmlns:r="http://schemas.openxmlformats.org/officeDocument/2006/relationships">
+  <p:cSld>
+    <p:spTree>
+      <p:nvGrpSpPr>
+        <p:cNvPr id="1" name=""/>
+        <p:cNvGrpSpPr/>
+        <p:nvPr/>
+      </p:nvGrpSpPr>
+      <p:grpSpPr/>
+      <p:sp>
+        <p:nvSpPr>
+          <p:cNvPr id="2" name="TextBox 1"/>
+          <p:cNvSpPr txBox="1"/>
+          <p:nvPr/>
+        </p:nvSpPr>
+        <p:spPr>
+          <a:xfrm>
+            <a:off x="548640" y="365760"/>
+            <a:ext cx="11064240" cy="1005840"/>
+          </a:xfrm>
+          <a:prstGeom prst="rect">
+            <a:avLst/>
+          </a:prstGeom>
+          <a:noFill/>
+        </p:spPr>
+        <p:txBody>
+          <a:bodyPr wrap="square">
+            <a:spAutoFit/>
+          </a:bodyPr>
+          <a:lstStyle/>
+          <a:p>
+            <a:r>
+              <a:rPr sz="3600" b="1">
+                <a:solidFill>
+                  <a:srgbClr val="5A0A7A"/>
+                </a:solidFill>
+              </a:rPr>
+              <a:t>Why machines beat humans at Track A</a:t>
+            </a:r>
+          </a:p>
+        </p:txBody>
+      </p:sp>
+      <p:sp>
+        <p:nvSpPr>
+          <p:cNvPr id="3" name="TextBox 2"/>
+          <p:cNvSpPr txBox="1"/>
+          <p:nvPr/>
+        </p:nvSpPr>
+        <p:spPr>
+          <a:xfrm>
+            <a:off x="731520" y="1463040"/>
+            <a:ext cx="10789920" cy="5120640"/>
+          </a:xfrm>
+          <a:prstGeom prst="rect">
+            <a:avLst/>
+          </a:prstGeom>
+          <a:noFill/>
+        </p:spPr>
+        <p:txBody>
+          <a:bodyPr wrap="square">
+            <a:spAutoFit/>
+          </a:bodyPr>
+          <a:lstStyle/>
+          <a:p>
+            <a:pPr>
+              <a:spcAft>
+                <a:spcPts val="800"/>
+              </a:spcAft>
+            </a:pPr>
+            <a:r>
+              <a:rPr sz="2200">
+                <a:solidFill>
+                  <a:srgbClr val="212121"/>
+                </a:solidFill>
+              </a:rPr>
+              <a:t>Sequentially, race.c is bulletproof — run it a million times, the bug may never show.</a:t>
+            </a:r>
+          </a:p>
+          <a:p>
+            <a:pPr>
+              <a:spcAft>
+                <a:spcPts val="800"/>
+              </a:spcAft>
+            </a:pPr>
+            <a:r>
+              <a:rPr sz="2200">
+                <a:solidFill>
+                  <a:srgbClr val="212121"/>
+                </a:solidFill>
+              </a:rPr>
+              <a:t>Two threads of just 2 and 1 statements already have 3 interleavings; real code has billions.</a:t>
+            </a:r>
+          </a:p>
+          <a:p>
+            <a:pPr>
+              <a:spcAft>
+                <a:spcPts val="800"/>
+              </a:spcAft>
+            </a:pPr>
+            <a:r>
+              <a:rPr sz="2200">
+                <a:solidFill>
+                  <a:srgbClr val="212121"/>
+                </a:solidFill>
+              </a:rPr>
+              <a:t>The model checker enumerates every interleaving up to the context bound — including the one that kills the assertion.</a:t>
+            </a:r>
+          </a:p>
+          <a:p>
+            <a:pPr>
+              <a:spcAft>
+                <a:spcPts val="800"/>
+              </a:spcAft>
+            </a:pPr>
+            <a:r>
+              <a:rPr sz="2200">
+                <a:solidFill>
+                  <a:srgbClr val="212121"/>
+                </a:solidFill>
+              </a:rPr>
+              <a:t/>
+            </a:r>
+          </a:p>
+          <a:p>
+            <a:pPr>
+              <a:spcAft>
+                <a:spcPts val="800"/>
+              </a:spcAft>
+            </a:pPr>
+            <a:r>
+              <a:rPr sz="2200">
+                <a:solidFill>
+                  <a:srgbClr val="212121"/>
+                </a:solidFill>
+              </a:rPr>
+              <a:t>The counterexample you get includes the thread schedule: read it as a story of who ran when.</a:t>
             </a:r>
           </a:p>
         </p:txBody>
@@ -4463,6 +5357,230 @@
                 </a:solidFill>
               </a:rPr>
               <a:t>(yes, FAILED — your tool just found a real bug)</a:t>
+            </a:r>
+          </a:p>
+        </p:txBody>
+      </p:sp>
+    </p:spTree>
+  </p:cSld>
+  <p:clrMapOvr>
+    <a:masterClrMapping/>
+  </p:clrMapOvr>
+</p:sld>
+</file>
+
+<file path=ppt/slides/slide20.xml><?xml version="1.0" encoding="utf-8"?>
+<p:sld xmlns:a="http://schemas.openxmlformats.org/drawingml/2006/main" xmlns:p="http://schemas.openxmlformats.org/presentationml/2006/main" xmlns:r="http://schemas.openxmlformats.org/officeDocument/2006/relationships">
+  <p:cSld>
+    <p:spTree>
+      <p:nvGrpSpPr>
+        <p:cNvPr id="1" name=""/>
+        <p:cNvGrpSpPr/>
+        <p:nvPr/>
+      </p:nvGrpSpPr>
+      <p:grpSpPr/>
+      <p:sp>
+        <p:nvSpPr>
+          <p:cNvPr id="2" name="TextBox 1"/>
+          <p:cNvSpPr txBox="1"/>
+          <p:nvPr/>
+        </p:nvSpPr>
+        <p:spPr>
+          <a:xfrm>
+            <a:off x="548640" y="365760"/>
+            <a:ext cx="11064240" cy="1005840"/>
+          </a:xfrm>
+          <a:prstGeom prst="rect">
+            <a:avLst/>
+          </a:prstGeom>
+          <a:noFill/>
+        </p:spPr>
+        <p:txBody>
+          <a:bodyPr wrap="square">
+            <a:spAutoFit/>
+          </a:bodyPr>
+          <a:lstStyle/>
+          <a:p>
+            <a:r>
+              <a:rPr sz="3600" b="1">
+                <a:solidFill>
+                  <a:srgbClr val="5A0A7A"/>
+                </a:solidFill>
+              </a:rPr>
+              <a:t>Debrief</a:t>
+            </a:r>
+          </a:p>
+        </p:txBody>
+      </p:sp>
+      <p:sp>
+        <p:nvSpPr>
+          <p:cNvPr id="3" name="TextBox 2"/>
+          <p:cNvSpPr txBox="1"/>
+          <p:nvPr/>
+        </p:nvSpPr>
+        <p:spPr>
+          <a:xfrm>
+            <a:off x="731520" y="1463040"/>
+            <a:ext cx="10789920" cy="5120640"/>
+          </a:xfrm>
+          <a:prstGeom prst="rect">
+            <a:avLst/>
+          </a:prstGeom>
+          <a:noFill/>
+        </p:spPr>
+        <p:txBody>
+          <a:bodyPr wrap="square">
+            <a:spAutoFit/>
+          </a:bodyPr>
+          <a:lstStyle/>
+          <a:p>
+            <a:pPr>
+              <a:spcAft>
+                <a:spcPts val="800"/>
+              </a:spcAft>
+            </a:pPr>
+            <a:r>
+              <a:rPr sz="2200">
+                <a:solidFill>
+                  <a:srgbClr val="212121"/>
+                </a:solidFill>
+              </a:rPr>
+              <a:t>One thing the tool caught that YOU wouldn't have?</a:t>
+            </a:r>
+          </a:p>
+          <a:p>
+            <a:pPr>
+              <a:spcAft>
+                <a:spcPts val="800"/>
+              </a:spcAft>
+            </a:pPr>
+            <a:r>
+              <a:rPr sz="2200">
+                <a:solidFill>
+                  <a:srgbClr val="212121"/>
+                </a:solidFill>
+              </a:rPr>
+              <a:t>The arc you just walked: intuition → concepts → tools → application</a:t>
+            </a:r>
+          </a:p>
+          <a:p>
+            <a:pPr>
+              <a:spcAft>
+                <a:spcPts val="800"/>
+              </a:spcAft>
+            </a:pPr>
+            <a:r>
+              <a:rPr sz="2200">
+                <a:solidFill>
+                  <a:srgbClr val="212121"/>
+                </a:solidFill>
+              </a:rPr>
+              <a:t/>
+            </a:r>
+          </a:p>
+          <a:p>
+            <a:pPr>
+              <a:spcAft>
+                <a:spcPts val="800"/>
+              </a:spcAft>
+            </a:pPr>
+            <a:r>
+              <a:rPr sz="2200">
+                <a:solidFill>
+                  <a:srgbClr val="212121"/>
+                </a:solidFill>
+              </a:rPr>
+              <a:t>Where next:</a:t>
+            </a:r>
+          </a:p>
+          <a:p>
+            <a:pPr lvl="1">
+              <a:spcAft>
+                <a:spcPts val="800"/>
+              </a:spcAft>
+            </a:pPr>
+            <a:r>
+              <a:rPr sz="2000">
+                <a:solidFill>
+                  <a:srgbClr val="212121"/>
+                </a:solidFill>
+              </a:rPr>
+              <a:t>SV-COMP benchmarks: sv-comp.sosy-lab.org</a:t>
+            </a:r>
+          </a:p>
+          <a:p>
+            <a:pPr lvl="1">
+              <a:spcAft>
+                <a:spcPts val="800"/>
+              </a:spcAft>
+            </a:pPr>
+            <a:r>
+              <a:rPr sz="2000">
+                <a:solidFill>
+                  <a:srgbClr val="212121"/>
+                </a:solidFill>
+              </a:rPr>
+              <a:t>Full course: COMP63342 Software Security (slides online)</a:t>
+            </a:r>
+          </a:p>
+          <a:p>
+            <a:pPr lvl="1">
+              <a:spcAft>
+                <a:spcPts val="800"/>
+              </a:spcAft>
+            </a:pPr>
+            <a:r>
+              <a:rPr sz="2000">
+                <a:solidFill>
+                  <a:srgbClr val="212121"/>
+                </a:solidFill>
+              </a:rPr>
+              <a:t>ESBMC: esbmc.org · Z3: github.com/Z3Prover/z3</a:t>
+            </a:r>
+          </a:p>
+          <a:p>
+            <a:pPr lvl="1">
+              <a:spcAft>
+                <a:spcPts val="800"/>
+              </a:spcAft>
+            </a:pPr>
+            <a:r>
+              <a:rPr sz="2000">
+                <a:solidFill>
+                  <a:srgbClr val="212121"/>
+                </a:solidFill>
+              </a:rPr>
+              <a:t>The complementary technique: fuzzing (AFL, OSS-Fuzz)</a:t>
+            </a:r>
+          </a:p>
+          <a:p>
+            <a:pPr>
+              <a:spcAft>
+                <a:spcPts val="800"/>
+              </a:spcAft>
+            </a:pPr>
+            <a:r>
+              <a:rPr sz="2200">
+                <a:solidFill>
+                  <a:srgbClr val="212121"/>
+                </a:solidFill>
+              </a:rPr>
+              <a:t/>
+            </a:r>
+          </a:p>
+          <a:p>
+            <a:pPr>
+              <a:spcAft>
+                <a:spcPts val="800"/>
+              </a:spcAft>
+            </a:pPr>
+            <a:r>
+              <a:rPr sz="2200">
+                <a:solidFill>
+                  <a:srgbClr val="212121"/>
+                </a:solidFill>
+              </a:rPr>
+              <a:t>Feedback poll: pace / best lab / one improvement. Thank you!</a:t>
             </a:r>
           </a:p>
         </p:txBody>
@@ -5178,7 +6296,7 @@
                   <a:srgbClr val="5A0A7A"/>
                 </a:solidFill>
               </a:rPr>
-              <a:t>Checkpoint before Lab 2</a:t>
+              <a:t>Z3's Python API — the whole toolkit</a:t>
             </a:r>
           </a:p>
         </p:txBody>
@@ -5191,8 +6309,8 @@
         </p:nvSpPr>
         <p:spPr>
           <a:xfrm>
-            <a:off x="731520" y="2011680"/>
-            <a:ext cx="10789920" cy="4572000"/>
+            <a:off x="731520" y="1463040"/>
+            <a:ext cx="10789920" cy="5120640"/>
           </a:xfrm>
           <a:prstGeom prst="rect">
             <a:avLst/>
@@ -5207,44 +6325,63 @@
           <a:p>
             <a:pPr>
               <a:spcAft>
-                <a:spcPts val="800"/>
-              </a:spcAft>
-            </a:pPr>
-            <a:r>
-              <a:rPr sz="2800">
-                <a:solidFill>
-                  <a:srgbClr val="212121"/>
-                </a:solidFill>
-              </a:rPr>
-              <a:t>What does unsat mean in Stage 1?</a:t>
-            </a:r>
-          </a:p>
-          <a:p>
-            <a:pPr>
-              <a:spcAft>
-                <a:spcPts val="800"/>
-              </a:spcAft>
-            </a:pPr>
-            <a:r>
-              <a:rPr sz="2800">
-                <a:solidFill>
-                  <a:srgbClr val="212121"/>
-                </a:solidFill>
-              </a:rPr>
-              <a:t>What does unsat mean in Stage 3?</a:t>
-            </a:r>
-          </a:p>
-          <a:p>
-            <a:pPr>
-              <a:spcAft>
-                <a:spcPts val="800"/>
-              </a:spcAft>
-            </a:pPr>
-            <a:r>
-              <a:rPr sz="2800">
-                <a:solidFill>
-                  <a:srgbClr val="212121"/>
-                </a:solidFill>
+                <a:spcPts val="0"/>
+              </a:spcAft>
+            </a:pPr>
+            <a:r>
+              <a:rPr sz="1800">
+                <a:solidFill>
+                  <a:srgbClr val="212121"/>
+                </a:solidFill>
+                <a:latin typeface="Courier New"/>
+              </a:rPr>
+              <a:t>from z3 import Bools, Ints, BitVec, Solver, sat, unsat</a:t>
+            </a:r>
+          </a:p>
+          <a:p>
+            <a:pPr>
+              <a:spcAft>
+                <a:spcPts val="0"/>
+              </a:spcAft>
+            </a:pPr>
+            <a:r>
+              <a:rPr sz="1800">
+                <a:solidFill>
+                  <a:srgbClr val="212121"/>
+                </a:solidFill>
+                <a:latin typeface="Courier New"/>
+              </a:rPr>
+              <a:t>a, b = Bools("a b")     # symbolic booleans, not values</a:t>
+            </a:r>
+          </a:p>
+          <a:p>
+            <a:pPr>
+              <a:spcAft>
+                <a:spcPts val="0"/>
+              </a:spcAft>
+            </a:pPr>
+            <a:r>
+              <a:rPr sz="1800">
+                <a:solidFill>
+                  <a:srgbClr val="212121"/>
+                </a:solidFill>
+                <a:latin typeface="Courier New"/>
+              </a:rPr>
+              <a:t>x = BitVec("x", 32)     # a 32-bit machine integer</a:t>
+            </a:r>
+          </a:p>
+          <a:p>
+            <a:pPr>
+              <a:spcAft>
+                <a:spcPts val="0"/>
+              </a:spcAft>
+            </a:pPr>
+            <a:r>
+              <a:rPr sz="1800">
+                <a:solidFill>
+                  <a:srgbClr val="212121"/>
+                </a:solidFill>
+                <a:latin typeface="Courier New"/>
               </a:rPr>
               <a:t/>
             </a:r>
@@ -5252,16 +6389,95 @@
           <a:p>
             <a:pPr>
               <a:spcAft>
-                <a:spcPts val="800"/>
-              </a:spcAft>
-            </a:pPr>
-            <a:r>
-              <a:rPr sz="2800">
-                <a:solidFill>
-                  <a:srgbClr val="212121"/>
-                </a:solidFill>
-              </a:rPr>
-              <a:t>Same verdict — two different questions answered. If you can articulate the difference, you understand verification.</a:t>
+                <a:spcPts val="0"/>
+              </a:spcAft>
+            </a:pPr>
+            <a:r>
+              <a:rPr sz="1800">
+                <a:solidFill>
+                  <a:srgbClr val="212121"/>
+                </a:solidFill>
+                <a:latin typeface="Courier New"/>
+              </a:rPr>
+              <a:t>s = Solver()</a:t>
+            </a:r>
+          </a:p>
+          <a:p>
+            <a:pPr>
+              <a:spcAft>
+                <a:spcPts val="0"/>
+              </a:spcAft>
+            </a:pPr>
+            <a:r>
+              <a:rPr sz="1800">
+                <a:solidFill>
+                  <a:srgbClr val="212121"/>
+                </a:solidFill>
+                <a:latin typeface="Courier New"/>
+              </a:rPr>
+              <a:t>s.add(formula)           # constrain</a:t>
+            </a:r>
+          </a:p>
+          <a:p>
+            <a:pPr>
+              <a:spcAft>
+                <a:spcPts val="0"/>
+              </a:spcAft>
+            </a:pPr>
+            <a:r>
+              <a:rPr sz="1800">
+                <a:solidFill>
+                  <a:srgbClr val="212121"/>
+                </a:solidFill>
+                <a:latin typeface="Courier New"/>
+              </a:rPr>
+              <a:t>s.check()                # -&gt; sat or unsat</a:t>
+            </a:r>
+          </a:p>
+          <a:p>
+            <a:pPr>
+              <a:spcAft>
+                <a:spcPts val="0"/>
+              </a:spcAft>
+            </a:pPr>
+            <a:r>
+              <a:rPr sz="1800">
+                <a:solidFill>
+                  <a:srgbClr val="212121"/>
+                </a:solidFill>
+                <a:latin typeface="Courier New"/>
+              </a:rPr>
+              <a:t>s.model()                # the witness, when sat</a:t>
+            </a:r>
+          </a:p>
+          <a:p>
+            <a:pPr>
+              <a:spcAft>
+                <a:spcPts val="800"/>
+              </a:spcAft>
+            </a:pPr>
+            <a:r>
+              <a:rPr sz="2200">
+                <a:solidFill>
+                  <a:srgbClr val="212121"/>
+                </a:solidFill>
+              </a:rPr>
+              <a:t/>
+            </a:r>
+          </a:p>
+          <a:p>
+            <a:pPr>
+              <a:spcAft>
+                <a:spcPts val="800"/>
+              </a:spcAft>
+            </a:pPr>
+            <a:r>
+              <a:rPr sz="2200">
+                <a:solidFill>
+                  <a:srgbClr val="212121"/>
+                </a:solidFill>
+              </a:rPr>
+              <a:t>Every stage of lab1.py is these five calls — nothing else.</a:t>
             </a:r>
           </a:p>
         </p:txBody>
@@ -5312,7 +6528,7 @@
                   <a:srgbClr val="5A0A7A"/>
                 </a:solidFill>
               </a:rPr>
-              <a:t>Lab 2 — Bug hunting (40 min)</a:t>
+              <a:t>Walkthrough: equivalent() from lab1.py</a:t>
             </a:r>
           </a:p>
         </p:txBody>
@@ -5325,8 +6541,8 @@
         </p:nvSpPr>
         <p:spPr>
           <a:xfrm>
-            <a:off x="731520" y="1371600"/>
-            <a:ext cx="10789920" cy="5212080"/>
+            <a:off x="731520" y="1463040"/>
+            <a:ext cx="10789920" cy="5120640"/>
           </a:xfrm>
           <a:prstGeom prst="rect">
             <a:avLst/>
@@ -5341,6 +6557,118 @@
           <a:p>
             <a:pPr>
               <a:spcAft>
+                <a:spcPts val="0"/>
+              </a:spcAft>
+            </a:pPr>
+            <a:r>
+              <a:rPr sz="1800">
+                <a:solidFill>
+                  <a:srgbClr val="212121"/>
+                </a:solidFill>
+                <a:latin typeface="Courier New"/>
+              </a:rPr>
+              <a:t>def equivalent(lhs, rhs, name):</a:t>
+            </a:r>
+          </a:p>
+          <a:p>
+            <a:pPr>
+              <a:spcAft>
+                <a:spcPts val="0"/>
+              </a:spcAft>
+            </a:pPr>
+            <a:r>
+              <a:rPr sz="1800">
+                <a:solidFill>
+                  <a:srgbClr val="212121"/>
+                </a:solidFill>
+                <a:latin typeface="Courier New"/>
+              </a:rPr>
+              <a:t>    slv = Solver()</a:t>
+            </a:r>
+          </a:p>
+          <a:p>
+            <a:pPr>
+              <a:spcAft>
+                <a:spcPts val="0"/>
+              </a:spcAft>
+            </a:pPr>
+            <a:r>
+              <a:rPr sz="1800">
+                <a:solidFill>
+                  <a:srgbClr val="212121"/>
+                </a:solidFill>
+                <a:latin typeface="Courier New"/>
+              </a:rPr>
+              <a:t>    slv.add(lhs != rhs)            # can they EVER differ?</a:t>
+            </a:r>
+          </a:p>
+          <a:p>
+            <a:pPr>
+              <a:spcAft>
+                <a:spcPts val="0"/>
+              </a:spcAft>
+            </a:pPr>
+            <a:r>
+              <a:rPr sz="1800">
+                <a:solidFill>
+                  <a:srgbClr val="212121"/>
+                </a:solidFill>
+                <a:latin typeface="Courier New"/>
+              </a:rPr>
+              <a:t>    if slv.check() == unsat:       # never differ: a proof</a:t>
+            </a:r>
+          </a:p>
+          <a:p>
+            <a:pPr>
+              <a:spcAft>
+                <a:spcPts val="0"/>
+              </a:spcAft>
+            </a:pPr>
+            <a:r>
+              <a:rPr sz="1800">
+                <a:solidFill>
+                  <a:srgbClr val="212121"/>
+                </a:solidFill>
+                <a:latin typeface="Courier New"/>
+              </a:rPr>
+              <a:t>        print(name, "EQUIVALENT")</a:t>
+            </a:r>
+          </a:p>
+          <a:p>
+            <a:pPr>
+              <a:spcAft>
+                <a:spcPts val="0"/>
+              </a:spcAft>
+            </a:pPr>
+            <a:r>
+              <a:rPr sz="1800">
+                <a:solidFill>
+                  <a:srgbClr val="212121"/>
+                </a:solidFill>
+                <a:latin typeface="Courier New"/>
+              </a:rPr>
+              <a:t>    else:                          # a witness they differ</a:t>
+            </a:r>
+          </a:p>
+          <a:p>
+            <a:pPr>
+              <a:spcAft>
+                <a:spcPts val="0"/>
+              </a:spcAft>
+            </a:pPr>
+            <a:r>
+              <a:rPr sz="1800">
+                <a:solidFill>
+                  <a:srgbClr val="212121"/>
+                </a:solidFill>
+                <a:latin typeface="Courier New"/>
+              </a:rPr>
+              <a:t>        print(name, slv.model())</a:t>
+            </a:r>
+          </a:p>
+          <a:p>
+            <a:pPr>
+              <a:spcAft>
                 <a:spcPts val="800"/>
               </a:spcAft>
             </a:pPr>
@@ -5350,266 +6678,11 @@
                   <a:srgbClr val="212121"/>
                 </a:solidFill>
               </a:rPr>
-              <a:t>predict → verify → READ THE COUNTEREXAMPLE → fix → re-verify</a:t>
-            </a:r>
-          </a:p>
-        </p:txBody>
-      </p:sp>
-      <p:graphicFrame>
-        <p:nvGraphicFramePr>
-          <p:cNvPr id="4" name="Table 3"/>
-          <p:cNvGraphicFramePr>
-            <a:graphicFrameLocks noGrp="1"/>
-          </p:cNvGraphicFramePr>
-          <p:nvPr/>
-        </p:nvGraphicFramePr>
-        <p:xfrm>
-          <a:off x="731520" y="2103120"/>
-          <a:ext cx="7498080" cy="1828800"/>
-        </p:xfrm>
-        <a:graphic>
-          <a:graphicData uri="http://schemas.openxmlformats.org/drawingml/2006/table">
-            <a:tbl>
-              <a:tblPr firstRow="1" bandRow="1">
-                <a:tableStyleId>{5C22544A-7EE6-4342-B048-85BDC9FD1C3A}</a:tableStyleId>
-              </a:tblPr>
-              <a:tblGrid>
-                <a:gridCol w="731520"/>
-                <a:gridCol w="4754880"/>
-                <a:gridCol w="2011680"/>
-              </a:tblGrid>
-              <a:tr h="365760">
-                <a:tc>
-                  <a:txBody>
-                    <a:bodyPr/>
-                    <a:lstStyle/>
-                    <a:p>
-                      <a:r>
-                        <a:rPr sz="1800" b="1"/>
-                        <a:t>#</a:t>
-                      </a:r>
-                    </a:p>
-                  </a:txBody>
-                  <a:tcPr/>
-                </a:tc>
-                <a:tc>
-                  <a:txBody>
-                    <a:bodyPr/>
-                    <a:lstStyle/>
-                    <a:p>
-                      <a:r>
-                        <a:rPr sz="1800" b="1"/>
-                        <a:t>File</a:t>
-                      </a:r>
-                    </a:p>
-                  </a:txBody>
-                  <a:tcPr/>
-                </a:tc>
-                <a:tc>
-                  <a:txBody>
-                    <a:bodyPr/>
-                    <a:lstStyle/>
-                    <a:p>
-                      <a:r>
-                        <a:rPr sz="1800" b="1"/>
-                        <a:t>By</a:t>
-                      </a:r>
-                    </a:p>
-                  </a:txBody>
-                  <a:tcPr/>
-                </a:tc>
-              </a:tr>
-              <a:tr h="365760">
-                <a:tc>
-                  <a:txBody>
-                    <a:bodyPr/>
-                    <a:lstStyle/>
-                    <a:p>
-                      <a:r>
-                        <a:rPr sz="1800"/>
-                        <a:t>1</a:t>
-                      </a:r>
-                    </a:p>
-                  </a:txBody>
-                  <a:tcPr/>
-                </a:tc>
-                <a:tc>
-                  <a:txBody>
-                    <a:bodyPr/>
-                    <a:lstStyle/>
-                    <a:p>
-                      <a:r>
-                        <a:rPr sz="1800"/>
-                        <a:t>overflow.c</a:t>
-                      </a:r>
-                    </a:p>
-                  </a:txBody>
-                  <a:tcPr/>
-                </a:tc>
-                <a:tc>
-                  <a:txBody>
-                    <a:bodyPr/>
-                    <a:lstStyle/>
-                    <a:p>
-                      <a:r>
-                        <a:rPr sz="1800"/>
-                        <a:t>—</a:t>
-                      </a:r>
-                    </a:p>
-                  </a:txBody>
-                  <a:tcPr/>
-                </a:tc>
-              </a:tr>
-              <a:tr h="365760">
-                <a:tc>
-                  <a:txBody>
-                    <a:bodyPr/>
-                    <a:lstStyle/>
-                    <a:p>
-                      <a:r>
-                        <a:rPr sz="1800"/>
-                        <a:t>2</a:t>
-                      </a:r>
-                    </a:p>
-                  </a:txBody>
-                  <a:tcPr/>
-                </a:tc>
-                <a:tc>
-                  <a:txBody>
-                    <a:bodyPr/>
-                    <a:lstStyle/>
-                    <a:p>
-                      <a:r>
-                        <a:rPr sz="1800"/>
-                        <a:t>leak.c</a:t>
-                      </a:r>
-                    </a:p>
-                  </a:txBody>
-                  <a:tcPr/>
-                </a:tc>
-                <a:tc>
-                  <a:txBody>
-                    <a:bodyPr/>
-                    <a:lstStyle/>
-                    <a:p>
-                      <a:r>
-                        <a:rPr sz="1800"/>
-                        <a:t>19:05</a:t>
-                      </a:r>
-                    </a:p>
-                  </a:txBody>
-                  <a:tcPr/>
-                </a:tc>
-              </a:tr>
-              <a:tr h="365760">
-                <a:tc>
-                  <a:txBody>
-                    <a:bodyPr/>
-                    <a:lstStyle/>
-                    <a:p>
-                      <a:r>
-                        <a:rPr sz="1800"/>
-                        <a:t>3</a:t>
-                      </a:r>
-                    </a:p>
-                  </a:txBody>
-                  <a:tcPr/>
-                </a:tc>
-                <a:tc>
-                  <a:txBody>
-                    <a:bodyPr/>
-                    <a:lstStyle/>
-                    <a:p>
-                      <a:r>
-                        <a:rPr sz="1800"/>
-                        <a:t>vla.c  (two bugs!)</a:t>
-                      </a:r>
-                    </a:p>
-                  </a:txBody>
-                  <a:tcPr/>
-                </a:tc>
-                <a:tc>
-                  <a:txBody>
-                    <a:bodyPr/>
-                    <a:lstStyle/>
-                    <a:p>
-                      <a:r>
-                        <a:rPr sz="1800"/>
-                        <a:t>19:20</a:t>
-                      </a:r>
-                    </a:p>
-                  </a:txBody>
-                  <a:tcPr/>
-                </a:tc>
-              </a:tr>
-              <a:tr h="365760">
-                <a:tc>
-                  <a:txBody>
-                    <a:bodyPr/>
-                    <a:lstStyle/>
-                    <a:p>
-                      <a:r>
-                        <a:rPr sz="1800"/>
-                        <a:t>4</a:t>
-                      </a:r>
-                    </a:p>
-                  </a:txBody>
-                  <a:tcPr/>
-                </a:tc>
-                <a:tc>
-                  <a:txBody>
-                    <a:bodyPr/>
-                    <a:lstStyle/>
-                    <a:p>
-                      <a:r>
-                        <a:rPr sz="1800"/>
-                        <a:t>getpassword.c</a:t>
-                      </a:r>
-                    </a:p>
-                  </a:txBody>
-                  <a:tcPr/>
-                </a:tc>
-                <a:tc>
-                  <a:txBody>
-                    <a:bodyPr/>
-                    <a:lstStyle/>
-                    <a:p>
-                      <a:r>
-                        <a:rPr sz="1800"/>
-                        <a:t>stretch</a:t>
-                      </a:r>
-                    </a:p>
-                  </a:txBody>
-                  <a:tcPr/>
-                </a:tc>
-              </a:tr>
-            </a:tbl>
-          </a:graphicData>
-        </a:graphic>
-      </p:graphicFrame>
-      <p:sp>
-        <p:nvSpPr>
-          <p:cNvPr id="5" name="TextBox 4"/>
-          <p:cNvSpPr txBox="1"/>
-          <p:nvPr/>
-        </p:nvSpPr>
-        <p:spPr>
-          <a:xfrm>
-            <a:off x="731520" y="4754880"/>
-            <a:ext cx="10789920" cy="1828799"/>
-          </a:xfrm>
-          <a:prstGeom prst="rect">
-            <a:avLst/>
-          </a:prstGeom>
-          <a:noFill/>
-        </p:spPr>
-        <p:txBody>
-          <a:bodyPr wrap="square">
-            <a:spAutoFit/>
-          </a:bodyPr>
-          <a:lstStyle/>
-          <a:p>
-            <a:pPr>
+              <a:t/>
+            </a:r>
+          </a:p>
+          <a:p>
+            <a:pPr lvl="1">
               <a:spcAft>
                 <a:spcPts val="800"/>
               </a:spcAft>
@@ -5620,11 +6693,27 @@
                   <a:srgbClr val="212121"/>
                 </a:solidFill>
               </a:rPr>
-              <a:t>Done = VERIFICATION SUCCESSFUL on your fixed file, same flags.</a:t>
-            </a:r>
-          </a:p>
-          <a:p>
-            <a:pPr>
+              <a:t>1a De Morgan: EQUIVALENT   ·   1b distribution: EQUIVALENT</a:t>
+            </a:r>
+          </a:p>
+          <a:p>
+            <a:pPr lvl="1">
+              <a:spcAft>
+                <a:spcPts val="0"/>
+              </a:spcAft>
+            </a:pPr>
+            <a:r>
+              <a:rPr sz="1800">
+                <a:solidFill>
+                  <a:srgbClr val="212121"/>
+                </a:solidFill>
+                <a:latin typeface="Courier New"/>
+              </a:rPr>
+              <a:t>1c trick question: NOT equivalent, counterexample: [b = False]</a:t>
+            </a:r>
+          </a:p>
+          <a:p>
+            <a:pPr lvl="1">
               <a:spcAft>
                 <a:spcPts val="800"/>
               </a:spcAft>
@@ -5635,7 +6724,7 @@
                   <a:srgbClr val="212121"/>
                 </a:solidFill>
               </a:rPr>
-              <a:t>Finished early? You are now a TA — help the pair next to you.</a:t>
+              <a:t>Read the model: with b = False, a → (b → a) is true but b is false.</a:t>
             </a:r>
           </a:p>
         </p:txBody>
@@ -5686,7 +6775,7 @@
                   <a:srgbClr val="5A0A7A"/>
                 </a:solidFill>
               </a:rPr>
-              <a:t>How to read a counterexample</a:t>
+              <a:t>Walkthrough: Stage 3 is ESBMC by hand</a:t>
             </a:r>
           </a:p>
         </p:txBody>
@@ -5725,7 +6814,7 @@
                 </a:solidFill>
                 <a:latin typeface="Courier New"/>
               </a:rPr>
-              <a:t>State 3  file overflow.c  line 21 ...</a:t>
+              <a:t>x, y, z = BitVec("x", 32), BitVec("y", 32), BitVec("z", 32)</a:t>
             </a:r>
           </a:p>
           <a:p>
@@ -5741,7 +6830,7 @@
                 </a:solidFill>
                 <a:latin typeface="Courier New"/>
               </a:rPr>
-              <a:t>  i = 2 (00000000 ... 010)        ← inputs the solver chose</a:t>
+              <a:t>s.add(y == x + 1)        # int y = x + 1;</a:t>
             </a:r>
           </a:p>
           <a:p>
@@ -5757,7 +6846,7 @@
                 </a:solidFill>
                 <a:latin typeface="Courier New"/>
               </a:rPr>
-              <a:t>...</a:t>
+              <a:t>s.add(z == y * 2)        # int z = y * 2;</a:t>
             </a:r>
           </a:p>
           <a:p>
@@ -5773,7 +6862,22 @@
                 </a:solidFill>
                 <a:latin typeface="Courier New"/>
               </a:rPr>
-              <a:t>Violated property:</a:t>
+              <a:t>s.add(Not(z &gt;= 2))       # assert(z &gt;= 2) — NEGATED</a:t>
+            </a:r>
+          </a:p>
+          <a:p>
+            <a:pPr>
+              <a:spcAft>
+                <a:spcPts val="800"/>
+              </a:spcAft>
+            </a:pPr>
+            <a:r>
+              <a:rPr sz="2200">
+                <a:solidFill>
+                  <a:srgbClr val="212121"/>
+                </a:solidFill>
+              </a:rPr>
+              <a:t/>
             </a:r>
           </a:p>
           <a:p>
@@ -5789,23 +6893,22 @@
                 </a:solidFill>
                 <a:latin typeface="Courier New"/>
               </a:rPr>
-              <a:t>  dereference failure: array bounds violated   ← what broke</a:t>
-            </a:r>
-          </a:p>
-          <a:p>
-            <a:pPr>
-              <a:spcAft>
-                <a:spcPts val="0"/>
-              </a:spcAft>
-            </a:pPr>
-            <a:r>
-              <a:rPr sz="1800">
-                <a:solidFill>
-                  <a:srgbClr val="212121"/>
-                </a:solidFill>
-                <a:latin typeface="Courier New"/>
-              </a:rPr>
-              <a:t>  CWE: CWE-121, CWE-125, ...                    ← the vuln class</a:t>
+              <a:t>sat — counterexample e.g. x = 1073741824 (= 2^30)</a:t>
+            </a:r>
+          </a:p>
+          <a:p>
+            <a:pPr lvl="1">
+              <a:spcAft>
+                <a:spcPts val="800"/>
+              </a:spcAft>
+            </a:pPr>
+            <a:r>
+              <a:rPr sz="2000">
+                <a:solidFill>
+                  <a:srgbClr val="212121"/>
+                </a:solidFill>
+              </a:rPr>
+              <a:t>y * 2 overflows the 32-bit range: z comes out negative.</a:t>
             </a:r>
           </a:p>
           <a:p>
@@ -5820,6 +6923,21 @@
                   <a:srgbClr val="212121"/>
                 </a:solidFill>
               </a:rPr>
+              <a:t>Would your test suite have tried 1073741824?</a:t>
+            </a:r>
+          </a:p>
+          <a:p>
+            <a:pPr>
+              <a:spcAft>
+                <a:spcPts val="800"/>
+              </a:spcAft>
+            </a:pPr>
+            <a:r>
+              <a:rPr sz="2200">
+                <a:solidFill>
+                  <a:srgbClr val="212121"/>
+                </a:solidFill>
+              </a:rPr>
               <a:t/>
             </a:r>
           </a:p>
@@ -5835,22 +6953,7 @@
                   <a:srgbClr val="212121"/>
                 </a:solidFill>
               </a:rPr>
-              <a:t>Read bottom-up: what was violated, then scroll up for which values caused it.</a:t>
-            </a:r>
-          </a:p>
-          <a:p>
-            <a:pPr>
-              <a:spcAft>
-                <a:spcPts val="800"/>
-              </a:spcAft>
-            </a:pPr>
-            <a:r>
-              <a:rPr sz="2200">
-                <a:solidFill>
-                  <a:srgbClr val="212121"/>
-                </a:solidFill>
-              </a:rPr>
-              <a:t>Those values are a ready-made failing test case — keep them.</a:t>
+              <a:t>ESBMC builds exactly this formula from your C — automatically. That's Lab 2.</a:t>
             </a:r>
           </a:p>
         </p:txBody>
@@ -5881,7 +6984,7 @@
         </p:nvSpPr>
         <p:spPr>
           <a:xfrm>
-            <a:off x="548640" y="2377440"/>
+            <a:off x="548640" y="365760"/>
             <a:ext cx="11064240" cy="1005840"/>
           </a:xfrm>
           <a:prstGeom prst="rect">
@@ -5896,12 +6999,95 @@
           <a:lstStyle/>
           <a:p>
             <a:r>
-              <a:rPr sz="4400" b="1">
+              <a:rPr sz="3600" b="1">
                 <a:solidFill>
                   <a:srgbClr val="5A0A7A"/>
                 </a:solidFill>
               </a:rPr>
-              <a:t>Break — back at 19:40</a:t>
+              <a:t>Checkpoint before Lab 2</a:t>
+            </a:r>
+          </a:p>
+        </p:txBody>
+      </p:sp>
+      <p:sp>
+        <p:nvSpPr>
+          <p:cNvPr id="3" name="TextBox 2"/>
+          <p:cNvSpPr txBox="1"/>
+          <p:nvPr/>
+        </p:nvSpPr>
+        <p:spPr>
+          <a:xfrm>
+            <a:off x="731520" y="2011680"/>
+            <a:ext cx="10789920" cy="4572000"/>
+          </a:xfrm>
+          <a:prstGeom prst="rect">
+            <a:avLst/>
+          </a:prstGeom>
+          <a:noFill/>
+        </p:spPr>
+        <p:txBody>
+          <a:bodyPr wrap="square">
+            <a:spAutoFit/>
+          </a:bodyPr>
+          <a:lstStyle/>
+          <a:p>
+            <a:pPr>
+              <a:spcAft>
+                <a:spcPts val="800"/>
+              </a:spcAft>
+            </a:pPr>
+            <a:r>
+              <a:rPr sz="2800">
+                <a:solidFill>
+                  <a:srgbClr val="212121"/>
+                </a:solidFill>
+              </a:rPr>
+              <a:t>What does unsat mean in Stage 1?</a:t>
+            </a:r>
+          </a:p>
+          <a:p>
+            <a:pPr>
+              <a:spcAft>
+                <a:spcPts val="800"/>
+              </a:spcAft>
+            </a:pPr>
+            <a:r>
+              <a:rPr sz="2800">
+                <a:solidFill>
+                  <a:srgbClr val="212121"/>
+                </a:solidFill>
+              </a:rPr>
+              <a:t>What does unsat mean in Stage 3?</a:t>
+            </a:r>
+          </a:p>
+          <a:p>
+            <a:pPr>
+              <a:spcAft>
+                <a:spcPts val="800"/>
+              </a:spcAft>
+            </a:pPr>
+            <a:r>
+              <a:rPr sz="2800">
+                <a:solidFill>
+                  <a:srgbClr val="212121"/>
+                </a:solidFill>
+              </a:rPr>
+              <a:t/>
+            </a:r>
+          </a:p>
+          <a:p>
+            <a:pPr>
+              <a:spcAft>
+                <a:spcPts val="800"/>
+              </a:spcAft>
+            </a:pPr>
+            <a:r>
+              <a:rPr sz="2800">
+                <a:solidFill>
+                  <a:srgbClr val="212121"/>
+                </a:solidFill>
+              </a:rPr>
+              <a:t>Same verdict — two different questions answered. If you can articulate the difference, you understand verification.</a:t>
             </a:r>
           </a:p>
         </p:txBody>

</xml_diff>

<commit_message>
Move abstract-interpretation fundamentals into Session 1; lean recap in Session 2
Add two slides to Session 1 after the BMC pipeline — the
over-approximate-to-a-fixpoint idea on a worked interval loop, and abstract
domain / widening / narrowing — placed before the Astrée case study.
Session 2 keeps a single framing slide that recaps the mechanism and ties
it to Lab 3 k-induction.
</commit_message>
<xml_diff>
--- a/slides/session2/01-session2-hands-on.pptx
+++ b/slides/session2/01-session2-hands-on.pptx
@@ -26,6 +26,7 @@
     <p:sldId id="274" r:id="rId25"/>
     <p:sldId id="275" r:id="rId26"/>
     <p:sldId id="276" r:id="rId27"/>
+    <p:sldId id="277" r:id="rId28"/>
   </p:sldIdLst>
   <p:sldSz cx="12191695" cy="6858000" type="screen4x3"/>
   <p:notesSz cx="6858000" cy="9144000"/>
@@ -3255,6 +3256,252 @@
                   <a:srgbClr val="5A0A7A"/>
                 </a:solidFill>
               </a:rPr>
+              <a:t>Box B: hand that same Python to ESBMC</a:t>
+            </a:r>
+          </a:p>
+        </p:txBody>
+      </p:sp>
+      <p:sp>
+        <p:nvSpPr>
+          <p:cNvPr id="3" name="TextBox 2"/>
+          <p:cNvSpPr txBox="1"/>
+          <p:nvPr/>
+        </p:nvSpPr>
+        <p:spPr>
+          <a:xfrm>
+            <a:off x="731520" y="1463040"/>
+            <a:ext cx="10789920" cy="5120640"/>
+          </a:xfrm>
+          <a:prstGeom prst="rect">
+            <a:avLst/>
+          </a:prstGeom>
+          <a:noFill/>
+        </p:spPr>
+        <p:txBody>
+          <a:bodyPr wrap="square">
+            <a:spAutoFit/>
+          </a:bodyPr>
+          <a:lstStyle/>
+          <a:p>
+            <a:pPr>
+              <a:spcAft>
+                <a:spcPts val="0"/>
+              </a:spcAft>
+            </a:pPr>
+            <a:r>
+              <a:rPr sz="1800">
+                <a:solidFill>
+                  <a:srgbClr val="212121"/>
+                </a:solidFill>
+                <a:latin typeface="Courier New"/>
+              </a:rPr>
+              <a:t>def f(x: int) -&gt; int:</a:t>
+            </a:r>
+          </a:p>
+          <a:p>
+            <a:pPr>
+              <a:spcAft>
+                <a:spcPts val="0"/>
+              </a:spcAft>
+            </a:pPr>
+            <a:r>
+              <a:rPr sz="1800">
+                <a:solidFill>
+                  <a:srgbClr val="212121"/>
+                </a:solidFill>
+                <a:latin typeface="Courier New"/>
+              </a:rPr>
+              <a:t>    y = x + 1</a:t>
+            </a:r>
+          </a:p>
+          <a:p>
+            <a:pPr>
+              <a:spcAft>
+                <a:spcPts val="0"/>
+              </a:spcAft>
+            </a:pPr>
+            <a:r>
+              <a:rPr sz="1800">
+                <a:solidFill>
+                  <a:srgbClr val="212121"/>
+                </a:solidFill>
+                <a:latin typeface="Courier New"/>
+              </a:rPr>
+              <a:t>    z = y * 2</a:t>
+            </a:r>
+          </a:p>
+          <a:p>
+            <a:pPr>
+              <a:spcAft>
+                <a:spcPts val="0"/>
+              </a:spcAft>
+            </a:pPr>
+            <a:r>
+              <a:rPr sz="1800">
+                <a:solidFill>
+                  <a:srgbClr val="212121"/>
+                </a:solidFill>
+                <a:latin typeface="Courier New"/>
+              </a:rPr>
+              <a:t>    assert z &gt;= 2        # ESBMC negates this for you</a:t>
+            </a:r>
+          </a:p>
+          <a:p>
+            <a:pPr>
+              <a:spcAft>
+                <a:spcPts val="0"/>
+              </a:spcAft>
+            </a:pPr>
+            <a:r>
+              <a:rPr sz="1800">
+                <a:solidFill>
+                  <a:srgbClr val="212121"/>
+                </a:solidFill>
+                <a:latin typeface="Courier New"/>
+              </a:rPr>
+              <a:t>x: int = nondet_int()    # every int at once, like BitVec("x")</a:t>
+            </a:r>
+          </a:p>
+          <a:p>
+            <a:pPr>
+              <a:spcAft>
+                <a:spcPts val="0"/>
+              </a:spcAft>
+            </a:pPr>
+            <a:r>
+              <a:rPr sz="1800">
+                <a:solidFill>
+                  <a:srgbClr val="212121"/>
+                </a:solidFill>
+                <a:latin typeface="Courier New"/>
+              </a:rPr>
+              <a:t>f(x)</a:t>
+            </a:r>
+          </a:p>
+          <a:p>
+            <a:pPr>
+              <a:spcAft>
+                <a:spcPts val="800"/>
+              </a:spcAft>
+            </a:pPr>
+            <a:r>
+              <a:rPr sz="2200">
+                <a:solidFill>
+                  <a:srgbClr val="212121"/>
+                </a:solidFill>
+              </a:rPr>
+              <a:t/>
+            </a:r>
+          </a:p>
+          <a:p>
+            <a:pPr>
+              <a:spcAft>
+                <a:spcPts val="0"/>
+              </a:spcAft>
+            </a:pPr>
+            <a:r>
+              <a:rPr sz="1800">
+                <a:solidFill>
+                  <a:srgbClr val="212121"/>
+                </a:solidFill>
+                <a:latin typeface="Courier New"/>
+              </a:rPr>
+              <a:t>esbmc stage3_esbmc.py  →  VERIFICATION FAILED   (x = 2^63 - 1)</a:t>
+            </a:r>
+          </a:p>
+          <a:p>
+            <a:pPr lvl="1">
+              <a:spcAft>
+                <a:spcPts val="800"/>
+              </a:spcAft>
+            </a:pPr>
+            <a:r>
+              <a:rPr sz="2000">
+                <a:solidFill>
+                  <a:srgbClr val="212121"/>
+                </a:solidFill>
+              </a:rPr>
+              <a:t>You wrote the function; ESBMC wrote AND solved the formula.</a:t>
+            </a:r>
+          </a:p>
+          <a:p>
+            <a:pPr lvl="1">
+              <a:spcAft>
+                <a:spcPts val="800"/>
+              </a:spcAft>
+            </a:pPr>
+            <a:r>
+              <a:rPr sz="2000">
+                <a:solidFill>
+                  <a:srgbClr val="212121"/>
+                </a:solidFill>
+              </a:rPr>
+              <a:t>Z3 is the SMT engine; ESBMC is a model checker built ON it — it calls Z3 underneath.</a:t>
+            </a:r>
+          </a:p>
+          <a:p>
+            <a:pPr lvl="1">
+              <a:spcAft>
+                <a:spcPts val="800"/>
+              </a:spcAft>
+            </a:pPr>
+            <a:r>
+              <a:rPr sz="2000">
+                <a:solidFill>
+                  <a:srgbClr val="212121"/>
+                </a:solidFill>
+              </a:rPr>
+              <a:t>Same bug, different number: 2^30 (your 32-bit BitVec) vs 2^63 — ESBMC models a Python int as 64-bit.</a:t>
+            </a:r>
+          </a:p>
+        </p:txBody>
+      </p:sp>
+    </p:spTree>
+  </p:cSld>
+  <p:clrMapOvr>
+    <a:masterClrMapping/>
+  </p:clrMapOvr>
+</p:sld>
+</file>
+
+<file path=ppt/slides/slide11.xml><?xml version="1.0" encoding="utf-8"?>
+<p:sld xmlns:a="http://schemas.openxmlformats.org/drawingml/2006/main" xmlns:p="http://schemas.openxmlformats.org/presentationml/2006/main" xmlns:r="http://schemas.openxmlformats.org/officeDocument/2006/relationships">
+  <p:cSld>
+    <p:spTree>
+      <p:nvGrpSpPr>
+        <p:cNvPr id="1" name=""/>
+        <p:cNvGrpSpPr/>
+        <p:nvPr/>
+      </p:nvGrpSpPr>
+      <p:grpSpPr/>
+      <p:sp>
+        <p:nvSpPr>
+          <p:cNvPr id="2" name="TextBox 1"/>
+          <p:cNvSpPr txBox="1"/>
+          <p:nvPr/>
+        </p:nvSpPr>
+        <p:spPr>
+          <a:xfrm>
+            <a:off x="548640" y="365760"/>
+            <a:ext cx="11064240" cy="1005840"/>
+          </a:xfrm>
+          <a:prstGeom prst="rect">
+            <a:avLst/>
+          </a:prstGeom>
+          <a:noFill/>
+        </p:spPr>
+        <p:txBody>
+          <a:bodyPr wrap="square">
+            <a:spAutoFit/>
+          </a:bodyPr>
+          <a:lstStyle/>
+          <a:p>
+            <a:r>
+              <a:rPr sz="3600" b="1">
+                <a:solidFill>
+                  <a:srgbClr val="5A0A7A"/>
+                </a:solidFill>
+              </a:rPr>
               <a:t>Checkpoint before Lab 2</a:t>
             </a:r>
           </a:p>
@@ -3351,7 +3598,7 @@
 </p:sld>
 </file>
 
-<file path=ppt/slides/slide11.xml><?xml version="1.0" encoding="utf-8"?>
+<file path=ppt/slides/slide12.xml><?xml version="1.0" encoding="utf-8"?>
 <p:sld xmlns:a="http://schemas.openxmlformats.org/drawingml/2006/main" xmlns:p="http://schemas.openxmlformats.org/presentationml/2006/main" xmlns:r="http://schemas.openxmlformats.org/officeDocument/2006/relationships">
   <p:cSld>
     <p:spTree>
@@ -3741,7 +3988,7 @@
 </p:sld>
 </file>
 
-<file path=ppt/slides/slide12.xml><?xml version="1.0" encoding="utf-8"?>
+<file path=ppt/slides/slide13.xml><?xml version="1.0" encoding="utf-8"?>
 <p:sld xmlns:a="http://schemas.openxmlformats.org/drawingml/2006/main" xmlns:p="http://schemas.openxmlformats.org/presentationml/2006/main" xmlns:r="http://schemas.openxmlformats.org/officeDocument/2006/relationships">
   <p:cSld>
     <p:spTree>
@@ -3960,236 +4207,6 @@
                 </a:solidFill>
               </a:rPr>
               <a:t>Read bottom-up: what was violated, then scroll up for which values caused it.</a:t>
-            </a:r>
-          </a:p>
-        </p:txBody>
-      </p:sp>
-    </p:spTree>
-  </p:cSld>
-  <p:clrMapOvr>
-    <a:masterClrMapping/>
-  </p:clrMapOvr>
-</p:sld>
-</file>
-
-<file path=ppt/slides/slide13.xml><?xml version="1.0" encoding="utf-8"?>
-<p:sld xmlns:a="http://schemas.openxmlformats.org/drawingml/2006/main" xmlns:p="http://schemas.openxmlformats.org/presentationml/2006/main" xmlns:r="http://schemas.openxmlformats.org/officeDocument/2006/relationships">
-  <p:cSld>
-    <p:spTree>
-      <p:nvGrpSpPr>
-        <p:cNvPr id="1" name=""/>
-        <p:cNvGrpSpPr/>
-        <p:nvPr/>
-      </p:nvGrpSpPr>
-      <p:grpSpPr/>
-      <p:sp>
-        <p:nvSpPr>
-          <p:cNvPr id="2" name="TextBox 1"/>
-          <p:cNvSpPr txBox="1"/>
-          <p:nvPr/>
-        </p:nvSpPr>
-        <p:spPr>
-          <a:xfrm>
-            <a:off x="548640" y="365760"/>
-            <a:ext cx="11064240" cy="1005840"/>
-          </a:xfrm>
-          <a:prstGeom prst="rect">
-            <a:avLst/>
-          </a:prstGeom>
-          <a:noFill/>
-        </p:spPr>
-        <p:txBody>
-          <a:bodyPr wrap="square">
-            <a:spAutoFit/>
-          </a:bodyPr>
-          <a:lstStyle/>
-          <a:p>
-            <a:r>
-              <a:rPr sz="3600" b="1">
-                <a:solidFill>
-                  <a:srgbClr val="5A0A7A"/>
-                </a:solidFill>
-              </a:rPr>
-              <a:t>Deep dive: overflow.c — the trace</a:t>
-            </a:r>
-          </a:p>
-        </p:txBody>
-      </p:sp>
-      <p:sp>
-        <p:nvSpPr>
-          <p:cNvPr id="3" name="TextBox 2"/>
-          <p:cNvSpPr txBox="1"/>
-          <p:nvPr/>
-        </p:nvSpPr>
-        <p:spPr>
-          <a:xfrm>
-            <a:off x="731520" y="1463040"/>
-            <a:ext cx="10789920" cy="5120640"/>
-          </a:xfrm>
-          <a:prstGeom prst="rect">
-            <a:avLst/>
-          </a:prstGeom>
-          <a:noFill/>
-        </p:spPr>
-        <p:txBody>
-          <a:bodyPr wrap="square">
-            <a:spAutoFit/>
-          </a:bodyPr>
-          <a:lstStyle/>
-          <a:p>
-            <a:pPr>
-              <a:spcAft>
-                <a:spcPts val="0"/>
-              </a:spcAft>
-            </a:pPr>
-            <a:r>
-              <a:rPr sz="1800">
-                <a:solidFill>
-                  <a:srgbClr val="212121"/>
-                </a:solidFill>
-                <a:latin typeface="Courier New"/>
-              </a:rPr>
-              <a:t>State 1 ...  a = { 0, -1 }   ← stack garbage in the array</a:t>
-            </a:r>
-          </a:p>
-          <a:p>
-            <a:pPr>
-              <a:spcAft>
-                <a:spcPts val="0"/>
-              </a:spcAft>
-            </a:pPr>
-            <a:r>
-              <a:rPr sz="1800">
-                <a:solidFill>
-                  <a:srgbClr val="212121"/>
-                </a:solidFill>
-                <a:latin typeface="Courier New"/>
-              </a:rPr>
-              <a:t>State 2 ...  i = -1          ← the index the solver chose</a:t>
-            </a:r>
-          </a:p>
-          <a:p>
-            <a:pPr>
-              <a:spcAft>
-                <a:spcPts val="0"/>
-              </a:spcAft>
-            </a:pPr>
-            <a:r>
-              <a:rPr sz="1800">
-                <a:solidFill>
-                  <a:srgbClr val="212121"/>
-                </a:solidFill>
-                <a:latin typeface="Courier New"/>
-              </a:rPr>
-              <a:t>State 3 ...  x = -1          ← the branch the solver chose</a:t>
-            </a:r>
-          </a:p>
-          <a:p>
-            <a:pPr>
-              <a:spcAft>
-                <a:spcPts val="0"/>
-              </a:spcAft>
-            </a:pPr>
-            <a:r>
-              <a:rPr sz="1800">
-                <a:solidFill>
-                  <a:srgbClr val="212121"/>
-                </a:solidFill>
-                <a:latin typeface="Courier New"/>
-              </a:rPr>
-              <a:t>Violated property:</a:t>
-            </a:r>
-          </a:p>
-          <a:p>
-            <a:pPr>
-              <a:spcAft>
-                <a:spcPts val="0"/>
-              </a:spcAft>
-            </a:pPr>
-            <a:r>
-              <a:rPr sz="1800">
-                <a:solidFill>
-                  <a:srgbClr val="212121"/>
-                </a:solidFill>
-                <a:latin typeface="Courier New"/>
-              </a:rPr>
-              <a:t>  file overflow.c line 24 ... assertion main</a:t>
-            </a:r>
-          </a:p>
-          <a:p>
-            <a:pPr>
-              <a:spcAft>
-                <a:spcPts val="0"/>
-              </a:spcAft>
-            </a:pPr>
-            <a:r>
-              <a:rPr sz="1800">
-                <a:solidFill>
-                  <a:srgbClr val="212121"/>
-                </a:solidFill>
-                <a:latin typeface="Courier New"/>
-              </a:rPr>
-              <a:t>  !((_Bool)((signed long int)(!(p[1] == 1))))</a:t>
-            </a:r>
-          </a:p>
-          <a:p>
-            <a:pPr>
-              <a:spcAft>
-                <a:spcPts val="800"/>
-              </a:spcAft>
-            </a:pPr>
-            <a:r>
-              <a:rPr sz="2200">
-                <a:solidFill>
-                  <a:srgbClr val="212121"/>
-                </a:solidFill>
-              </a:rPr>
-              <a:t/>
-            </a:r>
-          </a:p>
-          <a:p>
-            <a:pPr lvl="1">
-              <a:spcAft>
-                <a:spcPts val="800"/>
-              </a:spcAft>
-            </a:pPr>
-            <a:r>
-              <a:rPr sz="2000">
-                <a:solidFill>
-                  <a:srgbClr val="212121"/>
-                </a:solidFill>
-              </a:rPr>
-              <a:t>x = -1 takes the else branch; a[i + 1] with i = -1 writes a[0].</a:t>
-            </a:r>
-          </a:p>
-          <a:p>
-            <a:pPr lvl="1">
-              <a:spcAft>
-                <a:spcPts val="800"/>
-              </a:spcAft>
-            </a:pPr>
-            <a:r>
-              <a:rPr sz="2000">
-                <a:solidFill>
-                  <a:srgbClr val="212121"/>
-                </a:solidFill>
-              </a:rPr>
-              <a:t>So a[1] keeps its garbage (-1) and assert(*(p + 1) == 1) dies.</a:t>
-            </a:r>
-          </a:p>
-          <a:p>
-            <a:pPr>
-              <a:spcAft>
-                <a:spcPts val="800"/>
-              </a:spcAft>
-            </a:pPr>
-            <a:r>
-              <a:rPr sz="2200">
-                <a:solidFill>
-                  <a:srgbClr val="212121"/>
-                </a:solidFill>
-              </a:rPr>
-              <a:t>i = -1, x = -1 is a ready-made failing test case — keep it.</a:t>
             </a:r>
           </a:p>
         </p:txBody>
@@ -4240,7 +4257,7 @@
                   <a:srgbClr val="5A0A7A"/>
                 </a:solidFill>
               </a:rPr>
-              <a:t>Deep dive: what broke, and its CWE</a:t>
+              <a:t>Deep dive: overflow.c — the trace</a:t>
             </a:r>
           </a:p>
         </p:txBody>
@@ -4269,6 +4286,102 @@
           <a:p>
             <a:pPr>
               <a:spcAft>
+                <a:spcPts val="0"/>
+              </a:spcAft>
+            </a:pPr>
+            <a:r>
+              <a:rPr sz="1800">
+                <a:solidFill>
+                  <a:srgbClr val="212121"/>
+                </a:solidFill>
+                <a:latin typeface="Courier New"/>
+              </a:rPr>
+              <a:t>State 1 ...  a = { 0, -1 }   ← stack garbage in the array</a:t>
+            </a:r>
+          </a:p>
+          <a:p>
+            <a:pPr>
+              <a:spcAft>
+                <a:spcPts val="0"/>
+              </a:spcAft>
+            </a:pPr>
+            <a:r>
+              <a:rPr sz="1800">
+                <a:solidFill>
+                  <a:srgbClr val="212121"/>
+                </a:solidFill>
+                <a:latin typeface="Courier New"/>
+              </a:rPr>
+              <a:t>State 2 ...  i = -1          ← the index the solver chose</a:t>
+            </a:r>
+          </a:p>
+          <a:p>
+            <a:pPr>
+              <a:spcAft>
+                <a:spcPts val="0"/>
+              </a:spcAft>
+            </a:pPr>
+            <a:r>
+              <a:rPr sz="1800">
+                <a:solidFill>
+                  <a:srgbClr val="212121"/>
+                </a:solidFill>
+                <a:latin typeface="Courier New"/>
+              </a:rPr>
+              <a:t>State 3 ...  x = -1          ← the branch the solver chose</a:t>
+            </a:r>
+          </a:p>
+          <a:p>
+            <a:pPr>
+              <a:spcAft>
+                <a:spcPts val="0"/>
+              </a:spcAft>
+            </a:pPr>
+            <a:r>
+              <a:rPr sz="1800">
+                <a:solidFill>
+                  <a:srgbClr val="212121"/>
+                </a:solidFill>
+                <a:latin typeface="Courier New"/>
+              </a:rPr>
+              <a:t>Violated property:</a:t>
+            </a:r>
+          </a:p>
+          <a:p>
+            <a:pPr>
+              <a:spcAft>
+                <a:spcPts val="0"/>
+              </a:spcAft>
+            </a:pPr>
+            <a:r>
+              <a:rPr sz="1800">
+                <a:solidFill>
+                  <a:srgbClr val="212121"/>
+                </a:solidFill>
+                <a:latin typeface="Courier New"/>
+              </a:rPr>
+              <a:t>  file overflow.c line 24 ... assertion main</a:t>
+            </a:r>
+          </a:p>
+          <a:p>
+            <a:pPr>
+              <a:spcAft>
+                <a:spcPts val="0"/>
+              </a:spcAft>
+            </a:pPr>
+            <a:r>
+              <a:rPr sz="1800">
+                <a:solidFill>
+                  <a:srgbClr val="212121"/>
+                </a:solidFill>
+                <a:latin typeface="Courier New"/>
+              </a:rPr>
+              <a:t>  !((_Bool)((signed long int)(!(p[1] == 1))))</a:t>
+            </a:r>
+          </a:p>
+          <a:p>
+            <a:pPr>
+              <a:spcAft>
                 <a:spcPts val="800"/>
               </a:spcAft>
             </a:pPr>
@@ -4278,7 +4391,7 @@
                   <a:srgbClr val="212121"/>
                 </a:solidFill>
               </a:rPr>
-              <a:t>Two shapes of violated property:</a:t>
+              <a:t/>
             </a:r>
           </a:p>
           <a:p>
@@ -4293,28 +4406,12 @@
                   <a:srgbClr val="212121"/>
                 </a:solidFill>
               </a:rPr>
-              <a:t>an assertion — names YOUR line:</a:t>
+              <a:t>x = -1 takes the else branch; a[i + 1] with i = -1 writes a[0].</a:t>
             </a:r>
           </a:p>
           <a:p>
             <a:pPr lvl="1">
               <a:spcAft>
-                <a:spcPts val="0"/>
-              </a:spcAft>
-            </a:pPr>
-            <a:r>
-              <a:rPr sz="1800">
-                <a:solidFill>
-                  <a:srgbClr val="212121"/>
-                </a:solidFill>
-                <a:latin typeface="Courier New"/>
-              </a:rPr>
-              <a:t>  overflow.c line 24 ... assertion main</a:t>
-            </a:r>
-          </a:p>
-          <a:p>
-            <a:pPr lvl="1">
-              <a:spcAft>
                 <a:spcPts val="800"/>
               </a:spcAft>
             </a:pPr>
@@ -4324,54 +4421,7 @@
                   <a:srgbClr val="212121"/>
                 </a:solidFill>
               </a:rPr>
-              <a:t>a built-in check — names the bug kind plus its CWE classes:</a:t>
-            </a:r>
-          </a:p>
-          <a:p>
-            <a:pPr lvl="1">
-              <a:spcAft>
-                <a:spcPts val="0"/>
-              </a:spcAft>
-            </a:pPr>
-            <a:r>
-              <a:rPr sz="1800">
-                <a:solidFill>
-                  <a:srgbClr val="212121"/>
-                </a:solidFill>
-                <a:latin typeface="Courier New"/>
-              </a:rPr>
-              <a:t>  dereference failure: array bounds violated</a:t>
-            </a:r>
-          </a:p>
-          <a:p>
-            <a:pPr lvl="1">
-              <a:spcAft>
-                <a:spcPts val="0"/>
-              </a:spcAft>
-            </a:pPr>
-            <a:r>
-              <a:rPr sz="1800">
-                <a:solidFill>
-                  <a:srgbClr val="212121"/>
-                </a:solidFill>
-                <a:latin typeface="Courier New"/>
-              </a:rPr>
-              <a:t>  CWE: CWE-121, CWE-125, CWE-129, CWE-131, CWE-193, CWE-787</a:t>
-            </a:r>
-          </a:p>
-          <a:p>
-            <a:pPr lvl="2">
-              <a:spcAft>
-                <a:spcPts val="800"/>
-              </a:spcAft>
-            </a:pPr>
-            <a:r>
-              <a:rPr sz="1800">
-                <a:solidFill>
-                  <a:srgbClr val="212121"/>
-                </a:solidFill>
-              </a:rPr>
-              <a:t>  (stack overflow · OOB read · bad index · size miscalc · off-by-one · OOB write)</a:t>
+              <a:t>So a[1] keeps its garbage (-1) and assert(*(p + 1) == 1) dies.</a:t>
             </a:r>
           </a:p>
           <a:p>
@@ -4386,37 +4436,7 @@
                   <a:srgbClr val="212121"/>
                 </a:solidFill>
               </a:rPr>
-              <a:t/>
-            </a:r>
-          </a:p>
-          <a:p>
-            <a:pPr>
-              <a:spcAft>
-                <a:spcPts val="800"/>
-              </a:spcAft>
-            </a:pPr>
-            <a:r>
-              <a:rPr sz="2200">
-                <a:solidFill>
-                  <a:srgbClr val="212121"/>
-                </a:solidFill>
-              </a:rPr>
-              <a:t>The path may point inside ESBMC's model of the C library (io.c line 91 = the gets model).</a:t>
-            </a:r>
-          </a:p>
-          <a:p>
-            <a:pPr lvl="1">
-              <a:spcAft>
-                <a:spcPts val="800"/>
-              </a:spcAft>
-            </a:pPr>
-            <a:r>
-              <a:rPr sz="2000">
-                <a:solidFill>
-                  <a:srgbClr val="212121"/>
-                </a:solidFill>
-              </a:rPr>
-              <a:t>That names the API you misused — it is not a bug in ESBMC.</a:t>
+              <a:t>i = -1, x = -1 is a ready-made failing test case — keep it.</a:t>
             </a:r>
           </a:p>
         </p:txBody>
@@ -4447,7 +4467,7 @@
         </p:nvSpPr>
         <p:spPr>
           <a:xfrm>
-            <a:off x="548640" y="2377440"/>
+            <a:off x="548640" y="365760"/>
             <a:ext cx="11064240" cy="1005840"/>
           </a:xfrm>
           <a:prstGeom prst="rect">
@@ -4462,12 +4482,188 @@
           <a:lstStyle/>
           <a:p>
             <a:r>
-              <a:rPr sz="4400" b="1">
+              <a:rPr sz="3600" b="1">
                 <a:solidFill>
                   <a:srgbClr val="5A0A7A"/>
                 </a:solidFill>
               </a:rPr>
-              <a:t>Break — back at 19:40</a:t>
+              <a:t>Deep dive: what broke, and its CWE</a:t>
+            </a:r>
+          </a:p>
+        </p:txBody>
+      </p:sp>
+      <p:sp>
+        <p:nvSpPr>
+          <p:cNvPr id="3" name="TextBox 2"/>
+          <p:cNvSpPr txBox="1"/>
+          <p:nvPr/>
+        </p:nvSpPr>
+        <p:spPr>
+          <a:xfrm>
+            <a:off x="731520" y="1463040"/>
+            <a:ext cx="10789920" cy="5120640"/>
+          </a:xfrm>
+          <a:prstGeom prst="rect">
+            <a:avLst/>
+          </a:prstGeom>
+          <a:noFill/>
+        </p:spPr>
+        <p:txBody>
+          <a:bodyPr wrap="square">
+            <a:spAutoFit/>
+          </a:bodyPr>
+          <a:lstStyle/>
+          <a:p>
+            <a:pPr>
+              <a:spcAft>
+                <a:spcPts val="800"/>
+              </a:spcAft>
+            </a:pPr>
+            <a:r>
+              <a:rPr sz="2200">
+                <a:solidFill>
+                  <a:srgbClr val="212121"/>
+                </a:solidFill>
+              </a:rPr>
+              <a:t>Two shapes of violated property:</a:t>
+            </a:r>
+          </a:p>
+          <a:p>
+            <a:pPr lvl="1">
+              <a:spcAft>
+                <a:spcPts val="800"/>
+              </a:spcAft>
+            </a:pPr>
+            <a:r>
+              <a:rPr sz="2000">
+                <a:solidFill>
+                  <a:srgbClr val="212121"/>
+                </a:solidFill>
+              </a:rPr>
+              <a:t>an assertion — names YOUR line:</a:t>
+            </a:r>
+          </a:p>
+          <a:p>
+            <a:pPr lvl="1">
+              <a:spcAft>
+                <a:spcPts val="0"/>
+              </a:spcAft>
+            </a:pPr>
+            <a:r>
+              <a:rPr sz="1800">
+                <a:solidFill>
+                  <a:srgbClr val="212121"/>
+                </a:solidFill>
+                <a:latin typeface="Courier New"/>
+              </a:rPr>
+              <a:t>  overflow.c line 24 ... assertion main</a:t>
+            </a:r>
+          </a:p>
+          <a:p>
+            <a:pPr lvl="1">
+              <a:spcAft>
+                <a:spcPts val="800"/>
+              </a:spcAft>
+            </a:pPr>
+            <a:r>
+              <a:rPr sz="2000">
+                <a:solidFill>
+                  <a:srgbClr val="212121"/>
+                </a:solidFill>
+              </a:rPr>
+              <a:t>a built-in check — names the bug kind plus its CWE classes:</a:t>
+            </a:r>
+          </a:p>
+          <a:p>
+            <a:pPr lvl="1">
+              <a:spcAft>
+                <a:spcPts val="0"/>
+              </a:spcAft>
+            </a:pPr>
+            <a:r>
+              <a:rPr sz="1800">
+                <a:solidFill>
+                  <a:srgbClr val="212121"/>
+                </a:solidFill>
+                <a:latin typeface="Courier New"/>
+              </a:rPr>
+              <a:t>  dereference failure: array bounds violated</a:t>
+            </a:r>
+          </a:p>
+          <a:p>
+            <a:pPr lvl="1">
+              <a:spcAft>
+                <a:spcPts val="0"/>
+              </a:spcAft>
+            </a:pPr>
+            <a:r>
+              <a:rPr sz="1800">
+                <a:solidFill>
+                  <a:srgbClr val="212121"/>
+                </a:solidFill>
+                <a:latin typeface="Courier New"/>
+              </a:rPr>
+              <a:t>  CWE: CWE-121, CWE-125, CWE-129, CWE-131, CWE-193, CWE-787</a:t>
+            </a:r>
+          </a:p>
+          <a:p>
+            <a:pPr lvl="2">
+              <a:spcAft>
+                <a:spcPts val="800"/>
+              </a:spcAft>
+            </a:pPr>
+            <a:r>
+              <a:rPr sz="1800">
+                <a:solidFill>
+                  <a:srgbClr val="212121"/>
+                </a:solidFill>
+              </a:rPr>
+              <a:t>  (stack overflow · OOB read · bad index · size miscalc · off-by-one · OOB write)</a:t>
+            </a:r>
+          </a:p>
+          <a:p>
+            <a:pPr>
+              <a:spcAft>
+                <a:spcPts val="800"/>
+              </a:spcAft>
+            </a:pPr>
+            <a:r>
+              <a:rPr sz="2200">
+                <a:solidFill>
+                  <a:srgbClr val="212121"/>
+                </a:solidFill>
+              </a:rPr>
+              <a:t/>
+            </a:r>
+          </a:p>
+          <a:p>
+            <a:pPr>
+              <a:spcAft>
+                <a:spcPts val="800"/>
+              </a:spcAft>
+            </a:pPr>
+            <a:r>
+              <a:rPr sz="2200">
+                <a:solidFill>
+                  <a:srgbClr val="212121"/>
+                </a:solidFill>
+              </a:rPr>
+              <a:t>The path may point inside ESBMC's model of the C library (io.c line 91 = the gets model).</a:t>
+            </a:r>
+          </a:p>
+          <a:p>
+            <a:pPr lvl="1">
+              <a:spcAft>
+                <a:spcPts val="800"/>
+              </a:spcAft>
+            </a:pPr>
+            <a:r>
+              <a:rPr sz="2000">
+                <a:solidFill>
+                  <a:srgbClr val="212121"/>
+                </a:solidFill>
+              </a:rPr>
+              <a:t>That names the API you misused — it is not a bug in ESBMC.</a:t>
             </a:r>
           </a:p>
         </p:txBody>
@@ -4498,7 +4694,7 @@
         </p:nvSpPr>
         <p:spPr>
           <a:xfrm>
-            <a:off x="548640" y="365760"/>
+            <a:off x="548640" y="2377440"/>
             <a:ext cx="11064240" cy="1005840"/>
           </a:xfrm>
           <a:prstGeom prst="rect">
@@ -4513,110 +4709,12 @@
           <a:lstStyle/>
           <a:p>
             <a:r>
-              <a:rPr sz="3600" b="1">
+              <a:rPr sz="4400" b="1">
                 <a:solidFill>
                   <a:srgbClr val="5A0A7A"/>
                 </a:solidFill>
               </a:rPr>
-              <a:t>Lab 3 — Specifications (35 min)</a:t>
-            </a:r>
-          </a:p>
-        </p:txBody>
-      </p:sp>
-      <p:sp>
-        <p:nvSpPr>
-          <p:cNvPr id="3" name="TextBox 2"/>
-          <p:cNvSpPr txBox="1"/>
-          <p:nvPr/>
-        </p:nvSpPr>
-        <p:spPr>
-          <a:xfrm>
-            <a:off x="731520" y="1828800"/>
-            <a:ext cx="10789920" cy="4754880"/>
-          </a:xfrm>
-          <a:prstGeom prst="rect">
-            <a:avLst/>
-          </a:prstGeom>
-          <a:noFill/>
-        </p:spPr>
-        <p:txBody>
-          <a:bodyPr wrap="square">
-            <a:spAutoFit/>
-          </a:bodyPr>
-          <a:lstStyle/>
-          <a:p>
-            <a:pPr>
-              <a:spcAft>
-                <a:spcPts val="800"/>
-              </a:spcAft>
-            </a:pPr>
-            <a:r>
-              <a:rPr sz="2800">
-                <a:solidFill>
-                  <a:srgbClr val="212121"/>
-                </a:solidFill>
-              </a:rPr>
-              <a:t>triangle.c verifies SUCCESSFUL as shipped.</a:t>
-            </a:r>
-          </a:p>
-          <a:p>
-            <a:pPr>
-              <a:spcAft>
-                <a:spcPts val="800"/>
-              </a:spcAft>
-            </a:pPr>
-            <a:r>
-              <a:rPr sz="2800">
-                <a:solidFill>
-                  <a:srgbClr val="212121"/>
-                </a:solidFill>
-              </a:rPr>
-              <a:t>Does that mean it's correct?</a:t>
-            </a:r>
-          </a:p>
-          <a:p>
-            <a:pPr>
-              <a:spcAft>
-                <a:spcPts val="800"/>
-              </a:spcAft>
-            </a:pPr>
-            <a:r>
-              <a:rPr sz="2800">
-                <a:solidFill>
-                  <a:srgbClr val="212121"/>
-                </a:solidFill>
-              </a:rPr>
-              <a:t>Write the two TODO properties and find out.</a:t>
-            </a:r>
-          </a:p>
-          <a:p>
-            <a:pPr>
-              <a:spcAft>
-                <a:spcPts val="800"/>
-              </a:spcAft>
-            </a:pPr>
-            <a:r>
-              <a:rPr sz="2800">
-                <a:solidFill>
-                  <a:srgbClr val="212121"/>
-                </a:solidFill>
-              </a:rPr>
-              <a:t/>
-            </a:r>
-          </a:p>
-          <a:p>
-            <a:pPr>
-              <a:spcAft>
-                <a:spcPts val="800"/>
-              </a:spcAft>
-            </a:pPr>
-            <a:r>
-              <a:rPr sz="2800">
-                <a:solidFill>
-                  <a:srgbClr val="212121"/>
-                </a:solidFill>
-              </a:rPr>
-              <a:t>The tool checks what you specify — with a weak spec, green is cheap.</a:t>
+              <a:t>Break — back at 19:40</a:t>
             </a:r>
           </a:p>
         </p:txBody>
@@ -4667,7 +4765,7 @@
                   <a:srgbClr val="5A0A7A"/>
                 </a:solidFill>
               </a:rPr>
-              <a:t>Your specification toolkit</a:t>
+              <a:t>Lab 3 — Specifications (35 min)</a:t>
             </a:r>
           </a:p>
         </p:txBody>
@@ -4680,8 +4778,8 @@
         </p:nvSpPr>
         <p:spPr>
           <a:xfrm>
-            <a:off x="731520" y="1463040"/>
-            <a:ext cx="10789920" cy="5120640"/>
+            <a:off x="731520" y="1828800"/>
+            <a:ext cx="10789920" cy="4754880"/>
           </a:xfrm>
           <a:prstGeom prst="rect">
             <a:avLst/>
@@ -4696,47 +4794,59 @@
           <a:p>
             <a:pPr>
               <a:spcAft>
-                <a:spcPts val="0"/>
-              </a:spcAft>
-            </a:pPr>
-            <a:r>
-              <a:rPr sz="1800">
-                <a:solidFill>
-                  <a:srgbClr val="212121"/>
-                </a:solidFill>
-                <a:latin typeface="Courier New"/>
-              </a:rPr>
-              <a:t>int nondet_int(void);              /* any possible int */</a:t>
-            </a:r>
-          </a:p>
-          <a:p>
-            <a:pPr>
-              <a:spcAft>
-                <a:spcPts val="0"/>
-              </a:spcAft>
-            </a:pPr>
-            <a:r>
-              <a:rPr sz="1800">
-                <a:solidFill>
-                  <a:srgbClr val="212121"/>
-                </a:solidFill>
-                <a:latin typeface="Courier New"/>
-              </a:rPr>
-              <a:t>void __ESBMC_assume(_Bool);</a:t>
-            </a:r>
-          </a:p>
-          <a:p>
-            <a:pPr>
-              <a:spcAft>
-                <a:spcPts val="0"/>
-              </a:spcAft>
-            </a:pPr>
-            <a:r>
-              <a:rPr sz="1800">
-                <a:solidFill>
-                  <a:srgbClr val="212121"/>
-                </a:solidFill>
-                <a:latin typeface="Courier New"/>
+                <a:spcPts val="800"/>
+              </a:spcAft>
+            </a:pPr>
+            <a:r>
+              <a:rPr sz="2800">
+                <a:solidFill>
+                  <a:srgbClr val="212121"/>
+                </a:solidFill>
+              </a:rPr>
+              <a:t>triangle.c verifies SUCCESSFUL as shipped.</a:t>
+            </a:r>
+          </a:p>
+          <a:p>
+            <a:pPr>
+              <a:spcAft>
+                <a:spcPts val="800"/>
+              </a:spcAft>
+            </a:pPr>
+            <a:r>
+              <a:rPr sz="2800">
+                <a:solidFill>
+                  <a:srgbClr val="212121"/>
+                </a:solidFill>
+              </a:rPr>
+              <a:t>Does that mean it's correct?</a:t>
+            </a:r>
+          </a:p>
+          <a:p>
+            <a:pPr>
+              <a:spcAft>
+                <a:spcPts val="800"/>
+              </a:spcAft>
+            </a:pPr>
+            <a:r>
+              <a:rPr sz="2800">
+                <a:solidFill>
+                  <a:srgbClr val="212121"/>
+                </a:solidFill>
+              </a:rPr>
+              <a:t>Write the two TODO properties and find out.</a:t>
+            </a:r>
+          </a:p>
+          <a:p>
+            <a:pPr>
+              <a:spcAft>
+                <a:spcPts val="800"/>
+              </a:spcAft>
+            </a:pPr>
+            <a:r>
+              <a:rPr sz="2800">
+                <a:solidFill>
+                  <a:srgbClr val="212121"/>
+                </a:solidFill>
               </a:rPr>
               <a:t/>
             </a:r>
@@ -4744,79 +4854,16 @@
           <a:p>
             <a:pPr>
               <a:spcAft>
-                <a:spcPts val="0"/>
-              </a:spcAft>
-            </a:pPr>
-            <a:r>
-              <a:rPr sz="1800">
-                <a:solidFill>
-                  <a:srgbClr val="212121"/>
-                </a:solidFill>
-                <a:latin typeface="Courier New"/>
-              </a:rPr>
-              <a:t>int x = nondet_int();              /* every value at once */</a:t>
-            </a:r>
-          </a:p>
-          <a:p>
-            <a:pPr>
-              <a:spcAft>
-                <a:spcPts val="0"/>
-              </a:spcAft>
-            </a:pPr>
-            <a:r>
-              <a:rPr sz="1800">
-                <a:solidFill>
-                  <a:srgbClr val="212121"/>
-                </a:solidFill>
-                <a:latin typeface="Courier New"/>
-              </a:rPr>
-              <a:t>__ESBMC_assume(x &gt; 0 &amp;&amp; x &lt; 100);  /* now: every value in 1..99 */</a:t>
-            </a:r>
-          </a:p>
-          <a:p>
-            <a:pPr>
-              <a:spcAft>
-                <a:spcPts val="0"/>
-              </a:spcAft>
-            </a:pPr>
-            <a:r>
-              <a:rPr sz="1800">
-                <a:solidFill>
-                  <a:srgbClr val="212121"/>
-                </a:solidFill>
-                <a:latin typeface="Courier New"/>
-              </a:rPr>
-              <a:t>assert(property(x));               /* must hold for ALL of them */</a:t>
-            </a:r>
-          </a:p>
-          <a:p>
-            <a:pPr>
-              <a:spcAft>
-                <a:spcPts val="800"/>
-              </a:spcAft>
-            </a:pPr>
-            <a:r>
-              <a:rPr sz="2200">
-                <a:solidFill>
-                  <a:srgbClr val="212121"/>
-                </a:solidFill>
-              </a:rPr>
-              <a:t/>
-            </a:r>
-          </a:p>
-          <a:p>
-            <a:pPr>
-              <a:spcAft>
-                <a:spcPts val="800"/>
-              </a:spcAft>
-            </a:pPr>
-            <a:r>
-              <a:rPr sz="2200">
-                <a:solidFill>
-                  <a:srgbClr val="212121"/>
-                </a:solidFill>
-              </a:rPr>
-              <a:t>One nondet input = all tests of that input at once.</a:t>
+                <a:spcPts val="800"/>
+              </a:spcAft>
+            </a:pPr>
+            <a:r>
+              <a:rPr sz="2800">
+                <a:solidFill>
+                  <a:srgbClr val="212121"/>
+                </a:solidFill>
+              </a:rPr>
+              <a:t>The tool checks what you specify — with a weak spec, green is cheap.</a:t>
             </a:r>
           </a:p>
         </p:txBody>
@@ -4867,7 +4914,7 @@
                   <a:srgbClr val="5A0A7A"/>
                 </a:solidFill>
               </a:rPr>
-              <a:t>Lab 3, Part 2 — what did we prove?</a:t>
+              <a:t>Your specification toolkit</a:t>
             </a:r>
           </a:p>
         </p:txBody>
@@ -4906,7 +4953,7 @@
                 </a:solidFill>
                 <a:latin typeface="Courier New"/>
               </a:rPr>
-              <a:t>esbmc unwind.c --unwind 5      →  ?</a:t>
+              <a:t>int nondet_int(void);              /* any possible int */</a:t>
             </a:r>
           </a:p>
           <a:p>
@@ -4922,7 +4969,7 @@
                 </a:solidFill>
                 <a:latin typeface="Courier New"/>
               </a:rPr>
-              <a:t>esbmc unwind.c --unwind 20     →  ?</a:t>
+              <a:t>void __ESBMC_assume(_Bool);</a:t>
             </a:r>
           </a:p>
           <a:p>
@@ -4938,7 +4985,55 @@
                 </a:solidFill>
                 <a:latin typeface="Courier New"/>
               </a:rPr>
-              <a:t>esbmc unwind.c --unwind 60     →  ?</a:t>
+              <a:t/>
+            </a:r>
+          </a:p>
+          <a:p>
+            <a:pPr>
+              <a:spcAft>
+                <a:spcPts val="0"/>
+              </a:spcAft>
+            </a:pPr>
+            <a:r>
+              <a:rPr sz="1800">
+                <a:solidFill>
+                  <a:srgbClr val="212121"/>
+                </a:solidFill>
+                <a:latin typeface="Courier New"/>
+              </a:rPr>
+              <a:t>int x = nondet_int();              /* every value at once */</a:t>
+            </a:r>
+          </a:p>
+          <a:p>
+            <a:pPr>
+              <a:spcAft>
+                <a:spcPts val="0"/>
+              </a:spcAft>
+            </a:pPr>
+            <a:r>
+              <a:rPr sz="1800">
+                <a:solidFill>
+                  <a:srgbClr val="212121"/>
+                </a:solidFill>
+                <a:latin typeface="Courier New"/>
+              </a:rPr>
+              <a:t>__ESBMC_assume(x &gt; 0 &amp;&amp; x &lt; 100);  /* now: every value in 1..99 */</a:t>
+            </a:r>
+          </a:p>
+          <a:p>
+            <a:pPr>
+              <a:spcAft>
+                <a:spcPts val="0"/>
+              </a:spcAft>
+            </a:pPr>
+            <a:r>
+              <a:rPr sz="1800">
+                <a:solidFill>
+                  <a:srgbClr val="212121"/>
+                </a:solidFill>
+                <a:latin typeface="Courier New"/>
+              </a:rPr>
+              <a:t>assert(property(x));               /* must hold for ALL of them */</a:t>
             </a:r>
           </a:p>
           <a:p>
@@ -4968,37 +5063,7 @@
                   <a:srgbClr val="212121"/>
                 </a:solidFill>
               </a:rPr>
-              <a:t>What is the unwinding assertion telling you at 5 and 20?</a:t>
-            </a:r>
-          </a:p>
-          <a:p>
-            <a:pPr>
-              <a:spcAft>
-                <a:spcPts val="800"/>
-              </a:spcAft>
-            </a:pPr>
-            <a:r>
-              <a:rPr sz="2200">
-                <a:solidFill>
-                  <a:srgbClr val="212121"/>
-                </a:solidFill>
-              </a:rPr>
-              <a:t>At 60 — what exactly is proven, and for which n?</a:t>
-            </a:r>
-          </a:p>
-          <a:p>
-            <a:pPr>
-              <a:spcAft>
-                <a:spcPts val="800"/>
-              </a:spcAft>
-            </a:pPr>
-            <a:r>
-              <a:rPr sz="2200">
-                <a:solidFill>
-                  <a:srgbClr val="212121"/>
-                </a:solidFill>
-              </a:rPr>
-              <a:t>Stretch: --k-induction answers VERIFICATION UNKNOWN. Why is the unbounded question fundamentally harder? (Background deck: 03-k-induction.pptx)</a:t>
+              <a:t>One nondet input = all tests of that input at once.</a:t>
             </a:r>
           </a:p>
         </p:txBody>
@@ -5049,7 +5114,7 @@
                   <a:srgbClr val="5A0A7A"/>
                 </a:solidFill>
               </a:rPr>
-              <a:t>Lab 4 — Team challenge (30 min)</a:t>
+              <a:t>Lab 3, Part 2 — what did we prove?</a:t>
             </a:r>
           </a:p>
         </p:txBody>
@@ -5078,6 +5143,54 @@
           <a:p>
             <a:pPr>
               <a:spcAft>
+                <a:spcPts val="0"/>
+              </a:spcAft>
+            </a:pPr>
+            <a:r>
+              <a:rPr sz="1800">
+                <a:solidFill>
+                  <a:srgbClr val="212121"/>
+                </a:solidFill>
+                <a:latin typeface="Courier New"/>
+              </a:rPr>
+              <a:t>esbmc unwind.c --unwind 5      →  ?</a:t>
+            </a:r>
+          </a:p>
+          <a:p>
+            <a:pPr>
+              <a:spcAft>
+                <a:spcPts val="0"/>
+              </a:spcAft>
+            </a:pPr>
+            <a:r>
+              <a:rPr sz="1800">
+                <a:solidFill>
+                  <a:srgbClr val="212121"/>
+                </a:solidFill>
+                <a:latin typeface="Courier New"/>
+              </a:rPr>
+              <a:t>esbmc unwind.c --unwind 20     →  ?</a:t>
+            </a:r>
+          </a:p>
+          <a:p>
+            <a:pPr>
+              <a:spcAft>
+                <a:spcPts val="0"/>
+              </a:spcAft>
+            </a:pPr>
+            <a:r>
+              <a:rPr sz="1800">
+                <a:solidFill>
+                  <a:srgbClr val="212121"/>
+                </a:solidFill>
+                <a:latin typeface="Courier New"/>
+              </a:rPr>
+              <a:t>esbmc unwind.c --unwind 60     →  ?</a:t>
+            </a:r>
+          </a:p>
+          <a:p>
+            <a:pPr>
+              <a:spcAft>
                 <a:spcPts val="800"/>
               </a:spcAft>
             </a:pPr>
@@ -5087,37 +5200,7 @@
                   <a:srgbClr val="212121"/>
                 </a:solidFill>
               </a:rPr>
-              <a:t>Teams of 3–4. Points on the whiteboard:</a:t>
-            </a:r>
-          </a:p>
-          <a:p>
-            <a:pPr lvl="1">
-              <a:spcAft>
-                <a:spcPts val="800"/>
-              </a:spcAft>
-            </a:pPr>
-            <a:r>
-              <a:rPr sz="2000">
-                <a:solidFill>
-                  <a:srgbClr val="212121"/>
-                </a:solidFill>
-              </a:rPr>
-              <a:t>1 pt — verdict predicted correctly in writing, before running</a:t>
-            </a:r>
-          </a:p>
-          <a:p>
-            <a:pPr lvl="1">
-              <a:spcAft>
-                <a:spcPts val="800"/>
-              </a:spcAft>
-            </a:pPr>
-            <a:r>
-              <a:rPr sz="2000">
-                <a:solidFill>
-                  <a:srgbClr val="212121"/>
-                </a:solidFill>
-              </a:rPr>
-              <a:t>2 pts — file fixed and re-verified</a:t>
+              <a:t/>
             </a:r>
           </a:p>
           <a:p>
@@ -5132,7 +5215,7 @@
                   <a:srgbClr val="212121"/>
                 </a:solidFill>
               </a:rPr>
-              <a:t/>
+              <a:t>What is the unwinding assertion telling you at 5 and 20?</a:t>
             </a:r>
           </a:p>
           <a:p>
@@ -5147,23 +5230,7 @@
                   <a:srgbClr val="212121"/>
                 </a:solidFill>
               </a:rPr>
-              <a:t>Track A:  race.c — write down the failing interleaving first, then</a:t>
-            </a:r>
-          </a:p>
-          <a:p>
-            <a:pPr>
-              <a:spcAft>
-                <a:spcPts val="0"/>
-              </a:spcAft>
-            </a:pPr>
-            <a:r>
-              <a:rPr sz="1800">
-                <a:solidFill>
-                  <a:srgbClr val="212121"/>
-                </a:solidFill>
-                <a:latin typeface="Courier New"/>
-              </a:rPr>
-              <a:t>esbmc race.c --context-bound 2</a:t>
+              <a:t>At 60 — what exactly is proven, and for which n?</a:t>
             </a:r>
           </a:p>
           <a:p>
@@ -5178,7 +5245,7 @@
                   <a:srgbClr val="212121"/>
                 </a:solidFill>
               </a:rPr>
-              <a:t>Track B:  float.c — primary-school arithmetic. Or is it?</a:t>
+              <a:t>Stretch: --k-induction answers VERIFICATION UNKNOWN. Why is the unbounded question fundamentally harder? (Background deck: 03-k-induction.pptx)</a:t>
             </a:r>
           </a:p>
         </p:txBody>
@@ -5409,7 +5476,7 @@
                   <a:srgbClr val="5A0A7A"/>
                 </a:solidFill>
               </a:rPr>
-              <a:t>Why machines beat humans at Track A</a:t>
+              <a:t>Lab 4 — Team challenge (30 min)</a:t>
             </a:r>
           </a:p>
         </p:txBody>
@@ -5447,7 +5514,37 @@
                   <a:srgbClr val="212121"/>
                 </a:solidFill>
               </a:rPr>
-              <a:t>Sequentially, race.c is bulletproof — run it a million times, the bug may never show.</a:t>
+              <a:t>Teams of 3–4. Points on the whiteboard:</a:t>
+            </a:r>
+          </a:p>
+          <a:p>
+            <a:pPr lvl="1">
+              <a:spcAft>
+                <a:spcPts val="800"/>
+              </a:spcAft>
+            </a:pPr>
+            <a:r>
+              <a:rPr sz="2000">
+                <a:solidFill>
+                  <a:srgbClr val="212121"/>
+                </a:solidFill>
+              </a:rPr>
+              <a:t>1 pt — verdict predicted correctly in writing, before running</a:t>
+            </a:r>
+          </a:p>
+          <a:p>
+            <a:pPr lvl="1">
+              <a:spcAft>
+                <a:spcPts val="800"/>
+              </a:spcAft>
+            </a:pPr>
+            <a:r>
+              <a:rPr sz="2000">
+                <a:solidFill>
+                  <a:srgbClr val="212121"/>
+                </a:solidFill>
+              </a:rPr>
+              <a:t>2 pts — file fixed and re-verified</a:t>
             </a:r>
           </a:p>
           <a:p>
@@ -5462,7 +5559,7 @@
                   <a:srgbClr val="212121"/>
                 </a:solidFill>
               </a:rPr>
-              <a:t>Two threads of just 2 and 1 statements already have 3 interleavings; real code has billions.</a:t>
+              <a:t/>
             </a:r>
           </a:p>
           <a:p>
@@ -5477,7 +5574,23 @@
                   <a:srgbClr val="212121"/>
                 </a:solidFill>
               </a:rPr>
-              <a:t>The model checker enumerates every interleaving up to the context bound — including the one that kills the assertion.</a:t>
+              <a:t>Track A:  race.c — write down the failing interleaving first, then</a:t>
+            </a:r>
+          </a:p>
+          <a:p>
+            <a:pPr>
+              <a:spcAft>
+                <a:spcPts val="0"/>
+              </a:spcAft>
+            </a:pPr>
+            <a:r>
+              <a:rPr sz="1800">
+                <a:solidFill>
+                  <a:srgbClr val="212121"/>
+                </a:solidFill>
+                <a:latin typeface="Courier New"/>
+              </a:rPr>
+              <a:t>esbmc race.c --context-bound 2</a:t>
             </a:r>
           </a:p>
           <a:p>
@@ -5492,22 +5605,7 @@
                   <a:srgbClr val="212121"/>
                 </a:solidFill>
               </a:rPr>
-              <a:t/>
-            </a:r>
-          </a:p>
-          <a:p>
-            <a:pPr>
-              <a:spcAft>
-                <a:spcPts val="800"/>
-              </a:spcAft>
-            </a:pPr>
-            <a:r>
-              <a:rPr sz="2200">
-                <a:solidFill>
-                  <a:srgbClr val="212121"/>
-                </a:solidFill>
-              </a:rPr>
-              <a:t>The counterexample you get includes the thread schedule: read it as a story of who ran when.</a:t>
+              <a:t>Track B:  float.c — primary-school arithmetic. Or is it?</a:t>
             </a:r>
           </a:p>
         </p:txBody>
@@ -5521,6 +5619,155 @@
 </file>
 
 <file path=ppt/slides/slide21.xml><?xml version="1.0" encoding="utf-8"?>
+<p:sld xmlns:a="http://schemas.openxmlformats.org/drawingml/2006/main" xmlns:p="http://schemas.openxmlformats.org/presentationml/2006/main" xmlns:r="http://schemas.openxmlformats.org/officeDocument/2006/relationships">
+  <p:cSld>
+    <p:spTree>
+      <p:nvGrpSpPr>
+        <p:cNvPr id="1" name=""/>
+        <p:cNvGrpSpPr/>
+        <p:nvPr/>
+      </p:nvGrpSpPr>
+      <p:grpSpPr/>
+      <p:sp>
+        <p:nvSpPr>
+          <p:cNvPr id="2" name="TextBox 1"/>
+          <p:cNvSpPr txBox="1"/>
+          <p:nvPr/>
+        </p:nvSpPr>
+        <p:spPr>
+          <a:xfrm>
+            <a:off x="548640" y="365760"/>
+            <a:ext cx="11064240" cy="1005840"/>
+          </a:xfrm>
+          <a:prstGeom prst="rect">
+            <a:avLst/>
+          </a:prstGeom>
+          <a:noFill/>
+        </p:spPr>
+        <p:txBody>
+          <a:bodyPr wrap="square">
+            <a:spAutoFit/>
+          </a:bodyPr>
+          <a:lstStyle/>
+          <a:p>
+            <a:r>
+              <a:rPr sz="3600" b="1">
+                <a:solidFill>
+                  <a:srgbClr val="5A0A7A"/>
+                </a:solidFill>
+              </a:rPr>
+              <a:t>Why machines beat humans at Track A</a:t>
+            </a:r>
+          </a:p>
+        </p:txBody>
+      </p:sp>
+      <p:sp>
+        <p:nvSpPr>
+          <p:cNvPr id="3" name="TextBox 2"/>
+          <p:cNvSpPr txBox="1"/>
+          <p:nvPr/>
+        </p:nvSpPr>
+        <p:spPr>
+          <a:xfrm>
+            <a:off x="731520" y="1463040"/>
+            <a:ext cx="10789920" cy="5120640"/>
+          </a:xfrm>
+          <a:prstGeom prst="rect">
+            <a:avLst/>
+          </a:prstGeom>
+          <a:noFill/>
+        </p:spPr>
+        <p:txBody>
+          <a:bodyPr wrap="square">
+            <a:spAutoFit/>
+          </a:bodyPr>
+          <a:lstStyle/>
+          <a:p>
+            <a:pPr>
+              <a:spcAft>
+                <a:spcPts val="800"/>
+              </a:spcAft>
+            </a:pPr>
+            <a:r>
+              <a:rPr sz="2200">
+                <a:solidFill>
+                  <a:srgbClr val="212121"/>
+                </a:solidFill>
+              </a:rPr>
+              <a:t>Sequentially, race.c is bulletproof — run it a million times, the bug may never show.</a:t>
+            </a:r>
+          </a:p>
+          <a:p>
+            <a:pPr>
+              <a:spcAft>
+                <a:spcPts val="800"/>
+              </a:spcAft>
+            </a:pPr>
+            <a:r>
+              <a:rPr sz="2200">
+                <a:solidFill>
+                  <a:srgbClr val="212121"/>
+                </a:solidFill>
+              </a:rPr>
+              <a:t>Two threads of just 2 and 1 statements already have 3 interleavings; real code has billions.</a:t>
+            </a:r>
+          </a:p>
+          <a:p>
+            <a:pPr>
+              <a:spcAft>
+                <a:spcPts val="800"/>
+              </a:spcAft>
+            </a:pPr>
+            <a:r>
+              <a:rPr sz="2200">
+                <a:solidFill>
+                  <a:srgbClr val="212121"/>
+                </a:solidFill>
+              </a:rPr>
+              <a:t>The model checker enumerates every interleaving up to the context bound — including the one that kills the assertion.</a:t>
+            </a:r>
+          </a:p>
+          <a:p>
+            <a:pPr>
+              <a:spcAft>
+                <a:spcPts val="800"/>
+              </a:spcAft>
+            </a:pPr>
+            <a:r>
+              <a:rPr sz="2200">
+                <a:solidFill>
+                  <a:srgbClr val="212121"/>
+                </a:solidFill>
+              </a:rPr>
+              <a:t/>
+            </a:r>
+          </a:p>
+          <a:p>
+            <a:pPr>
+              <a:spcAft>
+                <a:spcPts val="800"/>
+              </a:spcAft>
+            </a:pPr>
+            <a:r>
+              <a:rPr sz="2200">
+                <a:solidFill>
+                  <a:srgbClr val="212121"/>
+                </a:solidFill>
+              </a:rPr>
+              <a:t>The counterexample you get includes the thread schedule: read it as a story of who ran when.</a:t>
+            </a:r>
+          </a:p>
+        </p:txBody>
+      </p:sp>
+    </p:spTree>
+  </p:cSld>
+  <p:clrMapOvr>
+    <a:masterClrMapping/>
+  </p:clrMapOvr>
+</p:sld>
+</file>
+
+<file path=ppt/slides/slide22.xml><?xml version="1.0" encoding="utf-8"?>
 <p:sld xmlns:a="http://schemas.openxmlformats.org/drawingml/2006/main" xmlns:p="http://schemas.openxmlformats.org/presentationml/2006/main" xmlns:r="http://schemas.openxmlformats.org/officeDocument/2006/relationships">
   <p:cSld>
     <p:spTree>
@@ -6283,7 +6530,7 @@
                   <a:srgbClr val="5A0A7A"/>
                 </a:solidFill>
               </a:rPr>
-              <a:t>Lab 1 — Constraint solving (35 min)</a:t>
+              <a:t>Another route to a proof: abstract interpretation</a:t>
             </a:r>
           </a:p>
         </p:txBody>
@@ -6296,8 +6543,8 @@
         </p:nvSpPr>
         <p:spPr>
           <a:xfrm>
-            <a:off x="731520" y="1463040"/>
-            <a:ext cx="10789920" cy="5120640"/>
+            <a:off x="731520" y="1828800"/>
+            <a:ext cx="10789920" cy="4754880"/>
           </a:xfrm>
           <a:prstGeom prst="rect">
             <a:avLst/>
@@ -6316,12 +6563,42 @@
               </a:spcAft>
             </a:pPr>
             <a:r>
+              <a:rPr sz="2400">
+                <a:solidFill>
+                  <a:srgbClr val="212121"/>
+                </a:solidFill>
+              </a:rPr>
+              <a:t>Tonight's trick hunts a counterexample. Abstract interpretation proves P the other way — over-approximate every run at once to a fixpoint invariant: no bound, no search.</a:t>
+            </a:r>
+          </a:p>
+          <a:p>
+            <a:pPr>
+              <a:spcAft>
+                <a:spcPts val="800"/>
+              </a:spcAft>
+            </a:pPr>
+            <a:r>
+              <a:rPr sz="2400">
+                <a:solidFill>
+                  <a:srgbClr val="212121"/>
+                </a:solidFill>
+              </a:rPr>
+              <a:t/>
+            </a:r>
+          </a:p>
+          <a:p>
+            <a:pPr lvl="1">
+              <a:spcAft>
+                <a:spcPts val="800"/>
+              </a:spcAft>
+            </a:pPr>
+            <a:r>
               <a:rPr sz="2200">
                 <a:solidFill>
                   <a:srgbClr val="212121"/>
                 </a:solidFill>
               </a:rPr>
-              <a:t>labs/lab1/lab1.py — three stages, instructions inside.</a:t>
+              <a:t>You met the mechanism in Session 1: abstract domain, widening (∇), narrowing (Δ) — iterate to a fixpoint; if it implies P, P holds for every run.</a:t>
             </a:r>
           </a:p>
           <a:p>
@@ -6331,12 +6608,12 @@
               </a:spcAft>
             </a:pPr>
             <a:r>
-              <a:rPr sz="2000">
-                <a:solidFill>
-                  <a:srgbClr val="212121"/>
-                </a:solidFill>
-              </a:rPr>
-              <a:t>Stage 1 (guided): are these formulas equivalent? Encode lhs ≠ rhs, ask the solver.</a:t>
+              <a:rPr sz="2200">
+                <a:solidFill>
+                  <a:srgbClr val="212121"/>
+                </a:solidFill>
+              </a:rPr>
+              <a:t>Sound, not complete: too coarse an over-approximation → a false alarm. (Astrée proved the A380 fly-by-wire this way.)</a:t>
             </a:r>
           </a:p>
           <a:p>
@@ -6346,72 +6623,12 @@
               </a:spcAft>
             </a:pPr>
             <a:r>
-              <a:rPr sz="2000">
-                <a:solidFill>
-                  <a:srgbClr val="212121"/>
-                </a:solidFill>
-              </a:rPr>
-              <a:t>Stage 2: SEND + MORE = MONEY — let Z3 search 10⁸ assignments.</a:t>
-            </a:r>
-          </a:p>
-          <a:p>
-            <a:pPr lvl="1">
-              <a:spcAft>
-                <a:spcPts val="800"/>
-              </a:spcAft>
-            </a:pPr>
-            <a:r>
-              <a:rPr sz="2000">
-                <a:solidFill>
-                  <a:srgbClr val="212121"/>
-                </a:solidFill>
-              </a:rPr>
-              <a:t>Stage 3: a 3-line C function as SSA equations — you are doing ESBMC's job by hand.</a:t>
-            </a:r>
-          </a:p>
-          <a:p>
-            <a:pPr>
-              <a:spcAft>
-                <a:spcPts val="800"/>
-              </a:spcAft>
-            </a:pPr>
-            <a:r>
               <a:rPr sz="2200">
                 <a:solidFill>
                   <a:srgbClr val="212121"/>
                 </a:solidFill>
               </a:rPr>
-              <a:t/>
-            </a:r>
-          </a:p>
-          <a:p>
-            <a:pPr>
-              <a:spcAft>
-                <a:spcPts val="800"/>
-              </a:spcAft>
-            </a:pPr>
-            <a:r>
-              <a:rPr sz="2200">
-                <a:solidFill>
-                  <a:srgbClr val="212121"/>
-                </a:solidFill>
-              </a:rPr>
-              <a:t>Predict before every run: write your guess as a comment first.</a:t>
-            </a:r>
-          </a:p>
-          <a:p>
-            <a:pPr lvl="1">
-              <a:spcAft>
-                <a:spcPts val="800"/>
-              </a:spcAft>
-            </a:pPr>
-            <a:r>
-              <a:rPr sz="2000">
-                <a:solidFill>
-                  <a:srgbClr val="212121"/>
-                </a:solidFill>
-              </a:rPr>
-              <a:t>Box B (optional): re-run Stage 3 as Python ESBMC checks for you — stage3_esbmc.py.</a:t>
+              <a:t>ESBMC ships it too — --interval-analysis — feeding the invariant k-induction needs for unwind.c (Lab 3).</a:t>
             </a:r>
           </a:p>
         </p:txBody>
@@ -6462,7 +6679,7 @@
                   <a:srgbClr val="5A0A7A"/>
                 </a:solidFill>
               </a:rPr>
-              <a:t>Z3's Python API — the whole toolkit</a:t>
+              <a:t>Lab 1 — Constraint solving (35 min)</a:t>
             </a:r>
           </a:p>
         </p:txBody>
@@ -6491,63 +6708,74 @@
           <a:p>
             <a:pPr>
               <a:spcAft>
-                <a:spcPts val="0"/>
-              </a:spcAft>
-            </a:pPr>
-            <a:r>
-              <a:rPr sz="1800">
-                <a:solidFill>
-                  <a:srgbClr val="212121"/>
-                </a:solidFill>
-                <a:latin typeface="Courier New"/>
-              </a:rPr>
-              <a:t>from z3 import Bools, Ints, BitVec, Solver, sat, unsat</a:t>
-            </a:r>
-          </a:p>
-          <a:p>
-            <a:pPr>
-              <a:spcAft>
-                <a:spcPts val="0"/>
-              </a:spcAft>
-            </a:pPr>
-            <a:r>
-              <a:rPr sz="1800">
-                <a:solidFill>
-                  <a:srgbClr val="212121"/>
-                </a:solidFill>
-                <a:latin typeface="Courier New"/>
-              </a:rPr>
-              <a:t>a, b = Bools("a b")     # symbolic booleans, not values</a:t>
-            </a:r>
-          </a:p>
-          <a:p>
-            <a:pPr>
-              <a:spcAft>
-                <a:spcPts val="0"/>
-              </a:spcAft>
-            </a:pPr>
-            <a:r>
-              <a:rPr sz="1800">
-                <a:solidFill>
-                  <a:srgbClr val="212121"/>
-                </a:solidFill>
-                <a:latin typeface="Courier New"/>
-              </a:rPr>
-              <a:t>x = BitVec("x", 32)     # a 32-bit machine integer</a:t>
-            </a:r>
-          </a:p>
-          <a:p>
-            <a:pPr>
-              <a:spcAft>
-                <a:spcPts val="0"/>
-              </a:spcAft>
-            </a:pPr>
-            <a:r>
-              <a:rPr sz="1800">
-                <a:solidFill>
-                  <a:srgbClr val="212121"/>
-                </a:solidFill>
-                <a:latin typeface="Courier New"/>
+                <a:spcPts val="800"/>
+              </a:spcAft>
+            </a:pPr>
+            <a:r>
+              <a:rPr sz="2200">
+                <a:solidFill>
+                  <a:srgbClr val="212121"/>
+                </a:solidFill>
+              </a:rPr>
+              <a:t>labs/lab1/lab1.py — three stages, instructions inside.</a:t>
+            </a:r>
+          </a:p>
+          <a:p>
+            <a:pPr lvl="1">
+              <a:spcAft>
+                <a:spcPts val="800"/>
+              </a:spcAft>
+            </a:pPr>
+            <a:r>
+              <a:rPr sz="2000">
+                <a:solidFill>
+                  <a:srgbClr val="212121"/>
+                </a:solidFill>
+              </a:rPr>
+              <a:t>Stage 1 (guided): are these formulas equivalent? Encode lhs ≠ rhs, ask the solver.</a:t>
+            </a:r>
+          </a:p>
+          <a:p>
+            <a:pPr lvl="1">
+              <a:spcAft>
+                <a:spcPts val="800"/>
+              </a:spcAft>
+            </a:pPr>
+            <a:r>
+              <a:rPr sz="2000">
+                <a:solidFill>
+                  <a:srgbClr val="212121"/>
+                </a:solidFill>
+              </a:rPr>
+              <a:t>Stage 2: SEND + MORE = MONEY — let Z3 search 10⁸ assignments.</a:t>
+            </a:r>
+          </a:p>
+          <a:p>
+            <a:pPr lvl="1">
+              <a:spcAft>
+                <a:spcPts val="800"/>
+              </a:spcAft>
+            </a:pPr>
+            <a:r>
+              <a:rPr sz="2000">
+                <a:solidFill>
+                  <a:srgbClr val="212121"/>
+                </a:solidFill>
+              </a:rPr>
+              <a:t>Stage 3: a 3-line C function as SSA equations — you are doing ESBMC's job by hand.</a:t>
+            </a:r>
+          </a:p>
+          <a:p>
+            <a:pPr>
+              <a:spcAft>
+                <a:spcPts val="800"/>
+              </a:spcAft>
+            </a:pPr>
+            <a:r>
+              <a:rPr sz="2200">
+                <a:solidFill>
+                  <a:srgbClr val="212121"/>
+                </a:solidFill>
               </a:rPr>
               <a:t/>
             </a:r>
@@ -6555,70 +6783,6 @@
           <a:p>
             <a:pPr>
               <a:spcAft>
-                <a:spcPts val="0"/>
-              </a:spcAft>
-            </a:pPr>
-            <a:r>
-              <a:rPr sz="1800">
-                <a:solidFill>
-                  <a:srgbClr val="212121"/>
-                </a:solidFill>
-                <a:latin typeface="Courier New"/>
-              </a:rPr>
-              <a:t>s = Solver()</a:t>
-            </a:r>
-          </a:p>
-          <a:p>
-            <a:pPr>
-              <a:spcAft>
-                <a:spcPts val="0"/>
-              </a:spcAft>
-            </a:pPr>
-            <a:r>
-              <a:rPr sz="1800">
-                <a:solidFill>
-                  <a:srgbClr val="212121"/>
-                </a:solidFill>
-                <a:latin typeface="Courier New"/>
-              </a:rPr>
-              <a:t>s.add(formula)           # constrain</a:t>
-            </a:r>
-          </a:p>
-          <a:p>
-            <a:pPr>
-              <a:spcAft>
-                <a:spcPts val="0"/>
-              </a:spcAft>
-            </a:pPr>
-            <a:r>
-              <a:rPr sz="1800">
-                <a:solidFill>
-                  <a:srgbClr val="212121"/>
-                </a:solidFill>
-                <a:latin typeface="Courier New"/>
-              </a:rPr>
-              <a:t>s.check()                # -&gt; sat or unsat</a:t>
-            </a:r>
-          </a:p>
-          <a:p>
-            <a:pPr>
-              <a:spcAft>
-                <a:spcPts val="0"/>
-              </a:spcAft>
-            </a:pPr>
-            <a:r>
-              <a:rPr sz="1800">
-                <a:solidFill>
-                  <a:srgbClr val="212121"/>
-                </a:solidFill>
-                <a:latin typeface="Courier New"/>
-              </a:rPr>
-              <a:t>s.model()                # the witness, when sat</a:t>
-            </a:r>
-          </a:p>
-          <a:p>
-            <a:pPr>
-              <a:spcAft>
                 <a:spcPts val="800"/>
               </a:spcAft>
             </a:pPr>
@@ -6628,22 +6792,22 @@
                   <a:srgbClr val="212121"/>
                 </a:solidFill>
               </a:rPr>
-              <a:t/>
-            </a:r>
-          </a:p>
-          <a:p>
-            <a:pPr>
-              <a:spcAft>
-                <a:spcPts val="800"/>
-              </a:spcAft>
-            </a:pPr>
-            <a:r>
-              <a:rPr sz="2200">
-                <a:solidFill>
-                  <a:srgbClr val="212121"/>
-                </a:solidFill>
-              </a:rPr>
-              <a:t>Every stage of lab1.py is these five calls — nothing else.</a:t>
+              <a:t>Predict before every run: write your guess as a comment first.</a:t>
+            </a:r>
+          </a:p>
+          <a:p>
+            <a:pPr lvl="1">
+              <a:spcAft>
+                <a:spcPts val="800"/>
+              </a:spcAft>
+            </a:pPr>
+            <a:r>
+              <a:rPr sz="2000">
+                <a:solidFill>
+                  <a:srgbClr val="212121"/>
+                </a:solidFill>
+              </a:rPr>
+              <a:t>Box B (optional): re-run Stage 3 as Python ESBMC checks for you — stage3_esbmc.py.</a:t>
             </a:r>
           </a:p>
         </p:txBody>
@@ -6694,7 +6858,7 @@
                   <a:srgbClr val="5A0A7A"/>
                 </a:solidFill>
               </a:rPr>
-              <a:t>Walkthrough: equivalent() from lab1.py</a:t>
+              <a:t>Z3's Python API — the whole toolkit</a:t>
             </a:r>
           </a:p>
         </p:txBody>
@@ -6733,7 +6897,7 @@
                 </a:solidFill>
                 <a:latin typeface="Courier New"/>
               </a:rPr>
-              <a:t>def equivalent(lhs, rhs, name):</a:t>
+              <a:t>from z3 import Bools, Ints, BitVec, Solver, sat, unsat</a:t>
             </a:r>
           </a:p>
           <a:p>
@@ -6749,7 +6913,7 @@
                 </a:solidFill>
                 <a:latin typeface="Courier New"/>
               </a:rPr>
-              <a:t>    slv = Solver()</a:t>
+              <a:t>a, b = Bools("a b")     # symbolic booleans, not values</a:t>
             </a:r>
           </a:p>
           <a:p>
@@ -6765,7 +6929,7 @@
                 </a:solidFill>
                 <a:latin typeface="Courier New"/>
               </a:rPr>
-              <a:t>    slv.add(lhs != rhs)            # can they EVER differ?</a:t>
+              <a:t>x = BitVec("x", 32)     # a 32-bit machine integer</a:t>
             </a:r>
           </a:p>
           <a:p>
@@ -6781,7 +6945,7 @@
                 </a:solidFill>
                 <a:latin typeface="Courier New"/>
               </a:rPr>
-              <a:t>    if slv.check() == unsat:       # never differ: a proof</a:t>
+              <a:t/>
             </a:r>
           </a:p>
           <a:p>
@@ -6797,7 +6961,7 @@
                 </a:solidFill>
                 <a:latin typeface="Courier New"/>
               </a:rPr>
-              <a:t>        print(name, "EQUIVALENT")</a:t>
+              <a:t>s = Solver()</a:t>
             </a:r>
           </a:p>
           <a:p>
@@ -6813,7 +6977,7 @@
                 </a:solidFill>
                 <a:latin typeface="Courier New"/>
               </a:rPr>
-              <a:t>    else:                          # a witness they differ</a:t>
+              <a:t>s.add(formula)           # constrain</a:t>
             </a:r>
           </a:p>
           <a:p>
@@ -6829,7 +6993,23 @@
                 </a:solidFill>
                 <a:latin typeface="Courier New"/>
               </a:rPr>
-              <a:t>        print(name, slv.model())</a:t>
+              <a:t>s.check()                # -&gt; sat or unsat</a:t>
+            </a:r>
+          </a:p>
+          <a:p>
+            <a:pPr>
+              <a:spcAft>
+                <a:spcPts val="0"/>
+              </a:spcAft>
+            </a:pPr>
+            <a:r>
+              <a:rPr sz="1800">
+                <a:solidFill>
+                  <a:srgbClr val="212121"/>
+                </a:solidFill>
+                <a:latin typeface="Courier New"/>
+              </a:rPr>
+              <a:t>s.model()                # the witness, when sat</a:t>
             </a:r>
           </a:p>
           <a:p>
@@ -6848,49 +7028,18 @@
             </a:r>
           </a:p>
           <a:p>
-            <a:pPr lvl="1">
-              <a:spcAft>
-                <a:spcPts val="800"/>
-              </a:spcAft>
-            </a:pPr>
-            <a:r>
-              <a:rPr sz="2000">
-                <a:solidFill>
-                  <a:srgbClr val="212121"/>
-                </a:solidFill>
-              </a:rPr>
-              <a:t>1a De Morgan: EQUIVALENT   ·   1b distribution: EQUIVALENT</a:t>
-            </a:r>
-          </a:p>
-          <a:p>
-            <a:pPr lvl="1">
-              <a:spcAft>
-                <a:spcPts val="0"/>
-              </a:spcAft>
-            </a:pPr>
-            <a:r>
-              <a:rPr sz="1800">
-                <a:solidFill>
-                  <a:srgbClr val="212121"/>
-                </a:solidFill>
-                <a:latin typeface="Courier New"/>
-              </a:rPr>
-              <a:t>1c trick question: NOT equivalent, counterexample: [b = False]</a:t>
-            </a:r>
-          </a:p>
-          <a:p>
-            <a:pPr lvl="1">
-              <a:spcAft>
-                <a:spcPts val="800"/>
-              </a:spcAft>
-            </a:pPr>
-            <a:r>
-              <a:rPr sz="2000">
-                <a:solidFill>
-                  <a:srgbClr val="212121"/>
-                </a:solidFill>
-              </a:rPr>
-              <a:t>Read the model: with b = False, a → (b → a) is true but b is false.</a:t>
+            <a:pPr>
+              <a:spcAft>
+                <a:spcPts val="800"/>
+              </a:spcAft>
+            </a:pPr>
+            <a:r>
+              <a:rPr sz="2200">
+                <a:solidFill>
+                  <a:srgbClr val="212121"/>
+                </a:solidFill>
+              </a:rPr>
+              <a:t>Every stage of lab1.py is these five calls — nothing else.</a:t>
             </a:r>
           </a:p>
         </p:txBody>
@@ -6941,7 +7090,7 @@
                   <a:srgbClr val="5A0A7A"/>
                 </a:solidFill>
               </a:rPr>
-              <a:t>Walkthrough: Stage 3 is ESBMC by hand</a:t>
+              <a:t>Walkthrough: equivalent() from lab1.py</a:t>
             </a:r>
           </a:p>
         </p:txBody>
@@ -6980,7 +7129,7 @@
                 </a:solidFill>
                 <a:latin typeface="Courier New"/>
               </a:rPr>
-              <a:t>x, y, z = BitVec("x", 32), BitVec("y", 32), BitVec("z", 32)</a:t>
+              <a:t>def equivalent(lhs, rhs, name):</a:t>
             </a:r>
           </a:p>
           <a:p>
@@ -6996,7 +7145,7 @@
                 </a:solidFill>
                 <a:latin typeface="Courier New"/>
               </a:rPr>
-              <a:t>s.add(y == x + 1)        # int y = x + 1;</a:t>
+              <a:t>    slv = Solver()</a:t>
             </a:r>
           </a:p>
           <a:p>
@@ -7012,7 +7161,7 @@
                 </a:solidFill>
                 <a:latin typeface="Courier New"/>
               </a:rPr>
-              <a:t>s.add(z == y * 2)        # int z = y * 2;</a:t>
+              <a:t>    slv.add(lhs != rhs)            # can they EVER differ?</a:t>
             </a:r>
           </a:p>
           <a:p>
@@ -7028,7 +7177,55 @@
                 </a:solidFill>
                 <a:latin typeface="Courier New"/>
               </a:rPr>
-              <a:t>s.add(Not(z &gt;= 2))       # assert(z &gt;= 2) — NEGATED</a:t>
+              <a:t>    if slv.check() == unsat:       # never differ: a proof</a:t>
+            </a:r>
+          </a:p>
+          <a:p>
+            <a:pPr>
+              <a:spcAft>
+                <a:spcPts val="0"/>
+              </a:spcAft>
+            </a:pPr>
+            <a:r>
+              <a:rPr sz="1800">
+                <a:solidFill>
+                  <a:srgbClr val="212121"/>
+                </a:solidFill>
+                <a:latin typeface="Courier New"/>
+              </a:rPr>
+              <a:t>        print(name, "EQUIVALENT")</a:t>
+            </a:r>
+          </a:p>
+          <a:p>
+            <a:pPr>
+              <a:spcAft>
+                <a:spcPts val="0"/>
+              </a:spcAft>
+            </a:pPr>
+            <a:r>
+              <a:rPr sz="1800">
+                <a:solidFill>
+                  <a:srgbClr val="212121"/>
+                </a:solidFill>
+                <a:latin typeface="Courier New"/>
+              </a:rPr>
+              <a:t>    else:                          # a witness they differ</a:t>
+            </a:r>
+          </a:p>
+          <a:p>
+            <a:pPr>
+              <a:spcAft>
+                <a:spcPts val="0"/>
+              </a:spcAft>
+            </a:pPr>
+            <a:r>
+              <a:rPr sz="1800">
+                <a:solidFill>
+                  <a:srgbClr val="212121"/>
+                </a:solidFill>
+                <a:latin typeface="Courier New"/>
+              </a:rPr>
+              <a:t>        print(name, slv.model())</a:t>
             </a:r>
           </a:p>
           <a:p>
@@ -7047,7 +7244,22 @@
             </a:r>
           </a:p>
           <a:p>
-            <a:pPr>
+            <a:pPr lvl="1">
+              <a:spcAft>
+                <a:spcPts val="800"/>
+              </a:spcAft>
+            </a:pPr>
+            <a:r>
+              <a:rPr sz="2000">
+                <a:solidFill>
+                  <a:srgbClr val="212121"/>
+                </a:solidFill>
+              </a:rPr>
+              <a:t>1a De Morgan: EQUIVALENT   ·   1b distribution: EQUIVALENT</a:t>
+            </a:r>
+          </a:p>
+          <a:p>
+            <a:pPr lvl="1">
               <a:spcAft>
                 <a:spcPts val="0"/>
               </a:spcAft>
@@ -7059,7 +7271,7 @@
                 </a:solidFill>
                 <a:latin typeface="Courier New"/>
               </a:rPr>
-              <a:t>sat — counterexample e.g. x = 1073741824 (= 2^30)</a:t>
+              <a:t>1c trick question: NOT equivalent, counterexample: [b = False]</a:t>
             </a:r>
           </a:p>
           <a:p>
@@ -7074,52 +7286,7 @@
                   <a:srgbClr val="212121"/>
                 </a:solidFill>
               </a:rPr>
-              <a:t>y * 2 overflows the 32-bit range: z comes out negative.</a:t>
-            </a:r>
-          </a:p>
-          <a:p>
-            <a:pPr>
-              <a:spcAft>
-                <a:spcPts val="800"/>
-              </a:spcAft>
-            </a:pPr>
-            <a:r>
-              <a:rPr sz="2200">
-                <a:solidFill>
-                  <a:srgbClr val="212121"/>
-                </a:solidFill>
-              </a:rPr>
-              <a:t>Would your test suite have tried 1073741824?</a:t>
-            </a:r>
-          </a:p>
-          <a:p>
-            <a:pPr>
-              <a:spcAft>
-                <a:spcPts val="800"/>
-              </a:spcAft>
-            </a:pPr>
-            <a:r>
-              <a:rPr sz="2200">
-                <a:solidFill>
-                  <a:srgbClr val="212121"/>
-                </a:solidFill>
-              </a:rPr>
-              <a:t/>
-            </a:r>
-          </a:p>
-          <a:p>
-            <a:pPr>
-              <a:spcAft>
-                <a:spcPts val="800"/>
-              </a:spcAft>
-            </a:pPr>
-            <a:r>
-              <a:rPr sz="2200">
-                <a:solidFill>
-                  <a:srgbClr val="212121"/>
-                </a:solidFill>
-              </a:rPr>
-              <a:t>ESBMC builds exactly this formula from your C — automatically. That's Lab 2.</a:t>
+              <a:t>Read the model: with b = False, a → (b → a) is true but b is false.</a:t>
             </a:r>
           </a:p>
         </p:txBody>
@@ -7170,7 +7337,7 @@
                   <a:srgbClr val="5A0A7A"/>
                 </a:solidFill>
               </a:rPr>
-              <a:t>Box B: hand that same Python to ESBMC</a:t>
+              <a:t>Walkthrough: Stage 3 is ESBMC by hand</a:t>
             </a:r>
           </a:p>
         </p:txBody>
@@ -7209,7 +7376,7 @@
                 </a:solidFill>
                 <a:latin typeface="Courier New"/>
               </a:rPr>
-              <a:t>def f(x: int) -&gt; int:</a:t>
+              <a:t>x, y, z = BitVec("x", 32), BitVec("y", 32), BitVec("z", 32)</a:t>
             </a:r>
           </a:p>
           <a:p>
@@ -7225,7 +7392,7 @@
                 </a:solidFill>
                 <a:latin typeface="Courier New"/>
               </a:rPr>
-              <a:t>    y = x + 1</a:t>
+              <a:t>s.add(y == x + 1)        # int y = x + 1;</a:t>
             </a:r>
           </a:p>
           <a:p>
@@ -7241,7 +7408,7 @@
                 </a:solidFill>
                 <a:latin typeface="Courier New"/>
               </a:rPr>
-              <a:t>    z = y * 2</a:t>
+              <a:t>s.add(z == y * 2)        # int z = y * 2;</a:t>
             </a:r>
           </a:p>
           <a:p>
@@ -7257,7 +7424,22 @@
                 </a:solidFill>
                 <a:latin typeface="Courier New"/>
               </a:rPr>
-              <a:t>    assert z &gt;= 2        # ESBMC negates this for you</a:t>
+              <a:t>s.add(Not(z &gt;= 2))       # assert(z &gt;= 2) — NEGATED</a:t>
+            </a:r>
+          </a:p>
+          <a:p>
+            <a:pPr>
+              <a:spcAft>
+                <a:spcPts val="800"/>
+              </a:spcAft>
+            </a:pPr>
+            <a:r>
+              <a:rPr sz="2200">
+                <a:solidFill>
+                  <a:srgbClr val="212121"/>
+                </a:solidFill>
+              </a:rPr>
+              <a:t/>
             </a:r>
           </a:p>
           <a:p>
@@ -7273,23 +7455,22 @@
                 </a:solidFill>
                 <a:latin typeface="Courier New"/>
               </a:rPr>
-              <a:t>x: int = nondet_int()    # every int at once, like BitVec("x")</a:t>
-            </a:r>
-          </a:p>
-          <a:p>
-            <a:pPr>
-              <a:spcAft>
-                <a:spcPts val="0"/>
-              </a:spcAft>
-            </a:pPr>
-            <a:r>
-              <a:rPr sz="1800">
-                <a:solidFill>
-                  <a:srgbClr val="212121"/>
-                </a:solidFill>
-                <a:latin typeface="Courier New"/>
-              </a:rPr>
-              <a:t>f(x)</a:t>
+              <a:t>sat — counterexample e.g. x = 1073741824 (= 2^30)</a:t>
+            </a:r>
+          </a:p>
+          <a:p>
+            <a:pPr lvl="1">
+              <a:spcAft>
+                <a:spcPts val="800"/>
+              </a:spcAft>
+            </a:pPr>
+            <a:r>
+              <a:rPr sz="2000">
+                <a:solidFill>
+                  <a:srgbClr val="212121"/>
+                </a:solidFill>
+              </a:rPr>
+              <a:t>y * 2 overflows the 32-bit range: z comes out negative.</a:t>
             </a:r>
           </a:p>
           <a:p>
@@ -7304,68 +7485,37 @@
                   <a:srgbClr val="212121"/>
                 </a:solidFill>
               </a:rPr>
+              <a:t>Would your test suite have tried 1073741824?</a:t>
+            </a:r>
+          </a:p>
+          <a:p>
+            <a:pPr>
+              <a:spcAft>
+                <a:spcPts val="800"/>
+              </a:spcAft>
+            </a:pPr>
+            <a:r>
+              <a:rPr sz="2200">
+                <a:solidFill>
+                  <a:srgbClr val="212121"/>
+                </a:solidFill>
+              </a:rPr>
               <a:t/>
             </a:r>
           </a:p>
           <a:p>
             <a:pPr>
               <a:spcAft>
-                <a:spcPts val="0"/>
-              </a:spcAft>
-            </a:pPr>
-            <a:r>
-              <a:rPr sz="1800">
-                <a:solidFill>
-                  <a:srgbClr val="212121"/>
-                </a:solidFill>
-                <a:latin typeface="Courier New"/>
-              </a:rPr>
-              <a:t>esbmc stage3_esbmc.py  →  VERIFICATION FAILED   (x = 2^63 - 1)</a:t>
-            </a:r>
-          </a:p>
-          <a:p>
-            <a:pPr lvl="1">
-              <a:spcAft>
-                <a:spcPts val="800"/>
-              </a:spcAft>
-            </a:pPr>
-            <a:r>
-              <a:rPr sz="2000">
-                <a:solidFill>
-                  <a:srgbClr val="212121"/>
-                </a:solidFill>
-              </a:rPr>
-              <a:t>You wrote the function; ESBMC wrote AND solved the formula.</a:t>
-            </a:r>
-          </a:p>
-          <a:p>
-            <a:pPr lvl="1">
-              <a:spcAft>
-                <a:spcPts val="800"/>
-              </a:spcAft>
-            </a:pPr>
-            <a:r>
-              <a:rPr sz="2000">
-                <a:solidFill>
-                  <a:srgbClr val="212121"/>
-                </a:solidFill>
-              </a:rPr>
-              <a:t>Z3 is the SMT engine; ESBMC is a model checker built ON it — it calls Z3 underneath.</a:t>
-            </a:r>
-          </a:p>
-          <a:p>
-            <a:pPr lvl="1">
-              <a:spcAft>
-                <a:spcPts val="800"/>
-              </a:spcAft>
-            </a:pPr>
-            <a:r>
-              <a:rPr sz="2000">
-                <a:solidFill>
-                  <a:srgbClr val="212121"/>
-                </a:solidFill>
-              </a:rPr>
-              <a:t>Same bug, different number: 2^30 (your 32-bit BitVec) vs 2^63 — ESBMC models a Python int as 64-bit.</a:t>
+                <a:spcPts val="800"/>
+              </a:spcAft>
+            </a:pPr>
+            <a:r>
+              <a:rPr sz="2200">
+                <a:solidFill>
+                  <a:srgbClr val="212121"/>
+                </a:solidFill>
+              </a:rPr>
+              <a:t>ESBMC builds exactly this formula from your C — automatically. That's Lab 2.</a:t>
             </a:r>
           </a:p>
         </p:txBody>

</xml_diff>

<commit_message>
updated Session 2 slides
Signed-off-by: Lucas Cordeiro <lucasccordeiro@gmail.com>
</commit_message>
<xml_diff>
--- a/slides/session2/01-session2-hands-on.pptx
+++ b/slides/session2/01-session2-hands-on.pptx
@@ -5,30 +5,30 @@
     <p:sldMasterId id="2147483648" r:id="rId1"/>
   </p:sldMasterIdLst>
   <p:sldIdLst>
-    <p:sldId id="256" r:id="rId7"/>
-    <p:sldId id="257" r:id="rId8"/>
-    <p:sldId id="258" r:id="rId9"/>
-    <p:sldId id="259" r:id="rId10"/>
-    <p:sldId id="260" r:id="rId11"/>
-    <p:sldId id="261" r:id="rId12"/>
-    <p:sldId id="262" r:id="rId13"/>
-    <p:sldId id="263" r:id="rId14"/>
-    <p:sldId id="264" r:id="rId15"/>
-    <p:sldId id="265" r:id="rId16"/>
-    <p:sldId id="266" r:id="rId17"/>
-    <p:sldId id="267" r:id="rId18"/>
-    <p:sldId id="268" r:id="rId19"/>
-    <p:sldId id="269" r:id="rId20"/>
-    <p:sldId id="270" r:id="rId21"/>
-    <p:sldId id="271" r:id="rId22"/>
-    <p:sldId id="272" r:id="rId23"/>
-    <p:sldId id="273" r:id="rId24"/>
-    <p:sldId id="274" r:id="rId25"/>
-    <p:sldId id="275" r:id="rId26"/>
-    <p:sldId id="276" r:id="rId27"/>
-    <p:sldId id="277" r:id="rId28"/>
+    <p:sldId id="256" r:id="rId2"/>
+    <p:sldId id="257" r:id="rId3"/>
+    <p:sldId id="258" r:id="rId4"/>
+    <p:sldId id="259" r:id="rId5"/>
+    <p:sldId id="260" r:id="rId6"/>
+    <p:sldId id="261" r:id="rId7"/>
+    <p:sldId id="262" r:id="rId8"/>
+    <p:sldId id="263" r:id="rId9"/>
+    <p:sldId id="264" r:id="rId10"/>
+    <p:sldId id="265" r:id="rId11"/>
+    <p:sldId id="266" r:id="rId12"/>
+    <p:sldId id="267" r:id="rId13"/>
+    <p:sldId id="268" r:id="rId14"/>
+    <p:sldId id="269" r:id="rId15"/>
+    <p:sldId id="270" r:id="rId16"/>
+    <p:sldId id="271" r:id="rId17"/>
+    <p:sldId id="272" r:id="rId18"/>
+    <p:sldId id="273" r:id="rId19"/>
+    <p:sldId id="274" r:id="rId20"/>
+    <p:sldId id="275" r:id="rId21"/>
+    <p:sldId id="276" r:id="rId22"/>
+    <p:sldId id="277" r:id="rId23"/>
   </p:sldIdLst>
-  <p:sldSz cx="12191695" cy="6858000" type="screen4x3"/>
+  <p:sldSz cx="12192000" cy="6858000"/>
   <p:notesSz cx="6858000" cy="9144000"/>
   <p:defaultTextStyle>
     <a:defPPr>
@@ -125,6 +125,22 @@
       </a:defRPr>
     </a:lvl9pPr>
   </p:defaultTextStyle>
+  <p:extLst>
+    <p:ext uri="{EFAFB233-063F-42B5-8137-9DF3F51BA10A}">
+      <p15:sldGuideLst xmlns:p15="http://schemas.microsoft.com/office/powerpoint/2012/main">
+        <p15:guide id="1" orient="horz" pos="2160">
+          <p15:clr>
+            <a:srgbClr val="A4A3A4"/>
+          </p15:clr>
+        </p15:guide>
+        <p15:guide id="2" pos="2880">
+          <p15:clr>
+            <a:srgbClr val="A4A3A4"/>
+          </p15:clr>
+        </p15:guide>
+      </p15:sldGuideLst>
+    </p:ext>
+  </p:extLst>
 </p:presentation>
 </file>
 
@@ -166,10 +182,9 @@
           <a:lstStyle/>
           <a:p>
             <a:r>
-              <a:rPr lang="en-US" smtClean="0"/>
+              <a:rPr lang="en-US"/>
               <a:t>Click to edit Master title style</a:t>
             </a:r>
-            <a:endParaRPr lang="en-US"/>
           </a:p>
         </p:txBody>
       </p:sp>
@@ -285,10 +300,9 @@
           </a:lstStyle>
           <a:p>
             <a:r>
-              <a:rPr lang="en-US" smtClean="0"/>
+              <a:rPr lang="en-US"/>
               <a:t>Click to edit Master subtitle style</a:t>
             </a:r>
-            <a:endParaRPr lang="en-US"/>
           </a:p>
         </p:txBody>
       </p:sp>
@@ -309,7 +323,7 @@
           <a:p>
             <a:fld id="{5BCAD085-E8A6-8845-BD4E-CB4CCA059FC4}" type="datetimeFigureOut">
               <a:rPr lang="en-US" smtClean="0"/>
-              <a:t>1/27/13</a:t>
+              <a:t>6/13/26</a:t>
             </a:fld>
             <a:endParaRPr lang="en-US"/>
           </a:p>
@@ -403,10 +417,9 @@
           <a:lstStyle/>
           <a:p>
             <a:r>
-              <a:rPr lang="en-US" smtClean="0"/>
+              <a:rPr lang="en-US"/>
               <a:t>Click to edit Master title style</a:t>
             </a:r>
-            <a:endParaRPr lang="en-US"/>
           </a:p>
         </p:txBody>
       </p:sp>
@@ -427,38 +440,37 @@
           <a:p>
             <a:pPr lvl="0"/>
             <a:r>
-              <a:rPr lang="en-US" smtClean="0"/>
+              <a:rPr lang="en-US"/>
               <a:t>Click to edit Master text styles</a:t>
             </a:r>
           </a:p>
           <a:p>
             <a:pPr lvl="1"/>
             <a:r>
-              <a:rPr lang="en-US" smtClean="0"/>
+              <a:rPr lang="en-US"/>
               <a:t>Second level</a:t>
             </a:r>
           </a:p>
           <a:p>
             <a:pPr lvl="2"/>
             <a:r>
-              <a:rPr lang="en-US" smtClean="0"/>
+              <a:rPr lang="en-US"/>
               <a:t>Third level</a:t>
             </a:r>
           </a:p>
           <a:p>
             <a:pPr lvl="3"/>
             <a:r>
-              <a:rPr lang="en-US" smtClean="0"/>
+              <a:rPr lang="en-US"/>
               <a:t>Fourth level</a:t>
             </a:r>
           </a:p>
           <a:p>
             <a:pPr lvl="4"/>
             <a:r>
-              <a:rPr lang="en-US" smtClean="0"/>
+              <a:rPr lang="en-US"/>
               <a:t>Fifth level</a:t>
             </a:r>
-            <a:endParaRPr lang="en-US"/>
           </a:p>
         </p:txBody>
       </p:sp>
@@ -479,7 +491,7 @@
           <a:p>
             <a:fld id="{5BCAD085-E8A6-8845-BD4E-CB4CCA059FC4}" type="datetimeFigureOut">
               <a:rPr lang="en-US" smtClean="0"/>
-              <a:t>1/27/13</a:t>
+              <a:t>6/13/26</a:t>
             </a:fld>
             <a:endParaRPr lang="en-US"/>
           </a:p>
@@ -578,10 +590,9 @@
           <a:lstStyle/>
           <a:p>
             <a:r>
-              <a:rPr lang="en-US" smtClean="0"/>
+              <a:rPr lang="en-US"/>
               <a:t>Click to edit Master title style</a:t>
             </a:r>
-            <a:endParaRPr lang="en-US"/>
           </a:p>
         </p:txBody>
       </p:sp>
@@ -607,38 +618,37 @@
           <a:p>
             <a:pPr lvl="0"/>
             <a:r>
-              <a:rPr lang="en-US" smtClean="0"/>
+              <a:rPr lang="en-US"/>
               <a:t>Click to edit Master text styles</a:t>
             </a:r>
           </a:p>
           <a:p>
             <a:pPr lvl="1"/>
             <a:r>
-              <a:rPr lang="en-US" smtClean="0"/>
+              <a:rPr lang="en-US"/>
               <a:t>Second level</a:t>
             </a:r>
           </a:p>
           <a:p>
             <a:pPr lvl="2"/>
             <a:r>
-              <a:rPr lang="en-US" smtClean="0"/>
+              <a:rPr lang="en-US"/>
               <a:t>Third level</a:t>
             </a:r>
           </a:p>
           <a:p>
             <a:pPr lvl="3"/>
             <a:r>
-              <a:rPr lang="en-US" smtClean="0"/>
+              <a:rPr lang="en-US"/>
               <a:t>Fourth level</a:t>
             </a:r>
           </a:p>
           <a:p>
             <a:pPr lvl="4"/>
             <a:r>
-              <a:rPr lang="en-US" smtClean="0"/>
+              <a:rPr lang="en-US"/>
               <a:t>Fifth level</a:t>
             </a:r>
-            <a:endParaRPr lang="en-US"/>
           </a:p>
         </p:txBody>
       </p:sp>
@@ -659,7 +669,7 @@
           <a:p>
             <a:fld id="{5BCAD085-E8A6-8845-BD4E-CB4CCA059FC4}" type="datetimeFigureOut">
               <a:rPr lang="en-US" smtClean="0"/>
-              <a:t>1/27/13</a:t>
+              <a:t>6/13/26</a:t>
             </a:fld>
             <a:endParaRPr lang="en-US"/>
           </a:p>
@@ -753,10 +763,9 @@
           <a:lstStyle/>
           <a:p>
             <a:r>
-              <a:rPr lang="en-US" smtClean="0"/>
+              <a:rPr lang="en-US"/>
               <a:t>Click to edit Master title style</a:t>
             </a:r>
-            <a:endParaRPr lang="en-US"/>
           </a:p>
         </p:txBody>
       </p:sp>
@@ -777,38 +786,37 @@
           <a:p>
             <a:pPr lvl="0"/>
             <a:r>
-              <a:rPr lang="en-US" smtClean="0"/>
+              <a:rPr lang="en-US"/>
               <a:t>Click to edit Master text styles</a:t>
             </a:r>
           </a:p>
           <a:p>
             <a:pPr lvl="1"/>
             <a:r>
-              <a:rPr lang="en-US" smtClean="0"/>
+              <a:rPr lang="en-US"/>
               <a:t>Second level</a:t>
             </a:r>
           </a:p>
           <a:p>
             <a:pPr lvl="2"/>
             <a:r>
-              <a:rPr lang="en-US" smtClean="0"/>
+              <a:rPr lang="en-US"/>
               <a:t>Third level</a:t>
             </a:r>
           </a:p>
           <a:p>
             <a:pPr lvl="3"/>
             <a:r>
-              <a:rPr lang="en-US" smtClean="0"/>
+              <a:rPr lang="en-US"/>
               <a:t>Fourth level</a:t>
             </a:r>
           </a:p>
           <a:p>
             <a:pPr lvl="4"/>
             <a:r>
-              <a:rPr lang="en-US" smtClean="0"/>
+              <a:rPr lang="en-US"/>
               <a:t>Fifth level</a:t>
             </a:r>
-            <a:endParaRPr lang="en-US"/>
           </a:p>
         </p:txBody>
       </p:sp>
@@ -829,7 +837,7 @@
           <a:p>
             <a:fld id="{5BCAD085-E8A6-8845-BD4E-CB4CCA059FC4}" type="datetimeFigureOut">
               <a:rPr lang="en-US" smtClean="0"/>
-              <a:t>1/27/13</a:t>
+              <a:t>6/13/26</a:t>
             </a:fld>
             <a:endParaRPr lang="en-US"/>
           </a:p>
@@ -932,10 +940,9 @@
           </a:lstStyle>
           <a:p>
             <a:r>
-              <a:rPr lang="en-US" smtClean="0"/>
+              <a:rPr lang="en-US"/>
               <a:t>Click to edit Master title style</a:t>
             </a:r>
-            <a:endParaRPr lang="en-US"/>
           </a:p>
         </p:txBody>
       </p:sp>
@@ -1052,7 +1059,7 @@
           <a:p>
             <a:pPr lvl="0"/>
             <a:r>
-              <a:rPr lang="en-US" smtClean="0"/>
+              <a:rPr lang="en-US"/>
               <a:t>Click to edit Master text styles</a:t>
             </a:r>
           </a:p>
@@ -1075,7 +1082,7 @@
           <a:p>
             <a:fld id="{5BCAD085-E8A6-8845-BD4E-CB4CCA059FC4}" type="datetimeFigureOut">
               <a:rPr lang="en-US" smtClean="0"/>
-              <a:t>1/27/13</a:t>
+              <a:t>6/13/26</a:t>
             </a:fld>
             <a:endParaRPr lang="en-US"/>
           </a:p>
@@ -1169,10 +1176,9 @@
           <a:lstStyle/>
           <a:p>
             <a:r>
-              <a:rPr lang="en-US" smtClean="0"/>
+              <a:rPr lang="en-US"/>
               <a:t>Click to edit Master title style</a:t>
             </a:r>
-            <a:endParaRPr lang="en-US"/>
           </a:p>
         </p:txBody>
       </p:sp>
@@ -1226,38 +1232,37 @@
           <a:p>
             <a:pPr lvl="0"/>
             <a:r>
-              <a:rPr lang="en-US" smtClean="0"/>
+              <a:rPr lang="en-US"/>
               <a:t>Click to edit Master text styles</a:t>
             </a:r>
           </a:p>
           <a:p>
             <a:pPr lvl="1"/>
             <a:r>
-              <a:rPr lang="en-US" smtClean="0"/>
+              <a:rPr lang="en-US"/>
               <a:t>Second level</a:t>
             </a:r>
           </a:p>
           <a:p>
             <a:pPr lvl="2"/>
             <a:r>
-              <a:rPr lang="en-US" smtClean="0"/>
+              <a:rPr lang="en-US"/>
               <a:t>Third level</a:t>
             </a:r>
           </a:p>
           <a:p>
             <a:pPr lvl="3"/>
             <a:r>
-              <a:rPr lang="en-US" smtClean="0"/>
+              <a:rPr lang="en-US"/>
               <a:t>Fourth level</a:t>
             </a:r>
           </a:p>
           <a:p>
             <a:pPr lvl="4"/>
             <a:r>
-              <a:rPr lang="en-US" smtClean="0"/>
+              <a:rPr lang="en-US"/>
               <a:t>Fifth level</a:t>
             </a:r>
-            <a:endParaRPr lang="en-US"/>
           </a:p>
         </p:txBody>
       </p:sp>
@@ -1311,38 +1316,37 @@
           <a:p>
             <a:pPr lvl="0"/>
             <a:r>
-              <a:rPr lang="en-US" smtClean="0"/>
+              <a:rPr lang="en-US"/>
               <a:t>Click to edit Master text styles</a:t>
             </a:r>
           </a:p>
           <a:p>
             <a:pPr lvl="1"/>
             <a:r>
-              <a:rPr lang="en-US" smtClean="0"/>
+              <a:rPr lang="en-US"/>
               <a:t>Second level</a:t>
             </a:r>
           </a:p>
           <a:p>
             <a:pPr lvl="2"/>
             <a:r>
-              <a:rPr lang="en-US" smtClean="0"/>
+              <a:rPr lang="en-US"/>
               <a:t>Third level</a:t>
             </a:r>
           </a:p>
           <a:p>
             <a:pPr lvl="3"/>
             <a:r>
-              <a:rPr lang="en-US" smtClean="0"/>
+              <a:rPr lang="en-US"/>
               <a:t>Fourth level</a:t>
             </a:r>
           </a:p>
           <a:p>
             <a:pPr lvl="4"/>
             <a:r>
-              <a:rPr lang="en-US" smtClean="0"/>
+              <a:rPr lang="en-US"/>
               <a:t>Fifth level</a:t>
             </a:r>
-            <a:endParaRPr lang="en-US"/>
           </a:p>
         </p:txBody>
       </p:sp>
@@ -1363,7 +1367,7 @@
           <a:p>
             <a:fld id="{5BCAD085-E8A6-8845-BD4E-CB4CCA059FC4}" type="datetimeFigureOut">
               <a:rPr lang="en-US" smtClean="0"/>
-              <a:t>1/27/13</a:t>
+              <a:t>6/13/26</a:t>
             </a:fld>
             <a:endParaRPr lang="en-US"/>
           </a:p>
@@ -1461,10 +1465,9 @@
           </a:lstStyle>
           <a:p>
             <a:r>
-              <a:rPr lang="en-US" smtClean="0"/>
+              <a:rPr lang="en-US"/>
               <a:t>Click to edit Master title style</a:t>
             </a:r>
-            <a:endParaRPr lang="en-US"/>
           </a:p>
         </p:txBody>
       </p:sp>
@@ -1527,7 +1530,7 @@
           <a:p>
             <a:pPr lvl="0"/>
             <a:r>
-              <a:rPr lang="en-US" smtClean="0"/>
+              <a:rPr lang="en-US"/>
               <a:t>Click to edit Master text styles</a:t>
             </a:r>
           </a:p>
@@ -1583,38 +1586,37 @@
           <a:p>
             <a:pPr lvl="0"/>
             <a:r>
-              <a:rPr lang="en-US" smtClean="0"/>
+              <a:rPr lang="en-US"/>
               <a:t>Click to edit Master text styles</a:t>
             </a:r>
           </a:p>
           <a:p>
             <a:pPr lvl="1"/>
             <a:r>
-              <a:rPr lang="en-US" smtClean="0"/>
+              <a:rPr lang="en-US"/>
               <a:t>Second level</a:t>
             </a:r>
           </a:p>
           <a:p>
             <a:pPr lvl="2"/>
             <a:r>
-              <a:rPr lang="en-US" smtClean="0"/>
+              <a:rPr lang="en-US"/>
               <a:t>Third level</a:t>
             </a:r>
           </a:p>
           <a:p>
             <a:pPr lvl="3"/>
             <a:r>
-              <a:rPr lang="en-US" smtClean="0"/>
+              <a:rPr lang="en-US"/>
               <a:t>Fourth level</a:t>
             </a:r>
           </a:p>
           <a:p>
             <a:pPr lvl="4"/>
             <a:r>
-              <a:rPr lang="en-US" smtClean="0"/>
+              <a:rPr lang="en-US"/>
               <a:t>Fifth level</a:t>
             </a:r>
-            <a:endParaRPr lang="en-US"/>
           </a:p>
         </p:txBody>
       </p:sp>
@@ -1677,7 +1679,7 @@
           <a:p>
             <a:pPr lvl="0"/>
             <a:r>
-              <a:rPr lang="en-US" smtClean="0"/>
+              <a:rPr lang="en-US"/>
               <a:t>Click to edit Master text styles</a:t>
             </a:r>
           </a:p>
@@ -1733,38 +1735,37 @@
           <a:p>
             <a:pPr lvl="0"/>
             <a:r>
-              <a:rPr lang="en-US" smtClean="0"/>
+              <a:rPr lang="en-US"/>
               <a:t>Click to edit Master text styles</a:t>
             </a:r>
           </a:p>
           <a:p>
             <a:pPr lvl="1"/>
             <a:r>
-              <a:rPr lang="en-US" smtClean="0"/>
+              <a:rPr lang="en-US"/>
               <a:t>Second level</a:t>
             </a:r>
           </a:p>
           <a:p>
             <a:pPr lvl="2"/>
             <a:r>
-              <a:rPr lang="en-US" smtClean="0"/>
+              <a:rPr lang="en-US"/>
               <a:t>Third level</a:t>
             </a:r>
           </a:p>
           <a:p>
             <a:pPr lvl="3"/>
             <a:r>
-              <a:rPr lang="en-US" smtClean="0"/>
+              <a:rPr lang="en-US"/>
               <a:t>Fourth level</a:t>
             </a:r>
           </a:p>
           <a:p>
             <a:pPr lvl="4"/>
             <a:r>
-              <a:rPr lang="en-US" smtClean="0"/>
+              <a:rPr lang="en-US"/>
               <a:t>Fifth level</a:t>
             </a:r>
-            <a:endParaRPr lang="en-US"/>
           </a:p>
         </p:txBody>
       </p:sp>
@@ -1785,7 +1786,7 @@
           <a:p>
             <a:fld id="{5BCAD085-E8A6-8845-BD4E-CB4CCA059FC4}" type="datetimeFigureOut">
               <a:rPr lang="en-US" smtClean="0"/>
-              <a:t>1/27/13</a:t>
+              <a:t>6/13/26</a:t>
             </a:fld>
             <a:endParaRPr lang="en-US"/>
           </a:p>
@@ -1879,10 +1880,9 @@
           <a:lstStyle/>
           <a:p>
             <a:r>
-              <a:rPr lang="en-US" smtClean="0"/>
+              <a:rPr lang="en-US"/>
               <a:t>Click to edit Master title style</a:t>
             </a:r>
-            <a:endParaRPr lang="en-US"/>
           </a:p>
         </p:txBody>
       </p:sp>
@@ -1903,7 +1903,7 @@
           <a:p>
             <a:fld id="{5BCAD085-E8A6-8845-BD4E-CB4CCA059FC4}" type="datetimeFigureOut">
               <a:rPr lang="en-US" smtClean="0"/>
-              <a:t>1/27/13</a:t>
+              <a:t>6/13/26</a:t>
             </a:fld>
             <a:endParaRPr lang="en-US"/>
           </a:p>
@@ -1998,7 +1998,7 @@
           <a:p>
             <a:fld id="{5BCAD085-E8A6-8845-BD4E-CB4CCA059FC4}" type="datetimeFigureOut">
               <a:rPr lang="en-US" smtClean="0"/>
-              <a:t>1/27/13</a:t>
+              <a:t>6/13/26</a:t>
             </a:fld>
             <a:endParaRPr lang="en-US"/>
           </a:p>
@@ -2101,10 +2101,9 @@
           </a:lstStyle>
           <a:p>
             <a:r>
-              <a:rPr lang="en-US" smtClean="0"/>
+              <a:rPr lang="en-US"/>
               <a:t>Click to edit Master title style</a:t>
             </a:r>
-            <a:endParaRPr lang="en-US"/>
           </a:p>
         </p:txBody>
       </p:sp>
@@ -2158,38 +2157,37 @@
           <a:p>
             <a:pPr lvl="0"/>
             <a:r>
-              <a:rPr lang="en-US" smtClean="0"/>
+              <a:rPr lang="en-US"/>
               <a:t>Click to edit Master text styles</a:t>
             </a:r>
           </a:p>
           <a:p>
             <a:pPr lvl="1"/>
             <a:r>
-              <a:rPr lang="en-US" smtClean="0"/>
+              <a:rPr lang="en-US"/>
               <a:t>Second level</a:t>
             </a:r>
           </a:p>
           <a:p>
             <a:pPr lvl="2"/>
             <a:r>
-              <a:rPr lang="en-US" smtClean="0"/>
+              <a:rPr lang="en-US"/>
               <a:t>Third level</a:t>
             </a:r>
           </a:p>
           <a:p>
             <a:pPr lvl="3"/>
             <a:r>
-              <a:rPr lang="en-US" smtClean="0"/>
+              <a:rPr lang="en-US"/>
               <a:t>Fourth level</a:t>
             </a:r>
           </a:p>
           <a:p>
             <a:pPr lvl="4"/>
             <a:r>
-              <a:rPr lang="en-US" smtClean="0"/>
+              <a:rPr lang="en-US"/>
               <a:t>Fifth level</a:t>
             </a:r>
-            <a:endParaRPr lang="en-US"/>
           </a:p>
         </p:txBody>
       </p:sp>
@@ -2252,7 +2250,7 @@
           <a:p>
             <a:pPr lvl="0"/>
             <a:r>
-              <a:rPr lang="en-US" smtClean="0"/>
+              <a:rPr lang="en-US"/>
               <a:t>Click to edit Master text styles</a:t>
             </a:r>
           </a:p>
@@ -2275,7 +2273,7 @@
           <a:p>
             <a:fld id="{5BCAD085-E8A6-8845-BD4E-CB4CCA059FC4}" type="datetimeFigureOut">
               <a:rPr lang="en-US" smtClean="0"/>
-              <a:t>1/27/13</a:t>
+              <a:t>6/13/26</a:t>
             </a:fld>
             <a:endParaRPr lang="en-US"/>
           </a:p>
@@ -2378,10 +2376,9 @@
           </a:lstStyle>
           <a:p>
             <a:r>
-              <a:rPr lang="en-US" smtClean="0"/>
+              <a:rPr lang="en-US"/>
               <a:t>Click to edit Master title style</a:t>
             </a:r>
-            <a:endParaRPr lang="en-US"/>
           </a:p>
         </p:txBody>
       </p:sp>
@@ -2505,7 +2502,7 @@
           <a:p>
             <a:pPr lvl="0"/>
             <a:r>
-              <a:rPr lang="en-US" smtClean="0"/>
+              <a:rPr lang="en-US"/>
               <a:t>Click to edit Master text styles</a:t>
             </a:r>
           </a:p>
@@ -2528,7 +2525,7 @@
           <a:p>
             <a:fld id="{5BCAD085-E8A6-8845-BD4E-CB4CCA059FC4}" type="datetimeFigureOut">
               <a:rPr lang="en-US" smtClean="0"/>
-              <a:t>1/27/13</a:t>
+              <a:t>6/13/26</a:t>
             </a:fld>
             <a:endParaRPr lang="en-US"/>
           </a:p>
@@ -2637,10 +2634,9 @@
           <a:lstStyle/>
           <a:p>
             <a:r>
-              <a:rPr lang="en-US" smtClean="0"/>
+              <a:rPr lang="en-US"/>
               <a:t>Click to edit Master title style</a:t>
             </a:r>
-            <a:endParaRPr lang="en-US"/>
           </a:p>
         </p:txBody>
       </p:sp>
@@ -2671,38 +2667,37 @@
           <a:p>
             <a:pPr lvl="0"/>
             <a:r>
-              <a:rPr lang="en-US" smtClean="0"/>
+              <a:rPr lang="en-US"/>
               <a:t>Click to edit Master text styles</a:t>
             </a:r>
           </a:p>
           <a:p>
             <a:pPr lvl="1"/>
             <a:r>
-              <a:rPr lang="en-US" smtClean="0"/>
+              <a:rPr lang="en-US"/>
               <a:t>Second level</a:t>
             </a:r>
           </a:p>
           <a:p>
             <a:pPr lvl="2"/>
             <a:r>
-              <a:rPr lang="en-US" smtClean="0"/>
+              <a:rPr lang="en-US"/>
               <a:t>Third level</a:t>
             </a:r>
           </a:p>
           <a:p>
             <a:pPr lvl="3"/>
             <a:r>
-              <a:rPr lang="en-US" smtClean="0"/>
+              <a:rPr lang="en-US"/>
               <a:t>Fourth level</a:t>
             </a:r>
           </a:p>
           <a:p>
             <a:pPr lvl="4"/>
             <a:r>
-              <a:rPr lang="en-US" smtClean="0"/>
+              <a:rPr lang="en-US"/>
               <a:t>Fifth level</a:t>
             </a:r>
-            <a:endParaRPr lang="en-US"/>
           </a:p>
         </p:txBody>
       </p:sp>
@@ -2741,7 +2736,7 @@
           <a:p>
             <a:fld id="{5BCAD085-E8A6-8845-BD4E-CB4CCA059FC4}" type="datetimeFigureOut">
               <a:rPr lang="en-US" smtClean="0"/>
-              <a:t>1/27/13</a:t>
+              <a:t>6/13/26</a:t>
             </a:fld>
             <a:endParaRPr lang="en-US"/>
           </a:p>
@@ -3100,7 +3095,7 @@
 </file>
 
 <file path=ppt/slides/slide1.xml><?xml version="1.0" encoding="utf-8"?>
-<p:sld xmlns:a="http://schemas.openxmlformats.org/drawingml/2006/main" xmlns:p="http://schemas.openxmlformats.org/presentationml/2006/main" xmlns:r="http://schemas.openxmlformats.org/officeDocument/2006/relationships">
+<p:sld xmlns:a="http://schemas.openxmlformats.org/drawingml/2006/main" xmlns:r="http://schemas.openxmlformats.org/officeDocument/2006/relationships" xmlns:p="http://schemas.openxmlformats.org/presentationml/2006/main">
   <p:cSld>
     <p:spTree>
       <p:nvGrpSpPr>
@@ -3108,7 +3103,14 @@
         <p:cNvGrpSpPr/>
         <p:nvPr/>
       </p:nvGrpSpPr>
-      <p:grpSpPr/>
+      <p:grpSpPr>
+        <a:xfrm>
+          <a:off x="0" y="0"/>
+          <a:ext cx="0" cy="0"/>
+          <a:chOff x="0" y="0"/>
+          <a:chExt cx="0" cy="0"/>
+        </a:xfrm>
+      </p:grpSpPr>
       <p:sp>
         <p:nvSpPr>
           <p:cNvPr id="2" name="TextBox 1"/>
@@ -3219,7 +3221,7 @@
 </file>
 
 <file path=ppt/slides/slide10.xml><?xml version="1.0" encoding="utf-8"?>
-<p:sld xmlns:a="http://schemas.openxmlformats.org/drawingml/2006/main" xmlns:p="http://schemas.openxmlformats.org/presentationml/2006/main" xmlns:r="http://schemas.openxmlformats.org/officeDocument/2006/relationships">
+<p:sld xmlns:a="http://schemas.openxmlformats.org/drawingml/2006/main" xmlns:r="http://schemas.openxmlformats.org/officeDocument/2006/relationships" xmlns:p="http://schemas.openxmlformats.org/presentationml/2006/main">
   <p:cSld>
     <p:spTree>
       <p:nvGrpSpPr>
@@ -3227,7 +3229,14 @@
         <p:cNvGrpSpPr/>
         <p:nvPr/>
       </p:nvGrpSpPr>
-      <p:grpSpPr/>
+      <p:grpSpPr>
+        <a:xfrm>
+          <a:off x="0" y="0"/>
+          <a:ext cx="0" cy="0"/>
+          <a:chOff x="0" y="0"/>
+          <a:chExt cx="0" cy="0"/>
+        </a:xfrm>
+      </p:grpSpPr>
       <p:sp>
         <p:nvSpPr>
           <p:cNvPr id="2" name="TextBox 1"/>
@@ -3289,7 +3298,7 @@
               </a:spcAft>
             </a:pPr>
             <a:r>
-              <a:rPr sz="1800">
+              <a:rPr sz="1800" dirty="0">
                 <a:solidFill>
                   <a:srgbClr val="212121"/>
                 </a:solidFill>
@@ -3305,7 +3314,7 @@
               </a:spcAft>
             </a:pPr>
             <a:r>
-              <a:rPr sz="1800">
+              <a:rPr sz="1800" dirty="0">
                 <a:solidFill>
                   <a:srgbClr val="212121"/>
                 </a:solidFill>
@@ -3321,7 +3330,7 @@
               </a:spcAft>
             </a:pPr>
             <a:r>
-              <a:rPr sz="1800">
+              <a:rPr sz="1800" dirty="0">
                 <a:solidFill>
                   <a:srgbClr val="212121"/>
                 </a:solidFill>
@@ -3337,7 +3346,7 @@
               </a:spcAft>
             </a:pPr>
             <a:r>
-              <a:rPr sz="1800">
+              <a:rPr sz="1800" dirty="0">
                 <a:solidFill>
                   <a:srgbClr val="212121"/>
                 </a:solidFill>
@@ -3353,13 +3362,49 @@
               </a:spcAft>
             </a:pPr>
             <a:r>
-              <a:rPr sz="1800">
+              <a:rPr sz="1800" dirty="0">
                 <a:solidFill>
                   <a:srgbClr val="212121"/>
                 </a:solidFill>
                 <a:latin typeface="Courier New"/>
               </a:rPr>
-              <a:t>x: int = nondet_int()    # every int at once, like BitVec("x")</a:t>
+              <a:t>x: int = </a:t>
+            </a:r>
+            <a:r>
+              <a:rPr sz="1800" dirty="0" err="1">
+                <a:solidFill>
+                  <a:srgbClr val="212121"/>
+                </a:solidFill>
+                <a:latin typeface="Courier New"/>
+              </a:rPr>
+              <a:t>nondet_int</a:t>
+            </a:r>
+            <a:r>
+              <a:rPr sz="1800" dirty="0">
+                <a:solidFill>
+                  <a:srgbClr val="212121"/>
+                </a:solidFill>
+                <a:latin typeface="Courier New"/>
+              </a:rPr>
+              <a:t>()    # every int at once, like </a:t>
+            </a:r>
+            <a:r>
+              <a:rPr sz="1800" dirty="0" err="1">
+                <a:solidFill>
+                  <a:srgbClr val="212121"/>
+                </a:solidFill>
+                <a:latin typeface="Courier New"/>
+              </a:rPr>
+              <a:t>BitVec</a:t>
+            </a:r>
+            <a:r>
+              <a:rPr sz="1800" dirty="0">
+                <a:solidFill>
+                  <a:srgbClr val="212121"/>
+                </a:solidFill>
+                <a:latin typeface="Courier New"/>
+              </a:rPr>
+              <a:t>("x")</a:t>
             </a:r>
           </a:p>
           <a:p>
@@ -3369,7 +3414,7 @@
               </a:spcAft>
             </a:pPr>
             <a:r>
-              <a:rPr sz="1800">
+              <a:rPr sz="1800" dirty="0">
                 <a:solidFill>
                   <a:srgbClr val="212121"/>
                 </a:solidFill>
@@ -3384,14 +3429,12 @@
                 <a:spcPts val="800"/>
               </a:spcAft>
             </a:pPr>
-            <a:r>
-              <a:rPr sz="2200">
-                <a:solidFill>
-                  <a:srgbClr val="212121"/>
-                </a:solidFill>
-              </a:rPr>
-              <a:t/>
-            </a:r>
+            <a:endParaRPr sz="1800" dirty="0">
+              <a:solidFill>
+                <a:srgbClr val="212121"/>
+              </a:solidFill>
+              <a:latin typeface="Courier New"/>
+            </a:endParaRPr>
           </a:p>
           <a:p>
             <a:pPr>
@@ -3400,13 +3443,22 @@
               </a:spcAft>
             </a:pPr>
             <a:r>
-              <a:rPr sz="1800">
+              <a:rPr sz="1800" dirty="0" err="1">
                 <a:solidFill>
                   <a:srgbClr val="212121"/>
                 </a:solidFill>
                 <a:latin typeface="Courier New"/>
               </a:rPr>
-              <a:t>esbmc stage3_esbmc.py  →  VERIFICATION FAILED   (x = 2^63 - 1)</a:t>
+              <a:t>esbmc</a:t>
+            </a:r>
+            <a:r>
+              <a:rPr sz="1800" dirty="0">
+                <a:solidFill>
+                  <a:srgbClr val="212121"/>
+                </a:solidFill>
+                <a:latin typeface="Courier New"/>
+              </a:rPr>
+              <a:t> stage3_esbmc.py  →  VERIFICATION FAILED   (x = 2^63 - 1)</a:t>
             </a:r>
           </a:p>
           <a:p>
@@ -3416,7 +3468,7 @@
               </a:spcAft>
             </a:pPr>
             <a:r>
-              <a:rPr sz="2000">
+              <a:rPr sz="2000" dirty="0">
                 <a:solidFill>
                   <a:srgbClr val="212121"/>
                 </a:solidFill>
@@ -3431,7 +3483,7 @@
               </a:spcAft>
             </a:pPr>
             <a:r>
-              <a:rPr sz="2000">
+              <a:rPr sz="2000" dirty="0">
                 <a:solidFill>
                   <a:srgbClr val="212121"/>
                 </a:solidFill>
@@ -3446,12 +3498,28 @@
               </a:spcAft>
             </a:pPr>
             <a:r>
-              <a:rPr sz="2000">
-                <a:solidFill>
-                  <a:srgbClr val="212121"/>
-                </a:solidFill>
-              </a:rPr>
-              <a:t>Same bug, different number: 2^30 (your 32-bit BitVec) vs 2^63 — ESBMC models a Python int as 64-bit.</a:t>
+              <a:rPr sz="2000" dirty="0">
+                <a:solidFill>
+                  <a:srgbClr val="212121"/>
+                </a:solidFill>
+              </a:rPr>
+              <a:t>Same bug, different number: 2^30 (your 32-bit </a:t>
+            </a:r>
+            <a:r>
+              <a:rPr sz="2000" dirty="0" err="1">
+                <a:solidFill>
+                  <a:srgbClr val="212121"/>
+                </a:solidFill>
+              </a:rPr>
+              <a:t>BitVec</a:t>
+            </a:r>
+            <a:r>
+              <a:rPr sz="2000" dirty="0">
+                <a:solidFill>
+                  <a:srgbClr val="212121"/>
+                </a:solidFill>
+              </a:rPr>
+              <a:t>) vs 2^63 — ESBMC models a Python int as 64-bit.</a:t>
             </a:r>
           </a:p>
         </p:txBody>
@@ -3465,7 +3533,7 @@
 </file>
 
 <file path=ppt/slides/slide11.xml><?xml version="1.0" encoding="utf-8"?>
-<p:sld xmlns:a="http://schemas.openxmlformats.org/drawingml/2006/main" xmlns:p="http://schemas.openxmlformats.org/presentationml/2006/main" xmlns:r="http://schemas.openxmlformats.org/officeDocument/2006/relationships">
+<p:sld xmlns:a="http://schemas.openxmlformats.org/drawingml/2006/main" xmlns:r="http://schemas.openxmlformats.org/officeDocument/2006/relationships" xmlns:p="http://schemas.openxmlformats.org/presentationml/2006/main">
   <p:cSld>
     <p:spTree>
       <p:nvGrpSpPr>
@@ -3473,7 +3541,14 @@
         <p:cNvGrpSpPr/>
         <p:nvPr/>
       </p:nvGrpSpPr>
-      <p:grpSpPr/>
+      <p:grpSpPr>
+        <a:xfrm>
+          <a:off x="0" y="0"/>
+          <a:ext cx="0" cy="0"/>
+          <a:chOff x="0" y="0"/>
+          <a:chExt cx="0" cy="0"/>
+        </a:xfrm>
+      </p:grpSpPr>
       <p:sp>
         <p:nvSpPr>
           <p:cNvPr id="2" name="TextBox 1"/>
@@ -3564,14 +3639,11 @@
                 <a:spcPts val="800"/>
               </a:spcAft>
             </a:pPr>
-            <a:r>
-              <a:rPr sz="2800">
-                <a:solidFill>
-                  <a:srgbClr val="212121"/>
-                </a:solidFill>
-              </a:rPr>
-              <a:t/>
-            </a:r>
+            <a:endParaRPr sz="2800">
+              <a:solidFill>
+                <a:srgbClr val="212121"/>
+              </a:solidFill>
+            </a:endParaRPr>
           </a:p>
           <a:p>
             <a:pPr>
@@ -3599,7 +3671,7 @@
 </file>
 
 <file path=ppt/slides/slide12.xml><?xml version="1.0" encoding="utf-8"?>
-<p:sld xmlns:a="http://schemas.openxmlformats.org/drawingml/2006/main" xmlns:p="http://schemas.openxmlformats.org/presentationml/2006/main" xmlns:r="http://schemas.openxmlformats.org/officeDocument/2006/relationships">
+<p:sld xmlns:a="http://schemas.openxmlformats.org/drawingml/2006/main" xmlns:r="http://schemas.openxmlformats.org/officeDocument/2006/relationships" xmlns:p="http://schemas.openxmlformats.org/presentationml/2006/main">
   <p:cSld>
     <p:spTree>
       <p:nvGrpSpPr>
@@ -3607,7 +3679,14 @@
         <p:cNvGrpSpPr/>
         <p:nvPr/>
       </p:nvGrpSpPr>
-      <p:grpSpPr/>
+      <p:grpSpPr>
+        <a:xfrm>
+          <a:off x="0" y="0"/>
+          <a:ext cx="0" cy="0"/>
+          <a:chOff x="0" y="0"/>
+          <a:chExt cx="0" cy="0"/>
+        </a:xfrm>
+      </p:grpSpPr>
       <p:sp>
         <p:nvSpPr>
           <p:cNvPr id="2" name="TextBox 1"/>
@@ -3698,9 +3777,27 @@
                 <a:tableStyleId>{5C22544A-7EE6-4342-B048-85BDC9FD1C3A}</a:tableStyleId>
               </a:tblPr>
               <a:tblGrid>
-                <a:gridCol w="731520"/>
-                <a:gridCol w="4754880"/>
-                <a:gridCol w="2011680"/>
+                <a:gridCol w="731520">
+                  <a:extLst>
+                    <a:ext uri="{9D8B030D-6E8A-4147-A177-3AD203B41FA5}">
+                      <a16:colId xmlns:a16="http://schemas.microsoft.com/office/drawing/2014/main" val="20000"/>
+                    </a:ext>
+                  </a:extLst>
+                </a:gridCol>
+                <a:gridCol w="4754880">
+                  <a:extLst>
+                    <a:ext uri="{9D8B030D-6E8A-4147-A177-3AD203B41FA5}">
+                      <a16:colId xmlns:a16="http://schemas.microsoft.com/office/drawing/2014/main" val="20001"/>
+                    </a:ext>
+                  </a:extLst>
+                </a:gridCol>
+                <a:gridCol w="2011680">
+                  <a:extLst>
+                    <a:ext uri="{9D8B030D-6E8A-4147-A177-3AD203B41FA5}">
+                      <a16:colId xmlns:a16="http://schemas.microsoft.com/office/drawing/2014/main" val="20002"/>
+                    </a:ext>
+                  </a:extLst>
+                </a:gridCol>
               </a:tblGrid>
               <a:tr h="365760">
                 <a:tc>
@@ -3742,6 +3839,11 @@
                   </a:txBody>
                   <a:tcPr/>
                 </a:tc>
+                <a:extLst>
+                  <a:ext uri="{0D108BD9-81ED-4DB2-BD59-A6C34878D82A}">
+                    <a16:rowId xmlns:a16="http://schemas.microsoft.com/office/drawing/2014/main" val="10000"/>
+                  </a:ext>
+                </a:extLst>
               </a:tr>
               <a:tr h="365760">
                 <a:tc>
@@ -3783,6 +3885,11 @@
                   </a:txBody>
                   <a:tcPr/>
                 </a:tc>
+                <a:extLst>
+                  <a:ext uri="{0D108BD9-81ED-4DB2-BD59-A6C34878D82A}">
+                    <a16:rowId xmlns:a16="http://schemas.microsoft.com/office/drawing/2014/main" val="10001"/>
+                  </a:ext>
+                </a:extLst>
               </a:tr>
               <a:tr h="365760">
                 <a:tc>
@@ -3824,6 +3931,11 @@
                   </a:txBody>
                   <a:tcPr/>
                 </a:tc>
+                <a:extLst>
+                  <a:ext uri="{0D108BD9-81ED-4DB2-BD59-A6C34878D82A}">
+                    <a16:rowId xmlns:a16="http://schemas.microsoft.com/office/drawing/2014/main" val="10002"/>
+                  </a:ext>
+                </a:extLst>
               </a:tr>
               <a:tr h="365760">
                 <a:tc>
@@ -3865,6 +3977,11 @@
                   </a:txBody>
                   <a:tcPr/>
                 </a:tc>
+                <a:extLst>
+                  <a:ext uri="{0D108BD9-81ED-4DB2-BD59-A6C34878D82A}">
+                    <a16:rowId xmlns:a16="http://schemas.microsoft.com/office/drawing/2014/main" val="10003"/>
+                  </a:ext>
+                </a:extLst>
               </a:tr>
               <a:tr h="365760">
                 <a:tc>
@@ -3906,6 +4023,11 @@
                   </a:txBody>
                   <a:tcPr/>
                 </a:tc>
+                <a:extLst>
+                  <a:ext uri="{0D108BD9-81ED-4DB2-BD59-A6C34878D82A}">
+                    <a16:rowId xmlns:a16="http://schemas.microsoft.com/office/drawing/2014/main" val="10004"/>
+                  </a:ext>
+                </a:extLst>
               </a:tr>
             </a:tbl>
           </a:graphicData>
@@ -3989,7 +4111,7 @@
 </file>
 
 <file path=ppt/slides/slide13.xml><?xml version="1.0" encoding="utf-8"?>
-<p:sld xmlns:a="http://schemas.openxmlformats.org/drawingml/2006/main" xmlns:p="http://schemas.openxmlformats.org/presentationml/2006/main" xmlns:r="http://schemas.openxmlformats.org/officeDocument/2006/relationships">
+<p:sld xmlns:a="http://schemas.openxmlformats.org/drawingml/2006/main" xmlns:r="http://schemas.openxmlformats.org/officeDocument/2006/relationships" xmlns:p="http://schemas.openxmlformats.org/presentationml/2006/main">
   <p:cSld>
     <p:spTree>
       <p:nvGrpSpPr>
@@ -3997,7 +4119,14 @@
         <p:cNvGrpSpPr/>
         <p:nvPr/>
       </p:nvGrpSpPr>
-      <p:grpSpPr/>
+      <p:grpSpPr>
+        <a:xfrm>
+          <a:off x="0" y="0"/>
+          <a:ext cx="0" cy="0"/>
+          <a:chOff x="0" y="0"/>
+          <a:chExt cx="0" cy="0"/>
+        </a:xfrm>
+      </p:grpSpPr>
       <p:sp>
         <p:nvSpPr>
           <p:cNvPr id="2" name="TextBox 1"/>
@@ -4185,14 +4314,12 @@
                 <a:spcPts val="800"/>
               </a:spcAft>
             </a:pPr>
-            <a:r>
-              <a:rPr sz="2200">
-                <a:solidFill>
-                  <a:srgbClr val="212121"/>
-                </a:solidFill>
-              </a:rPr>
-              <a:t/>
-            </a:r>
+            <a:endParaRPr sz="1800">
+              <a:solidFill>
+                <a:srgbClr val="212121"/>
+              </a:solidFill>
+              <a:latin typeface="Courier New"/>
+            </a:endParaRPr>
           </a:p>
           <a:p>
             <a:pPr>
@@ -4220,7 +4347,7 @@
 </file>
 
 <file path=ppt/slides/slide14.xml><?xml version="1.0" encoding="utf-8"?>
-<p:sld xmlns:a="http://schemas.openxmlformats.org/drawingml/2006/main" xmlns:p="http://schemas.openxmlformats.org/presentationml/2006/main" xmlns:r="http://schemas.openxmlformats.org/officeDocument/2006/relationships">
+<p:sld xmlns:a="http://schemas.openxmlformats.org/drawingml/2006/main" xmlns:r="http://schemas.openxmlformats.org/officeDocument/2006/relationships" xmlns:p="http://schemas.openxmlformats.org/presentationml/2006/main">
   <p:cSld>
     <p:spTree>
       <p:nvGrpSpPr>
@@ -4228,7 +4355,14 @@
         <p:cNvGrpSpPr/>
         <p:nvPr/>
       </p:nvGrpSpPr>
-      <p:grpSpPr/>
+      <p:grpSpPr>
+        <a:xfrm>
+          <a:off x="0" y="0"/>
+          <a:ext cx="0" cy="0"/>
+          <a:chOff x="0" y="0"/>
+          <a:chExt cx="0" cy="0"/>
+        </a:xfrm>
+      </p:grpSpPr>
       <p:sp>
         <p:nvSpPr>
           <p:cNvPr id="2" name="TextBox 1"/>
@@ -4385,14 +4519,12 @@
                 <a:spcPts val="800"/>
               </a:spcAft>
             </a:pPr>
-            <a:r>
-              <a:rPr sz="2200">
-                <a:solidFill>
-                  <a:srgbClr val="212121"/>
-                </a:solidFill>
-              </a:rPr>
-              <a:t/>
-            </a:r>
+            <a:endParaRPr sz="1800">
+              <a:solidFill>
+                <a:srgbClr val="212121"/>
+              </a:solidFill>
+              <a:latin typeface="Courier New"/>
+            </a:endParaRPr>
           </a:p>
           <a:p>
             <a:pPr lvl="1">
@@ -4450,7 +4582,7 @@
 </file>
 
 <file path=ppt/slides/slide15.xml><?xml version="1.0" encoding="utf-8"?>
-<p:sld xmlns:a="http://schemas.openxmlformats.org/drawingml/2006/main" xmlns:p="http://schemas.openxmlformats.org/presentationml/2006/main" xmlns:r="http://schemas.openxmlformats.org/officeDocument/2006/relationships">
+<p:sld xmlns:a="http://schemas.openxmlformats.org/drawingml/2006/main" xmlns:r="http://schemas.openxmlformats.org/officeDocument/2006/relationships" xmlns:p="http://schemas.openxmlformats.org/presentationml/2006/main">
   <p:cSld>
     <p:spTree>
       <p:nvGrpSpPr>
@@ -4458,7 +4590,14 @@
         <p:cNvGrpSpPr/>
         <p:nvPr/>
       </p:nvGrpSpPr>
-      <p:grpSpPr/>
+      <p:grpSpPr>
+        <a:xfrm>
+          <a:off x="0" y="0"/>
+          <a:ext cx="0" cy="0"/>
+          <a:chOff x="0" y="0"/>
+          <a:chExt cx="0" cy="0"/>
+        </a:xfrm>
+      </p:grpSpPr>
       <p:sp>
         <p:nvSpPr>
           <p:cNvPr id="2" name="TextBox 1"/>
@@ -4627,14 +4766,11 @@
                 <a:spcPts val="800"/>
               </a:spcAft>
             </a:pPr>
-            <a:r>
-              <a:rPr sz="2200">
-                <a:solidFill>
-                  <a:srgbClr val="212121"/>
-                </a:solidFill>
-              </a:rPr>
-              <a:t/>
-            </a:r>
+            <a:endParaRPr sz="1800">
+              <a:solidFill>
+                <a:srgbClr val="212121"/>
+              </a:solidFill>
+            </a:endParaRPr>
           </a:p>
           <a:p>
             <a:pPr>
@@ -4677,7 +4813,7 @@
 </file>
 
 <file path=ppt/slides/slide16.xml><?xml version="1.0" encoding="utf-8"?>
-<p:sld xmlns:a="http://schemas.openxmlformats.org/drawingml/2006/main" xmlns:p="http://schemas.openxmlformats.org/presentationml/2006/main" xmlns:r="http://schemas.openxmlformats.org/officeDocument/2006/relationships">
+<p:sld xmlns:a="http://schemas.openxmlformats.org/drawingml/2006/main" xmlns:r="http://schemas.openxmlformats.org/officeDocument/2006/relationships" xmlns:p="http://schemas.openxmlformats.org/presentationml/2006/main">
   <p:cSld>
     <p:spTree>
       <p:nvGrpSpPr>
@@ -4685,7 +4821,14 @@
         <p:cNvGrpSpPr/>
         <p:nvPr/>
       </p:nvGrpSpPr>
-      <p:grpSpPr/>
+      <p:grpSpPr>
+        <a:xfrm>
+          <a:off x="0" y="0"/>
+          <a:ext cx="0" cy="0"/>
+          <a:chOff x="0" y="0"/>
+          <a:chExt cx="0" cy="0"/>
+        </a:xfrm>
+      </p:grpSpPr>
       <p:sp>
         <p:nvSpPr>
           <p:cNvPr id="2" name="TextBox 1"/>
@@ -4728,7 +4871,7 @@
 </file>
 
 <file path=ppt/slides/slide17.xml><?xml version="1.0" encoding="utf-8"?>
-<p:sld xmlns:a="http://schemas.openxmlformats.org/drawingml/2006/main" xmlns:p="http://schemas.openxmlformats.org/presentationml/2006/main" xmlns:r="http://schemas.openxmlformats.org/officeDocument/2006/relationships">
+<p:sld xmlns:a="http://schemas.openxmlformats.org/drawingml/2006/main" xmlns:r="http://schemas.openxmlformats.org/officeDocument/2006/relationships" xmlns:p="http://schemas.openxmlformats.org/presentationml/2006/main">
   <p:cSld>
     <p:spTree>
       <p:nvGrpSpPr>
@@ -4736,7 +4879,14 @@
         <p:cNvGrpSpPr/>
         <p:nvPr/>
       </p:nvGrpSpPr>
-      <p:grpSpPr/>
+      <p:grpSpPr>
+        <a:xfrm>
+          <a:off x="0" y="0"/>
+          <a:ext cx="0" cy="0"/>
+          <a:chOff x="0" y="0"/>
+          <a:chExt cx="0" cy="0"/>
+        </a:xfrm>
+      </p:grpSpPr>
       <p:sp>
         <p:nvSpPr>
           <p:cNvPr id="2" name="TextBox 1"/>
@@ -4842,14 +4992,11 @@
                 <a:spcPts val="800"/>
               </a:spcAft>
             </a:pPr>
-            <a:r>
-              <a:rPr sz="2800">
-                <a:solidFill>
-                  <a:srgbClr val="212121"/>
-                </a:solidFill>
-              </a:rPr>
-              <a:t/>
-            </a:r>
+            <a:endParaRPr sz="2800">
+              <a:solidFill>
+                <a:srgbClr val="212121"/>
+              </a:solidFill>
+            </a:endParaRPr>
           </a:p>
           <a:p>
             <a:pPr>
@@ -4877,7 +5024,7 @@
 </file>
 
 <file path=ppt/slides/slide18.xml><?xml version="1.0" encoding="utf-8"?>
-<p:sld xmlns:a="http://schemas.openxmlformats.org/drawingml/2006/main" xmlns:p="http://schemas.openxmlformats.org/presentationml/2006/main" xmlns:r="http://schemas.openxmlformats.org/officeDocument/2006/relationships">
+<p:sld xmlns:a="http://schemas.openxmlformats.org/drawingml/2006/main" xmlns:r="http://schemas.openxmlformats.org/officeDocument/2006/relationships" xmlns:p="http://schemas.openxmlformats.org/presentationml/2006/main">
   <p:cSld>
     <p:spTree>
       <p:nvGrpSpPr>
@@ -4885,7 +5032,14 @@
         <p:cNvGrpSpPr/>
         <p:nvPr/>
       </p:nvGrpSpPr>
-      <p:grpSpPr/>
+      <p:grpSpPr>
+        <a:xfrm>
+          <a:off x="0" y="0"/>
+          <a:ext cx="0" cy="0"/>
+          <a:chOff x="0" y="0"/>
+          <a:chExt cx="0" cy="0"/>
+        </a:xfrm>
+      </p:grpSpPr>
       <p:sp>
         <p:nvSpPr>
           <p:cNvPr id="2" name="TextBox 1"/>
@@ -4978,6 +5132,19 @@
                 <a:spcPts val="0"/>
               </a:spcAft>
             </a:pPr>
+            <a:endParaRPr sz="1800">
+              <a:solidFill>
+                <a:srgbClr val="212121"/>
+              </a:solidFill>
+              <a:latin typeface="Courier New"/>
+            </a:endParaRPr>
+          </a:p>
+          <a:p>
+            <a:pPr>
+              <a:spcAft>
+                <a:spcPts val="0"/>
+              </a:spcAft>
+            </a:pPr>
             <a:r>
               <a:rPr sz="1800">
                 <a:solidFill>
@@ -4985,7 +5152,7 @@
                 </a:solidFill>
                 <a:latin typeface="Courier New"/>
               </a:rPr>
-              <a:t/>
+              <a:t>int x = nondet_int();              /* every value at once */</a:t>
             </a:r>
           </a:p>
           <a:p>
@@ -5001,7 +5168,7 @@
                 </a:solidFill>
                 <a:latin typeface="Courier New"/>
               </a:rPr>
-              <a:t>int x = nondet_int();              /* every value at once */</a:t>
+              <a:t>__ESBMC_assume(x &gt; 0 &amp;&amp; x &lt; 100);  /* now: every value in 1..99 */</a:t>
             </a:r>
           </a:p>
           <a:p>
@@ -5017,22 +5184,6 @@
                 </a:solidFill>
                 <a:latin typeface="Courier New"/>
               </a:rPr>
-              <a:t>__ESBMC_assume(x &gt; 0 &amp;&amp; x &lt; 100);  /* now: every value in 1..99 */</a:t>
-            </a:r>
-          </a:p>
-          <a:p>
-            <a:pPr>
-              <a:spcAft>
-                <a:spcPts val="0"/>
-              </a:spcAft>
-            </a:pPr>
-            <a:r>
-              <a:rPr sz="1800">
-                <a:solidFill>
-                  <a:srgbClr val="212121"/>
-                </a:solidFill>
-                <a:latin typeface="Courier New"/>
-              </a:rPr>
               <a:t>assert(property(x));               /* must hold for ALL of them */</a:t>
             </a:r>
           </a:p>
@@ -5042,14 +5193,12 @@
                 <a:spcPts val="800"/>
               </a:spcAft>
             </a:pPr>
-            <a:r>
-              <a:rPr sz="2200">
-                <a:solidFill>
-                  <a:srgbClr val="212121"/>
-                </a:solidFill>
-              </a:rPr>
-              <a:t/>
-            </a:r>
+            <a:endParaRPr sz="1800">
+              <a:solidFill>
+                <a:srgbClr val="212121"/>
+              </a:solidFill>
+              <a:latin typeface="Courier New"/>
+            </a:endParaRPr>
           </a:p>
           <a:p>
             <a:pPr>
@@ -5077,7 +5226,7 @@
 </file>
 
 <file path=ppt/slides/slide19.xml><?xml version="1.0" encoding="utf-8"?>
-<p:sld xmlns:a="http://schemas.openxmlformats.org/drawingml/2006/main" xmlns:p="http://schemas.openxmlformats.org/presentationml/2006/main" xmlns:r="http://schemas.openxmlformats.org/officeDocument/2006/relationships">
+<p:sld xmlns:a="http://schemas.openxmlformats.org/drawingml/2006/main" xmlns:r="http://schemas.openxmlformats.org/officeDocument/2006/relationships" xmlns:p="http://schemas.openxmlformats.org/presentationml/2006/main">
   <p:cSld>
     <p:spTree>
       <p:nvGrpSpPr>
@@ -5085,7 +5234,14 @@
         <p:cNvGrpSpPr/>
         <p:nvPr/>
       </p:nvGrpSpPr>
-      <p:grpSpPr/>
+      <p:grpSpPr>
+        <a:xfrm>
+          <a:off x="0" y="0"/>
+          <a:ext cx="0" cy="0"/>
+          <a:chOff x="0" y="0"/>
+          <a:chExt cx="0" cy="0"/>
+        </a:xfrm>
+      </p:grpSpPr>
       <p:sp>
         <p:nvSpPr>
           <p:cNvPr id="2" name="TextBox 1"/>
@@ -5194,14 +5350,12 @@
                 <a:spcPts val="800"/>
               </a:spcAft>
             </a:pPr>
-            <a:r>
-              <a:rPr sz="2200">
-                <a:solidFill>
-                  <a:srgbClr val="212121"/>
-                </a:solidFill>
-              </a:rPr>
-              <a:t/>
-            </a:r>
+            <a:endParaRPr sz="1800">
+              <a:solidFill>
+                <a:srgbClr val="212121"/>
+              </a:solidFill>
+              <a:latin typeface="Courier New"/>
+            </a:endParaRPr>
           </a:p>
           <a:p>
             <a:pPr>
@@ -5259,7 +5413,7 @@
 </file>
 
 <file path=ppt/slides/slide2.xml><?xml version="1.0" encoding="utf-8"?>
-<p:sld xmlns:a="http://schemas.openxmlformats.org/drawingml/2006/main" xmlns:p="http://schemas.openxmlformats.org/presentationml/2006/main" xmlns:r="http://schemas.openxmlformats.org/officeDocument/2006/relationships">
+<p:sld xmlns:a="http://schemas.openxmlformats.org/drawingml/2006/main" xmlns:r="http://schemas.openxmlformats.org/officeDocument/2006/relationships" xmlns:p="http://schemas.openxmlformats.org/presentationml/2006/main">
   <p:cSld>
     <p:spTree>
       <p:nvGrpSpPr>
@@ -5267,7 +5421,14 @@
         <p:cNvGrpSpPr/>
         <p:nvPr/>
       </p:nvGrpSpPr>
-      <p:grpSpPr/>
+      <p:grpSpPr>
+        <a:xfrm>
+          <a:off x="0" y="0"/>
+          <a:ext cx="0" cy="0"/>
+          <a:chOff x="0" y="0"/>
+          <a:chExt cx="0" cy="0"/>
+        </a:xfrm>
+      </p:grpSpPr>
       <p:sp>
         <p:nvSpPr>
           <p:cNvPr id="2" name="TextBox 1"/>
@@ -5373,14 +5534,11 @@
                 <a:spcPts val="800"/>
               </a:spcAft>
             </a:pPr>
-            <a:r>
-              <a:rPr sz="2400">
-                <a:solidFill>
-                  <a:srgbClr val="212121"/>
-                </a:solidFill>
-              </a:rPr>
-              <a:t/>
-            </a:r>
+            <a:endParaRPr sz="2400">
+              <a:solidFill>
+                <a:srgbClr val="212121"/>
+              </a:solidFill>
+            </a:endParaRPr>
           </a:p>
           <a:p>
             <a:pPr>
@@ -5439,7 +5597,7 @@
 </file>
 
 <file path=ppt/slides/slide20.xml><?xml version="1.0" encoding="utf-8"?>
-<p:sld xmlns:a="http://schemas.openxmlformats.org/drawingml/2006/main" xmlns:p="http://schemas.openxmlformats.org/presentationml/2006/main" xmlns:r="http://schemas.openxmlformats.org/officeDocument/2006/relationships">
+<p:sld xmlns:a="http://schemas.openxmlformats.org/drawingml/2006/main" xmlns:r="http://schemas.openxmlformats.org/officeDocument/2006/relationships" xmlns:p="http://schemas.openxmlformats.org/presentationml/2006/main">
   <p:cSld>
     <p:spTree>
       <p:nvGrpSpPr>
@@ -5447,7 +5605,14 @@
         <p:cNvGrpSpPr/>
         <p:nvPr/>
       </p:nvGrpSpPr>
-      <p:grpSpPr/>
+      <p:grpSpPr>
+        <a:xfrm>
+          <a:off x="0" y="0"/>
+          <a:ext cx="0" cy="0"/>
+          <a:chOff x="0" y="0"/>
+          <a:chExt cx="0" cy="0"/>
+        </a:xfrm>
+      </p:grpSpPr>
       <p:sp>
         <p:nvSpPr>
           <p:cNvPr id="2" name="TextBox 1"/>
@@ -5553,14 +5718,11 @@
                 <a:spcPts val="800"/>
               </a:spcAft>
             </a:pPr>
-            <a:r>
-              <a:rPr sz="2200">
-                <a:solidFill>
-                  <a:srgbClr val="212121"/>
-                </a:solidFill>
-              </a:rPr>
-              <a:t/>
-            </a:r>
+            <a:endParaRPr sz="2000">
+              <a:solidFill>
+                <a:srgbClr val="212121"/>
+              </a:solidFill>
+            </a:endParaRPr>
           </a:p>
           <a:p>
             <a:pPr>
@@ -5619,7 +5781,7 @@
 </file>
 
 <file path=ppt/slides/slide21.xml><?xml version="1.0" encoding="utf-8"?>
-<p:sld xmlns:a="http://schemas.openxmlformats.org/drawingml/2006/main" xmlns:p="http://schemas.openxmlformats.org/presentationml/2006/main" xmlns:r="http://schemas.openxmlformats.org/officeDocument/2006/relationships">
+<p:sld xmlns:a="http://schemas.openxmlformats.org/drawingml/2006/main" xmlns:r="http://schemas.openxmlformats.org/officeDocument/2006/relationships" xmlns:p="http://schemas.openxmlformats.org/presentationml/2006/main">
   <p:cSld>
     <p:spTree>
       <p:nvGrpSpPr>
@@ -5627,7 +5789,14 @@
         <p:cNvGrpSpPr/>
         <p:nvPr/>
       </p:nvGrpSpPr>
-      <p:grpSpPr/>
+      <p:grpSpPr>
+        <a:xfrm>
+          <a:off x="0" y="0"/>
+          <a:ext cx="0" cy="0"/>
+          <a:chOff x="0" y="0"/>
+          <a:chExt cx="0" cy="0"/>
+        </a:xfrm>
+      </p:grpSpPr>
       <p:sp>
         <p:nvSpPr>
           <p:cNvPr id="2" name="TextBox 1"/>
@@ -5733,14 +5902,11 @@
                 <a:spcPts val="800"/>
               </a:spcAft>
             </a:pPr>
-            <a:r>
-              <a:rPr sz="2200">
-                <a:solidFill>
-                  <a:srgbClr val="212121"/>
-                </a:solidFill>
-              </a:rPr>
-              <a:t/>
-            </a:r>
+            <a:endParaRPr sz="2200">
+              <a:solidFill>
+                <a:srgbClr val="212121"/>
+              </a:solidFill>
+            </a:endParaRPr>
           </a:p>
           <a:p>
             <a:pPr>
@@ -5768,7 +5934,7 @@
 </file>
 
 <file path=ppt/slides/slide22.xml><?xml version="1.0" encoding="utf-8"?>
-<p:sld xmlns:a="http://schemas.openxmlformats.org/drawingml/2006/main" xmlns:p="http://schemas.openxmlformats.org/presentationml/2006/main" xmlns:r="http://schemas.openxmlformats.org/officeDocument/2006/relationships">
+<p:sld xmlns:a="http://schemas.openxmlformats.org/drawingml/2006/main" xmlns:r="http://schemas.openxmlformats.org/officeDocument/2006/relationships" xmlns:p="http://schemas.openxmlformats.org/presentationml/2006/main">
   <p:cSld>
     <p:spTree>
       <p:nvGrpSpPr>
@@ -5776,7 +5942,14 @@
         <p:cNvGrpSpPr/>
         <p:nvPr/>
       </p:nvGrpSpPr>
-      <p:grpSpPr/>
+      <p:grpSpPr>
+        <a:xfrm>
+          <a:off x="0" y="0"/>
+          <a:ext cx="0" cy="0"/>
+          <a:chOff x="0" y="0"/>
+          <a:chExt cx="0" cy="0"/>
+        </a:xfrm>
+      </p:grpSpPr>
       <p:sp>
         <p:nvSpPr>
           <p:cNvPr id="2" name="TextBox 1"/>
@@ -5867,27 +6040,24 @@
                 <a:spcPts val="800"/>
               </a:spcAft>
             </a:pPr>
+            <a:endParaRPr sz="2200">
+              <a:solidFill>
+                <a:srgbClr val="212121"/>
+              </a:solidFill>
+            </a:endParaRPr>
+          </a:p>
+          <a:p>
+            <a:pPr>
+              <a:spcAft>
+                <a:spcPts val="800"/>
+              </a:spcAft>
+            </a:pPr>
             <a:r>
               <a:rPr sz="2200">
                 <a:solidFill>
                   <a:srgbClr val="212121"/>
                 </a:solidFill>
               </a:rPr>
-              <a:t/>
-            </a:r>
-          </a:p>
-          <a:p>
-            <a:pPr>
-              <a:spcAft>
-                <a:spcPts val="800"/>
-              </a:spcAft>
-            </a:pPr>
-            <a:r>
-              <a:rPr sz="2200">
-                <a:solidFill>
-                  <a:srgbClr val="212121"/>
-                </a:solidFill>
-              </a:rPr>
               <a:t>Where next:</a:t>
             </a:r>
           </a:p>
@@ -5957,14 +6127,11 @@
                 <a:spcPts val="800"/>
               </a:spcAft>
             </a:pPr>
-            <a:r>
-              <a:rPr sz="2200">
-                <a:solidFill>
-                  <a:srgbClr val="212121"/>
-                </a:solidFill>
-              </a:rPr>
-              <a:t/>
-            </a:r>
+            <a:endParaRPr sz="2000">
+              <a:solidFill>
+                <a:srgbClr val="212121"/>
+              </a:solidFill>
+            </a:endParaRPr>
           </a:p>
           <a:p>
             <a:pPr>
@@ -5992,7 +6159,7 @@
 </file>
 
 <file path=ppt/slides/slide3.xml><?xml version="1.0" encoding="utf-8"?>
-<p:sld xmlns:a="http://schemas.openxmlformats.org/drawingml/2006/main" xmlns:p="http://schemas.openxmlformats.org/presentationml/2006/main" xmlns:r="http://schemas.openxmlformats.org/officeDocument/2006/relationships">
+<p:sld xmlns:a="http://schemas.openxmlformats.org/drawingml/2006/main" xmlns:r="http://schemas.openxmlformats.org/officeDocument/2006/relationships" xmlns:p="http://schemas.openxmlformats.org/presentationml/2006/main">
   <p:cSld>
     <p:spTree>
       <p:nvGrpSpPr>
@@ -6000,7 +6167,14 @@
         <p:cNvGrpSpPr/>
         <p:nvPr/>
       </p:nvGrpSpPr>
-      <p:grpSpPr/>
+      <p:grpSpPr>
+        <a:xfrm>
+          <a:off x="0" y="0"/>
+          <a:ext cx="0" cy="0"/>
+          <a:chOff x="0" y="0"/>
+          <a:chExt cx="0" cy="0"/>
+        </a:xfrm>
+      </p:grpSpPr>
       <p:sp>
         <p:nvSpPr>
           <p:cNvPr id="2" name="TextBox 1"/>
@@ -6044,7 +6218,7 @@
         </p:nvGraphicFramePr>
         <p:xfrm>
           <a:off x="731520" y="1463040"/>
-          <a:ext cx="10698480" cy="2194560"/>
+          <a:ext cx="10698480" cy="2377440"/>
         </p:xfrm>
         <a:graphic>
           <a:graphicData uri="http://schemas.openxmlformats.org/drawingml/2006/table">
@@ -6053,9 +6227,27 @@
                 <a:tableStyleId>{5C22544A-7EE6-4342-B048-85BDC9FD1C3A}</a:tableStyleId>
               </a:tblPr>
               <a:tblGrid>
-                <a:gridCol w="1463040"/>
-                <a:gridCol w="1645920"/>
-                <a:gridCol w="7589520"/>
+                <a:gridCol w="1463040">
+                  <a:extLst>
+                    <a:ext uri="{9D8B030D-6E8A-4147-A177-3AD203B41FA5}">
+                      <a16:colId xmlns:a16="http://schemas.microsoft.com/office/drawing/2014/main" val="20000"/>
+                    </a:ext>
+                  </a:extLst>
+                </a:gridCol>
+                <a:gridCol w="1645920">
+                  <a:extLst>
+                    <a:ext uri="{9D8B030D-6E8A-4147-A177-3AD203B41FA5}">
+                      <a16:colId xmlns:a16="http://schemas.microsoft.com/office/drawing/2014/main" val="20001"/>
+                    </a:ext>
+                  </a:extLst>
+                </a:gridCol>
+                <a:gridCol w="7589520">
+                  <a:extLst>
+                    <a:ext uri="{9D8B030D-6E8A-4147-A177-3AD203B41FA5}">
+                      <a16:colId xmlns:a16="http://schemas.microsoft.com/office/drawing/2014/main" val="20002"/>
+                    </a:ext>
+                  </a:extLst>
+                </a:gridCol>
               </a:tblGrid>
               <a:tr h="365760">
                 <a:tc>
@@ -6097,6 +6289,11 @@
                   </a:txBody>
                   <a:tcPr/>
                 </a:tc>
+                <a:extLst>
+                  <a:ext uri="{0D108BD9-81ED-4DB2-BD59-A6C34878D82A}">
+                    <a16:rowId xmlns:a16="http://schemas.microsoft.com/office/drawing/2014/main" val="10000"/>
+                  </a:ext>
+                </a:extLst>
               </a:tr>
               <a:tr h="365760">
                 <a:tc>
@@ -6138,6 +6335,11 @@
                   </a:txBody>
                   <a:tcPr/>
                 </a:tc>
+                <a:extLst>
+                  <a:ext uri="{0D108BD9-81ED-4DB2-BD59-A6C34878D82A}">
+                    <a16:rowId xmlns:a16="http://schemas.microsoft.com/office/drawing/2014/main" val="10001"/>
+                  </a:ext>
+                </a:extLst>
               </a:tr>
               <a:tr h="365760">
                 <a:tc>
@@ -6170,10 +6372,17 @@
                   <a:txBody>
                     <a:bodyPr/>
                     <a:lstStyle/>
-                    <a:p/>
+                    <a:p>
+                      <a:endParaRPr/>
+                    </a:p>
                   </a:txBody>
                   <a:tcPr/>
                 </a:tc>
+                <a:extLst>
+                  <a:ext uri="{0D108BD9-81ED-4DB2-BD59-A6C34878D82A}">
+                    <a16:rowId xmlns:a16="http://schemas.microsoft.com/office/drawing/2014/main" val="10002"/>
+                  </a:ext>
+                </a:extLst>
               </a:tr>
               <a:tr h="365760">
                 <a:tc>
@@ -6215,6 +6424,11 @@
                   </a:txBody>
                   <a:tcPr/>
                 </a:tc>
+                <a:extLst>
+                  <a:ext uri="{0D108BD9-81ED-4DB2-BD59-A6C34878D82A}">
+                    <a16:rowId xmlns:a16="http://schemas.microsoft.com/office/drawing/2014/main" val="10003"/>
+                  </a:ext>
+                </a:extLst>
               </a:tr>
               <a:tr h="365760">
                 <a:tc>
@@ -6256,6 +6470,11 @@
                   </a:txBody>
                   <a:tcPr/>
                 </a:tc>
+                <a:extLst>
+                  <a:ext uri="{0D108BD9-81ED-4DB2-BD59-A6C34878D82A}">
+                    <a16:rowId xmlns:a16="http://schemas.microsoft.com/office/drawing/2014/main" val="10004"/>
+                  </a:ext>
+                </a:extLst>
               </a:tr>
               <a:tr h="365760">
                 <a:tc>
@@ -6275,7 +6494,9 @@
                   <a:txBody>
                     <a:bodyPr/>
                     <a:lstStyle/>
-                    <a:p/>
+                    <a:p>
+                      <a:endParaRPr/>
+                    </a:p>
                   </a:txBody>
                   <a:tcPr/>
                 </a:tc>
@@ -6292,6 +6513,11 @@
                   </a:txBody>
                   <a:tcPr/>
                 </a:tc>
+                <a:extLst>
+                  <a:ext uri="{0D108BD9-81ED-4DB2-BD59-A6C34878D82A}">
+                    <a16:rowId xmlns:a16="http://schemas.microsoft.com/office/drawing/2014/main" val="10005"/>
+                  </a:ext>
+                </a:extLst>
               </a:tr>
             </a:tbl>
           </a:graphicData>
@@ -6344,7 +6570,7 @@
 </file>
 
 <file path=ppt/slides/slide4.xml><?xml version="1.0" encoding="utf-8"?>
-<p:sld xmlns:a="http://schemas.openxmlformats.org/drawingml/2006/main" xmlns:p="http://schemas.openxmlformats.org/presentationml/2006/main" xmlns:r="http://schemas.openxmlformats.org/officeDocument/2006/relationships">
+<p:sld xmlns:a="http://schemas.openxmlformats.org/drawingml/2006/main" xmlns:r="http://schemas.openxmlformats.org/officeDocument/2006/relationships" xmlns:p="http://schemas.openxmlformats.org/presentationml/2006/main">
   <p:cSld>
     <p:spTree>
       <p:nvGrpSpPr>
@@ -6352,7 +6578,14 @@
         <p:cNvGrpSpPr/>
         <p:nvPr/>
       </p:nvGrpSpPr>
-      <p:grpSpPr/>
+      <p:grpSpPr>
+        <a:xfrm>
+          <a:off x="0" y="0"/>
+          <a:ext cx="0" cy="0"/>
+          <a:chOff x="0" y="0"/>
+          <a:chExt cx="0" cy="0"/>
+        </a:xfrm>
+      </p:grpSpPr>
       <p:sp>
         <p:nvSpPr>
           <p:cNvPr id="2" name="TextBox 1"/>
@@ -6458,14 +6691,11 @@
                 <a:spcPts val="800"/>
               </a:spcAft>
             </a:pPr>
-            <a:r>
-              <a:rPr sz="2600">
-                <a:solidFill>
-                  <a:srgbClr val="212121"/>
-                </a:solidFill>
-              </a:rPr>
-              <a:t/>
-            </a:r>
+            <a:endParaRPr sz="2400">
+              <a:solidFill>
+                <a:srgbClr val="212121"/>
+              </a:solidFill>
+            </a:endParaRPr>
           </a:p>
           <a:p>
             <a:pPr>
@@ -6493,7 +6723,7 @@
 </file>
 
 <file path=ppt/slides/slide5.xml><?xml version="1.0" encoding="utf-8"?>
-<p:sld xmlns:a="http://schemas.openxmlformats.org/drawingml/2006/main" xmlns:p="http://schemas.openxmlformats.org/presentationml/2006/main" xmlns:r="http://schemas.openxmlformats.org/officeDocument/2006/relationships">
+<p:sld xmlns:a="http://schemas.openxmlformats.org/drawingml/2006/main" xmlns:r="http://schemas.openxmlformats.org/officeDocument/2006/relationships" xmlns:p="http://schemas.openxmlformats.org/presentationml/2006/main">
   <p:cSld>
     <p:spTree>
       <p:nvGrpSpPr>
@@ -6501,7 +6731,14 @@
         <p:cNvGrpSpPr/>
         <p:nvPr/>
       </p:nvGrpSpPr>
-      <p:grpSpPr/>
+      <p:grpSpPr>
+        <a:xfrm>
+          <a:off x="0" y="0"/>
+          <a:ext cx="0" cy="0"/>
+          <a:chOff x="0" y="0"/>
+          <a:chExt cx="0" cy="0"/>
+        </a:xfrm>
+      </p:grpSpPr>
       <p:sp>
         <p:nvSpPr>
           <p:cNvPr id="2" name="TextBox 1"/>
@@ -6544,7 +6781,7 @@
         <p:spPr>
           <a:xfrm>
             <a:off x="731520" y="1828800"/>
-            <a:ext cx="10789920" cy="4754880"/>
+            <a:ext cx="10789920" cy="3642023"/>
           </a:xfrm>
           <a:prstGeom prst="rect">
             <a:avLst/>
@@ -6563,28 +6800,41 @@
               </a:spcAft>
             </a:pPr>
             <a:r>
-              <a:rPr sz="2400">
-                <a:solidFill>
-                  <a:srgbClr val="212121"/>
-                </a:solidFill>
-              </a:rPr>
-              <a:t>Tonight's trick hunts a counterexample. Abstract interpretation proves P the other way — over-approximate every run at once to a fixpoint invariant: no bound, no search.</a:t>
-            </a:r>
-          </a:p>
-          <a:p>
-            <a:pPr>
-              <a:spcAft>
-                <a:spcPts val="800"/>
-              </a:spcAft>
-            </a:pPr>
-            <a:r>
-              <a:rPr sz="2400">
-                <a:solidFill>
-                  <a:srgbClr val="212121"/>
-                </a:solidFill>
-              </a:rPr>
-              <a:t/>
-            </a:r>
+              <a:rPr sz="2400" dirty="0">
+                <a:solidFill>
+                  <a:srgbClr val="212121"/>
+                </a:solidFill>
+              </a:rPr>
+              <a:t>Tonight's trick hunts a counterexample. Abstract interpretation proves P the other way</a:t>
+            </a:r>
+            <a:r>
+              <a:rPr lang="en-GB" sz="2400" dirty="0">
+                <a:solidFill>
+                  <a:srgbClr val="212121"/>
+                </a:solidFill>
+              </a:rPr>
+              <a:t>;</a:t>
+            </a:r>
+            <a:r>
+              <a:rPr sz="2400" dirty="0">
+                <a:solidFill>
+                  <a:srgbClr val="212121"/>
+                </a:solidFill>
+              </a:rPr>
+              <a:t> over-approximate every run at once to a fixpoint invariant: no bound, no search.</a:t>
+            </a:r>
+          </a:p>
+          <a:p>
+            <a:pPr>
+              <a:spcAft>
+                <a:spcPts val="800"/>
+              </a:spcAft>
+            </a:pPr>
+            <a:endParaRPr sz="2400" dirty="0">
+              <a:solidFill>
+                <a:srgbClr val="212121"/>
+              </a:solidFill>
+            </a:endParaRPr>
           </a:p>
           <a:p>
             <a:pPr lvl="1">
@@ -6593,12 +6843,28 @@
               </a:spcAft>
             </a:pPr>
             <a:r>
-              <a:rPr sz="2200">
-                <a:solidFill>
-                  <a:srgbClr val="212121"/>
-                </a:solidFill>
-              </a:rPr>
-              <a:t>You met the mechanism in Session 1: abstract domain, widening (∇), narrowing (Δ) — iterate to a fixpoint; if it implies P, P holds for every run.</a:t>
+              <a:rPr sz="2200" dirty="0">
+                <a:solidFill>
+                  <a:srgbClr val="212121"/>
+                </a:solidFill>
+              </a:rPr>
+              <a:t>You met the mechanism in Session 1: abstract domain, widening (∇), narrowing (</a:t>
+            </a:r>
+            <a:r>
+              <a:rPr sz="2200" dirty="0" err="1">
+                <a:solidFill>
+                  <a:srgbClr val="212121"/>
+                </a:solidFill>
+              </a:rPr>
+              <a:t>Δ</a:t>
+            </a:r>
+            <a:r>
+              <a:rPr sz="2200" dirty="0">
+                <a:solidFill>
+                  <a:srgbClr val="212121"/>
+                </a:solidFill>
+              </a:rPr>
+              <a:t>) — iterate to a fixpoint; if it implies P, P holds for every run.</a:t>
             </a:r>
           </a:p>
           <a:p>
@@ -6608,7 +6874,7 @@
               </a:spcAft>
             </a:pPr>
             <a:r>
-              <a:rPr sz="2200">
+              <a:rPr sz="2200" dirty="0">
                 <a:solidFill>
                   <a:srgbClr val="212121"/>
                 </a:solidFill>
@@ -6623,12 +6889,44 @@
               </a:spcAft>
             </a:pPr>
             <a:r>
-              <a:rPr sz="2200">
-                <a:solidFill>
-                  <a:srgbClr val="212121"/>
-                </a:solidFill>
-              </a:rPr>
-              <a:t>ESBMC ships it too — --interval-analysis — feeding the invariant k-induction needs for unwind.c (Lab 3).</a:t>
+              <a:rPr sz="2200" dirty="0">
+                <a:solidFill>
+                  <a:srgbClr val="212121"/>
+                </a:solidFill>
+              </a:rPr>
+              <a:t>ESBMC ships it too</a:t>
+            </a:r>
+            <a:r>
+              <a:rPr lang="en-GB" sz="2200" dirty="0">
+                <a:solidFill>
+                  <a:srgbClr val="212121"/>
+                </a:solidFill>
+              </a:rPr>
+              <a:t>:</a:t>
+            </a:r>
+            <a:r>
+              <a:rPr sz="2200" dirty="0">
+                <a:solidFill>
+                  <a:srgbClr val="212121"/>
+                </a:solidFill>
+              </a:rPr>
+              <a:t> --interval-analysis — feeding the invariant k-induction needs for </a:t>
+            </a:r>
+            <a:r>
+              <a:rPr sz="2200" dirty="0" err="1">
+                <a:solidFill>
+                  <a:srgbClr val="212121"/>
+                </a:solidFill>
+              </a:rPr>
+              <a:t>unwind.c</a:t>
+            </a:r>
+            <a:r>
+              <a:rPr sz="2200" dirty="0">
+                <a:solidFill>
+                  <a:srgbClr val="212121"/>
+                </a:solidFill>
+              </a:rPr>
+              <a:t> (Lab 3).</a:t>
             </a:r>
           </a:p>
         </p:txBody>
@@ -6642,7 +6940,7 @@
 </file>
 
 <file path=ppt/slides/slide6.xml><?xml version="1.0" encoding="utf-8"?>
-<p:sld xmlns:a="http://schemas.openxmlformats.org/drawingml/2006/main" xmlns:p="http://schemas.openxmlformats.org/presentationml/2006/main" xmlns:r="http://schemas.openxmlformats.org/officeDocument/2006/relationships">
+<p:sld xmlns:a="http://schemas.openxmlformats.org/drawingml/2006/main" xmlns:r="http://schemas.openxmlformats.org/officeDocument/2006/relationships" xmlns:p="http://schemas.openxmlformats.org/presentationml/2006/main">
   <p:cSld>
     <p:spTree>
       <p:nvGrpSpPr>
@@ -6650,7 +6948,14 @@
         <p:cNvGrpSpPr/>
         <p:nvPr/>
       </p:nvGrpSpPr>
-      <p:grpSpPr/>
+      <p:grpSpPr>
+        <a:xfrm>
+          <a:off x="0" y="0"/>
+          <a:ext cx="0" cy="0"/>
+          <a:chOff x="0" y="0"/>
+          <a:chExt cx="0" cy="0"/>
+        </a:xfrm>
+      </p:grpSpPr>
       <p:sp>
         <p:nvSpPr>
           <p:cNvPr id="2" name="TextBox 1"/>
@@ -6771,14 +7076,11 @@
                 <a:spcPts val="800"/>
               </a:spcAft>
             </a:pPr>
-            <a:r>
-              <a:rPr sz="2200">
-                <a:solidFill>
-                  <a:srgbClr val="212121"/>
-                </a:solidFill>
-              </a:rPr>
-              <a:t/>
-            </a:r>
+            <a:endParaRPr sz="2000">
+              <a:solidFill>
+                <a:srgbClr val="212121"/>
+              </a:solidFill>
+            </a:endParaRPr>
           </a:p>
           <a:p>
             <a:pPr>
@@ -6821,7 +7123,7 @@
 </file>
 
 <file path=ppt/slides/slide7.xml><?xml version="1.0" encoding="utf-8"?>
-<p:sld xmlns:a="http://schemas.openxmlformats.org/drawingml/2006/main" xmlns:p="http://schemas.openxmlformats.org/presentationml/2006/main" xmlns:r="http://schemas.openxmlformats.org/officeDocument/2006/relationships">
+<p:sld xmlns:a="http://schemas.openxmlformats.org/drawingml/2006/main" xmlns:r="http://schemas.openxmlformats.org/officeDocument/2006/relationships" xmlns:p="http://schemas.openxmlformats.org/presentationml/2006/main">
   <p:cSld>
     <p:spTree>
       <p:nvGrpSpPr>
@@ -6829,7 +7131,14 @@
         <p:cNvGrpSpPr/>
         <p:nvPr/>
       </p:nvGrpSpPr>
-      <p:grpSpPr/>
+      <p:grpSpPr>
+        <a:xfrm>
+          <a:off x="0" y="0"/>
+          <a:ext cx="0" cy="0"/>
+          <a:chOff x="0" y="0"/>
+          <a:chExt cx="0" cy="0"/>
+        </a:xfrm>
+      </p:grpSpPr>
       <p:sp>
         <p:nvSpPr>
           <p:cNvPr id="2" name="TextBox 1"/>
@@ -6872,7 +7181,7 @@
         <p:spPr>
           <a:xfrm>
             <a:off x="731520" y="1463040"/>
-            <a:ext cx="10789920" cy="5120640"/>
+            <a:ext cx="10789920" cy="3026470"/>
           </a:xfrm>
           <a:prstGeom prst="rect">
             <a:avLst/>
@@ -6891,14 +7200,65 @@
               </a:spcAft>
             </a:pPr>
             <a:r>
-              <a:rPr sz="1800">
+              <a:rPr sz="1800" dirty="0">
                 <a:solidFill>
                   <a:srgbClr val="212121"/>
                 </a:solidFill>
                 <a:latin typeface="Courier New"/>
               </a:rPr>
-              <a:t>from z3 import Bools, Ints, BitVec, Solver, sat, unsat</a:t>
-            </a:r>
+              <a:t>from z3 import Bools, </a:t>
+            </a:r>
+            <a:r>
+              <a:rPr sz="1800" dirty="0" err="1">
+                <a:solidFill>
+                  <a:srgbClr val="212121"/>
+                </a:solidFill>
+                <a:latin typeface="Courier New"/>
+              </a:rPr>
+              <a:t>Ints</a:t>
+            </a:r>
+            <a:r>
+              <a:rPr sz="1800" dirty="0">
+                <a:solidFill>
+                  <a:srgbClr val="212121"/>
+                </a:solidFill>
+                <a:latin typeface="Courier New"/>
+              </a:rPr>
+              <a:t>, </a:t>
+            </a:r>
+            <a:r>
+              <a:rPr sz="1800" dirty="0" err="1">
+                <a:solidFill>
+                  <a:srgbClr val="212121"/>
+                </a:solidFill>
+                <a:latin typeface="Courier New"/>
+              </a:rPr>
+              <a:t>BitVec</a:t>
+            </a:r>
+            <a:r>
+              <a:rPr sz="1800" dirty="0">
+                <a:solidFill>
+                  <a:srgbClr val="212121"/>
+                </a:solidFill>
+                <a:latin typeface="Courier New"/>
+              </a:rPr>
+              <a:t>, Solver, sat, </a:t>
+            </a:r>
+            <a:r>
+              <a:rPr sz="1800" dirty="0" err="1">
+                <a:solidFill>
+                  <a:srgbClr val="212121"/>
+                </a:solidFill>
+                <a:latin typeface="Courier New"/>
+              </a:rPr>
+              <a:t>unsat</a:t>
+            </a:r>
+            <a:endParaRPr sz="1800" dirty="0">
+              <a:solidFill>
+                <a:srgbClr val="212121"/>
+              </a:solidFill>
+              <a:latin typeface="Courier New"/>
+            </a:endParaRPr>
           </a:p>
           <a:p>
             <a:pPr>
@@ -6907,13 +7267,31 @@
               </a:spcAft>
             </a:pPr>
             <a:r>
-              <a:rPr sz="1800">
+              <a:rPr sz="1800" dirty="0">
                 <a:solidFill>
                   <a:srgbClr val="212121"/>
                 </a:solidFill>
                 <a:latin typeface="Courier New"/>
               </a:rPr>
-              <a:t>a, b = Bools("a b")     # symbolic booleans, not values</a:t>
+              <a:t>a, b = Bools("a b")     # symbolic </a:t>
+            </a:r>
+            <a:r>
+              <a:rPr sz="1800" dirty="0" err="1">
+                <a:solidFill>
+                  <a:srgbClr val="212121"/>
+                </a:solidFill>
+                <a:latin typeface="Courier New"/>
+              </a:rPr>
+              <a:t>booleans</a:t>
+            </a:r>
+            <a:r>
+              <a:rPr sz="1800" dirty="0">
+                <a:solidFill>
+                  <a:srgbClr val="212121"/>
+                </a:solidFill>
+                <a:latin typeface="Courier New"/>
+              </a:rPr>
+              <a:t>, not values</a:t>
             </a:r>
           </a:p>
           <a:p>
@@ -6923,13 +7301,31 @@
               </a:spcAft>
             </a:pPr>
             <a:r>
-              <a:rPr sz="1800">
+              <a:rPr sz="1800" dirty="0">
                 <a:solidFill>
                   <a:srgbClr val="212121"/>
                 </a:solidFill>
                 <a:latin typeface="Courier New"/>
               </a:rPr>
-              <a:t>x = BitVec("x", 32)     # a 32-bit machine integer</a:t>
+              <a:t>x = </a:t>
+            </a:r>
+            <a:r>
+              <a:rPr sz="1800" dirty="0" err="1">
+                <a:solidFill>
+                  <a:srgbClr val="212121"/>
+                </a:solidFill>
+                <a:latin typeface="Courier New"/>
+              </a:rPr>
+              <a:t>BitVec</a:t>
+            </a:r>
+            <a:r>
+              <a:rPr sz="1800" dirty="0">
+                <a:solidFill>
+                  <a:srgbClr val="212121"/>
+                </a:solidFill>
+                <a:latin typeface="Courier New"/>
+              </a:rPr>
+              <a:t>("x", 32)     # a 32-bit machine integer</a:t>
             </a:r>
           </a:p>
           <a:p>
@@ -6938,14 +7334,27 @@
                 <a:spcPts val="0"/>
               </a:spcAft>
             </a:pPr>
-            <a:r>
-              <a:rPr sz="1800">
+            <a:endParaRPr sz="1800" dirty="0">
+              <a:solidFill>
+                <a:srgbClr val="212121"/>
+              </a:solidFill>
+              <a:latin typeface="Courier New"/>
+            </a:endParaRPr>
+          </a:p>
+          <a:p>
+            <a:pPr>
+              <a:spcAft>
+                <a:spcPts val="0"/>
+              </a:spcAft>
+            </a:pPr>
+            <a:r>
+              <a:rPr sz="1800" dirty="0">
                 <a:solidFill>
                   <a:srgbClr val="212121"/>
                 </a:solidFill>
                 <a:latin typeface="Courier New"/>
               </a:rPr>
-              <a:t/>
+              <a:t>s = Solver()</a:t>
             </a:r>
           </a:p>
           <a:p>
@@ -6955,13 +7364,22 @@
               </a:spcAft>
             </a:pPr>
             <a:r>
-              <a:rPr sz="1800">
+              <a:rPr sz="1800" dirty="0" err="1">
                 <a:solidFill>
                   <a:srgbClr val="212121"/>
                 </a:solidFill>
                 <a:latin typeface="Courier New"/>
               </a:rPr>
-              <a:t>s = Solver()</a:t>
+              <a:t>s.add</a:t>
+            </a:r>
+            <a:r>
+              <a:rPr sz="1800" dirty="0">
+                <a:solidFill>
+                  <a:srgbClr val="212121"/>
+                </a:solidFill>
+                <a:latin typeface="Courier New"/>
+              </a:rPr>
+              <a:t>(formula)           # constrain</a:t>
             </a:r>
           </a:p>
           <a:p>
@@ -6971,14 +7389,38 @@
               </a:spcAft>
             </a:pPr>
             <a:r>
-              <a:rPr sz="1800">
+              <a:rPr sz="1800" dirty="0" err="1">
                 <a:solidFill>
                   <a:srgbClr val="212121"/>
                 </a:solidFill>
                 <a:latin typeface="Courier New"/>
               </a:rPr>
-              <a:t>s.add(formula)           # constrain</a:t>
-            </a:r>
+              <a:t>s.check</a:t>
+            </a:r>
+            <a:r>
+              <a:rPr sz="1800" dirty="0">
+                <a:solidFill>
+                  <a:srgbClr val="212121"/>
+                </a:solidFill>
+                <a:latin typeface="Courier New"/>
+              </a:rPr>
+              <a:t>()                # -&gt; sat or </a:t>
+            </a:r>
+            <a:r>
+              <a:rPr sz="1800" dirty="0" err="1">
+                <a:solidFill>
+                  <a:srgbClr val="212121"/>
+                </a:solidFill>
+                <a:latin typeface="Courier New"/>
+              </a:rPr>
+              <a:t>unsat</a:t>
+            </a:r>
+            <a:endParaRPr sz="1800" dirty="0">
+              <a:solidFill>
+                <a:srgbClr val="212121"/>
+              </a:solidFill>
+              <a:latin typeface="Courier New"/>
+            </a:endParaRPr>
           </a:p>
           <a:p>
             <a:pPr>
@@ -6987,59 +7429,66 @@
               </a:spcAft>
             </a:pPr>
             <a:r>
-              <a:rPr sz="1800">
+              <a:rPr sz="1800" dirty="0" err="1">
                 <a:solidFill>
                   <a:srgbClr val="212121"/>
                 </a:solidFill>
                 <a:latin typeface="Courier New"/>
               </a:rPr>
-              <a:t>s.check()                # -&gt; sat or unsat</a:t>
-            </a:r>
-          </a:p>
-          <a:p>
-            <a:pPr>
-              <a:spcAft>
-                <a:spcPts val="0"/>
-              </a:spcAft>
-            </a:pPr>
-            <a:r>
-              <a:rPr sz="1800">
+              <a:t>s.model</a:t>
+            </a:r>
+            <a:r>
+              <a:rPr sz="1800" dirty="0">
                 <a:solidFill>
                   <a:srgbClr val="212121"/>
                 </a:solidFill>
                 <a:latin typeface="Courier New"/>
               </a:rPr>
-              <a:t>s.model()                # the witness, when sat</a:t>
-            </a:r>
-          </a:p>
-          <a:p>
-            <a:pPr>
-              <a:spcAft>
-                <a:spcPts val="800"/>
-              </a:spcAft>
-            </a:pPr>
-            <a:r>
-              <a:rPr sz="2200">
-                <a:solidFill>
-                  <a:srgbClr val="212121"/>
-                </a:solidFill>
-              </a:rPr>
-              <a:t/>
-            </a:r>
-          </a:p>
-          <a:p>
-            <a:pPr>
-              <a:spcAft>
-                <a:spcPts val="800"/>
-              </a:spcAft>
-            </a:pPr>
-            <a:r>
-              <a:rPr sz="2200">
-                <a:solidFill>
-                  <a:srgbClr val="212121"/>
-                </a:solidFill>
-              </a:rPr>
-              <a:t>Every stage of lab1.py is these five calls — nothing else.</a:t>
+              <a:t>()                # the witness, when sat</a:t>
+            </a:r>
+          </a:p>
+          <a:p>
+            <a:pPr>
+              <a:spcAft>
+                <a:spcPts val="800"/>
+              </a:spcAft>
+            </a:pPr>
+            <a:endParaRPr sz="1800" dirty="0">
+              <a:solidFill>
+                <a:srgbClr val="212121"/>
+              </a:solidFill>
+              <a:latin typeface="Courier New"/>
+            </a:endParaRPr>
+          </a:p>
+          <a:p>
+            <a:pPr>
+              <a:spcAft>
+                <a:spcPts val="800"/>
+              </a:spcAft>
+            </a:pPr>
+            <a:r>
+              <a:rPr sz="2200" dirty="0">
+                <a:solidFill>
+                  <a:srgbClr val="212121"/>
+                </a:solidFill>
+              </a:rPr>
+              <a:t>Every stage of lab1.py is these five calls</a:t>
+            </a:r>
+            <a:r>
+              <a:rPr lang="en-GB" sz="2200" dirty="0">
+                <a:solidFill>
+                  <a:srgbClr val="212121"/>
+                </a:solidFill>
+              </a:rPr>
+              <a:t>;</a:t>
+            </a:r>
+            <a:r>
+              <a:rPr sz="2200" dirty="0">
+                <a:solidFill>
+                  <a:srgbClr val="212121"/>
+                </a:solidFill>
+              </a:rPr>
+              <a:t> nothing else.</a:t>
             </a:r>
           </a:p>
         </p:txBody>
@@ -7053,7 +7502,7 @@
 </file>
 
 <file path=ppt/slides/slide8.xml><?xml version="1.0" encoding="utf-8"?>
-<p:sld xmlns:a="http://schemas.openxmlformats.org/drawingml/2006/main" xmlns:p="http://schemas.openxmlformats.org/presentationml/2006/main" xmlns:r="http://schemas.openxmlformats.org/officeDocument/2006/relationships">
+<p:sld xmlns:a="http://schemas.openxmlformats.org/drawingml/2006/main" xmlns:r="http://schemas.openxmlformats.org/officeDocument/2006/relationships" xmlns:p="http://schemas.openxmlformats.org/presentationml/2006/main">
   <p:cSld>
     <p:spTree>
       <p:nvGrpSpPr>
@@ -7061,7 +7510,14 @@
         <p:cNvGrpSpPr/>
         <p:nvPr/>
       </p:nvGrpSpPr>
-      <p:grpSpPr/>
+      <p:grpSpPr>
+        <a:xfrm>
+          <a:off x="0" y="0"/>
+          <a:ext cx="0" cy="0"/>
+          <a:chOff x="0" y="0"/>
+          <a:chExt cx="0" cy="0"/>
+        </a:xfrm>
+      </p:grpSpPr>
       <p:sp>
         <p:nvSpPr>
           <p:cNvPr id="2" name="TextBox 1"/>
@@ -7234,14 +7690,12 @@
                 <a:spcPts val="800"/>
               </a:spcAft>
             </a:pPr>
-            <a:r>
-              <a:rPr sz="2200">
-                <a:solidFill>
-                  <a:srgbClr val="212121"/>
-                </a:solidFill>
-              </a:rPr>
-              <a:t/>
-            </a:r>
+            <a:endParaRPr sz="1800">
+              <a:solidFill>
+                <a:srgbClr val="212121"/>
+              </a:solidFill>
+              <a:latin typeface="Courier New"/>
+            </a:endParaRPr>
           </a:p>
           <a:p>
             <a:pPr lvl="1">
@@ -7300,7 +7754,7 @@
 </file>
 
 <file path=ppt/slides/slide9.xml><?xml version="1.0" encoding="utf-8"?>
-<p:sld xmlns:a="http://schemas.openxmlformats.org/drawingml/2006/main" xmlns:p="http://schemas.openxmlformats.org/presentationml/2006/main" xmlns:r="http://schemas.openxmlformats.org/officeDocument/2006/relationships">
+<p:sld xmlns:a="http://schemas.openxmlformats.org/drawingml/2006/main" xmlns:r="http://schemas.openxmlformats.org/officeDocument/2006/relationships" xmlns:p="http://schemas.openxmlformats.org/presentationml/2006/main">
   <p:cSld>
     <p:spTree>
       <p:nvGrpSpPr>
@@ -7308,7 +7762,14 @@
         <p:cNvGrpSpPr/>
         <p:nvPr/>
       </p:nvGrpSpPr>
-      <p:grpSpPr/>
+      <p:grpSpPr>
+        <a:xfrm>
+          <a:off x="0" y="0"/>
+          <a:ext cx="0" cy="0"/>
+          <a:chOff x="0" y="0"/>
+          <a:chExt cx="0" cy="0"/>
+        </a:xfrm>
+      </p:grpSpPr>
       <p:sp>
         <p:nvSpPr>
           <p:cNvPr id="2" name="TextBox 1"/>
@@ -7433,58 +7894,56 @@
                 <a:spcPts val="800"/>
               </a:spcAft>
             </a:pPr>
+            <a:endParaRPr sz="1800">
+              <a:solidFill>
+                <a:srgbClr val="212121"/>
+              </a:solidFill>
+              <a:latin typeface="Courier New"/>
+            </a:endParaRPr>
+          </a:p>
+          <a:p>
+            <a:pPr>
+              <a:spcAft>
+                <a:spcPts val="0"/>
+              </a:spcAft>
+            </a:pPr>
+            <a:r>
+              <a:rPr sz="1800">
+                <a:solidFill>
+                  <a:srgbClr val="212121"/>
+                </a:solidFill>
+                <a:latin typeface="Courier New"/>
+              </a:rPr>
+              <a:t>sat — counterexample e.g. x = 1073741824 (= 2^30)</a:t>
+            </a:r>
+          </a:p>
+          <a:p>
+            <a:pPr lvl="1">
+              <a:spcAft>
+                <a:spcPts val="800"/>
+              </a:spcAft>
+            </a:pPr>
+            <a:r>
+              <a:rPr sz="2000">
+                <a:solidFill>
+                  <a:srgbClr val="212121"/>
+                </a:solidFill>
+              </a:rPr>
+              <a:t>y * 2 overflows the 32-bit range: z comes out negative.</a:t>
+            </a:r>
+          </a:p>
+          <a:p>
+            <a:pPr>
+              <a:spcAft>
+                <a:spcPts val="800"/>
+              </a:spcAft>
+            </a:pPr>
             <a:r>
               <a:rPr sz="2200">
                 <a:solidFill>
                   <a:srgbClr val="212121"/>
                 </a:solidFill>
               </a:rPr>
-              <a:t/>
-            </a:r>
-          </a:p>
-          <a:p>
-            <a:pPr>
-              <a:spcAft>
-                <a:spcPts val="0"/>
-              </a:spcAft>
-            </a:pPr>
-            <a:r>
-              <a:rPr sz="1800">
-                <a:solidFill>
-                  <a:srgbClr val="212121"/>
-                </a:solidFill>
-                <a:latin typeface="Courier New"/>
-              </a:rPr>
-              <a:t>sat — counterexample e.g. x = 1073741824 (= 2^30)</a:t>
-            </a:r>
-          </a:p>
-          <a:p>
-            <a:pPr lvl="1">
-              <a:spcAft>
-                <a:spcPts val="800"/>
-              </a:spcAft>
-            </a:pPr>
-            <a:r>
-              <a:rPr sz="2000">
-                <a:solidFill>
-                  <a:srgbClr val="212121"/>
-                </a:solidFill>
-              </a:rPr>
-              <a:t>y * 2 overflows the 32-bit range: z comes out negative.</a:t>
-            </a:r>
-          </a:p>
-          <a:p>
-            <a:pPr>
-              <a:spcAft>
-                <a:spcPts val="800"/>
-              </a:spcAft>
-            </a:pPr>
-            <a:r>
-              <a:rPr sz="2200">
-                <a:solidFill>
-                  <a:srgbClr val="212121"/>
-                </a:solidFill>
-              </a:rPr>
               <a:t>Would your test suite have tried 1073741824?</a:t>
             </a:r>
           </a:p>
@@ -7494,14 +7953,11 @@
                 <a:spcPts val="800"/>
               </a:spcAft>
             </a:pPr>
-            <a:r>
-              <a:rPr sz="2200">
-                <a:solidFill>
-                  <a:srgbClr val="212121"/>
-                </a:solidFill>
-              </a:rPr>
-              <a:t/>
-            </a:r>
+            <a:endParaRPr sz="2200">
+              <a:solidFill>
+                <a:srgbClr val="212121"/>
+              </a:solidFill>
+            </a:endParaRPr>
           </a:p>
           <a:p>
             <a:pPr>

</xml_diff>

<commit_message>
Clarify Python integer semantics in Session 2 (machine word vs --ir)
Correct the Box B slide: the default 64-bit overflow witness (2^63) is a
modelling artifact that does not reproduce in real CPython (ints are
arbitrary-precision). Add a slide contrasting default machine-word integers
with --ir's unbounded integer/real arithmetic (witness x=-1, which does
reproduce) and --ir-ieee for reals. Record the --ir verdict in the
instructor ledger.
</commit_message>
<xml_diff>
--- a/slides/session2/01-session2-hands-on.pptx
+++ b/slides/session2/01-session2-hands-on.pptx
@@ -5,30 +5,31 @@
     <p:sldMasterId id="2147483648" r:id="rId1"/>
   </p:sldMasterIdLst>
   <p:sldIdLst>
-    <p:sldId id="256" r:id="rId2"/>
-    <p:sldId id="257" r:id="rId3"/>
-    <p:sldId id="258" r:id="rId4"/>
-    <p:sldId id="259" r:id="rId5"/>
-    <p:sldId id="260" r:id="rId6"/>
-    <p:sldId id="261" r:id="rId7"/>
-    <p:sldId id="262" r:id="rId8"/>
-    <p:sldId id="263" r:id="rId9"/>
-    <p:sldId id="264" r:id="rId10"/>
-    <p:sldId id="265" r:id="rId11"/>
-    <p:sldId id="266" r:id="rId12"/>
-    <p:sldId id="267" r:id="rId13"/>
-    <p:sldId id="268" r:id="rId14"/>
-    <p:sldId id="269" r:id="rId15"/>
-    <p:sldId id="270" r:id="rId16"/>
-    <p:sldId id="271" r:id="rId17"/>
-    <p:sldId id="272" r:id="rId18"/>
-    <p:sldId id="273" r:id="rId19"/>
-    <p:sldId id="274" r:id="rId20"/>
-    <p:sldId id="275" r:id="rId21"/>
-    <p:sldId id="276" r:id="rId22"/>
-    <p:sldId id="277" r:id="rId23"/>
+    <p:sldId id="256" r:id="rId7"/>
+    <p:sldId id="257" r:id="rId8"/>
+    <p:sldId id="258" r:id="rId9"/>
+    <p:sldId id="259" r:id="rId10"/>
+    <p:sldId id="260" r:id="rId11"/>
+    <p:sldId id="261" r:id="rId12"/>
+    <p:sldId id="262" r:id="rId13"/>
+    <p:sldId id="263" r:id="rId14"/>
+    <p:sldId id="264" r:id="rId15"/>
+    <p:sldId id="265" r:id="rId16"/>
+    <p:sldId id="266" r:id="rId17"/>
+    <p:sldId id="267" r:id="rId18"/>
+    <p:sldId id="268" r:id="rId19"/>
+    <p:sldId id="269" r:id="rId20"/>
+    <p:sldId id="270" r:id="rId21"/>
+    <p:sldId id="271" r:id="rId22"/>
+    <p:sldId id="272" r:id="rId23"/>
+    <p:sldId id="273" r:id="rId24"/>
+    <p:sldId id="274" r:id="rId25"/>
+    <p:sldId id="275" r:id="rId26"/>
+    <p:sldId id="276" r:id="rId27"/>
+    <p:sldId id="277" r:id="rId28"/>
+    <p:sldId id="278" r:id="rId29"/>
   </p:sldIdLst>
-  <p:sldSz cx="12192000" cy="6858000"/>
+  <p:sldSz cx="12191695" cy="6858000" type="screen4x3"/>
   <p:notesSz cx="6858000" cy="9144000"/>
   <p:defaultTextStyle>
     <a:defPPr>
@@ -125,22 +126,6 @@
       </a:defRPr>
     </a:lvl9pPr>
   </p:defaultTextStyle>
-  <p:extLst>
-    <p:ext uri="{EFAFB233-063F-42B5-8137-9DF3F51BA10A}">
-      <p15:sldGuideLst xmlns:p15="http://schemas.microsoft.com/office/powerpoint/2012/main">
-        <p15:guide id="1" orient="horz" pos="2160">
-          <p15:clr>
-            <a:srgbClr val="A4A3A4"/>
-          </p15:clr>
-        </p15:guide>
-        <p15:guide id="2" pos="2880">
-          <p15:clr>
-            <a:srgbClr val="A4A3A4"/>
-          </p15:clr>
-        </p15:guide>
-      </p15:sldGuideLst>
-    </p:ext>
-  </p:extLst>
 </p:presentation>
 </file>
 
@@ -182,9 +167,10 @@
           <a:lstStyle/>
           <a:p>
             <a:r>
-              <a:rPr lang="en-US"/>
+              <a:rPr lang="en-US" smtClean="0"/>
               <a:t>Click to edit Master title style</a:t>
             </a:r>
+            <a:endParaRPr lang="en-US"/>
           </a:p>
         </p:txBody>
       </p:sp>
@@ -300,9 +286,10 @@
           </a:lstStyle>
           <a:p>
             <a:r>
-              <a:rPr lang="en-US"/>
+              <a:rPr lang="en-US" smtClean="0"/>
               <a:t>Click to edit Master subtitle style</a:t>
             </a:r>
+            <a:endParaRPr lang="en-US"/>
           </a:p>
         </p:txBody>
       </p:sp>
@@ -323,7 +310,7 @@
           <a:p>
             <a:fld id="{5BCAD085-E8A6-8845-BD4E-CB4CCA059FC4}" type="datetimeFigureOut">
               <a:rPr lang="en-US" smtClean="0"/>
-              <a:t>6/13/26</a:t>
+              <a:t>1/27/13</a:t>
             </a:fld>
             <a:endParaRPr lang="en-US"/>
           </a:p>
@@ -417,9 +404,10 @@
           <a:lstStyle/>
           <a:p>
             <a:r>
-              <a:rPr lang="en-US"/>
+              <a:rPr lang="en-US" smtClean="0"/>
               <a:t>Click to edit Master title style</a:t>
             </a:r>
+            <a:endParaRPr lang="en-US"/>
           </a:p>
         </p:txBody>
       </p:sp>
@@ -440,37 +428,38 @@
           <a:p>
             <a:pPr lvl="0"/>
             <a:r>
-              <a:rPr lang="en-US"/>
+              <a:rPr lang="en-US" smtClean="0"/>
               <a:t>Click to edit Master text styles</a:t>
             </a:r>
           </a:p>
           <a:p>
             <a:pPr lvl="1"/>
             <a:r>
-              <a:rPr lang="en-US"/>
+              <a:rPr lang="en-US" smtClean="0"/>
               <a:t>Second level</a:t>
             </a:r>
           </a:p>
           <a:p>
             <a:pPr lvl="2"/>
             <a:r>
-              <a:rPr lang="en-US"/>
+              <a:rPr lang="en-US" smtClean="0"/>
               <a:t>Third level</a:t>
             </a:r>
           </a:p>
           <a:p>
             <a:pPr lvl="3"/>
             <a:r>
-              <a:rPr lang="en-US"/>
+              <a:rPr lang="en-US" smtClean="0"/>
               <a:t>Fourth level</a:t>
             </a:r>
           </a:p>
           <a:p>
             <a:pPr lvl="4"/>
             <a:r>
-              <a:rPr lang="en-US"/>
+              <a:rPr lang="en-US" smtClean="0"/>
               <a:t>Fifth level</a:t>
             </a:r>
+            <a:endParaRPr lang="en-US"/>
           </a:p>
         </p:txBody>
       </p:sp>
@@ -491,7 +480,7 @@
           <a:p>
             <a:fld id="{5BCAD085-E8A6-8845-BD4E-CB4CCA059FC4}" type="datetimeFigureOut">
               <a:rPr lang="en-US" smtClean="0"/>
-              <a:t>6/13/26</a:t>
+              <a:t>1/27/13</a:t>
             </a:fld>
             <a:endParaRPr lang="en-US"/>
           </a:p>
@@ -590,9 +579,10 @@
           <a:lstStyle/>
           <a:p>
             <a:r>
-              <a:rPr lang="en-US"/>
+              <a:rPr lang="en-US" smtClean="0"/>
               <a:t>Click to edit Master title style</a:t>
             </a:r>
+            <a:endParaRPr lang="en-US"/>
           </a:p>
         </p:txBody>
       </p:sp>
@@ -618,37 +608,38 @@
           <a:p>
             <a:pPr lvl="0"/>
             <a:r>
-              <a:rPr lang="en-US"/>
+              <a:rPr lang="en-US" smtClean="0"/>
               <a:t>Click to edit Master text styles</a:t>
             </a:r>
           </a:p>
           <a:p>
             <a:pPr lvl="1"/>
             <a:r>
-              <a:rPr lang="en-US"/>
+              <a:rPr lang="en-US" smtClean="0"/>
               <a:t>Second level</a:t>
             </a:r>
           </a:p>
           <a:p>
             <a:pPr lvl="2"/>
             <a:r>
-              <a:rPr lang="en-US"/>
+              <a:rPr lang="en-US" smtClean="0"/>
               <a:t>Third level</a:t>
             </a:r>
           </a:p>
           <a:p>
             <a:pPr lvl="3"/>
             <a:r>
-              <a:rPr lang="en-US"/>
+              <a:rPr lang="en-US" smtClean="0"/>
               <a:t>Fourth level</a:t>
             </a:r>
           </a:p>
           <a:p>
             <a:pPr lvl="4"/>
             <a:r>
-              <a:rPr lang="en-US"/>
+              <a:rPr lang="en-US" smtClean="0"/>
               <a:t>Fifth level</a:t>
             </a:r>
+            <a:endParaRPr lang="en-US"/>
           </a:p>
         </p:txBody>
       </p:sp>
@@ -669,7 +660,7 @@
           <a:p>
             <a:fld id="{5BCAD085-E8A6-8845-BD4E-CB4CCA059FC4}" type="datetimeFigureOut">
               <a:rPr lang="en-US" smtClean="0"/>
-              <a:t>6/13/26</a:t>
+              <a:t>1/27/13</a:t>
             </a:fld>
             <a:endParaRPr lang="en-US"/>
           </a:p>
@@ -763,9 +754,10 @@
           <a:lstStyle/>
           <a:p>
             <a:r>
-              <a:rPr lang="en-US"/>
+              <a:rPr lang="en-US" smtClean="0"/>
               <a:t>Click to edit Master title style</a:t>
             </a:r>
+            <a:endParaRPr lang="en-US"/>
           </a:p>
         </p:txBody>
       </p:sp>
@@ -786,37 +778,38 @@
           <a:p>
             <a:pPr lvl="0"/>
             <a:r>
-              <a:rPr lang="en-US"/>
+              <a:rPr lang="en-US" smtClean="0"/>
               <a:t>Click to edit Master text styles</a:t>
             </a:r>
           </a:p>
           <a:p>
             <a:pPr lvl="1"/>
             <a:r>
-              <a:rPr lang="en-US"/>
+              <a:rPr lang="en-US" smtClean="0"/>
               <a:t>Second level</a:t>
             </a:r>
           </a:p>
           <a:p>
             <a:pPr lvl="2"/>
             <a:r>
-              <a:rPr lang="en-US"/>
+              <a:rPr lang="en-US" smtClean="0"/>
               <a:t>Third level</a:t>
             </a:r>
           </a:p>
           <a:p>
             <a:pPr lvl="3"/>
             <a:r>
-              <a:rPr lang="en-US"/>
+              <a:rPr lang="en-US" smtClean="0"/>
               <a:t>Fourth level</a:t>
             </a:r>
           </a:p>
           <a:p>
             <a:pPr lvl="4"/>
             <a:r>
-              <a:rPr lang="en-US"/>
+              <a:rPr lang="en-US" smtClean="0"/>
               <a:t>Fifth level</a:t>
             </a:r>
+            <a:endParaRPr lang="en-US"/>
           </a:p>
         </p:txBody>
       </p:sp>
@@ -837,7 +830,7 @@
           <a:p>
             <a:fld id="{5BCAD085-E8A6-8845-BD4E-CB4CCA059FC4}" type="datetimeFigureOut">
               <a:rPr lang="en-US" smtClean="0"/>
-              <a:t>6/13/26</a:t>
+              <a:t>1/27/13</a:t>
             </a:fld>
             <a:endParaRPr lang="en-US"/>
           </a:p>
@@ -940,9 +933,10 @@
           </a:lstStyle>
           <a:p>
             <a:r>
-              <a:rPr lang="en-US"/>
+              <a:rPr lang="en-US" smtClean="0"/>
               <a:t>Click to edit Master title style</a:t>
             </a:r>
+            <a:endParaRPr lang="en-US"/>
           </a:p>
         </p:txBody>
       </p:sp>
@@ -1059,7 +1053,7 @@
           <a:p>
             <a:pPr lvl="0"/>
             <a:r>
-              <a:rPr lang="en-US"/>
+              <a:rPr lang="en-US" smtClean="0"/>
               <a:t>Click to edit Master text styles</a:t>
             </a:r>
           </a:p>
@@ -1082,7 +1076,7 @@
           <a:p>
             <a:fld id="{5BCAD085-E8A6-8845-BD4E-CB4CCA059FC4}" type="datetimeFigureOut">
               <a:rPr lang="en-US" smtClean="0"/>
-              <a:t>6/13/26</a:t>
+              <a:t>1/27/13</a:t>
             </a:fld>
             <a:endParaRPr lang="en-US"/>
           </a:p>
@@ -1176,9 +1170,10 @@
           <a:lstStyle/>
           <a:p>
             <a:r>
-              <a:rPr lang="en-US"/>
+              <a:rPr lang="en-US" smtClean="0"/>
               <a:t>Click to edit Master title style</a:t>
             </a:r>
+            <a:endParaRPr lang="en-US"/>
           </a:p>
         </p:txBody>
       </p:sp>
@@ -1232,37 +1227,38 @@
           <a:p>
             <a:pPr lvl="0"/>
             <a:r>
-              <a:rPr lang="en-US"/>
+              <a:rPr lang="en-US" smtClean="0"/>
               <a:t>Click to edit Master text styles</a:t>
             </a:r>
           </a:p>
           <a:p>
             <a:pPr lvl="1"/>
             <a:r>
-              <a:rPr lang="en-US"/>
+              <a:rPr lang="en-US" smtClean="0"/>
               <a:t>Second level</a:t>
             </a:r>
           </a:p>
           <a:p>
             <a:pPr lvl="2"/>
             <a:r>
-              <a:rPr lang="en-US"/>
+              <a:rPr lang="en-US" smtClean="0"/>
               <a:t>Third level</a:t>
             </a:r>
           </a:p>
           <a:p>
             <a:pPr lvl="3"/>
             <a:r>
-              <a:rPr lang="en-US"/>
+              <a:rPr lang="en-US" smtClean="0"/>
               <a:t>Fourth level</a:t>
             </a:r>
           </a:p>
           <a:p>
             <a:pPr lvl="4"/>
             <a:r>
-              <a:rPr lang="en-US"/>
+              <a:rPr lang="en-US" smtClean="0"/>
               <a:t>Fifth level</a:t>
             </a:r>
+            <a:endParaRPr lang="en-US"/>
           </a:p>
         </p:txBody>
       </p:sp>
@@ -1316,37 +1312,38 @@
           <a:p>
             <a:pPr lvl="0"/>
             <a:r>
-              <a:rPr lang="en-US"/>
+              <a:rPr lang="en-US" smtClean="0"/>
               <a:t>Click to edit Master text styles</a:t>
             </a:r>
           </a:p>
           <a:p>
             <a:pPr lvl="1"/>
             <a:r>
-              <a:rPr lang="en-US"/>
+              <a:rPr lang="en-US" smtClean="0"/>
               <a:t>Second level</a:t>
             </a:r>
           </a:p>
           <a:p>
             <a:pPr lvl="2"/>
             <a:r>
-              <a:rPr lang="en-US"/>
+              <a:rPr lang="en-US" smtClean="0"/>
               <a:t>Third level</a:t>
             </a:r>
           </a:p>
           <a:p>
             <a:pPr lvl="3"/>
             <a:r>
-              <a:rPr lang="en-US"/>
+              <a:rPr lang="en-US" smtClean="0"/>
               <a:t>Fourth level</a:t>
             </a:r>
           </a:p>
           <a:p>
             <a:pPr lvl="4"/>
             <a:r>
-              <a:rPr lang="en-US"/>
+              <a:rPr lang="en-US" smtClean="0"/>
               <a:t>Fifth level</a:t>
             </a:r>
+            <a:endParaRPr lang="en-US"/>
           </a:p>
         </p:txBody>
       </p:sp>
@@ -1367,7 +1364,7 @@
           <a:p>
             <a:fld id="{5BCAD085-E8A6-8845-BD4E-CB4CCA059FC4}" type="datetimeFigureOut">
               <a:rPr lang="en-US" smtClean="0"/>
-              <a:t>6/13/26</a:t>
+              <a:t>1/27/13</a:t>
             </a:fld>
             <a:endParaRPr lang="en-US"/>
           </a:p>
@@ -1465,9 +1462,10 @@
           </a:lstStyle>
           <a:p>
             <a:r>
-              <a:rPr lang="en-US"/>
+              <a:rPr lang="en-US" smtClean="0"/>
               <a:t>Click to edit Master title style</a:t>
             </a:r>
+            <a:endParaRPr lang="en-US"/>
           </a:p>
         </p:txBody>
       </p:sp>
@@ -1530,7 +1528,7 @@
           <a:p>
             <a:pPr lvl="0"/>
             <a:r>
-              <a:rPr lang="en-US"/>
+              <a:rPr lang="en-US" smtClean="0"/>
               <a:t>Click to edit Master text styles</a:t>
             </a:r>
           </a:p>
@@ -1586,37 +1584,38 @@
           <a:p>
             <a:pPr lvl="0"/>
             <a:r>
-              <a:rPr lang="en-US"/>
+              <a:rPr lang="en-US" smtClean="0"/>
               <a:t>Click to edit Master text styles</a:t>
             </a:r>
           </a:p>
           <a:p>
             <a:pPr lvl="1"/>
             <a:r>
-              <a:rPr lang="en-US"/>
+              <a:rPr lang="en-US" smtClean="0"/>
               <a:t>Second level</a:t>
             </a:r>
           </a:p>
           <a:p>
             <a:pPr lvl="2"/>
             <a:r>
-              <a:rPr lang="en-US"/>
+              <a:rPr lang="en-US" smtClean="0"/>
               <a:t>Third level</a:t>
             </a:r>
           </a:p>
           <a:p>
             <a:pPr lvl="3"/>
             <a:r>
-              <a:rPr lang="en-US"/>
+              <a:rPr lang="en-US" smtClean="0"/>
               <a:t>Fourth level</a:t>
             </a:r>
           </a:p>
           <a:p>
             <a:pPr lvl="4"/>
             <a:r>
-              <a:rPr lang="en-US"/>
+              <a:rPr lang="en-US" smtClean="0"/>
               <a:t>Fifth level</a:t>
             </a:r>
+            <a:endParaRPr lang="en-US"/>
           </a:p>
         </p:txBody>
       </p:sp>
@@ -1679,7 +1678,7 @@
           <a:p>
             <a:pPr lvl="0"/>
             <a:r>
-              <a:rPr lang="en-US"/>
+              <a:rPr lang="en-US" smtClean="0"/>
               <a:t>Click to edit Master text styles</a:t>
             </a:r>
           </a:p>
@@ -1735,37 +1734,38 @@
           <a:p>
             <a:pPr lvl="0"/>
             <a:r>
-              <a:rPr lang="en-US"/>
+              <a:rPr lang="en-US" smtClean="0"/>
               <a:t>Click to edit Master text styles</a:t>
             </a:r>
           </a:p>
           <a:p>
             <a:pPr lvl="1"/>
             <a:r>
-              <a:rPr lang="en-US"/>
+              <a:rPr lang="en-US" smtClean="0"/>
               <a:t>Second level</a:t>
             </a:r>
           </a:p>
           <a:p>
             <a:pPr lvl="2"/>
             <a:r>
-              <a:rPr lang="en-US"/>
+              <a:rPr lang="en-US" smtClean="0"/>
               <a:t>Third level</a:t>
             </a:r>
           </a:p>
           <a:p>
             <a:pPr lvl="3"/>
             <a:r>
-              <a:rPr lang="en-US"/>
+              <a:rPr lang="en-US" smtClean="0"/>
               <a:t>Fourth level</a:t>
             </a:r>
           </a:p>
           <a:p>
             <a:pPr lvl="4"/>
             <a:r>
-              <a:rPr lang="en-US"/>
+              <a:rPr lang="en-US" smtClean="0"/>
               <a:t>Fifth level</a:t>
             </a:r>
+            <a:endParaRPr lang="en-US"/>
           </a:p>
         </p:txBody>
       </p:sp>
@@ -1786,7 +1786,7 @@
           <a:p>
             <a:fld id="{5BCAD085-E8A6-8845-BD4E-CB4CCA059FC4}" type="datetimeFigureOut">
               <a:rPr lang="en-US" smtClean="0"/>
-              <a:t>6/13/26</a:t>
+              <a:t>1/27/13</a:t>
             </a:fld>
             <a:endParaRPr lang="en-US"/>
           </a:p>
@@ -1880,9 +1880,10 @@
           <a:lstStyle/>
           <a:p>
             <a:r>
-              <a:rPr lang="en-US"/>
+              <a:rPr lang="en-US" smtClean="0"/>
               <a:t>Click to edit Master title style</a:t>
             </a:r>
+            <a:endParaRPr lang="en-US"/>
           </a:p>
         </p:txBody>
       </p:sp>
@@ -1903,7 +1904,7 @@
           <a:p>
             <a:fld id="{5BCAD085-E8A6-8845-BD4E-CB4CCA059FC4}" type="datetimeFigureOut">
               <a:rPr lang="en-US" smtClean="0"/>
-              <a:t>6/13/26</a:t>
+              <a:t>1/27/13</a:t>
             </a:fld>
             <a:endParaRPr lang="en-US"/>
           </a:p>
@@ -1998,7 +1999,7 @@
           <a:p>
             <a:fld id="{5BCAD085-E8A6-8845-BD4E-CB4CCA059FC4}" type="datetimeFigureOut">
               <a:rPr lang="en-US" smtClean="0"/>
-              <a:t>6/13/26</a:t>
+              <a:t>1/27/13</a:t>
             </a:fld>
             <a:endParaRPr lang="en-US"/>
           </a:p>
@@ -2101,9 +2102,10 @@
           </a:lstStyle>
           <a:p>
             <a:r>
-              <a:rPr lang="en-US"/>
+              <a:rPr lang="en-US" smtClean="0"/>
               <a:t>Click to edit Master title style</a:t>
             </a:r>
+            <a:endParaRPr lang="en-US"/>
           </a:p>
         </p:txBody>
       </p:sp>
@@ -2157,37 +2159,38 @@
           <a:p>
             <a:pPr lvl="0"/>
             <a:r>
-              <a:rPr lang="en-US"/>
+              <a:rPr lang="en-US" smtClean="0"/>
               <a:t>Click to edit Master text styles</a:t>
             </a:r>
           </a:p>
           <a:p>
             <a:pPr lvl="1"/>
             <a:r>
-              <a:rPr lang="en-US"/>
+              <a:rPr lang="en-US" smtClean="0"/>
               <a:t>Second level</a:t>
             </a:r>
           </a:p>
           <a:p>
             <a:pPr lvl="2"/>
             <a:r>
-              <a:rPr lang="en-US"/>
+              <a:rPr lang="en-US" smtClean="0"/>
               <a:t>Third level</a:t>
             </a:r>
           </a:p>
           <a:p>
             <a:pPr lvl="3"/>
             <a:r>
-              <a:rPr lang="en-US"/>
+              <a:rPr lang="en-US" smtClean="0"/>
               <a:t>Fourth level</a:t>
             </a:r>
           </a:p>
           <a:p>
             <a:pPr lvl="4"/>
             <a:r>
-              <a:rPr lang="en-US"/>
+              <a:rPr lang="en-US" smtClean="0"/>
               <a:t>Fifth level</a:t>
             </a:r>
+            <a:endParaRPr lang="en-US"/>
           </a:p>
         </p:txBody>
       </p:sp>
@@ -2250,7 +2253,7 @@
           <a:p>
             <a:pPr lvl="0"/>
             <a:r>
-              <a:rPr lang="en-US"/>
+              <a:rPr lang="en-US" smtClean="0"/>
               <a:t>Click to edit Master text styles</a:t>
             </a:r>
           </a:p>
@@ -2273,7 +2276,7 @@
           <a:p>
             <a:fld id="{5BCAD085-E8A6-8845-BD4E-CB4CCA059FC4}" type="datetimeFigureOut">
               <a:rPr lang="en-US" smtClean="0"/>
-              <a:t>6/13/26</a:t>
+              <a:t>1/27/13</a:t>
             </a:fld>
             <a:endParaRPr lang="en-US"/>
           </a:p>
@@ -2376,9 +2379,10 @@
           </a:lstStyle>
           <a:p>
             <a:r>
-              <a:rPr lang="en-US"/>
+              <a:rPr lang="en-US" smtClean="0"/>
               <a:t>Click to edit Master title style</a:t>
             </a:r>
+            <a:endParaRPr lang="en-US"/>
           </a:p>
         </p:txBody>
       </p:sp>
@@ -2502,7 +2506,7 @@
           <a:p>
             <a:pPr lvl="0"/>
             <a:r>
-              <a:rPr lang="en-US"/>
+              <a:rPr lang="en-US" smtClean="0"/>
               <a:t>Click to edit Master text styles</a:t>
             </a:r>
           </a:p>
@@ -2525,7 +2529,7 @@
           <a:p>
             <a:fld id="{5BCAD085-E8A6-8845-BD4E-CB4CCA059FC4}" type="datetimeFigureOut">
               <a:rPr lang="en-US" smtClean="0"/>
-              <a:t>6/13/26</a:t>
+              <a:t>1/27/13</a:t>
             </a:fld>
             <a:endParaRPr lang="en-US"/>
           </a:p>
@@ -2634,9 +2638,10 @@
           <a:lstStyle/>
           <a:p>
             <a:r>
-              <a:rPr lang="en-US"/>
+              <a:rPr lang="en-US" smtClean="0"/>
               <a:t>Click to edit Master title style</a:t>
             </a:r>
+            <a:endParaRPr lang="en-US"/>
           </a:p>
         </p:txBody>
       </p:sp>
@@ -2667,37 +2672,38 @@
           <a:p>
             <a:pPr lvl="0"/>
             <a:r>
-              <a:rPr lang="en-US"/>
+              <a:rPr lang="en-US" smtClean="0"/>
               <a:t>Click to edit Master text styles</a:t>
             </a:r>
           </a:p>
           <a:p>
             <a:pPr lvl="1"/>
             <a:r>
-              <a:rPr lang="en-US"/>
+              <a:rPr lang="en-US" smtClean="0"/>
               <a:t>Second level</a:t>
             </a:r>
           </a:p>
           <a:p>
             <a:pPr lvl="2"/>
             <a:r>
-              <a:rPr lang="en-US"/>
+              <a:rPr lang="en-US" smtClean="0"/>
               <a:t>Third level</a:t>
             </a:r>
           </a:p>
           <a:p>
             <a:pPr lvl="3"/>
             <a:r>
-              <a:rPr lang="en-US"/>
+              <a:rPr lang="en-US" smtClean="0"/>
               <a:t>Fourth level</a:t>
             </a:r>
           </a:p>
           <a:p>
             <a:pPr lvl="4"/>
             <a:r>
-              <a:rPr lang="en-US"/>
+              <a:rPr lang="en-US" smtClean="0"/>
               <a:t>Fifth level</a:t>
             </a:r>
+            <a:endParaRPr lang="en-US"/>
           </a:p>
         </p:txBody>
       </p:sp>
@@ -2736,7 +2742,7 @@
           <a:p>
             <a:fld id="{5BCAD085-E8A6-8845-BD4E-CB4CCA059FC4}" type="datetimeFigureOut">
               <a:rPr lang="en-US" smtClean="0"/>
-              <a:t>6/13/26</a:t>
+              <a:t>1/27/13</a:t>
             </a:fld>
             <a:endParaRPr lang="en-US"/>
           </a:p>
@@ -3095,7 +3101,7 @@
 </file>
 
 <file path=ppt/slides/slide1.xml><?xml version="1.0" encoding="utf-8"?>
-<p:sld xmlns:a="http://schemas.openxmlformats.org/drawingml/2006/main" xmlns:r="http://schemas.openxmlformats.org/officeDocument/2006/relationships" xmlns:p="http://schemas.openxmlformats.org/presentationml/2006/main">
+<p:sld xmlns:a="http://schemas.openxmlformats.org/drawingml/2006/main" xmlns:p="http://schemas.openxmlformats.org/presentationml/2006/main" xmlns:r="http://schemas.openxmlformats.org/officeDocument/2006/relationships">
   <p:cSld>
     <p:spTree>
       <p:nvGrpSpPr>
@@ -3103,14 +3109,7 @@
         <p:cNvGrpSpPr/>
         <p:nvPr/>
       </p:nvGrpSpPr>
-      <p:grpSpPr>
-        <a:xfrm>
-          <a:off x="0" y="0"/>
-          <a:ext cx="0" cy="0"/>
-          <a:chOff x="0" y="0"/>
-          <a:chExt cx="0" cy="0"/>
-        </a:xfrm>
-      </p:grpSpPr>
+      <p:grpSpPr/>
       <p:sp>
         <p:nvSpPr>
           <p:cNvPr id="2" name="TextBox 1"/>
@@ -3221,7 +3220,7 @@
 </file>
 
 <file path=ppt/slides/slide10.xml><?xml version="1.0" encoding="utf-8"?>
-<p:sld xmlns:a="http://schemas.openxmlformats.org/drawingml/2006/main" xmlns:r="http://schemas.openxmlformats.org/officeDocument/2006/relationships" xmlns:p="http://schemas.openxmlformats.org/presentationml/2006/main">
+<p:sld xmlns:a="http://schemas.openxmlformats.org/drawingml/2006/main" xmlns:p="http://schemas.openxmlformats.org/presentationml/2006/main" xmlns:r="http://schemas.openxmlformats.org/officeDocument/2006/relationships">
   <p:cSld>
     <p:spTree>
       <p:nvGrpSpPr>
@@ -3229,14 +3228,7 @@
         <p:cNvGrpSpPr/>
         <p:nvPr/>
       </p:nvGrpSpPr>
-      <p:grpSpPr>
-        <a:xfrm>
-          <a:off x="0" y="0"/>
-          <a:ext cx="0" cy="0"/>
-          <a:chOff x="0" y="0"/>
-          <a:chExt cx="0" cy="0"/>
-        </a:xfrm>
-      </p:grpSpPr>
+      <p:grpSpPr/>
       <p:sp>
         <p:nvSpPr>
           <p:cNvPr id="2" name="TextBox 1"/>
@@ -3298,7 +3290,7 @@
               </a:spcAft>
             </a:pPr>
             <a:r>
-              <a:rPr sz="1800" dirty="0">
+              <a:rPr sz="1800">
                 <a:solidFill>
                   <a:srgbClr val="212121"/>
                 </a:solidFill>
@@ -3314,7 +3306,7 @@
               </a:spcAft>
             </a:pPr>
             <a:r>
-              <a:rPr sz="1800" dirty="0">
+              <a:rPr sz="1800">
                 <a:solidFill>
                   <a:srgbClr val="212121"/>
                 </a:solidFill>
@@ -3330,7 +3322,7 @@
               </a:spcAft>
             </a:pPr>
             <a:r>
-              <a:rPr sz="1800" dirty="0">
+              <a:rPr sz="1800">
                 <a:solidFill>
                   <a:srgbClr val="212121"/>
                 </a:solidFill>
@@ -3346,7 +3338,7 @@
               </a:spcAft>
             </a:pPr>
             <a:r>
-              <a:rPr sz="1800" dirty="0">
+              <a:rPr sz="1800">
                 <a:solidFill>
                   <a:srgbClr val="212121"/>
                 </a:solidFill>
@@ -3362,103 +3354,60 @@
               </a:spcAft>
             </a:pPr>
             <a:r>
-              <a:rPr sz="1800" dirty="0">
+              <a:rPr sz="1800">
                 <a:solidFill>
                   <a:srgbClr val="212121"/>
                 </a:solidFill>
                 <a:latin typeface="Courier New"/>
               </a:rPr>
-              <a:t>x: int = </a:t>
-            </a:r>
-            <a:r>
-              <a:rPr sz="1800" dirty="0" err="1">
+              <a:t>x: int = nondet_int()    # every int at once, like BitVec("x")</a:t>
+            </a:r>
+          </a:p>
+          <a:p>
+            <a:pPr>
+              <a:spcAft>
+                <a:spcPts val="0"/>
+              </a:spcAft>
+            </a:pPr>
+            <a:r>
+              <a:rPr sz="1800">
                 <a:solidFill>
                   <a:srgbClr val="212121"/>
                 </a:solidFill>
                 <a:latin typeface="Courier New"/>
               </a:rPr>
-              <a:t>nondet_int</a:t>
-            </a:r>
-            <a:r>
-              <a:rPr sz="1800" dirty="0">
+              <a:t>f(x)</a:t>
+            </a:r>
+          </a:p>
+          <a:p>
+            <a:pPr>
+              <a:spcAft>
+                <a:spcPts val="800"/>
+              </a:spcAft>
+            </a:pPr>
+            <a:r>
+              <a:rPr sz="2200">
+                <a:solidFill>
+                  <a:srgbClr val="212121"/>
+                </a:solidFill>
+              </a:rPr>
+              <a:t/>
+            </a:r>
+          </a:p>
+          <a:p>
+            <a:pPr>
+              <a:spcAft>
+                <a:spcPts val="0"/>
+              </a:spcAft>
+            </a:pPr>
+            <a:r>
+              <a:rPr sz="1800">
                 <a:solidFill>
                   <a:srgbClr val="212121"/>
                 </a:solidFill>
                 <a:latin typeface="Courier New"/>
               </a:rPr>
-              <a:t>()    # every int at once, like </a:t>
-            </a:r>
-            <a:r>
-              <a:rPr sz="1800" dirty="0" err="1">
-                <a:solidFill>
-                  <a:srgbClr val="212121"/>
-                </a:solidFill>
-                <a:latin typeface="Courier New"/>
-              </a:rPr>
-              <a:t>BitVec</a:t>
-            </a:r>
-            <a:r>
-              <a:rPr sz="1800" dirty="0">
-                <a:solidFill>
-                  <a:srgbClr val="212121"/>
-                </a:solidFill>
-                <a:latin typeface="Courier New"/>
-              </a:rPr>
-              <a:t>("x")</a:t>
-            </a:r>
-          </a:p>
-          <a:p>
-            <a:pPr>
-              <a:spcAft>
-                <a:spcPts val="0"/>
-              </a:spcAft>
-            </a:pPr>
-            <a:r>
-              <a:rPr sz="1800" dirty="0">
-                <a:solidFill>
-                  <a:srgbClr val="212121"/>
-                </a:solidFill>
-                <a:latin typeface="Courier New"/>
-              </a:rPr>
-              <a:t>f(x)</a:t>
-            </a:r>
-          </a:p>
-          <a:p>
-            <a:pPr>
-              <a:spcAft>
-                <a:spcPts val="800"/>
-              </a:spcAft>
-            </a:pPr>
-            <a:endParaRPr sz="1800" dirty="0">
-              <a:solidFill>
-                <a:srgbClr val="212121"/>
-              </a:solidFill>
-              <a:latin typeface="Courier New"/>
-            </a:endParaRPr>
-          </a:p>
-          <a:p>
-            <a:pPr>
-              <a:spcAft>
-                <a:spcPts val="0"/>
-              </a:spcAft>
-            </a:pPr>
-            <a:r>
-              <a:rPr sz="1800" dirty="0" err="1">
-                <a:solidFill>
-                  <a:srgbClr val="212121"/>
-                </a:solidFill>
-                <a:latin typeface="Courier New"/>
-              </a:rPr>
-              <a:t>esbmc</a:t>
-            </a:r>
-            <a:r>
-              <a:rPr sz="1800" dirty="0">
-                <a:solidFill>
-                  <a:srgbClr val="212121"/>
-                </a:solidFill>
-                <a:latin typeface="Courier New"/>
-              </a:rPr>
-              <a:t> stage3_esbmc.py  →  VERIFICATION FAILED   (x = 2^63 - 1)</a:t>
+              <a:t>esbmc stage3_esbmc.py  →  VERIFICATION FAILED   (x = 2^63 - 1)</a:t>
             </a:r>
           </a:p>
           <a:p>
@@ -3468,7 +3417,7 @@
               </a:spcAft>
             </a:pPr>
             <a:r>
-              <a:rPr sz="2000" dirty="0">
+              <a:rPr sz="2000">
                 <a:solidFill>
                   <a:srgbClr val="212121"/>
                 </a:solidFill>
@@ -3483,7 +3432,7 @@
               </a:spcAft>
             </a:pPr>
             <a:r>
-              <a:rPr sz="2000" dirty="0">
+              <a:rPr sz="2000">
                 <a:solidFill>
                   <a:srgbClr val="212121"/>
                 </a:solidFill>
@@ -3498,28 +3447,12 @@
               </a:spcAft>
             </a:pPr>
             <a:r>
-              <a:rPr sz="2000" dirty="0">
-                <a:solidFill>
-                  <a:srgbClr val="212121"/>
-                </a:solidFill>
-              </a:rPr>
-              <a:t>Same bug, different number: 2^30 (your 32-bit </a:t>
-            </a:r>
-            <a:r>
-              <a:rPr sz="2000" dirty="0" err="1">
-                <a:solidFill>
-                  <a:srgbClr val="212121"/>
-                </a:solidFill>
-              </a:rPr>
-              <a:t>BitVec</a:t>
-            </a:r>
-            <a:r>
-              <a:rPr sz="2000" dirty="0">
-                <a:solidFill>
-                  <a:srgbClr val="212121"/>
-                </a:solidFill>
-              </a:rPr>
-              <a:t>) vs 2^63 — ESBMC models a Python int as 64-bit.</a:t>
+              <a:rPr sz="2000">
+                <a:solidFill>
+                  <a:srgbClr val="212121"/>
+                </a:solidFill>
+              </a:rPr>
+              <a:t>Same overflow, wider word: 2^30 (your 32-bit BitVec) vs 2^63 (ESBMC's default 64-bit int). But should a Python int overflow at all? → next slide.</a:t>
             </a:r>
           </a:p>
         </p:txBody>
@@ -3533,7 +3466,7 @@
 </file>
 
 <file path=ppt/slides/slide11.xml><?xml version="1.0" encoding="utf-8"?>
-<p:sld xmlns:a="http://schemas.openxmlformats.org/drawingml/2006/main" xmlns:r="http://schemas.openxmlformats.org/officeDocument/2006/relationships" xmlns:p="http://schemas.openxmlformats.org/presentationml/2006/main">
+<p:sld xmlns:a="http://schemas.openxmlformats.org/drawingml/2006/main" xmlns:p="http://schemas.openxmlformats.org/presentationml/2006/main" xmlns:r="http://schemas.openxmlformats.org/officeDocument/2006/relationships">
   <p:cSld>
     <p:spTree>
       <p:nvGrpSpPr>
@@ -3541,14 +3474,7 @@
         <p:cNvGrpSpPr/>
         <p:nvPr/>
       </p:nvGrpSpPr>
-      <p:grpSpPr>
-        <a:xfrm>
-          <a:off x="0" y="0"/>
-          <a:ext cx="0" cy="0"/>
-          <a:chOff x="0" y="0"/>
-          <a:chExt cx="0" cy="0"/>
-        </a:xfrm>
-      </p:grpSpPr>
+      <p:grpSpPr/>
       <p:sp>
         <p:nvSpPr>
           <p:cNvPr id="2" name="TextBox 1"/>
@@ -3577,6 +3503,232 @@
                   <a:srgbClr val="5A0A7A"/>
                 </a:solidFill>
               </a:rPr>
+              <a:t>Which integers? machine word vs math (--ir)</a:t>
+            </a:r>
+          </a:p>
+        </p:txBody>
+      </p:sp>
+      <p:sp>
+        <p:nvSpPr>
+          <p:cNvPr id="3" name="TextBox 2"/>
+          <p:cNvSpPr txBox="1"/>
+          <p:nvPr/>
+        </p:nvSpPr>
+        <p:spPr>
+          <a:xfrm>
+            <a:off x="731520" y="1463040"/>
+            <a:ext cx="10789920" cy="5120640"/>
+          </a:xfrm>
+          <a:prstGeom prst="rect">
+            <a:avLst/>
+          </a:prstGeom>
+          <a:noFill/>
+        </p:spPr>
+        <p:txBody>
+          <a:bodyPr wrap="square">
+            <a:spAutoFit/>
+          </a:bodyPr>
+          <a:lstStyle/>
+          <a:p>
+            <a:pPr>
+              <a:spcAft>
+                <a:spcPts val="800"/>
+              </a:spcAft>
+            </a:pPr>
+            <a:r>
+              <a:rPr sz="2000">
+                <a:solidFill>
+                  <a:srgbClr val="212121"/>
+                </a:solidFill>
+              </a:rPr>
+              <a:t>Both runs print VERIFICATION FAILED — but only one counterexample is real in CPython:</a:t>
+            </a:r>
+          </a:p>
+          <a:p>
+            <a:pPr>
+              <a:spcAft>
+                <a:spcPts val="800"/>
+              </a:spcAft>
+            </a:pPr>
+            <a:r>
+              <a:rPr sz="2000">
+                <a:solidFill>
+                  <a:srgbClr val="212121"/>
+                </a:solidFill>
+              </a:rPr>
+              <a:t/>
+            </a:r>
+          </a:p>
+          <a:p>
+            <a:pPr>
+              <a:spcAft>
+                <a:spcPts val="0"/>
+              </a:spcAft>
+            </a:pPr>
+            <a:r>
+              <a:rPr sz="1600">
+                <a:solidFill>
+                  <a:srgbClr val="212121"/>
+                </a:solidFill>
+                <a:latin typeface="Courier New"/>
+              </a:rPr>
+              <a:t>esbmc stage3_esbmc.py        →  x = 2^63 - 1   default: int = 64-bit machine word</a:t>
+            </a:r>
+          </a:p>
+          <a:p>
+            <a:pPr>
+              <a:spcAft>
+                <a:spcPts val="0"/>
+              </a:spcAft>
+            </a:pPr>
+            <a:r>
+              <a:rPr sz="1600">
+                <a:solidFill>
+                  <a:srgbClr val="212121"/>
+                </a:solidFill>
+                <a:latin typeface="Courier New"/>
+              </a:rPr>
+              <a:t>esbmc stage3_esbmc.py --ir   →  x = -1         --ir: unbounded integer/real</a:t>
+            </a:r>
+          </a:p>
+          <a:p>
+            <a:pPr>
+              <a:spcAft>
+                <a:spcPts val="800"/>
+              </a:spcAft>
+            </a:pPr>
+            <a:r>
+              <a:rPr sz="2000">
+                <a:solidFill>
+                  <a:srgbClr val="212121"/>
+                </a:solidFill>
+              </a:rPr>
+              <a:t/>
+            </a:r>
+          </a:p>
+          <a:p>
+            <a:pPr lvl="1">
+              <a:spcAft>
+                <a:spcPts val="800"/>
+              </a:spcAft>
+            </a:pPr>
+            <a:r>
+              <a:rPr sz="1800">
+                <a:solidFill>
+                  <a:srgbClr val="212121"/>
+                </a:solidFill>
+              </a:rPr>
+              <a:t>Default blames x = 2^63 - 1 — but Python ints are unbounded, so that overflow never happens (z stays huge, z ≥ 2 holds). A modelling artifact.</a:t>
+            </a:r>
+          </a:p>
+          <a:p>
+            <a:pPr lvl="1">
+              <a:spcAft>
+                <a:spcPts val="800"/>
+              </a:spcAft>
+            </a:pPr>
+            <a:r>
+              <a:rPr sz="1800">
+                <a:solidFill>
+                  <a:srgbClr val="212121"/>
+                </a:solidFill>
+              </a:rPr>
+              <a:t>--ir blames x = -1 → z = 0 &lt; 2, which reproduces in real Python. Unbounded integer/real matches CPython's bignums — and is often faster.</a:t>
+            </a:r>
+          </a:p>
+          <a:p>
+            <a:pPr lvl="1">
+              <a:spcAft>
+                <a:spcPts val="800"/>
+              </a:spcAft>
+            </a:pPr>
+            <a:r>
+              <a:rPr sz="1800">
+                <a:solidFill>
+                  <a:srgbClr val="212121"/>
+                </a:solidFill>
+              </a:rPr>
+              <a:t>--ir-ieee adds IEEE-754 enclosure for reals — the honest model once floats appear (Lab 4, float.c).</a:t>
+            </a:r>
+          </a:p>
+          <a:p>
+            <a:pPr>
+              <a:spcAft>
+                <a:spcPts val="800"/>
+              </a:spcAft>
+            </a:pPr>
+            <a:r>
+              <a:rPr sz="2000">
+                <a:solidFill>
+                  <a:srgbClr val="212121"/>
+                </a:solidFill>
+              </a:rPr>
+              <a:t/>
+            </a:r>
+          </a:p>
+          <a:p>
+            <a:pPr>
+              <a:spcAft>
+                <a:spcPts val="800"/>
+              </a:spcAft>
+            </a:pPr>
+            <a:r>
+              <a:rPr sz="2000">
+                <a:solidFill>
+                  <a:srgbClr val="212121"/>
+                </a:solidFill>
+              </a:rPr>
+              <a:t>Match the integer model to your program. (Session 1: machine arithmetic ≠ mathematics.)</a:t>
+            </a:r>
+          </a:p>
+        </p:txBody>
+      </p:sp>
+    </p:spTree>
+  </p:cSld>
+  <p:clrMapOvr>
+    <a:masterClrMapping/>
+  </p:clrMapOvr>
+</p:sld>
+</file>
+
+<file path=ppt/slides/slide12.xml><?xml version="1.0" encoding="utf-8"?>
+<p:sld xmlns:a="http://schemas.openxmlformats.org/drawingml/2006/main" xmlns:p="http://schemas.openxmlformats.org/presentationml/2006/main" xmlns:r="http://schemas.openxmlformats.org/officeDocument/2006/relationships">
+  <p:cSld>
+    <p:spTree>
+      <p:nvGrpSpPr>
+        <p:cNvPr id="1" name=""/>
+        <p:cNvGrpSpPr/>
+        <p:nvPr/>
+      </p:nvGrpSpPr>
+      <p:grpSpPr/>
+      <p:sp>
+        <p:nvSpPr>
+          <p:cNvPr id="2" name="TextBox 1"/>
+          <p:cNvSpPr txBox="1"/>
+          <p:nvPr/>
+        </p:nvSpPr>
+        <p:spPr>
+          <a:xfrm>
+            <a:off x="548640" y="365760"/>
+            <a:ext cx="11064240" cy="1005840"/>
+          </a:xfrm>
+          <a:prstGeom prst="rect">
+            <a:avLst/>
+          </a:prstGeom>
+          <a:noFill/>
+        </p:spPr>
+        <p:txBody>
+          <a:bodyPr wrap="square">
+            <a:spAutoFit/>
+          </a:bodyPr>
+          <a:lstStyle/>
+          <a:p>
+            <a:r>
+              <a:rPr sz="3600" b="1">
+                <a:solidFill>
+                  <a:srgbClr val="5A0A7A"/>
+                </a:solidFill>
+              </a:rPr>
               <a:t>Checkpoint before Lab 2</a:t>
             </a:r>
           </a:p>
@@ -3639,11 +3791,14 @@
                 <a:spcPts val="800"/>
               </a:spcAft>
             </a:pPr>
-            <a:endParaRPr sz="2800">
-              <a:solidFill>
-                <a:srgbClr val="212121"/>
-              </a:solidFill>
-            </a:endParaRPr>
+            <a:r>
+              <a:rPr sz="2800">
+                <a:solidFill>
+                  <a:srgbClr val="212121"/>
+                </a:solidFill>
+              </a:rPr>
+              <a:t/>
+            </a:r>
           </a:p>
           <a:p>
             <a:pPr>
@@ -3670,8 +3825,8 @@
 </p:sld>
 </file>
 
-<file path=ppt/slides/slide12.xml><?xml version="1.0" encoding="utf-8"?>
-<p:sld xmlns:a="http://schemas.openxmlformats.org/drawingml/2006/main" xmlns:r="http://schemas.openxmlformats.org/officeDocument/2006/relationships" xmlns:p="http://schemas.openxmlformats.org/presentationml/2006/main">
+<file path=ppt/slides/slide13.xml><?xml version="1.0" encoding="utf-8"?>
+<p:sld xmlns:a="http://schemas.openxmlformats.org/drawingml/2006/main" xmlns:p="http://schemas.openxmlformats.org/presentationml/2006/main" xmlns:r="http://schemas.openxmlformats.org/officeDocument/2006/relationships">
   <p:cSld>
     <p:spTree>
       <p:nvGrpSpPr>
@@ -3679,14 +3834,7 @@
         <p:cNvGrpSpPr/>
         <p:nvPr/>
       </p:nvGrpSpPr>
-      <p:grpSpPr>
-        <a:xfrm>
-          <a:off x="0" y="0"/>
-          <a:ext cx="0" cy="0"/>
-          <a:chOff x="0" y="0"/>
-          <a:chExt cx="0" cy="0"/>
-        </a:xfrm>
-      </p:grpSpPr>
+      <p:grpSpPr/>
       <p:sp>
         <p:nvSpPr>
           <p:cNvPr id="2" name="TextBox 1"/>
@@ -3777,27 +3925,9 @@
                 <a:tableStyleId>{5C22544A-7EE6-4342-B048-85BDC9FD1C3A}</a:tableStyleId>
               </a:tblPr>
               <a:tblGrid>
-                <a:gridCol w="731520">
-                  <a:extLst>
-                    <a:ext uri="{9D8B030D-6E8A-4147-A177-3AD203B41FA5}">
-                      <a16:colId xmlns:a16="http://schemas.microsoft.com/office/drawing/2014/main" val="20000"/>
-                    </a:ext>
-                  </a:extLst>
-                </a:gridCol>
-                <a:gridCol w="4754880">
-                  <a:extLst>
-                    <a:ext uri="{9D8B030D-6E8A-4147-A177-3AD203B41FA5}">
-                      <a16:colId xmlns:a16="http://schemas.microsoft.com/office/drawing/2014/main" val="20001"/>
-                    </a:ext>
-                  </a:extLst>
-                </a:gridCol>
-                <a:gridCol w="2011680">
-                  <a:extLst>
-                    <a:ext uri="{9D8B030D-6E8A-4147-A177-3AD203B41FA5}">
-                      <a16:colId xmlns:a16="http://schemas.microsoft.com/office/drawing/2014/main" val="20002"/>
-                    </a:ext>
-                  </a:extLst>
-                </a:gridCol>
+                <a:gridCol w="731520"/>
+                <a:gridCol w="4754880"/>
+                <a:gridCol w="2011680"/>
               </a:tblGrid>
               <a:tr h="365760">
                 <a:tc>
@@ -3839,11 +3969,6 @@
                   </a:txBody>
                   <a:tcPr/>
                 </a:tc>
-                <a:extLst>
-                  <a:ext uri="{0D108BD9-81ED-4DB2-BD59-A6C34878D82A}">
-                    <a16:rowId xmlns:a16="http://schemas.microsoft.com/office/drawing/2014/main" val="10000"/>
-                  </a:ext>
-                </a:extLst>
               </a:tr>
               <a:tr h="365760">
                 <a:tc>
@@ -3885,11 +4010,6 @@
                   </a:txBody>
                   <a:tcPr/>
                 </a:tc>
-                <a:extLst>
-                  <a:ext uri="{0D108BD9-81ED-4DB2-BD59-A6C34878D82A}">
-                    <a16:rowId xmlns:a16="http://schemas.microsoft.com/office/drawing/2014/main" val="10001"/>
-                  </a:ext>
-                </a:extLst>
               </a:tr>
               <a:tr h="365760">
                 <a:tc>
@@ -3931,11 +4051,6 @@
                   </a:txBody>
                   <a:tcPr/>
                 </a:tc>
-                <a:extLst>
-                  <a:ext uri="{0D108BD9-81ED-4DB2-BD59-A6C34878D82A}">
-                    <a16:rowId xmlns:a16="http://schemas.microsoft.com/office/drawing/2014/main" val="10002"/>
-                  </a:ext>
-                </a:extLst>
               </a:tr>
               <a:tr h="365760">
                 <a:tc>
@@ -3977,11 +4092,6 @@
                   </a:txBody>
                   <a:tcPr/>
                 </a:tc>
-                <a:extLst>
-                  <a:ext uri="{0D108BD9-81ED-4DB2-BD59-A6C34878D82A}">
-                    <a16:rowId xmlns:a16="http://schemas.microsoft.com/office/drawing/2014/main" val="10003"/>
-                  </a:ext>
-                </a:extLst>
               </a:tr>
               <a:tr h="365760">
                 <a:tc>
@@ -4023,11 +4133,6 @@
                   </a:txBody>
                   <a:tcPr/>
                 </a:tc>
-                <a:extLst>
-                  <a:ext uri="{0D108BD9-81ED-4DB2-BD59-A6C34878D82A}">
-                    <a16:rowId xmlns:a16="http://schemas.microsoft.com/office/drawing/2014/main" val="10004"/>
-                  </a:ext>
-                </a:extLst>
               </a:tr>
             </a:tbl>
           </a:graphicData>
@@ -4110,8 +4215,8 @@
 </p:sld>
 </file>
 
-<file path=ppt/slides/slide13.xml><?xml version="1.0" encoding="utf-8"?>
-<p:sld xmlns:a="http://schemas.openxmlformats.org/drawingml/2006/main" xmlns:r="http://schemas.openxmlformats.org/officeDocument/2006/relationships" xmlns:p="http://schemas.openxmlformats.org/presentationml/2006/main">
+<file path=ppt/slides/slide14.xml><?xml version="1.0" encoding="utf-8"?>
+<p:sld xmlns:a="http://schemas.openxmlformats.org/drawingml/2006/main" xmlns:p="http://schemas.openxmlformats.org/presentationml/2006/main" xmlns:r="http://schemas.openxmlformats.org/officeDocument/2006/relationships">
   <p:cSld>
     <p:spTree>
       <p:nvGrpSpPr>
@@ -4119,14 +4224,7 @@
         <p:cNvGrpSpPr/>
         <p:nvPr/>
       </p:nvGrpSpPr>
-      <p:grpSpPr>
-        <a:xfrm>
-          <a:off x="0" y="0"/>
-          <a:ext cx="0" cy="0"/>
-          <a:chOff x="0" y="0"/>
-          <a:chExt cx="0" cy="0"/>
-        </a:xfrm>
-      </p:grpSpPr>
+      <p:grpSpPr/>
       <p:sp>
         <p:nvSpPr>
           <p:cNvPr id="2" name="TextBox 1"/>
@@ -4314,12 +4412,14 @@
                 <a:spcPts val="800"/>
               </a:spcAft>
             </a:pPr>
-            <a:endParaRPr sz="1800">
-              <a:solidFill>
-                <a:srgbClr val="212121"/>
-              </a:solidFill>
-              <a:latin typeface="Courier New"/>
-            </a:endParaRPr>
+            <a:r>
+              <a:rPr sz="2200">
+                <a:solidFill>
+                  <a:srgbClr val="212121"/>
+                </a:solidFill>
+              </a:rPr>
+              <a:t/>
+            </a:r>
           </a:p>
           <a:p>
             <a:pPr>
@@ -4346,8 +4446,8 @@
 </p:sld>
 </file>
 
-<file path=ppt/slides/slide14.xml><?xml version="1.0" encoding="utf-8"?>
-<p:sld xmlns:a="http://schemas.openxmlformats.org/drawingml/2006/main" xmlns:r="http://schemas.openxmlformats.org/officeDocument/2006/relationships" xmlns:p="http://schemas.openxmlformats.org/presentationml/2006/main">
+<file path=ppt/slides/slide15.xml><?xml version="1.0" encoding="utf-8"?>
+<p:sld xmlns:a="http://schemas.openxmlformats.org/drawingml/2006/main" xmlns:p="http://schemas.openxmlformats.org/presentationml/2006/main" xmlns:r="http://schemas.openxmlformats.org/officeDocument/2006/relationships">
   <p:cSld>
     <p:spTree>
       <p:nvGrpSpPr>
@@ -4355,14 +4455,7 @@
         <p:cNvGrpSpPr/>
         <p:nvPr/>
       </p:nvGrpSpPr>
-      <p:grpSpPr>
-        <a:xfrm>
-          <a:off x="0" y="0"/>
-          <a:ext cx="0" cy="0"/>
-          <a:chOff x="0" y="0"/>
-          <a:chExt cx="0" cy="0"/>
-        </a:xfrm>
-      </p:grpSpPr>
+      <p:grpSpPr/>
       <p:sp>
         <p:nvSpPr>
           <p:cNvPr id="2" name="TextBox 1"/>
@@ -4519,12 +4612,14 @@
                 <a:spcPts val="800"/>
               </a:spcAft>
             </a:pPr>
-            <a:endParaRPr sz="1800">
-              <a:solidFill>
-                <a:srgbClr val="212121"/>
-              </a:solidFill>
-              <a:latin typeface="Courier New"/>
-            </a:endParaRPr>
+            <a:r>
+              <a:rPr sz="2200">
+                <a:solidFill>
+                  <a:srgbClr val="212121"/>
+                </a:solidFill>
+              </a:rPr>
+              <a:t/>
+            </a:r>
           </a:p>
           <a:p>
             <a:pPr lvl="1">
@@ -4581,8 +4676,8 @@
 </p:sld>
 </file>
 
-<file path=ppt/slides/slide15.xml><?xml version="1.0" encoding="utf-8"?>
-<p:sld xmlns:a="http://schemas.openxmlformats.org/drawingml/2006/main" xmlns:r="http://schemas.openxmlformats.org/officeDocument/2006/relationships" xmlns:p="http://schemas.openxmlformats.org/presentationml/2006/main">
+<file path=ppt/slides/slide16.xml><?xml version="1.0" encoding="utf-8"?>
+<p:sld xmlns:a="http://schemas.openxmlformats.org/drawingml/2006/main" xmlns:p="http://schemas.openxmlformats.org/presentationml/2006/main" xmlns:r="http://schemas.openxmlformats.org/officeDocument/2006/relationships">
   <p:cSld>
     <p:spTree>
       <p:nvGrpSpPr>
@@ -4590,14 +4685,7 @@
         <p:cNvGrpSpPr/>
         <p:nvPr/>
       </p:nvGrpSpPr>
-      <p:grpSpPr>
-        <a:xfrm>
-          <a:off x="0" y="0"/>
-          <a:ext cx="0" cy="0"/>
-          <a:chOff x="0" y="0"/>
-          <a:chExt cx="0" cy="0"/>
-        </a:xfrm>
-      </p:grpSpPr>
+      <p:grpSpPr/>
       <p:sp>
         <p:nvSpPr>
           <p:cNvPr id="2" name="TextBox 1"/>
@@ -4766,11 +4854,14 @@
                 <a:spcPts val="800"/>
               </a:spcAft>
             </a:pPr>
-            <a:endParaRPr sz="1800">
-              <a:solidFill>
-                <a:srgbClr val="212121"/>
-              </a:solidFill>
-            </a:endParaRPr>
+            <a:r>
+              <a:rPr sz="2200">
+                <a:solidFill>
+                  <a:srgbClr val="212121"/>
+                </a:solidFill>
+              </a:rPr>
+              <a:t/>
+            </a:r>
           </a:p>
           <a:p>
             <a:pPr>
@@ -4812,8 +4903,8 @@
 </p:sld>
 </file>
 
-<file path=ppt/slides/slide16.xml><?xml version="1.0" encoding="utf-8"?>
-<p:sld xmlns:a="http://schemas.openxmlformats.org/drawingml/2006/main" xmlns:r="http://schemas.openxmlformats.org/officeDocument/2006/relationships" xmlns:p="http://schemas.openxmlformats.org/presentationml/2006/main">
+<file path=ppt/slides/slide17.xml><?xml version="1.0" encoding="utf-8"?>
+<p:sld xmlns:a="http://schemas.openxmlformats.org/drawingml/2006/main" xmlns:p="http://schemas.openxmlformats.org/presentationml/2006/main" xmlns:r="http://schemas.openxmlformats.org/officeDocument/2006/relationships">
   <p:cSld>
     <p:spTree>
       <p:nvGrpSpPr>
@@ -4821,14 +4912,7 @@
         <p:cNvGrpSpPr/>
         <p:nvPr/>
       </p:nvGrpSpPr>
-      <p:grpSpPr>
-        <a:xfrm>
-          <a:off x="0" y="0"/>
-          <a:ext cx="0" cy="0"/>
-          <a:chOff x="0" y="0"/>
-          <a:chExt cx="0" cy="0"/>
-        </a:xfrm>
-      </p:grpSpPr>
+      <p:grpSpPr/>
       <p:sp>
         <p:nvSpPr>
           <p:cNvPr id="2" name="TextBox 1"/>
@@ -4870,8 +4954,8 @@
 </p:sld>
 </file>
 
-<file path=ppt/slides/slide17.xml><?xml version="1.0" encoding="utf-8"?>
-<p:sld xmlns:a="http://schemas.openxmlformats.org/drawingml/2006/main" xmlns:r="http://schemas.openxmlformats.org/officeDocument/2006/relationships" xmlns:p="http://schemas.openxmlformats.org/presentationml/2006/main">
+<file path=ppt/slides/slide18.xml><?xml version="1.0" encoding="utf-8"?>
+<p:sld xmlns:a="http://schemas.openxmlformats.org/drawingml/2006/main" xmlns:p="http://schemas.openxmlformats.org/presentationml/2006/main" xmlns:r="http://schemas.openxmlformats.org/officeDocument/2006/relationships">
   <p:cSld>
     <p:spTree>
       <p:nvGrpSpPr>
@@ -4879,14 +4963,7 @@
         <p:cNvGrpSpPr/>
         <p:nvPr/>
       </p:nvGrpSpPr>
-      <p:grpSpPr>
-        <a:xfrm>
-          <a:off x="0" y="0"/>
-          <a:ext cx="0" cy="0"/>
-          <a:chOff x="0" y="0"/>
-          <a:chExt cx="0" cy="0"/>
-        </a:xfrm>
-      </p:grpSpPr>
+      <p:grpSpPr/>
       <p:sp>
         <p:nvSpPr>
           <p:cNvPr id="2" name="TextBox 1"/>
@@ -4992,11 +5069,14 @@
                 <a:spcPts val="800"/>
               </a:spcAft>
             </a:pPr>
-            <a:endParaRPr sz="2800">
-              <a:solidFill>
-                <a:srgbClr val="212121"/>
-              </a:solidFill>
-            </a:endParaRPr>
+            <a:r>
+              <a:rPr sz="2800">
+                <a:solidFill>
+                  <a:srgbClr val="212121"/>
+                </a:solidFill>
+              </a:rPr>
+              <a:t/>
+            </a:r>
           </a:p>
           <a:p>
             <a:pPr>
@@ -5023,8 +5103,8 @@
 </p:sld>
 </file>
 
-<file path=ppt/slides/slide18.xml><?xml version="1.0" encoding="utf-8"?>
-<p:sld xmlns:a="http://schemas.openxmlformats.org/drawingml/2006/main" xmlns:r="http://schemas.openxmlformats.org/officeDocument/2006/relationships" xmlns:p="http://schemas.openxmlformats.org/presentationml/2006/main">
+<file path=ppt/slides/slide19.xml><?xml version="1.0" encoding="utf-8"?>
+<p:sld xmlns:a="http://schemas.openxmlformats.org/drawingml/2006/main" xmlns:p="http://schemas.openxmlformats.org/presentationml/2006/main" xmlns:r="http://schemas.openxmlformats.org/officeDocument/2006/relationships">
   <p:cSld>
     <p:spTree>
       <p:nvGrpSpPr>
@@ -5032,14 +5112,7 @@
         <p:cNvGrpSpPr/>
         <p:nvPr/>
       </p:nvGrpSpPr>
-      <p:grpSpPr>
-        <a:xfrm>
-          <a:off x="0" y="0"/>
-          <a:ext cx="0" cy="0"/>
-          <a:chOff x="0" y="0"/>
-          <a:chExt cx="0" cy="0"/>
-        </a:xfrm>
-      </p:grpSpPr>
+      <p:grpSpPr/>
       <p:sp>
         <p:nvSpPr>
           <p:cNvPr id="2" name="TextBox 1"/>
@@ -5132,12 +5205,15 @@
                 <a:spcPts val="0"/>
               </a:spcAft>
             </a:pPr>
-            <a:endParaRPr sz="1800">
-              <a:solidFill>
-                <a:srgbClr val="212121"/>
-              </a:solidFill>
-              <a:latin typeface="Courier New"/>
-            </a:endParaRPr>
+            <a:r>
+              <a:rPr sz="1800">
+                <a:solidFill>
+                  <a:srgbClr val="212121"/>
+                </a:solidFill>
+                <a:latin typeface="Courier New"/>
+              </a:rPr>
+              <a:t/>
+            </a:r>
           </a:p>
           <a:p>
             <a:pPr>
@@ -5193,12 +5269,14 @@
                 <a:spcPts val="800"/>
               </a:spcAft>
             </a:pPr>
-            <a:endParaRPr sz="1800">
-              <a:solidFill>
-                <a:srgbClr val="212121"/>
-              </a:solidFill>
-              <a:latin typeface="Courier New"/>
-            </a:endParaRPr>
+            <a:r>
+              <a:rPr sz="2200">
+                <a:solidFill>
+                  <a:srgbClr val="212121"/>
+                </a:solidFill>
+              </a:rPr>
+              <a:t/>
+            </a:r>
           </a:p>
           <a:p>
             <a:pPr>
@@ -5225,8 +5303,8 @@
 </p:sld>
 </file>
 
-<file path=ppt/slides/slide19.xml><?xml version="1.0" encoding="utf-8"?>
-<p:sld xmlns:a="http://schemas.openxmlformats.org/drawingml/2006/main" xmlns:r="http://schemas.openxmlformats.org/officeDocument/2006/relationships" xmlns:p="http://schemas.openxmlformats.org/presentationml/2006/main">
+<file path=ppt/slides/slide2.xml><?xml version="1.0" encoding="utf-8"?>
+<p:sld xmlns:a="http://schemas.openxmlformats.org/drawingml/2006/main" xmlns:p="http://schemas.openxmlformats.org/presentationml/2006/main" xmlns:r="http://schemas.openxmlformats.org/officeDocument/2006/relationships">
   <p:cSld>
     <p:spTree>
       <p:nvGrpSpPr>
@@ -5234,14 +5312,7 @@
         <p:cNvGrpSpPr/>
         <p:nvPr/>
       </p:nvGrpSpPr>
-      <p:grpSpPr>
-        <a:xfrm>
-          <a:off x="0" y="0"/>
-          <a:ext cx="0" cy="0"/>
-          <a:chOff x="0" y="0"/>
-          <a:chExt cx="0" cy="0"/>
-        </a:xfrm>
-      </p:grpSpPr>
+      <p:grpSpPr/>
       <p:sp>
         <p:nvSpPr>
           <p:cNvPr id="2" name="TextBox 1"/>
@@ -5270,7 +5341,7 @@
                   <a:srgbClr val="5A0A7A"/>
                 </a:solidFill>
               </a:rPr>
-              <a:t>Lab 3, Part 2 — what did we prove?</a:t>
+              <a:t>Recap quiz (while machines boot)</a:t>
             </a:r>
           </a:p>
         </p:txBody>
@@ -5299,66 +5370,96 @@
           <a:p>
             <a:pPr>
               <a:spcAft>
+                <a:spcPts val="800"/>
+              </a:spcAft>
+            </a:pPr>
+            <a:r>
+              <a:rPr sz="2400">
+                <a:solidFill>
+                  <a:srgbClr val="212121"/>
+                </a:solidFill>
+              </a:rPr>
+              <a:t>1. To prove property P with a solver, you ask whether … is satisfiable?</a:t>
+            </a:r>
+          </a:p>
+          <a:p>
+            <a:pPr>
+              <a:spcAft>
+                <a:spcPts val="800"/>
+              </a:spcAft>
+            </a:pPr>
+            <a:r>
+              <a:rPr sz="2400">
+                <a:solidFill>
+                  <a:srgbClr val="212121"/>
+                </a:solidFill>
+              </a:rPr>
+              <a:t>2. sat + a model in that setup means …?</a:t>
+            </a:r>
+          </a:p>
+          <a:p>
+            <a:pPr>
+              <a:spcAft>
+                <a:spcPts val="800"/>
+              </a:spcAft>
+            </a:pPr>
+            <a:r>
+              <a:rPr sz="2400">
+                <a:solidFill>
+                  <a:srgbClr val="212121"/>
+                </a:solidFill>
+              </a:rPr>
+              <a:t>3. --unwind 5 reports a violated unwinding assertion. Is the program buggy?</a:t>
+            </a:r>
+          </a:p>
+          <a:p>
+            <a:pPr>
+              <a:spcAft>
+                <a:spcPts val="800"/>
+              </a:spcAft>
+            </a:pPr>
+            <a:r>
+              <a:rPr sz="2400">
+                <a:solidFill>
+                  <a:srgbClr val="212121"/>
+                </a:solidFill>
+              </a:rPr>
+              <a:t/>
+            </a:r>
+          </a:p>
+          <a:p>
+            <a:pPr>
+              <a:spcAft>
+                <a:spcPts val="800"/>
+              </a:spcAft>
+            </a:pPr>
+            <a:r>
+              <a:rPr sz="2400">
+                <a:solidFill>
+                  <a:srgbClr val="212121"/>
+                </a:solidFill>
+              </a:rPr>
+              <a:t>Smoke test, everyone:</a:t>
+            </a:r>
+          </a:p>
+          <a:p>
+            <a:pPr>
+              <a:spcAft>
                 <a:spcPts val="0"/>
               </a:spcAft>
             </a:pPr>
             <a:r>
-              <a:rPr sz="1800">
+              <a:rPr sz="2000">
                 <a:solidFill>
                   <a:srgbClr val="212121"/>
                 </a:solidFill>
                 <a:latin typeface="Courier New"/>
               </a:rPr>
-              <a:t>esbmc unwind.c --unwind 5      →  ?</a:t>
-            </a:r>
-          </a:p>
-          <a:p>
-            <a:pPr>
-              <a:spcAft>
-                <a:spcPts val="0"/>
-              </a:spcAft>
-            </a:pPr>
-            <a:r>
-              <a:rPr sz="1800">
-                <a:solidFill>
-                  <a:srgbClr val="212121"/>
-                </a:solidFill>
-                <a:latin typeface="Courier New"/>
-              </a:rPr>
-              <a:t>esbmc unwind.c --unwind 20     →  ?</a:t>
-            </a:r>
-          </a:p>
-          <a:p>
-            <a:pPr>
-              <a:spcAft>
-                <a:spcPts val="0"/>
-              </a:spcAft>
-            </a:pPr>
-            <a:r>
-              <a:rPr sz="1800">
-                <a:solidFill>
-                  <a:srgbClr val="212121"/>
-                </a:solidFill>
-                <a:latin typeface="Courier New"/>
-              </a:rPr>
-              <a:t>esbmc unwind.c --unwind 60     →  ?</a:t>
-            </a:r>
-          </a:p>
-          <a:p>
-            <a:pPr>
-              <a:spcAft>
-                <a:spcPts val="800"/>
-              </a:spcAft>
-            </a:pPr>
-            <a:endParaRPr sz="1800">
-              <a:solidFill>
-                <a:srgbClr val="212121"/>
-              </a:solidFill>
-              <a:latin typeface="Courier New"/>
-            </a:endParaRPr>
-          </a:p>
-          <a:p>
-            <a:pPr>
+              <a:t>esbmc lab4/float.c   →  VERIFICATION FAILED</a:t>
+            </a:r>
+          </a:p>
+          <a:p>
+            <a:pPr lvl="1">
               <a:spcAft>
                 <a:spcPts val="800"/>
               </a:spcAft>
@@ -5369,37 +5470,7 @@
                   <a:srgbClr val="212121"/>
                 </a:solidFill>
               </a:rPr>
-              <a:t>What is the unwinding assertion telling you at 5 and 20?</a:t>
-            </a:r>
-          </a:p>
-          <a:p>
-            <a:pPr>
-              <a:spcAft>
-                <a:spcPts val="800"/>
-              </a:spcAft>
-            </a:pPr>
-            <a:r>
-              <a:rPr sz="2200">
-                <a:solidFill>
-                  <a:srgbClr val="212121"/>
-                </a:solidFill>
-              </a:rPr>
-              <a:t>At 60 — what exactly is proven, and for which n?</a:t>
-            </a:r>
-          </a:p>
-          <a:p>
-            <a:pPr>
-              <a:spcAft>
-                <a:spcPts val="800"/>
-              </a:spcAft>
-            </a:pPr>
-            <a:r>
-              <a:rPr sz="2200">
-                <a:solidFill>
-                  <a:srgbClr val="212121"/>
-                </a:solidFill>
-              </a:rPr>
-              <a:t>Stretch: --k-induction answers VERIFICATION UNKNOWN. Why is the unbounded question fundamentally harder? (Background deck: 03-k-induction.pptx)</a:t>
+              <a:t>(yes, FAILED — your tool just found a real bug)</a:t>
             </a:r>
           </a:p>
         </p:txBody>
@@ -5412,8 +5483,8 @@
 </p:sld>
 </file>
 
-<file path=ppt/slides/slide2.xml><?xml version="1.0" encoding="utf-8"?>
-<p:sld xmlns:a="http://schemas.openxmlformats.org/drawingml/2006/main" xmlns:r="http://schemas.openxmlformats.org/officeDocument/2006/relationships" xmlns:p="http://schemas.openxmlformats.org/presentationml/2006/main">
+<file path=ppt/slides/slide20.xml><?xml version="1.0" encoding="utf-8"?>
+<p:sld xmlns:a="http://schemas.openxmlformats.org/drawingml/2006/main" xmlns:p="http://schemas.openxmlformats.org/presentationml/2006/main" xmlns:r="http://schemas.openxmlformats.org/officeDocument/2006/relationships">
   <p:cSld>
     <p:spTree>
       <p:nvGrpSpPr>
@@ -5421,14 +5492,7 @@
         <p:cNvGrpSpPr/>
         <p:nvPr/>
       </p:nvGrpSpPr>
-      <p:grpSpPr>
-        <a:xfrm>
-          <a:off x="0" y="0"/>
-          <a:ext cx="0" cy="0"/>
-          <a:chOff x="0" y="0"/>
-          <a:chExt cx="0" cy="0"/>
-        </a:xfrm>
-      </p:grpSpPr>
+      <p:grpSpPr/>
       <p:sp>
         <p:nvSpPr>
           <p:cNvPr id="2" name="TextBox 1"/>
@@ -5457,7 +5521,7 @@
                   <a:srgbClr val="5A0A7A"/>
                 </a:solidFill>
               </a:rPr>
-              <a:t>Recap quiz (while machines boot)</a:t>
+              <a:t>Lab 3, Part 2 — what did we prove?</a:t>
             </a:r>
           </a:p>
         </p:txBody>
@@ -5486,93 +5550,53 @@
           <a:p>
             <a:pPr>
               <a:spcAft>
-                <a:spcPts val="800"/>
-              </a:spcAft>
-            </a:pPr>
-            <a:r>
-              <a:rPr sz="2400">
-                <a:solidFill>
-                  <a:srgbClr val="212121"/>
-                </a:solidFill>
-              </a:rPr>
-              <a:t>1. To prove property P with a solver, you ask whether … is satisfiable?</a:t>
-            </a:r>
-          </a:p>
-          <a:p>
-            <a:pPr>
-              <a:spcAft>
-                <a:spcPts val="800"/>
-              </a:spcAft>
-            </a:pPr>
-            <a:r>
-              <a:rPr sz="2400">
-                <a:solidFill>
-                  <a:srgbClr val="212121"/>
-                </a:solidFill>
-              </a:rPr>
-              <a:t>2. sat + a model in that setup means …?</a:t>
-            </a:r>
-          </a:p>
-          <a:p>
-            <a:pPr>
-              <a:spcAft>
-                <a:spcPts val="800"/>
-              </a:spcAft>
-            </a:pPr>
-            <a:r>
-              <a:rPr sz="2400">
-                <a:solidFill>
-                  <a:srgbClr val="212121"/>
-                </a:solidFill>
-              </a:rPr>
-              <a:t>3. --unwind 5 reports a violated unwinding assertion. Is the program buggy?</a:t>
-            </a:r>
-          </a:p>
-          <a:p>
-            <a:pPr>
-              <a:spcAft>
-                <a:spcPts val="800"/>
-              </a:spcAft>
-            </a:pPr>
-            <a:endParaRPr sz="2400">
-              <a:solidFill>
-                <a:srgbClr val="212121"/>
-              </a:solidFill>
-            </a:endParaRPr>
-          </a:p>
-          <a:p>
-            <a:pPr>
-              <a:spcAft>
-                <a:spcPts val="800"/>
-              </a:spcAft>
-            </a:pPr>
-            <a:r>
-              <a:rPr sz="2400">
-                <a:solidFill>
-                  <a:srgbClr val="212121"/>
-                </a:solidFill>
-              </a:rPr>
-              <a:t>Smoke test, everyone:</a:t>
-            </a:r>
-          </a:p>
-          <a:p>
-            <a:pPr>
-              <a:spcAft>
                 <a:spcPts val="0"/>
               </a:spcAft>
             </a:pPr>
             <a:r>
-              <a:rPr sz="2000">
+              <a:rPr sz="1800">
                 <a:solidFill>
                   <a:srgbClr val="212121"/>
                 </a:solidFill>
                 <a:latin typeface="Courier New"/>
               </a:rPr>
-              <a:t>esbmc lab4/float.c   →  VERIFICATION FAILED</a:t>
-            </a:r>
-          </a:p>
-          <a:p>
-            <a:pPr lvl="1">
+              <a:t>esbmc unwind.c --unwind 5      →  ?</a:t>
+            </a:r>
+          </a:p>
+          <a:p>
+            <a:pPr>
+              <a:spcAft>
+                <a:spcPts val="0"/>
+              </a:spcAft>
+            </a:pPr>
+            <a:r>
+              <a:rPr sz="1800">
+                <a:solidFill>
+                  <a:srgbClr val="212121"/>
+                </a:solidFill>
+                <a:latin typeface="Courier New"/>
+              </a:rPr>
+              <a:t>esbmc unwind.c --unwind 20     →  ?</a:t>
+            </a:r>
+          </a:p>
+          <a:p>
+            <a:pPr>
+              <a:spcAft>
+                <a:spcPts val="0"/>
+              </a:spcAft>
+            </a:pPr>
+            <a:r>
+              <a:rPr sz="1800">
+                <a:solidFill>
+                  <a:srgbClr val="212121"/>
+                </a:solidFill>
+                <a:latin typeface="Courier New"/>
+              </a:rPr>
+              <a:t>esbmc unwind.c --unwind 60     →  ?</a:t>
+            </a:r>
+          </a:p>
+          <a:p>
+            <a:pPr>
               <a:spcAft>
                 <a:spcPts val="800"/>
               </a:spcAft>
@@ -5583,7 +5607,52 @@
                   <a:srgbClr val="212121"/>
                 </a:solidFill>
               </a:rPr>
-              <a:t>(yes, FAILED — your tool just found a real bug)</a:t>
+              <a:t/>
+            </a:r>
+          </a:p>
+          <a:p>
+            <a:pPr>
+              <a:spcAft>
+                <a:spcPts val="800"/>
+              </a:spcAft>
+            </a:pPr>
+            <a:r>
+              <a:rPr sz="2200">
+                <a:solidFill>
+                  <a:srgbClr val="212121"/>
+                </a:solidFill>
+              </a:rPr>
+              <a:t>What is the unwinding assertion telling you at 5 and 20?</a:t>
+            </a:r>
+          </a:p>
+          <a:p>
+            <a:pPr>
+              <a:spcAft>
+                <a:spcPts val="800"/>
+              </a:spcAft>
+            </a:pPr>
+            <a:r>
+              <a:rPr sz="2200">
+                <a:solidFill>
+                  <a:srgbClr val="212121"/>
+                </a:solidFill>
+              </a:rPr>
+              <a:t>At 60 — what exactly is proven, and for which n?</a:t>
+            </a:r>
+          </a:p>
+          <a:p>
+            <a:pPr>
+              <a:spcAft>
+                <a:spcPts val="800"/>
+              </a:spcAft>
+            </a:pPr>
+            <a:r>
+              <a:rPr sz="2200">
+                <a:solidFill>
+                  <a:srgbClr val="212121"/>
+                </a:solidFill>
+              </a:rPr>
+              <a:t>Stretch: --k-induction answers VERIFICATION UNKNOWN. Why is the unbounded question fundamentally harder? (Background deck: 03-k-induction.pptx)</a:t>
             </a:r>
           </a:p>
         </p:txBody>
@@ -5596,8 +5665,8 @@
 </p:sld>
 </file>
 
-<file path=ppt/slides/slide20.xml><?xml version="1.0" encoding="utf-8"?>
-<p:sld xmlns:a="http://schemas.openxmlformats.org/drawingml/2006/main" xmlns:r="http://schemas.openxmlformats.org/officeDocument/2006/relationships" xmlns:p="http://schemas.openxmlformats.org/presentationml/2006/main">
+<file path=ppt/slides/slide21.xml><?xml version="1.0" encoding="utf-8"?>
+<p:sld xmlns:a="http://schemas.openxmlformats.org/drawingml/2006/main" xmlns:p="http://schemas.openxmlformats.org/presentationml/2006/main" xmlns:r="http://schemas.openxmlformats.org/officeDocument/2006/relationships">
   <p:cSld>
     <p:spTree>
       <p:nvGrpSpPr>
@@ -5605,14 +5674,7 @@
         <p:cNvGrpSpPr/>
         <p:nvPr/>
       </p:nvGrpSpPr>
-      <p:grpSpPr>
-        <a:xfrm>
-          <a:off x="0" y="0"/>
-          <a:ext cx="0" cy="0"/>
-          <a:chOff x="0" y="0"/>
-          <a:chExt cx="0" cy="0"/>
-        </a:xfrm>
-      </p:grpSpPr>
+      <p:grpSpPr/>
       <p:sp>
         <p:nvSpPr>
           <p:cNvPr id="2" name="TextBox 1"/>
@@ -5718,11 +5780,14 @@
                 <a:spcPts val="800"/>
               </a:spcAft>
             </a:pPr>
-            <a:endParaRPr sz="2000">
-              <a:solidFill>
-                <a:srgbClr val="212121"/>
-              </a:solidFill>
-            </a:endParaRPr>
+            <a:r>
+              <a:rPr sz="2200">
+                <a:solidFill>
+                  <a:srgbClr val="212121"/>
+                </a:solidFill>
+              </a:rPr>
+              <a:t/>
+            </a:r>
           </a:p>
           <a:p>
             <a:pPr>
@@ -5780,8 +5845,8 @@
 </p:sld>
 </file>
 
-<file path=ppt/slides/slide21.xml><?xml version="1.0" encoding="utf-8"?>
-<p:sld xmlns:a="http://schemas.openxmlformats.org/drawingml/2006/main" xmlns:r="http://schemas.openxmlformats.org/officeDocument/2006/relationships" xmlns:p="http://schemas.openxmlformats.org/presentationml/2006/main">
+<file path=ppt/slides/slide22.xml><?xml version="1.0" encoding="utf-8"?>
+<p:sld xmlns:a="http://schemas.openxmlformats.org/drawingml/2006/main" xmlns:p="http://schemas.openxmlformats.org/presentationml/2006/main" xmlns:r="http://schemas.openxmlformats.org/officeDocument/2006/relationships">
   <p:cSld>
     <p:spTree>
       <p:nvGrpSpPr>
@@ -5789,14 +5854,7 @@
         <p:cNvGrpSpPr/>
         <p:nvPr/>
       </p:nvGrpSpPr>
-      <p:grpSpPr>
-        <a:xfrm>
-          <a:off x="0" y="0"/>
-          <a:ext cx="0" cy="0"/>
-          <a:chOff x="0" y="0"/>
-          <a:chExt cx="0" cy="0"/>
-        </a:xfrm>
-      </p:grpSpPr>
+      <p:grpSpPr/>
       <p:sp>
         <p:nvSpPr>
           <p:cNvPr id="2" name="TextBox 1"/>
@@ -5902,11 +5960,14 @@
                 <a:spcPts val="800"/>
               </a:spcAft>
             </a:pPr>
-            <a:endParaRPr sz="2200">
-              <a:solidFill>
-                <a:srgbClr val="212121"/>
-              </a:solidFill>
-            </a:endParaRPr>
+            <a:r>
+              <a:rPr sz="2200">
+                <a:solidFill>
+                  <a:srgbClr val="212121"/>
+                </a:solidFill>
+              </a:rPr>
+              <a:t/>
+            </a:r>
           </a:p>
           <a:p>
             <a:pPr>
@@ -5933,8 +5994,8 @@
 </p:sld>
 </file>
 
-<file path=ppt/slides/slide22.xml><?xml version="1.0" encoding="utf-8"?>
-<p:sld xmlns:a="http://schemas.openxmlformats.org/drawingml/2006/main" xmlns:r="http://schemas.openxmlformats.org/officeDocument/2006/relationships" xmlns:p="http://schemas.openxmlformats.org/presentationml/2006/main">
+<file path=ppt/slides/slide23.xml><?xml version="1.0" encoding="utf-8"?>
+<p:sld xmlns:a="http://schemas.openxmlformats.org/drawingml/2006/main" xmlns:p="http://schemas.openxmlformats.org/presentationml/2006/main" xmlns:r="http://schemas.openxmlformats.org/officeDocument/2006/relationships">
   <p:cSld>
     <p:spTree>
       <p:nvGrpSpPr>
@@ -5942,14 +6003,7 @@
         <p:cNvGrpSpPr/>
         <p:nvPr/>
       </p:nvGrpSpPr>
-      <p:grpSpPr>
-        <a:xfrm>
-          <a:off x="0" y="0"/>
-          <a:ext cx="0" cy="0"/>
-          <a:chOff x="0" y="0"/>
-          <a:chExt cx="0" cy="0"/>
-        </a:xfrm>
-      </p:grpSpPr>
+      <p:grpSpPr/>
       <p:sp>
         <p:nvSpPr>
           <p:cNvPr id="2" name="TextBox 1"/>
@@ -6040,24 +6094,27 @@
                 <a:spcPts val="800"/>
               </a:spcAft>
             </a:pPr>
-            <a:endParaRPr sz="2200">
-              <a:solidFill>
-                <a:srgbClr val="212121"/>
-              </a:solidFill>
-            </a:endParaRPr>
-          </a:p>
-          <a:p>
-            <a:pPr>
-              <a:spcAft>
-                <a:spcPts val="800"/>
-              </a:spcAft>
-            </a:pPr>
             <a:r>
               <a:rPr sz="2200">
                 <a:solidFill>
                   <a:srgbClr val="212121"/>
                 </a:solidFill>
               </a:rPr>
+              <a:t/>
+            </a:r>
+          </a:p>
+          <a:p>
+            <a:pPr>
+              <a:spcAft>
+                <a:spcPts val="800"/>
+              </a:spcAft>
+            </a:pPr>
+            <a:r>
+              <a:rPr sz="2200">
+                <a:solidFill>
+                  <a:srgbClr val="212121"/>
+                </a:solidFill>
+              </a:rPr>
               <a:t>Where next:</a:t>
             </a:r>
           </a:p>
@@ -6127,11 +6184,14 @@
                 <a:spcPts val="800"/>
               </a:spcAft>
             </a:pPr>
-            <a:endParaRPr sz="2000">
-              <a:solidFill>
-                <a:srgbClr val="212121"/>
-              </a:solidFill>
-            </a:endParaRPr>
+            <a:r>
+              <a:rPr sz="2200">
+                <a:solidFill>
+                  <a:srgbClr val="212121"/>
+                </a:solidFill>
+              </a:rPr>
+              <a:t/>
+            </a:r>
           </a:p>
           <a:p>
             <a:pPr>
@@ -6159,7 +6219,7 @@
 </file>
 
 <file path=ppt/slides/slide3.xml><?xml version="1.0" encoding="utf-8"?>
-<p:sld xmlns:a="http://schemas.openxmlformats.org/drawingml/2006/main" xmlns:r="http://schemas.openxmlformats.org/officeDocument/2006/relationships" xmlns:p="http://schemas.openxmlformats.org/presentationml/2006/main">
+<p:sld xmlns:a="http://schemas.openxmlformats.org/drawingml/2006/main" xmlns:p="http://schemas.openxmlformats.org/presentationml/2006/main" xmlns:r="http://schemas.openxmlformats.org/officeDocument/2006/relationships">
   <p:cSld>
     <p:spTree>
       <p:nvGrpSpPr>
@@ -6167,14 +6227,7 @@
         <p:cNvGrpSpPr/>
         <p:nvPr/>
       </p:nvGrpSpPr>
-      <p:grpSpPr>
-        <a:xfrm>
-          <a:off x="0" y="0"/>
-          <a:ext cx="0" cy="0"/>
-          <a:chOff x="0" y="0"/>
-          <a:chExt cx="0" cy="0"/>
-        </a:xfrm>
-      </p:grpSpPr>
+      <p:grpSpPr/>
       <p:sp>
         <p:nvSpPr>
           <p:cNvPr id="2" name="TextBox 1"/>
@@ -6218,7 +6271,7 @@
         </p:nvGraphicFramePr>
         <p:xfrm>
           <a:off x="731520" y="1463040"/>
-          <a:ext cx="10698480" cy="2377440"/>
+          <a:ext cx="10698480" cy="2194560"/>
         </p:xfrm>
         <a:graphic>
           <a:graphicData uri="http://schemas.openxmlformats.org/drawingml/2006/table">
@@ -6227,27 +6280,9 @@
                 <a:tableStyleId>{5C22544A-7EE6-4342-B048-85BDC9FD1C3A}</a:tableStyleId>
               </a:tblPr>
               <a:tblGrid>
-                <a:gridCol w="1463040">
-                  <a:extLst>
-                    <a:ext uri="{9D8B030D-6E8A-4147-A177-3AD203B41FA5}">
-                      <a16:colId xmlns:a16="http://schemas.microsoft.com/office/drawing/2014/main" val="20000"/>
-                    </a:ext>
-                  </a:extLst>
-                </a:gridCol>
-                <a:gridCol w="1645920">
-                  <a:extLst>
-                    <a:ext uri="{9D8B030D-6E8A-4147-A177-3AD203B41FA5}">
-                      <a16:colId xmlns:a16="http://schemas.microsoft.com/office/drawing/2014/main" val="20001"/>
-                    </a:ext>
-                  </a:extLst>
-                </a:gridCol>
-                <a:gridCol w="7589520">
-                  <a:extLst>
-                    <a:ext uri="{9D8B030D-6E8A-4147-A177-3AD203B41FA5}">
-                      <a16:colId xmlns:a16="http://schemas.microsoft.com/office/drawing/2014/main" val="20002"/>
-                    </a:ext>
-                  </a:extLst>
-                </a:gridCol>
+                <a:gridCol w="1463040"/>
+                <a:gridCol w="1645920"/>
+                <a:gridCol w="7589520"/>
               </a:tblGrid>
               <a:tr h="365760">
                 <a:tc>
@@ -6289,11 +6324,6 @@
                   </a:txBody>
                   <a:tcPr/>
                 </a:tc>
-                <a:extLst>
-                  <a:ext uri="{0D108BD9-81ED-4DB2-BD59-A6C34878D82A}">
-                    <a16:rowId xmlns:a16="http://schemas.microsoft.com/office/drawing/2014/main" val="10000"/>
-                  </a:ext>
-                </a:extLst>
               </a:tr>
               <a:tr h="365760">
                 <a:tc>
@@ -6335,11 +6365,6 @@
                   </a:txBody>
                   <a:tcPr/>
                 </a:tc>
-                <a:extLst>
-                  <a:ext uri="{0D108BD9-81ED-4DB2-BD59-A6C34878D82A}">
-                    <a16:rowId xmlns:a16="http://schemas.microsoft.com/office/drawing/2014/main" val="10001"/>
-                  </a:ext>
-                </a:extLst>
               </a:tr>
               <a:tr h="365760">
                 <a:tc>
@@ -6372,17 +6397,10 @@
                   <a:txBody>
                     <a:bodyPr/>
                     <a:lstStyle/>
-                    <a:p>
-                      <a:endParaRPr/>
-                    </a:p>
+                    <a:p/>
                   </a:txBody>
                   <a:tcPr/>
                 </a:tc>
-                <a:extLst>
-                  <a:ext uri="{0D108BD9-81ED-4DB2-BD59-A6C34878D82A}">
-                    <a16:rowId xmlns:a16="http://schemas.microsoft.com/office/drawing/2014/main" val="10002"/>
-                  </a:ext>
-                </a:extLst>
               </a:tr>
               <a:tr h="365760">
                 <a:tc>
@@ -6424,11 +6442,6 @@
                   </a:txBody>
                   <a:tcPr/>
                 </a:tc>
-                <a:extLst>
-                  <a:ext uri="{0D108BD9-81ED-4DB2-BD59-A6C34878D82A}">
-                    <a16:rowId xmlns:a16="http://schemas.microsoft.com/office/drawing/2014/main" val="10003"/>
-                  </a:ext>
-                </a:extLst>
               </a:tr>
               <a:tr h="365760">
                 <a:tc>
@@ -6470,11 +6483,6 @@
                   </a:txBody>
                   <a:tcPr/>
                 </a:tc>
-                <a:extLst>
-                  <a:ext uri="{0D108BD9-81ED-4DB2-BD59-A6C34878D82A}">
-                    <a16:rowId xmlns:a16="http://schemas.microsoft.com/office/drawing/2014/main" val="10004"/>
-                  </a:ext>
-                </a:extLst>
               </a:tr>
               <a:tr h="365760">
                 <a:tc>
@@ -6494,9 +6502,7 @@
                   <a:txBody>
                     <a:bodyPr/>
                     <a:lstStyle/>
-                    <a:p>
-                      <a:endParaRPr/>
-                    </a:p>
+                    <a:p/>
                   </a:txBody>
                   <a:tcPr/>
                 </a:tc>
@@ -6513,11 +6519,6 @@
                   </a:txBody>
                   <a:tcPr/>
                 </a:tc>
-                <a:extLst>
-                  <a:ext uri="{0D108BD9-81ED-4DB2-BD59-A6C34878D82A}">
-                    <a16:rowId xmlns:a16="http://schemas.microsoft.com/office/drawing/2014/main" val="10005"/>
-                  </a:ext>
-                </a:extLst>
               </a:tr>
             </a:tbl>
           </a:graphicData>
@@ -6570,7 +6571,7 @@
 </file>
 
 <file path=ppt/slides/slide4.xml><?xml version="1.0" encoding="utf-8"?>
-<p:sld xmlns:a="http://schemas.openxmlformats.org/drawingml/2006/main" xmlns:r="http://schemas.openxmlformats.org/officeDocument/2006/relationships" xmlns:p="http://schemas.openxmlformats.org/presentationml/2006/main">
+<p:sld xmlns:a="http://schemas.openxmlformats.org/drawingml/2006/main" xmlns:p="http://schemas.openxmlformats.org/presentationml/2006/main" xmlns:r="http://schemas.openxmlformats.org/officeDocument/2006/relationships">
   <p:cSld>
     <p:spTree>
       <p:nvGrpSpPr>
@@ -6578,14 +6579,7 @@
         <p:cNvGrpSpPr/>
         <p:nvPr/>
       </p:nvGrpSpPr>
-      <p:grpSpPr>
-        <a:xfrm>
-          <a:off x="0" y="0"/>
-          <a:ext cx="0" cy="0"/>
-          <a:chOff x="0" y="0"/>
-          <a:chExt cx="0" cy="0"/>
-        </a:xfrm>
-      </p:grpSpPr>
+      <p:grpSpPr/>
       <p:sp>
         <p:nvSpPr>
           <p:cNvPr id="2" name="TextBox 1"/>
@@ -6691,11 +6685,14 @@
                 <a:spcPts val="800"/>
               </a:spcAft>
             </a:pPr>
-            <a:endParaRPr sz="2400">
-              <a:solidFill>
-                <a:srgbClr val="212121"/>
-              </a:solidFill>
-            </a:endParaRPr>
+            <a:r>
+              <a:rPr sz="2600">
+                <a:solidFill>
+                  <a:srgbClr val="212121"/>
+                </a:solidFill>
+              </a:rPr>
+              <a:t/>
+            </a:r>
           </a:p>
           <a:p>
             <a:pPr>
@@ -6723,7 +6720,7 @@
 </file>
 
 <file path=ppt/slides/slide5.xml><?xml version="1.0" encoding="utf-8"?>
-<p:sld xmlns:a="http://schemas.openxmlformats.org/drawingml/2006/main" xmlns:r="http://schemas.openxmlformats.org/officeDocument/2006/relationships" xmlns:p="http://schemas.openxmlformats.org/presentationml/2006/main">
+<p:sld xmlns:a="http://schemas.openxmlformats.org/drawingml/2006/main" xmlns:p="http://schemas.openxmlformats.org/presentationml/2006/main" xmlns:r="http://schemas.openxmlformats.org/officeDocument/2006/relationships">
   <p:cSld>
     <p:spTree>
       <p:nvGrpSpPr>
@@ -6731,14 +6728,7 @@
         <p:cNvGrpSpPr/>
         <p:nvPr/>
       </p:nvGrpSpPr>
-      <p:grpSpPr>
-        <a:xfrm>
-          <a:off x="0" y="0"/>
-          <a:ext cx="0" cy="0"/>
-          <a:chOff x="0" y="0"/>
-          <a:chExt cx="0" cy="0"/>
-        </a:xfrm>
-      </p:grpSpPr>
+      <p:grpSpPr/>
       <p:sp>
         <p:nvSpPr>
           <p:cNvPr id="2" name="TextBox 1"/>
@@ -6781,7 +6771,7 @@
         <p:spPr>
           <a:xfrm>
             <a:off x="731520" y="1828800"/>
-            <a:ext cx="10789920" cy="3642023"/>
+            <a:ext cx="10789920" cy="4754880"/>
           </a:xfrm>
           <a:prstGeom prst="rect">
             <a:avLst/>
@@ -6800,41 +6790,28 @@
               </a:spcAft>
             </a:pPr>
             <a:r>
-              <a:rPr sz="2400" dirty="0">
-                <a:solidFill>
-                  <a:srgbClr val="212121"/>
-                </a:solidFill>
-              </a:rPr>
-              <a:t>Tonight's trick hunts a counterexample. Abstract interpretation proves P the other way</a:t>
-            </a:r>
-            <a:r>
-              <a:rPr lang="en-GB" sz="2400" dirty="0">
-                <a:solidFill>
-                  <a:srgbClr val="212121"/>
-                </a:solidFill>
-              </a:rPr>
-              <a:t>;</a:t>
-            </a:r>
-            <a:r>
-              <a:rPr sz="2400" dirty="0">
-                <a:solidFill>
-                  <a:srgbClr val="212121"/>
-                </a:solidFill>
-              </a:rPr>
-              <a:t> over-approximate every run at once to a fixpoint invariant: no bound, no search.</a:t>
-            </a:r>
-          </a:p>
-          <a:p>
-            <a:pPr>
-              <a:spcAft>
-                <a:spcPts val="800"/>
-              </a:spcAft>
-            </a:pPr>
-            <a:endParaRPr sz="2400" dirty="0">
-              <a:solidFill>
-                <a:srgbClr val="212121"/>
-              </a:solidFill>
-            </a:endParaRPr>
+              <a:rPr sz="2400">
+                <a:solidFill>
+                  <a:srgbClr val="212121"/>
+                </a:solidFill>
+              </a:rPr>
+              <a:t>Tonight's trick hunts a counterexample. Abstract interpretation proves P the other way — over-approximate every run at once to a fixpoint invariant: no bound, no search.</a:t>
+            </a:r>
+          </a:p>
+          <a:p>
+            <a:pPr>
+              <a:spcAft>
+                <a:spcPts val="800"/>
+              </a:spcAft>
+            </a:pPr>
+            <a:r>
+              <a:rPr sz="2400">
+                <a:solidFill>
+                  <a:srgbClr val="212121"/>
+                </a:solidFill>
+              </a:rPr>
+              <a:t/>
+            </a:r>
           </a:p>
           <a:p>
             <a:pPr lvl="1">
@@ -6843,28 +6820,12 @@
               </a:spcAft>
             </a:pPr>
             <a:r>
-              <a:rPr sz="2200" dirty="0">
-                <a:solidFill>
-                  <a:srgbClr val="212121"/>
-                </a:solidFill>
-              </a:rPr>
-              <a:t>You met the mechanism in Session 1: abstract domain, widening (∇), narrowing (</a:t>
-            </a:r>
-            <a:r>
-              <a:rPr sz="2200" dirty="0" err="1">
-                <a:solidFill>
-                  <a:srgbClr val="212121"/>
-                </a:solidFill>
-              </a:rPr>
-              <a:t>Δ</a:t>
-            </a:r>
-            <a:r>
-              <a:rPr sz="2200" dirty="0">
-                <a:solidFill>
-                  <a:srgbClr val="212121"/>
-                </a:solidFill>
-              </a:rPr>
-              <a:t>) — iterate to a fixpoint; if it implies P, P holds for every run.</a:t>
+              <a:rPr sz="2200">
+                <a:solidFill>
+                  <a:srgbClr val="212121"/>
+                </a:solidFill>
+              </a:rPr>
+              <a:t>You met the mechanism in Session 1: abstract domain, widening (∇), narrowing (Δ) — iterate to a fixpoint; if it implies P, P holds for every run.</a:t>
             </a:r>
           </a:p>
           <a:p>
@@ -6874,7 +6835,7 @@
               </a:spcAft>
             </a:pPr>
             <a:r>
-              <a:rPr sz="2200" dirty="0">
+              <a:rPr sz="2200">
                 <a:solidFill>
                   <a:srgbClr val="212121"/>
                 </a:solidFill>
@@ -6889,44 +6850,12 @@
               </a:spcAft>
             </a:pPr>
             <a:r>
-              <a:rPr sz="2200" dirty="0">
-                <a:solidFill>
-                  <a:srgbClr val="212121"/>
-                </a:solidFill>
-              </a:rPr>
-              <a:t>ESBMC ships it too</a:t>
-            </a:r>
-            <a:r>
-              <a:rPr lang="en-GB" sz="2200" dirty="0">
-                <a:solidFill>
-                  <a:srgbClr val="212121"/>
-                </a:solidFill>
-              </a:rPr>
-              <a:t>:</a:t>
-            </a:r>
-            <a:r>
-              <a:rPr sz="2200" dirty="0">
-                <a:solidFill>
-                  <a:srgbClr val="212121"/>
-                </a:solidFill>
-              </a:rPr>
-              <a:t> --interval-analysis — feeding the invariant k-induction needs for </a:t>
-            </a:r>
-            <a:r>
-              <a:rPr sz="2200" dirty="0" err="1">
-                <a:solidFill>
-                  <a:srgbClr val="212121"/>
-                </a:solidFill>
-              </a:rPr>
-              <a:t>unwind.c</a:t>
-            </a:r>
-            <a:r>
-              <a:rPr sz="2200" dirty="0">
-                <a:solidFill>
-                  <a:srgbClr val="212121"/>
-                </a:solidFill>
-              </a:rPr>
-              <a:t> (Lab 3).</a:t>
+              <a:rPr sz="2200">
+                <a:solidFill>
+                  <a:srgbClr val="212121"/>
+                </a:solidFill>
+              </a:rPr>
+              <a:t>ESBMC ships it too — --interval-analysis — feeding the invariant k-induction needs for unwind.c (Lab 3).</a:t>
             </a:r>
           </a:p>
         </p:txBody>
@@ -6940,7 +6869,7 @@
 </file>
 
 <file path=ppt/slides/slide6.xml><?xml version="1.0" encoding="utf-8"?>
-<p:sld xmlns:a="http://schemas.openxmlformats.org/drawingml/2006/main" xmlns:r="http://schemas.openxmlformats.org/officeDocument/2006/relationships" xmlns:p="http://schemas.openxmlformats.org/presentationml/2006/main">
+<p:sld xmlns:a="http://schemas.openxmlformats.org/drawingml/2006/main" xmlns:p="http://schemas.openxmlformats.org/presentationml/2006/main" xmlns:r="http://schemas.openxmlformats.org/officeDocument/2006/relationships">
   <p:cSld>
     <p:spTree>
       <p:nvGrpSpPr>
@@ -6948,14 +6877,7 @@
         <p:cNvGrpSpPr/>
         <p:nvPr/>
       </p:nvGrpSpPr>
-      <p:grpSpPr>
-        <a:xfrm>
-          <a:off x="0" y="0"/>
-          <a:ext cx="0" cy="0"/>
-          <a:chOff x="0" y="0"/>
-          <a:chExt cx="0" cy="0"/>
-        </a:xfrm>
-      </p:grpSpPr>
+      <p:grpSpPr/>
       <p:sp>
         <p:nvSpPr>
           <p:cNvPr id="2" name="TextBox 1"/>
@@ -7076,11 +6998,14 @@
                 <a:spcPts val="800"/>
               </a:spcAft>
             </a:pPr>
-            <a:endParaRPr sz="2000">
-              <a:solidFill>
-                <a:srgbClr val="212121"/>
-              </a:solidFill>
-            </a:endParaRPr>
+            <a:r>
+              <a:rPr sz="2200">
+                <a:solidFill>
+                  <a:srgbClr val="212121"/>
+                </a:solidFill>
+              </a:rPr>
+              <a:t/>
+            </a:r>
           </a:p>
           <a:p>
             <a:pPr>
@@ -7123,7 +7048,7 @@
 </file>
 
 <file path=ppt/slides/slide7.xml><?xml version="1.0" encoding="utf-8"?>
-<p:sld xmlns:a="http://schemas.openxmlformats.org/drawingml/2006/main" xmlns:r="http://schemas.openxmlformats.org/officeDocument/2006/relationships" xmlns:p="http://schemas.openxmlformats.org/presentationml/2006/main">
+<p:sld xmlns:a="http://schemas.openxmlformats.org/drawingml/2006/main" xmlns:p="http://schemas.openxmlformats.org/presentationml/2006/main" xmlns:r="http://schemas.openxmlformats.org/officeDocument/2006/relationships">
   <p:cSld>
     <p:spTree>
       <p:nvGrpSpPr>
@@ -7131,14 +7056,7 @@
         <p:cNvGrpSpPr/>
         <p:nvPr/>
       </p:nvGrpSpPr>
-      <p:grpSpPr>
-        <a:xfrm>
-          <a:off x="0" y="0"/>
-          <a:ext cx="0" cy="0"/>
-          <a:chOff x="0" y="0"/>
-          <a:chExt cx="0" cy="0"/>
-        </a:xfrm>
-      </p:grpSpPr>
+      <p:grpSpPr/>
       <p:sp>
         <p:nvSpPr>
           <p:cNvPr id="2" name="TextBox 1"/>
@@ -7181,7 +7099,7 @@
         <p:spPr>
           <a:xfrm>
             <a:off x="731520" y="1463040"/>
-            <a:ext cx="10789920" cy="3026470"/>
+            <a:ext cx="10789920" cy="5120640"/>
           </a:xfrm>
           <a:prstGeom prst="rect">
             <a:avLst/>
@@ -7200,65 +7118,94 @@
               </a:spcAft>
             </a:pPr>
             <a:r>
-              <a:rPr sz="1800" dirty="0">
+              <a:rPr sz="1800">
                 <a:solidFill>
                   <a:srgbClr val="212121"/>
                 </a:solidFill>
                 <a:latin typeface="Courier New"/>
               </a:rPr>
-              <a:t>from z3 import Bools, </a:t>
-            </a:r>
-            <a:r>
-              <a:rPr sz="1800" dirty="0" err="1">
+              <a:t>from z3 import Bools, Ints, BitVec, Solver, sat, unsat</a:t>
+            </a:r>
+          </a:p>
+          <a:p>
+            <a:pPr>
+              <a:spcAft>
+                <a:spcPts val="0"/>
+              </a:spcAft>
+            </a:pPr>
+            <a:r>
+              <a:rPr sz="1800">
                 <a:solidFill>
                   <a:srgbClr val="212121"/>
                 </a:solidFill>
                 <a:latin typeface="Courier New"/>
               </a:rPr>
-              <a:t>Ints</a:t>
-            </a:r>
-            <a:r>
-              <a:rPr sz="1800" dirty="0">
+              <a:t>a, b = Bools("a b")     # symbolic booleans, not values</a:t>
+            </a:r>
+          </a:p>
+          <a:p>
+            <a:pPr>
+              <a:spcAft>
+                <a:spcPts val="0"/>
+              </a:spcAft>
+            </a:pPr>
+            <a:r>
+              <a:rPr sz="1800">
                 <a:solidFill>
                   <a:srgbClr val="212121"/>
                 </a:solidFill>
                 <a:latin typeface="Courier New"/>
               </a:rPr>
-              <a:t>, </a:t>
-            </a:r>
-            <a:r>
-              <a:rPr sz="1800" dirty="0" err="1">
+              <a:t>x = BitVec("x", 32)     # a 32-bit machine integer</a:t>
+            </a:r>
+          </a:p>
+          <a:p>
+            <a:pPr>
+              <a:spcAft>
+                <a:spcPts val="0"/>
+              </a:spcAft>
+            </a:pPr>
+            <a:r>
+              <a:rPr sz="1800">
                 <a:solidFill>
                   <a:srgbClr val="212121"/>
                 </a:solidFill>
                 <a:latin typeface="Courier New"/>
               </a:rPr>
-              <a:t>BitVec</a:t>
-            </a:r>
-            <a:r>
-              <a:rPr sz="1800" dirty="0">
+              <a:t/>
+            </a:r>
+          </a:p>
+          <a:p>
+            <a:pPr>
+              <a:spcAft>
+                <a:spcPts val="0"/>
+              </a:spcAft>
+            </a:pPr>
+            <a:r>
+              <a:rPr sz="1800">
                 <a:solidFill>
                   <a:srgbClr val="212121"/>
                 </a:solidFill>
                 <a:latin typeface="Courier New"/>
               </a:rPr>
-              <a:t>, Solver, sat, </a:t>
-            </a:r>
-            <a:r>
-              <a:rPr sz="1800" dirty="0" err="1">
+              <a:t>s = Solver()</a:t>
+            </a:r>
+          </a:p>
+          <a:p>
+            <a:pPr>
+              <a:spcAft>
+                <a:spcPts val="0"/>
+              </a:spcAft>
+            </a:pPr>
+            <a:r>
+              <a:rPr sz="1800">
                 <a:solidFill>
                   <a:srgbClr val="212121"/>
                 </a:solidFill>
                 <a:latin typeface="Courier New"/>
               </a:rPr>
-              <a:t>unsat</a:t>
-            </a:r>
-            <a:endParaRPr sz="1800" dirty="0">
-              <a:solidFill>
-                <a:srgbClr val="212121"/>
-              </a:solidFill>
-              <a:latin typeface="Courier New"/>
-            </a:endParaRPr>
+              <a:t>s.add(formula)           # constrain</a:t>
+            </a:r>
           </a:p>
           <a:p>
             <a:pPr>
@@ -7267,228 +7214,59 @@
               </a:spcAft>
             </a:pPr>
             <a:r>
-              <a:rPr sz="1800" dirty="0">
+              <a:rPr sz="1800">
                 <a:solidFill>
                   <a:srgbClr val="212121"/>
                 </a:solidFill>
                 <a:latin typeface="Courier New"/>
               </a:rPr>
-              <a:t>a, b = Bools("a b")     # symbolic </a:t>
-            </a:r>
-            <a:r>
-              <a:rPr sz="1800" dirty="0" err="1">
+              <a:t>s.check()                # -&gt; sat or unsat</a:t>
+            </a:r>
+          </a:p>
+          <a:p>
+            <a:pPr>
+              <a:spcAft>
+                <a:spcPts val="0"/>
+              </a:spcAft>
+            </a:pPr>
+            <a:r>
+              <a:rPr sz="1800">
                 <a:solidFill>
                   <a:srgbClr val="212121"/>
                 </a:solidFill>
                 <a:latin typeface="Courier New"/>
               </a:rPr>
-              <a:t>booleans</a:t>
-            </a:r>
-            <a:r>
-              <a:rPr sz="1800" dirty="0">
-                <a:solidFill>
-                  <a:srgbClr val="212121"/>
-                </a:solidFill>
-                <a:latin typeface="Courier New"/>
-              </a:rPr>
-              <a:t>, not values</a:t>
-            </a:r>
-          </a:p>
-          <a:p>
-            <a:pPr>
-              <a:spcAft>
-                <a:spcPts val="0"/>
-              </a:spcAft>
-            </a:pPr>
-            <a:r>
-              <a:rPr sz="1800" dirty="0">
-                <a:solidFill>
-                  <a:srgbClr val="212121"/>
-                </a:solidFill>
-                <a:latin typeface="Courier New"/>
-              </a:rPr>
-              <a:t>x = </a:t>
-            </a:r>
-            <a:r>
-              <a:rPr sz="1800" dirty="0" err="1">
-                <a:solidFill>
-                  <a:srgbClr val="212121"/>
-                </a:solidFill>
-                <a:latin typeface="Courier New"/>
-              </a:rPr>
-              <a:t>BitVec</a:t>
-            </a:r>
-            <a:r>
-              <a:rPr sz="1800" dirty="0">
-                <a:solidFill>
-                  <a:srgbClr val="212121"/>
-                </a:solidFill>
-                <a:latin typeface="Courier New"/>
-              </a:rPr>
-              <a:t>("x", 32)     # a 32-bit machine integer</a:t>
-            </a:r>
-          </a:p>
-          <a:p>
-            <a:pPr>
-              <a:spcAft>
-                <a:spcPts val="0"/>
-              </a:spcAft>
-            </a:pPr>
-            <a:endParaRPr sz="1800" dirty="0">
-              <a:solidFill>
-                <a:srgbClr val="212121"/>
-              </a:solidFill>
-              <a:latin typeface="Courier New"/>
-            </a:endParaRPr>
-          </a:p>
-          <a:p>
-            <a:pPr>
-              <a:spcAft>
-                <a:spcPts val="0"/>
-              </a:spcAft>
-            </a:pPr>
-            <a:r>
-              <a:rPr sz="1800" dirty="0">
-                <a:solidFill>
-                  <a:srgbClr val="212121"/>
-                </a:solidFill>
-                <a:latin typeface="Courier New"/>
-              </a:rPr>
-              <a:t>s = Solver()</a:t>
-            </a:r>
-          </a:p>
-          <a:p>
-            <a:pPr>
-              <a:spcAft>
-                <a:spcPts val="0"/>
-              </a:spcAft>
-            </a:pPr>
-            <a:r>
-              <a:rPr sz="1800" dirty="0" err="1">
-                <a:solidFill>
-                  <a:srgbClr val="212121"/>
-                </a:solidFill>
-                <a:latin typeface="Courier New"/>
-              </a:rPr>
-              <a:t>s.add</a:t>
-            </a:r>
-            <a:r>
-              <a:rPr sz="1800" dirty="0">
-                <a:solidFill>
-                  <a:srgbClr val="212121"/>
-                </a:solidFill>
-                <a:latin typeface="Courier New"/>
-              </a:rPr>
-              <a:t>(formula)           # constrain</a:t>
-            </a:r>
-          </a:p>
-          <a:p>
-            <a:pPr>
-              <a:spcAft>
-                <a:spcPts val="0"/>
-              </a:spcAft>
-            </a:pPr>
-            <a:r>
-              <a:rPr sz="1800" dirty="0" err="1">
-                <a:solidFill>
-                  <a:srgbClr val="212121"/>
-                </a:solidFill>
-                <a:latin typeface="Courier New"/>
-              </a:rPr>
-              <a:t>s.check</a:t>
-            </a:r>
-            <a:r>
-              <a:rPr sz="1800" dirty="0">
-                <a:solidFill>
-                  <a:srgbClr val="212121"/>
-                </a:solidFill>
-                <a:latin typeface="Courier New"/>
-              </a:rPr>
-              <a:t>()                # -&gt; sat or </a:t>
-            </a:r>
-            <a:r>
-              <a:rPr sz="1800" dirty="0" err="1">
-                <a:solidFill>
-                  <a:srgbClr val="212121"/>
-                </a:solidFill>
-                <a:latin typeface="Courier New"/>
-              </a:rPr>
-              <a:t>unsat</a:t>
-            </a:r>
-            <a:endParaRPr sz="1800" dirty="0">
-              <a:solidFill>
-                <a:srgbClr val="212121"/>
-              </a:solidFill>
-              <a:latin typeface="Courier New"/>
-            </a:endParaRPr>
-          </a:p>
-          <a:p>
-            <a:pPr>
-              <a:spcAft>
-                <a:spcPts val="0"/>
-              </a:spcAft>
-            </a:pPr>
-            <a:r>
-              <a:rPr sz="1800" dirty="0" err="1">
-                <a:solidFill>
-                  <a:srgbClr val="212121"/>
-                </a:solidFill>
-                <a:latin typeface="Courier New"/>
-              </a:rPr>
-              <a:t>s.model</a:t>
-            </a:r>
-            <a:r>
-              <a:rPr sz="1800" dirty="0">
-                <a:solidFill>
-                  <a:srgbClr val="212121"/>
-                </a:solidFill>
-                <a:latin typeface="Courier New"/>
-              </a:rPr>
-              <a:t>()                # the witness, when sat</a:t>
-            </a:r>
-          </a:p>
-          <a:p>
-            <a:pPr>
-              <a:spcAft>
-                <a:spcPts val="800"/>
-              </a:spcAft>
-            </a:pPr>
-            <a:endParaRPr sz="1800" dirty="0">
-              <a:solidFill>
-                <a:srgbClr val="212121"/>
-              </a:solidFill>
-              <a:latin typeface="Courier New"/>
-            </a:endParaRPr>
-          </a:p>
-          <a:p>
-            <a:pPr>
-              <a:spcAft>
-                <a:spcPts val="800"/>
-              </a:spcAft>
-            </a:pPr>
-            <a:r>
-              <a:rPr sz="2200" dirty="0">
-                <a:solidFill>
-                  <a:srgbClr val="212121"/>
-                </a:solidFill>
-              </a:rPr>
-              <a:t>Every stage of lab1.py is these five calls</a:t>
-            </a:r>
-            <a:r>
-              <a:rPr lang="en-GB" sz="2200" dirty="0">
-                <a:solidFill>
-                  <a:srgbClr val="212121"/>
-                </a:solidFill>
-              </a:rPr>
-              <a:t>;</a:t>
-            </a:r>
-            <a:r>
-              <a:rPr sz="2200" dirty="0">
-                <a:solidFill>
-                  <a:srgbClr val="212121"/>
-                </a:solidFill>
-              </a:rPr>
-              <a:t> nothing else.</a:t>
+              <a:t>s.model()                # the witness, when sat</a:t>
+            </a:r>
+          </a:p>
+          <a:p>
+            <a:pPr>
+              <a:spcAft>
+                <a:spcPts val="800"/>
+              </a:spcAft>
+            </a:pPr>
+            <a:r>
+              <a:rPr sz="2200">
+                <a:solidFill>
+                  <a:srgbClr val="212121"/>
+                </a:solidFill>
+              </a:rPr>
+              <a:t/>
+            </a:r>
+          </a:p>
+          <a:p>
+            <a:pPr>
+              <a:spcAft>
+                <a:spcPts val="800"/>
+              </a:spcAft>
+            </a:pPr>
+            <a:r>
+              <a:rPr sz="2200">
+                <a:solidFill>
+                  <a:srgbClr val="212121"/>
+                </a:solidFill>
+              </a:rPr>
+              <a:t>Every stage of lab1.py is these five calls — nothing else.</a:t>
             </a:r>
           </a:p>
         </p:txBody>
@@ -7502,7 +7280,7 @@
 </file>
 
 <file path=ppt/slides/slide8.xml><?xml version="1.0" encoding="utf-8"?>
-<p:sld xmlns:a="http://schemas.openxmlformats.org/drawingml/2006/main" xmlns:r="http://schemas.openxmlformats.org/officeDocument/2006/relationships" xmlns:p="http://schemas.openxmlformats.org/presentationml/2006/main">
+<p:sld xmlns:a="http://schemas.openxmlformats.org/drawingml/2006/main" xmlns:p="http://schemas.openxmlformats.org/presentationml/2006/main" xmlns:r="http://schemas.openxmlformats.org/officeDocument/2006/relationships">
   <p:cSld>
     <p:spTree>
       <p:nvGrpSpPr>
@@ -7510,14 +7288,7 @@
         <p:cNvGrpSpPr/>
         <p:nvPr/>
       </p:nvGrpSpPr>
-      <p:grpSpPr>
-        <a:xfrm>
-          <a:off x="0" y="0"/>
-          <a:ext cx="0" cy="0"/>
-          <a:chOff x="0" y="0"/>
-          <a:chExt cx="0" cy="0"/>
-        </a:xfrm>
-      </p:grpSpPr>
+      <p:grpSpPr/>
       <p:sp>
         <p:nvSpPr>
           <p:cNvPr id="2" name="TextBox 1"/>
@@ -7690,12 +7461,14 @@
                 <a:spcPts val="800"/>
               </a:spcAft>
             </a:pPr>
-            <a:endParaRPr sz="1800">
-              <a:solidFill>
-                <a:srgbClr val="212121"/>
-              </a:solidFill>
-              <a:latin typeface="Courier New"/>
-            </a:endParaRPr>
+            <a:r>
+              <a:rPr sz="2200">
+                <a:solidFill>
+                  <a:srgbClr val="212121"/>
+                </a:solidFill>
+              </a:rPr>
+              <a:t/>
+            </a:r>
           </a:p>
           <a:p>
             <a:pPr lvl="1">
@@ -7754,7 +7527,7 @@
 </file>
 
 <file path=ppt/slides/slide9.xml><?xml version="1.0" encoding="utf-8"?>
-<p:sld xmlns:a="http://schemas.openxmlformats.org/drawingml/2006/main" xmlns:r="http://schemas.openxmlformats.org/officeDocument/2006/relationships" xmlns:p="http://schemas.openxmlformats.org/presentationml/2006/main">
+<p:sld xmlns:a="http://schemas.openxmlformats.org/drawingml/2006/main" xmlns:p="http://schemas.openxmlformats.org/presentationml/2006/main" xmlns:r="http://schemas.openxmlformats.org/officeDocument/2006/relationships">
   <p:cSld>
     <p:spTree>
       <p:nvGrpSpPr>
@@ -7762,14 +7535,7 @@
         <p:cNvGrpSpPr/>
         <p:nvPr/>
       </p:nvGrpSpPr>
-      <p:grpSpPr>
-        <a:xfrm>
-          <a:off x="0" y="0"/>
-          <a:ext cx="0" cy="0"/>
-          <a:chOff x="0" y="0"/>
-          <a:chExt cx="0" cy="0"/>
-        </a:xfrm>
-      </p:grpSpPr>
+      <p:grpSpPr/>
       <p:sp>
         <p:nvSpPr>
           <p:cNvPr id="2" name="TextBox 1"/>
@@ -7894,12 +7660,14 @@
                 <a:spcPts val="800"/>
               </a:spcAft>
             </a:pPr>
-            <a:endParaRPr sz="1800">
-              <a:solidFill>
-                <a:srgbClr val="212121"/>
-              </a:solidFill>
-              <a:latin typeface="Courier New"/>
-            </a:endParaRPr>
+            <a:r>
+              <a:rPr sz="2200">
+                <a:solidFill>
+                  <a:srgbClr val="212121"/>
+                </a:solidFill>
+              </a:rPr>
+              <a:t/>
+            </a:r>
           </a:p>
           <a:p>
             <a:pPr>
@@ -7953,11 +7721,14 @@
                 <a:spcPts val="800"/>
               </a:spcAft>
             </a:pPr>
-            <a:endParaRPr sz="2200">
-              <a:solidFill>
-                <a:srgbClr val="212121"/>
-              </a:solidFill>
-            </a:endParaRPr>
+            <a:r>
+              <a:rPr sz="2200">
+                <a:solidFill>
+                  <a:srgbClr val="212121"/>
+                </a:solidFill>
+              </a:rPr>
+              <a:t/>
+            </a:r>
           </a:p>
           <a:p>
             <a:pPr>

</xml_diff>

<commit_message>
Explain the Stage 1/3 pairing on the Session 2 checkpoint slide
Add a one-liner: Stages 1 and 3 are the unsat = a proof cases (equivalence,
safety), while Stage 2 (SEND + MORE = MONEY) is the sat = a solution mode —
so the checkpoint compares 1 and 3, not 1 and 2.
</commit_message>
<xml_diff>
--- a/slides/session2/01-session2-hands-on.pptx
+++ b/slides/session2/01-session2-hands-on.pptx
@@ -3742,8 +3742,8 @@
         </p:nvSpPr>
         <p:spPr>
           <a:xfrm>
-            <a:off x="731520" y="2011680"/>
-            <a:ext cx="10789920" cy="4572000"/>
+            <a:off x="731520" y="1828800"/>
+            <a:ext cx="10789920" cy="4754880"/>
           </a:xfrm>
           <a:prstGeom prst="rect">
             <a:avLst/>
@@ -3762,37 +3762,67 @@
               </a:spcAft>
             </a:pPr>
             <a:r>
-              <a:rPr sz="2800">
-                <a:solidFill>
-                  <a:srgbClr val="212121"/>
-                </a:solidFill>
-              </a:rPr>
-              <a:t>What does unsat mean in Stage 1?</a:t>
-            </a:r>
-          </a:p>
-          <a:p>
-            <a:pPr>
-              <a:spcAft>
-                <a:spcPts val="800"/>
-              </a:spcAft>
-            </a:pPr>
-            <a:r>
-              <a:rPr sz="2800">
-                <a:solidFill>
-                  <a:srgbClr val="212121"/>
-                </a:solidFill>
-              </a:rPr>
-              <a:t>What does unsat mean in Stage 3?</a:t>
-            </a:r>
-          </a:p>
-          <a:p>
-            <a:pPr>
-              <a:spcAft>
-                <a:spcPts val="800"/>
-              </a:spcAft>
-            </a:pPr>
-            <a:r>
-              <a:rPr sz="2800">
+              <a:rPr sz="2400">
+                <a:solidFill>
+                  <a:srgbClr val="212121"/>
+                </a:solidFill>
+              </a:rPr>
+              <a:t>Stage 1 — are two Boolean formulas equivalent? (you encoded lhs ≠ rhs)</a:t>
+            </a:r>
+          </a:p>
+          <a:p>
+            <a:pPr lvl="1">
+              <a:spcAft>
+                <a:spcPts val="800"/>
+              </a:spcAft>
+            </a:pPr>
+            <a:r>
+              <a:rPr sz="2200">
+                <a:solidFill>
+                  <a:srgbClr val="212121"/>
+                </a:solidFill>
+              </a:rPr>
+              <a:t>What does unsat mean here?</a:t>
+            </a:r>
+          </a:p>
+          <a:p>
+            <a:pPr>
+              <a:spcAft>
+                <a:spcPts val="800"/>
+              </a:spcAft>
+            </a:pPr>
+            <a:r>
+              <a:rPr sz="2400">
+                <a:solidFill>
+                  <a:srgbClr val="212121"/>
+                </a:solidFill>
+              </a:rPr>
+              <a:t>Stage 3 — a 3-line C function as SSA equations, assertion negated</a:t>
+            </a:r>
+          </a:p>
+          <a:p>
+            <a:pPr lvl="1">
+              <a:spcAft>
+                <a:spcPts val="800"/>
+              </a:spcAft>
+            </a:pPr>
+            <a:r>
+              <a:rPr sz="2200">
+                <a:solidFill>
+                  <a:srgbClr val="212121"/>
+                </a:solidFill>
+              </a:rPr>
+              <a:t>What does unsat mean here?</a:t>
+            </a:r>
+          </a:p>
+          <a:p>
+            <a:pPr>
+              <a:spcAft>
+                <a:spcPts val="800"/>
+              </a:spcAft>
+            </a:pPr>
+            <a:r>
+              <a:rPr sz="2400">
                 <a:solidFill>
                   <a:srgbClr val="212121"/>
                 </a:solidFill>
@@ -3807,12 +3837,42 @@
               </a:spcAft>
             </a:pPr>
             <a:r>
-              <a:rPr sz="2800">
-                <a:solidFill>
-                  <a:srgbClr val="212121"/>
-                </a:solidFill>
-              </a:rPr>
-              <a:t>Same verdict — two different questions answered. If you can articulate the difference, you understand verification.</a:t>
+              <a:rPr sz="2400">
+                <a:solidFill>
+                  <a:srgbClr val="212121"/>
+                </a:solidFill>
+              </a:rPr>
+              <a:t>Same verdict — two different questions answered (equivalence vs. a program is safe). If you can articulate the difference, you understand verification.</a:t>
+            </a:r>
+          </a:p>
+          <a:p>
+            <a:pPr>
+              <a:spcAft>
+                <a:spcPts val="800"/>
+              </a:spcAft>
+            </a:pPr>
+            <a:r>
+              <a:rPr sz="2400">
+                <a:solidFill>
+                  <a:srgbClr val="212121"/>
+                </a:solidFill>
+              </a:rPr>
+              <a:t/>
+            </a:r>
+          </a:p>
+          <a:p>
+            <a:pPr lvl="1">
+              <a:spcAft>
+                <a:spcPts val="800"/>
+              </a:spcAft>
+            </a:pPr>
+            <a:r>
+              <a:rPr sz="2200">
+                <a:solidFill>
+                  <a:srgbClr val="212121"/>
+                </a:solidFill>
+              </a:rPr>
+              <a:t>Why 1 and 3, not 2? Both are unsat = a proof. Stage 2 (SEND + MORE = MONEY) is the other mode: sat = a solution.</a:t>
             </a:r>
           </a:p>
         </p:txBody>

</xml_diff>

<commit_message>
Clarify enforce/replace contract semantics (per ESBMC docs)
Rewrite the Session 2 Lab 3 contract slide to mirror the official docs:
enforce = assume requires, run body, assert ensures + frame; replace = at a
call, assert requires, havoc the frame, assume ensures. This fixes the
earlier inaccurate 'assume requires' for replace, and adds a frame/assigns
definition. Apply the same correction to the Lab 3 README and the ledger.

Ref: esbmc.github.io/docs/theory/function-contracts
</commit_message>
<xml_diff>
--- a/slides/session2/01-session2-hands-on.pptx
+++ b/slides/session2/01-session2-hands-on.pptx
@@ -5615,7 +5615,7 @@
               </a:spcAft>
             </a:pPr>
             <a:r>
-              <a:rPr sz="1500">
+              <a:rPr sz="1400">
                 <a:solidFill>
                   <a:srgbClr val="212121"/>
                 </a:solidFill>
@@ -5631,7 +5631,7 @@
               </a:spcAft>
             </a:pPr>
             <a:r>
-              <a:rPr sz="1500">
+              <a:rPr sz="1400">
                 <a:solidFill>
                   <a:srgbClr val="212121"/>
                 </a:solidFill>
@@ -5647,7 +5647,7 @@
               </a:spcAft>
             </a:pPr>
             <a:r>
-              <a:rPr sz="1500">
+              <a:rPr sz="1400">
                 <a:solidFill>
                   <a:srgbClr val="212121"/>
                 </a:solidFill>
@@ -5663,7 +5663,7 @@
               </a:spcAft>
             </a:pPr>
             <a:r>
-              <a:rPr sz="1500">
+              <a:rPr sz="1400">
                 <a:solidFill>
                   <a:srgbClr val="212121"/>
                 </a:solidFill>
@@ -5679,7 +5679,7 @@
               </a:spcAft>
             </a:pPr>
             <a:r>
-              <a:rPr sz="1900">
+              <a:rPr sz="1800">
                 <a:solidFill>
                   <a:srgbClr val="212121"/>
                 </a:solidFill>
@@ -5694,12 +5694,12 @@
               </a:spcAft>
             </a:pPr>
             <a:r>
-              <a:rPr sz="1700">
-                <a:solidFill>
-                  <a:srgbClr val="212121"/>
-                </a:solidFill>
-              </a:rPr>
-              <a:t>--enforce-contract clamp — does the body keep its promise? (seeded bug → contract ensures counterexample → fix → SUCCESSFUL)</a:t>
+              <a:rPr sz="1600">
+                <a:solidFill>
+                  <a:srgbClr val="212121"/>
+                </a:solidFill>
+              </a:rPr>
+              <a:t>Enforce (--enforce-contract): assume requires → run body → assert ensures (+ frame). Proves the implementation meets its contract. (bug → contract ensures → fix → SUCCESSFUL)</a:t>
             </a:r>
           </a:p>
           <a:p>
@@ -5709,12 +5709,12 @@
               </a:spcAft>
             </a:pPr>
             <a:r>
-              <a:rPr sz="1700">
-                <a:solidFill>
-                  <a:srgbClr val="212121"/>
-                </a:solidFill>
-              </a:rPr>
-              <a:t>--replace-call-with-contract clamp — callers trust the contract, not the body: assume requires; havoc; assume ensures. Modular.</a:t>
+              <a:rPr sz="1600">
+                <a:solidFill>
+                  <a:srgbClr val="212121"/>
+                </a:solidFill>
+              </a:rPr>
+              <a:t>Replace (--replace-call-with-contract): at a call → assert requires → havoc frame → assume ensures. Verifies a caller against its callees' specs, without unrolling their bodies. Modular.</a:t>
             </a:r>
           </a:p>
           <a:p>
@@ -5724,7 +5724,22 @@
               </a:spcAft>
             </a:pPr>
             <a:r>
-              <a:rPr sz="1700">
+              <a:rPr sz="1600">
+                <a:solidFill>
+                  <a:srgbClr val="212121"/>
+                </a:solidFill>
+              </a:rPr>
+              <a:t>Frame (__ESBMC_assigns) = the locations a call may change; every other location is asserted unchanged. (clamp writes none.)</a:t>
+            </a:r>
+          </a:p>
+          <a:p>
+            <a:pPr lvl="1">
+              <a:spcAft>
+                <a:spcPts val="800"/>
+              </a:spcAft>
+            </a:pPr>
+            <a:r>
+              <a:rPr sz="1600">
                 <a:solidFill>
                   <a:srgbClr val="212121"/>
                 </a:solidFill>
@@ -5739,7 +5754,7 @@
               </a:spcAft>
             </a:pPr>
             <a:r>
-              <a:rPr sz="1900">
+              <a:rPr sz="1800">
                 <a:solidFill>
                   <a:srgbClr val="212121"/>
                 </a:solidFill>
@@ -5754,7 +5769,7 @@
               </a:spcAft>
             </a:pPr>
             <a:r>
-              <a:rPr sz="1900">
+              <a:rPr sz="1800">
                 <a:solidFill>
                   <a:srgbClr val="212121"/>
                 </a:solidFill>

</xml_diff>

<commit_message>
updated slides for Session 2
Signed-off-by: Lucas Cordeiro <lucasccordeiro@gmail.com>
</commit_message>
<xml_diff>
--- a/slides/session2/01-session2-hands-on.pptx
+++ b/slides/session2/01-session2-hands-on.pptx
@@ -5,32 +5,32 @@
     <p:sldMasterId id="2147483648" r:id="rId1"/>
   </p:sldMasterIdLst>
   <p:sldIdLst>
-    <p:sldId id="256" r:id="rId7"/>
-    <p:sldId id="257" r:id="rId8"/>
-    <p:sldId id="258" r:id="rId9"/>
-    <p:sldId id="259" r:id="rId10"/>
-    <p:sldId id="260" r:id="rId11"/>
-    <p:sldId id="261" r:id="rId12"/>
-    <p:sldId id="262" r:id="rId13"/>
-    <p:sldId id="263" r:id="rId14"/>
-    <p:sldId id="264" r:id="rId15"/>
-    <p:sldId id="265" r:id="rId16"/>
-    <p:sldId id="266" r:id="rId17"/>
-    <p:sldId id="267" r:id="rId18"/>
-    <p:sldId id="268" r:id="rId19"/>
-    <p:sldId id="269" r:id="rId20"/>
-    <p:sldId id="270" r:id="rId21"/>
-    <p:sldId id="271" r:id="rId22"/>
-    <p:sldId id="272" r:id="rId23"/>
-    <p:sldId id="273" r:id="rId24"/>
-    <p:sldId id="274" r:id="rId25"/>
-    <p:sldId id="275" r:id="rId26"/>
-    <p:sldId id="276" r:id="rId27"/>
-    <p:sldId id="277" r:id="rId28"/>
-    <p:sldId id="278" r:id="rId29"/>
-    <p:sldId id="279" r:id="rId30"/>
+    <p:sldId id="256" r:id="rId2"/>
+    <p:sldId id="257" r:id="rId3"/>
+    <p:sldId id="258" r:id="rId4"/>
+    <p:sldId id="259" r:id="rId5"/>
+    <p:sldId id="260" r:id="rId6"/>
+    <p:sldId id="261" r:id="rId7"/>
+    <p:sldId id="262" r:id="rId8"/>
+    <p:sldId id="263" r:id="rId9"/>
+    <p:sldId id="264" r:id="rId10"/>
+    <p:sldId id="265" r:id="rId11"/>
+    <p:sldId id="266" r:id="rId12"/>
+    <p:sldId id="267" r:id="rId13"/>
+    <p:sldId id="268" r:id="rId14"/>
+    <p:sldId id="269" r:id="rId15"/>
+    <p:sldId id="270" r:id="rId16"/>
+    <p:sldId id="271" r:id="rId17"/>
+    <p:sldId id="272" r:id="rId18"/>
+    <p:sldId id="273" r:id="rId19"/>
+    <p:sldId id="274" r:id="rId20"/>
+    <p:sldId id="275" r:id="rId21"/>
+    <p:sldId id="276" r:id="rId22"/>
+    <p:sldId id="277" r:id="rId23"/>
+    <p:sldId id="278" r:id="rId24"/>
+    <p:sldId id="279" r:id="rId25"/>
   </p:sldIdLst>
-  <p:sldSz cx="12191695" cy="6858000" type="screen4x3"/>
+  <p:sldSz cx="12192000" cy="6858000"/>
   <p:notesSz cx="6858000" cy="9144000"/>
   <p:defaultTextStyle>
     <a:defPPr>
@@ -127,6 +127,22 @@
       </a:defRPr>
     </a:lvl9pPr>
   </p:defaultTextStyle>
+  <p:extLst>
+    <p:ext uri="{EFAFB233-063F-42B5-8137-9DF3F51BA10A}">
+      <p15:sldGuideLst xmlns:p15="http://schemas.microsoft.com/office/powerpoint/2012/main">
+        <p15:guide id="1" orient="horz" pos="2160">
+          <p15:clr>
+            <a:srgbClr val="A4A3A4"/>
+          </p15:clr>
+        </p15:guide>
+        <p15:guide id="2" pos="2880">
+          <p15:clr>
+            <a:srgbClr val="A4A3A4"/>
+          </p15:clr>
+        </p15:guide>
+      </p15:sldGuideLst>
+    </p:ext>
+  </p:extLst>
 </p:presentation>
 </file>
 
@@ -168,10 +184,9 @@
           <a:lstStyle/>
           <a:p>
             <a:r>
-              <a:rPr lang="en-US" smtClean="0"/>
+              <a:rPr lang="en-US"/>
               <a:t>Click to edit Master title style</a:t>
             </a:r>
-            <a:endParaRPr lang="en-US"/>
           </a:p>
         </p:txBody>
       </p:sp>
@@ -287,10 +302,9 @@
           </a:lstStyle>
           <a:p>
             <a:r>
-              <a:rPr lang="en-US" smtClean="0"/>
+              <a:rPr lang="en-US"/>
               <a:t>Click to edit Master subtitle style</a:t>
             </a:r>
-            <a:endParaRPr lang="en-US"/>
           </a:p>
         </p:txBody>
       </p:sp>
@@ -311,7 +325,7 @@
           <a:p>
             <a:fld id="{5BCAD085-E8A6-8845-BD4E-CB4CCA059FC4}" type="datetimeFigureOut">
               <a:rPr lang="en-US" smtClean="0"/>
-              <a:t>1/27/13</a:t>
+              <a:t>6/13/26</a:t>
             </a:fld>
             <a:endParaRPr lang="en-US"/>
           </a:p>
@@ -405,10 +419,9 @@
           <a:lstStyle/>
           <a:p>
             <a:r>
-              <a:rPr lang="en-US" smtClean="0"/>
+              <a:rPr lang="en-US"/>
               <a:t>Click to edit Master title style</a:t>
             </a:r>
-            <a:endParaRPr lang="en-US"/>
           </a:p>
         </p:txBody>
       </p:sp>
@@ -429,38 +442,37 @@
           <a:p>
             <a:pPr lvl="0"/>
             <a:r>
-              <a:rPr lang="en-US" smtClean="0"/>
+              <a:rPr lang="en-US"/>
               <a:t>Click to edit Master text styles</a:t>
             </a:r>
           </a:p>
           <a:p>
             <a:pPr lvl="1"/>
             <a:r>
-              <a:rPr lang="en-US" smtClean="0"/>
+              <a:rPr lang="en-US"/>
               <a:t>Second level</a:t>
             </a:r>
           </a:p>
           <a:p>
             <a:pPr lvl="2"/>
             <a:r>
-              <a:rPr lang="en-US" smtClean="0"/>
+              <a:rPr lang="en-US"/>
               <a:t>Third level</a:t>
             </a:r>
           </a:p>
           <a:p>
             <a:pPr lvl="3"/>
             <a:r>
-              <a:rPr lang="en-US" smtClean="0"/>
+              <a:rPr lang="en-US"/>
               <a:t>Fourth level</a:t>
             </a:r>
           </a:p>
           <a:p>
             <a:pPr lvl="4"/>
             <a:r>
-              <a:rPr lang="en-US" smtClean="0"/>
+              <a:rPr lang="en-US"/>
               <a:t>Fifth level</a:t>
             </a:r>
-            <a:endParaRPr lang="en-US"/>
           </a:p>
         </p:txBody>
       </p:sp>
@@ -481,7 +493,7 @@
           <a:p>
             <a:fld id="{5BCAD085-E8A6-8845-BD4E-CB4CCA059FC4}" type="datetimeFigureOut">
               <a:rPr lang="en-US" smtClean="0"/>
-              <a:t>1/27/13</a:t>
+              <a:t>6/13/26</a:t>
             </a:fld>
             <a:endParaRPr lang="en-US"/>
           </a:p>
@@ -580,10 +592,9 @@
           <a:lstStyle/>
           <a:p>
             <a:r>
-              <a:rPr lang="en-US" smtClean="0"/>
+              <a:rPr lang="en-US"/>
               <a:t>Click to edit Master title style</a:t>
             </a:r>
-            <a:endParaRPr lang="en-US"/>
           </a:p>
         </p:txBody>
       </p:sp>
@@ -609,38 +620,37 @@
           <a:p>
             <a:pPr lvl="0"/>
             <a:r>
-              <a:rPr lang="en-US" smtClean="0"/>
+              <a:rPr lang="en-US"/>
               <a:t>Click to edit Master text styles</a:t>
             </a:r>
           </a:p>
           <a:p>
             <a:pPr lvl="1"/>
             <a:r>
-              <a:rPr lang="en-US" smtClean="0"/>
+              <a:rPr lang="en-US"/>
               <a:t>Second level</a:t>
             </a:r>
           </a:p>
           <a:p>
             <a:pPr lvl="2"/>
             <a:r>
-              <a:rPr lang="en-US" smtClean="0"/>
+              <a:rPr lang="en-US"/>
               <a:t>Third level</a:t>
             </a:r>
           </a:p>
           <a:p>
             <a:pPr lvl="3"/>
             <a:r>
-              <a:rPr lang="en-US" smtClean="0"/>
+              <a:rPr lang="en-US"/>
               <a:t>Fourth level</a:t>
             </a:r>
           </a:p>
           <a:p>
             <a:pPr lvl="4"/>
             <a:r>
-              <a:rPr lang="en-US" smtClean="0"/>
+              <a:rPr lang="en-US"/>
               <a:t>Fifth level</a:t>
             </a:r>
-            <a:endParaRPr lang="en-US"/>
           </a:p>
         </p:txBody>
       </p:sp>
@@ -661,7 +671,7 @@
           <a:p>
             <a:fld id="{5BCAD085-E8A6-8845-BD4E-CB4CCA059FC4}" type="datetimeFigureOut">
               <a:rPr lang="en-US" smtClean="0"/>
-              <a:t>1/27/13</a:t>
+              <a:t>6/13/26</a:t>
             </a:fld>
             <a:endParaRPr lang="en-US"/>
           </a:p>
@@ -755,10 +765,9 @@
           <a:lstStyle/>
           <a:p>
             <a:r>
-              <a:rPr lang="en-US" smtClean="0"/>
+              <a:rPr lang="en-US"/>
               <a:t>Click to edit Master title style</a:t>
             </a:r>
-            <a:endParaRPr lang="en-US"/>
           </a:p>
         </p:txBody>
       </p:sp>
@@ -779,38 +788,37 @@
           <a:p>
             <a:pPr lvl="0"/>
             <a:r>
-              <a:rPr lang="en-US" smtClean="0"/>
+              <a:rPr lang="en-US"/>
               <a:t>Click to edit Master text styles</a:t>
             </a:r>
           </a:p>
           <a:p>
             <a:pPr lvl="1"/>
             <a:r>
-              <a:rPr lang="en-US" smtClean="0"/>
+              <a:rPr lang="en-US"/>
               <a:t>Second level</a:t>
             </a:r>
           </a:p>
           <a:p>
             <a:pPr lvl="2"/>
             <a:r>
-              <a:rPr lang="en-US" smtClean="0"/>
+              <a:rPr lang="en-US"/>
               <a:t>Third level</a:t>
             </a:r>
           </a:p>
           <a:p>
             <a:pPr lvl="3"/>
             <a:r>
-              <a:rPr lang="en-US" smtClean="0"/>
+              <a:rPr lang="en-US"/>
               <a:t>Fourth level</a:t>
             </a:r>
           </a:p>
           <a:p>
             <a:pPr lvl="4"/>
             <a:r>
-              <a:rPr lang="en-US" smtClean="0"/>
+              <a:rPr lang="en-US"/>
               <a:t>Fifth level</a:t>
             </a:r>
-            <a:endParaRPr lang="en-US"/>
           </a:p>
         </p:txBody>
       </p:sp>
@@ -831,7 +839,7 @@
           <a:p>
             <a:fld id="{5BCAD085-E8A6-8845-BD4E-CB4CCA059FC4}" type="datetimeFigureOut">
               <a:rPr lang="en-US" smtClean="0"/>
-              <a:t>1/27/13</a:t>
+              <a:t>6/13/26</a:t>
             </a:fld>
             <a:endParaRPr lang="en-US"/>
           </a:p>
@@ -934,10 +942,9 @@
           </a:lstStyle>
           <a:p>
             <a:r>
-              <a:rPr lang="en-US" smtClean="0"/>
+              <a:rPr lang="en-US"/>
               <a:t>Click to edit Master title style</a:t>
             </a:r>
-            <a:endParaRPr lang="en-US"/>
           </a:p>
         </p:txBody>
       </p:sp>
@@ -1054,7 +1061,7 @@
           <a:p>
             <a:pPr lvl="0"/>
             <a:r>
-              <a:rPr lang="en-US" smtClean="0"/>
+              <a:rPr lang="en-US"/>
               <a:t>Click to edit Master text styles</a:t>
             </a:r>
           </a:p>
@@ -1077,7 +1084,7 @@
           <a:p>
             <a:fld id="{5BCAD085-E8A6-8845-BD4E-CB4CCA059FC4}" type="datetimeFigureOut">
               <a:rPr lang="en-US" smtClean="0"/>
-              <a:t>1/27/13</a:t>
+              <a:t>6/13/26</a:t>
             </a:fld>
             <a:endParaRPr lang="en-US"/>
           </a:p>
@@ -1171,10 +1178,9 @@
           <a:lstStyle/>
           <a:p>
             <a:r>
-              <a:rPr lang="en-US" smtClean="0"/>
+              <a:rPr lang="en-US"/>
               <a:t>Click to edit Master title style</a:t>
             </a:r>
-            <a:endParaRPr lang="en-US"/>
           </a:p>
         </p:txBody>
       </p:sp>
@@ -1228,38 +1234,37 @@
           <a:p>
             <a:pPr lvl="0"/>
             <a:r>
-              <a:rPr lang="en-US" smtClean="0"/>
+              <a:rPr lang="en-US"/>
               <a:t>Click to edit Master text styles</a:t>
             </a:r>
           </a:p>
           <a:p>
             <a:pPr lvl="1"/>
             <a:r>
-              <a:rPr lang="en-US" smtClean="0"/>
+              <a:rPr lang="en-US"/>
               <a:t>Second level</a:t>
             </a:r>
           </a:p>
           <a:p>
             <a:pPr lvl="2"/>
             <a:r>
-              <a:rPr lang="en-US" smtClean="0"/>
+              <a:rPr lang="en-US"/>
               <a:t>Third level</a:t>
             </a:r>
           </a:p>
           <a:p>
             <a:pPr lvl="3"/>
             <a:r>
-              <a:rPr lang="en-US" smtClean="0"/>
+              <a:rPr lang="en-US"/>
               <a:t>Fourth level</a:t>
             </a:r>
           </a:p>
           <a:p>
             <a:pPr lvl="4"/>
             <a:r>
-              <a:rPr lang="en-US" smtClean="0"/>
+              <a:rPr lang="en-US"/>
               <a:t>Fifth level</a:t>
             </a:r>
-            <a:endParaRPr lang="en-US"/>
           </a:p>
         </p:txBody>
       </p:sp>
@@ -1313,38 +1318,37 @@
           <a:p>
             <a:pPr lvl="0"/>
             <a:r>
-              <a:rPr lang="en-US" smtClean="0"/>
+              <a:rPr lang="en-US"/>
               <a:t>Click to edit Master text styles</a:t>
             </a:r>
           </a:p>
           <a:p>
             <a:pPr lvl="1"/>
             <a:r>
-              <a:rPr lang="en-US" smtClean="0"/>
+              <a:rPr lang="en-US"/>
               <a:t>Second level</a:t>
             </a:r>
           </a:p>
           <a:p>
             <a:pPr lvl="2"/>
             <a:r>
-              <a:rPr lang="en-US" smtClean="0"/>
+              <a:rPr lang="en-US"/>
               <a:t>Third level</a:t>
             </a:r>
           </a:p>
           <a:p>
             <a:pPr lvl="3"/>
             <a:r>
-              <a:rPr lang="en-US" smtClean="0"/>
+              <a:rPr lang="en-US"/>
               <a:t>Fourth level</a:t>
             </a:r>
           </a:p>
           <a:p>
             <a:pPr lvl="4"/>
             <a:r>
-              <a:rPr lang="en-US" smtClean="0"/>
+              <a:rPr lang="en-US"/>
               <a:t>Fifth level</a:t>
             </a:r>
-            <a:endParaRPr lang="en-US"/>
           </a:p>
         </p:txBody>
       </p:sp>
@@ -1365,7 +1369,7 @@
           <a:p>
             <a:fld id="{5BCAD085-E8A6-8845-BD4E-CB4CCA059FC4}" type="datetimeFigureOut">
               <a:rPr lang="en-US" smtClean="0"/>
-              <a:t>1/27/13</a:t>
+              <a:t>6/13/26</a:t>
             </a:fld>
             <a:endParaRPr lang="en-US"/>
           </a:p>
@@ -1463,10 +1467,9 @@
           </a:lstStyle>
           <a:p>
             <a:r>
-              <a:rPr lang="en-US" smtClean="0"/>
+              <a:rPr lang="en-US"/>
               <a:t>Click to edit Master title style</a:t>
             </a:r>
-            <a:endParaRPr lang="en-US"/>
           </a:p>
         </p:txBody>
       </p:sp>
@@ -1529,7 +1532,7 @@
           <a:p>
             <a:pPr lvl="0"/>
             <a:r>
-              <a:rPr lang="en-US" smtClean="0"/>
+              <a:rPr lang="en-US"/>
               <a:t>Click to edit Master text styles</a:t>
             </a:r>
           </a:p>
@@ -1585,38 +1588,37 @@
           <a:p>
             <a:pPr lvl="0"/>
             <a:r>
-              <a:rPr lang="en-US" smtClean="0"/>
+              <a:rPr lang="en-US"/>
               <a:t>Click to edit Master text styles</a:t>
             </a:r>
           </a:p>
           <a:p>
             <a:pPr lvl="1"/>
             <a:r>
-              <a:rPr lang="en-US" smtClean="0"/>
+              <a:rPr lang="en-US"/>
               <a:t>Second level</a:t>
             </a:r>
           </a:p>
           <a:p>
             <a:pPr lvl="2"/>
             <a:r>
-              <a:rPr lang="en-US" smtClean="0"/>
+              <a:rPr lang="en-US"/>
               <a:t>Third level</a:t>
             </a:r>
           </a:p>
           <a:p>
             <a:pPr lvl="3"/>
             <a:r>
-              <a:rPr lang="en-US" smtClean="0"/>
+              <a:rPr lang="en-US"/>
               <a:t>Fourth level</a:t>
             </a:r>
           </a:p>
           <a:p>
             <a:pPr lvl="4"/>
             <a:r>
-              <a:rPr lang="en-US" smtClean="0"/>
+              <a:rPr lang="en-US"/>
               <a:t>Fifth level</a:t>
             </a:r>
-            <a:endParaRPr lang="en-US"/>
           </a:p>
         </p:txBody>
       </p:sp>
@@ -1679,7 +1681,7 @@
           <a:p>
             <a:pPr lvl="0"/>
             <a:r>
-              <a:rPr lang="en-US" smtClean="0"/>
+              <a:rPr lang="en-US"/>
               <a:t>Click to edit Master text styles</a:t>
             </a:r>
           </a:p>
@@ -1735,38 +1737,37 @@
           <a:p>
             <a:pPr lvl="0"/>
             <a:r>
-              <a:rPr lang="en-US" smtClean="0"/>
+              <a:rPr lang="en-US"/>
               <a:t>Click to edit Master text styles</a:t>
             </a:r>
           </a:p>
           <a:p>
             <a:pPr lvl="1"/>
             <a:r>
-              <a:rPr lang="en-US" smtClean="0"/>
+              <a:rPr lang="en-US"/>
               <a:t>Second level</a:t>
             </a:r>
           </a:p>
           <a:p>
             <a:pPr lvl="2"/>
             <a:r>
-              <a:rPr lang="en-US" smtClean="0"/>
+              <a:rPr lang="en-US"/>
               <a:t>Third level</a:t>
             </a:r>
           </a:p>
           <a:p>
             <a:pPr lvl="3"/>
             <a:r>
-              <a:rPr lang="en-US" smtClean="0"/>
+              <a:rPr lang="en-US"/>
               <a:t>Fourth level</a:t>
             </a:r>
           </a:p>
           <a:p>
             <a:pPr lvl="4"/>
             <a:r>
-              <a:rPr lang="en-US" smtClean="0"/>
+              <a:rPr lang="en-US"/>
               <a:t>Fifth level</a:t>
             </a:r>
-            <a:endParaRPr lang="en-US"/>
           </a:p>
         </p:txBody>
       </p:sp>
@@ -1787,7 +1788,7 @@
           <a:p>
             <a:fld id="{5BCAD085-E8A6-8845-BD4E-CB4CCA059FC4}" type="datetimeFigureOut">
               <a:rPr lang="en-US" smtClean="0"/>
-              <a:t>1/27/13</a:t>
+              <a:t>6/13/26</a:t>
             </a:fld>
             <a:endParaRPr lang="en-US"/>
           </a:p>
@@ -1881,10 +1882,9 @@
           <a:lstStyle/>
           <a:p>
             <a:r>
-              <a:rPr lang="en-US" smtClean="0"/>
+              <a:rPr lang="en-US"/>
               <a:t>Click to edit Master title style</a:t>
             </a:r>
-            <a:endParaRPr lang="en-US"/>
           </a:p>
         </p:txBody>
       </p:sp>
@@ -1905,7 +1905,7 @@
           <a:p>
             <a:fld id="{5BCAD085-E8A6-8845-BD4E-CB4CCA059FC4}" type="datetimeFigureOut">
               <a:rPr lang="en-US" smtClean="0"/>
-              <a:t>1/27/13</a:t>
+              <a:t>6/13/26</a:t>
             </a:fld>
             <a:endParaRPr lang="en-US"/>
           </a:p>
@@ -2000,7 +2000,7 @@
           <a:p>
             <a:fld id="{5BCAD085-E8A6-8845-BD4E-CB4CCA059FC4}" type="datetimeFigureOut">
               <a:rPr lang="en-US" smtClean="0"/>
-              <a:t>1/27/13</a:t>
+              <a:t>6/13/26</a:t>
             </a:fld>
             <a:endParaRPr lang="en-US"/>
           </a:p>
@@ -2103,10 +2103,9 @@
           </a:lstStyle>
           <a:p>
             <a:r>
-              <a:rPr lang="en-US" smtClean="0"/>
+              <a:rPr lang="en-US"/>
               <a:t>Click to edit Master title style</a:t>
             </a:r>
-            <a:endParaRPr lang="en-US"/>
           </a:p>
         </p:txBody>
       </p:sp>
@@ -2160,38 +2159,37 @@
           <a:p>
             <a:pPr lvl="0"/>
             <a:r>
-              <a:rPr lang="en-US" smtClean="0"/>
+              <a:rPr lang="en-US"/>
               <a:t>Click to edit Master text styles</a:t>
             </a:r>
           </a:p>
           <a:p>
             <a:pPr lvl="1"/>
             <a:r>
-              <a:rPr lang="en-US" smtClean="0"/>
+              <a:rPr lang="en-US"/>
               <a:t>Second level</a:t>
             </a:r>
           </a:p>
           <a:p>
             <a:pPr lvl="2"/>
             <a:r>
-              <a:rPr lang="en-US" smtClean="0"/>
+              <a:rPr lang="en-US"/>
               <a:t>Third level</a:t>
             </a:r>
           </a:p>
           <a:p>
             <a:pPr lvl="3"/>
             <a:r>
-              <a:rPr lang="en-US" smtClean="0"/>
+              <a:rPr lang="en-US"/>
               <a:t>Fourth level</a:t>
             </a:r>
           </a:p>
           <a:p>
             <a:pPr lvl="4"/>
             <a:r>
-              <a:rPr lang="en-US" smtClean="0"/>
+              <a:rPr lang="en-US"/>
               <a:t>Fifth level</a:t>
             </a:r>
-            <a:endParaRPr lang="en-US"/>
           </a:p>
         </p:txBody>
       </p:sp>
@@ -2254,7 +2252,7 @@
           <a:p>
             <a:pPr lvl="0"/>
             <a:r>
-              <a:rPr lang="en-US" smtClean="0"/>
+              <a:rPr lang="en-US"/>
               <a:t>Click to edit Master text styles</a:t>
             </a:r>
           </a:p>
@@ -2277,7 +2275,7 @@
           <a:p>
             <a:fld id="{5BCAD085-E8A6-8845-BD4E-CB4CCA059FC4}" type="datetimeFigureOut">
               <a:rPr lang="en-US" smtClean="0"/>
-              <a:t>1/27/13</a:t>
+              <a:t>6/13/26</a:t>
             </a:fld>
             <a:endParaRPr lang="en-US"/>
           </a:p>
@@ -2380,10 +2378,9 @@
           </a:lstStyle>
           <a:p>
             <a:r>
-              <a:rPr lang="en-US" smtClean="0"/>
+              <a:rPr lang="en-US"/>
               <a:t>Click to edit Master title style</a:t>
             </a:r>
-            <a:endParaRPr lang="en-US"/>
           </a:p>
         </p:txBody>
       </p:sp>
@@ -2507,7 +2504,7 @@
           <a:p>
             <a:pPr lvl="0"/>
             <a:r>
-              <a:rPr lang="en-US" smtClean="0"/>
+              <a:rPr lang="en-US"/>
               <a:t>Click to edit Master text styles</a:t>
             </a:r>
           </a:p>
@@ -2530,7 +2527,7 @@
           <a:p>
             <a:fld id="{5BCAD085-E8A6-8845-BD4E-CB4CCA059FC4}" type="datetimeFigureOut">
               <a:rPr lang="en-US" smtClean="0"/>
-              <a:t>1/27/13</a:t>
+              <a:t>6/13/26</a:t>
             </a:fld>
             <a:endParaRPr lang="en-US"/>
           </a:p>
@@ -2639,10 +2636,9 @@
           <a:lstStyle/>
           <a:p>
             <a:r>
-              <a:rPr lang="en-US" smtClean="0"/>
+              <a:rPr lang="en-US"/>
               <a:t>Click to edit Master title style</a:t>
             </a:r>
-            <a:endParaRPr lang="en-US"/>
           </a:p>
         </p:txBody>
       </p:sp>
@@ -2673,38 +2669,37 @@
           <a:p>
             <a:pPr lvl="0"/>
             <a:r>
-              <a:rPr lang="en-US" smtClean="0"/>
+              <a:rPr lang="en-US"/>
               <a:t>Click to edit Master text styles</a:t>
             </a:r>
           </a:p>
           <a:p>
             <a:pPr lvl="1"/>
             <a:r>
-              <a:rPr lang="en-US" smtClean="0"/>
+              <a:rPr lang="en-US"/>
               <a:t>Second level</a:t>
             </a:r>
           </a:p>
           <a:p>
             <a:pPr lvl="2"/>
             <a:r>
-              <a:rPr lang="en-US" smtClean="0"/>
+              <a:rPr lang="en-US"/>
               <a:t>Third level</a:t>
             </a:r>
           </a:p>
           <a:p>
             <a:pPr lvl="3"/>
             <a:r>
-              <a:rPr lang="en-US" smtClean="0"/>
+              <a:rPr lang="en-US"/>
               <a:t>Fourth level</a:t>
             </a:r>
           </a:p>
           <a:p>
             <a:pPr lvl="4"/>
             <a:r>
-              <a:rPr lang="en-US" smtClean="0"/>
+              <a:rPr lang="en-US"/>
               <a:t>Fifth level</a:t>
             </a:r>
-            <a:endParaRPr lang="en-US"/>
           </a:p>
         </p:txBody>
       </p:sp>
@@ -2743,7 +2738,7 @@
           <a:p>
             <a:fld id="{5BCAD085-E8A6-8845-BD4E-CB4CCA059FC4}" type="datetimeFigureOut">
               <a:rPr lang="en-US" smtClean="0"/>
-              <a:t>1/27/13</a:t>
+              <a:t>6/13/26</a:t>
             </a:fld>
             <a:endParaRPr lang="en-US"/>
           </a:p>
@@ -3102,7 +3097,7 @@
 </file>
 
 <file path=ppt/slides/slide1.xml><?xml version="1.0" encoding="utf-8"?>
-<p:sld xmlns:a="http://schemas.openxmlformats.org/drawingml/2006/main" xmlns:p="http://schemas.openxmlformats.org/presentationml/2006/main" xmlns:r="http://schemas.openxmlformats.org/officeDocument/2006/relationships">
+<p:sld xmlns:a="http://schemas.openxmlformats.org/drawingml/2006/main" xmlns:r="http://schemas.openxmlformats.org/officeDocument/2006/relationships" xmlns:p="http://schemas.openxmlformats.org/presentationml/2006/main">
   <p:cSld>
     <p:spTree>
       <p:nvGrpSpPr>
@@ -3110,7 +3105,14 @@
         <p:cNvGrpSpPr/>
         <p:nvPr/>
       </p:nvGrpSpPr>
-      <p:grpSpPr/>
+      <p:grpSpPr>
+        <a:xfrm>
+          <a:off x="0" y="0"/>
+          <a:ext cx="0" cy="0"/>
+          <a:chOff x="0" y="0"/>
+          <a:chExt cx="0" cy="0"/>
+        </a:xfrm>
+      </p:grpSpPr>
       <p:sp>
         <p:nvSpPr>
           <p:cNvPr id="2" name="TextBox 1"/>
@@ -3221,7 +3223,7 @@
 </file>
 
 <file path=ppt/slides/slide10.xml><?xml version="1.0" encoding="utf-8"?>
-<p:sld xmlns:a="http://schemas.openxmlformats.org/drawingml/2006/main" xmlns:p="http://schemas.openxmlformats.org/presentationml/2006/main" xmlns:r="http://schemas.openxmlformats.org/officeDocument/2006/relationships">
+<p:sld xmlns:a="http://schemas.openxmlformats.org/drawingml/2006/main" xmlns:r="http://schemas.openxmlformats.org/officeDocument/2006/relationships" xmlns:p="http://schemas.openxmlformats.org/presentationml/2006/main">
   <p:cSld>
     <p:spTree>
       <p:nvGrpSpPr>
@@ -3229,7 +3231,14 @@
         <p:cNvGrpSpPr/>
         <p:nvPr/>
       </p:nvGrpSpPr>
-      <p:grpSpPr/>
+      <p:grpSpPr>
+        <a:xfrm>
+          <a:off x="0" y="0"/>
+          <a:ext cx="0" cy="0"/>
+          <a:chOff x="0" y="0"/>
+          <a:chExt cx="0" cy="0"/>
+        </a:xfrm>
+      </p:grpSpPr>
       <p:sp>
         <p:nvSpPr>
           <p:cNvPr id="2" name="TextBox 1"/>
@@ -3386,14 +3395,12 @@
                 <a:spcPts val="800"/>
               </a:spcAft>
             </a:pPr>
-            <a:r>
-              <a:rPr sz="2200">
-                <a:solidFill>
-                  <a:srgbClr val="212121"/>
-                </a:solidFill>
-              </a:rPr>
-              <a:t/>
-            </a:r>
+            <a:endParaRPr sz="1800">
+              <a:solidFill>
+                <a:srgbClr val="212121"/>
+              </a:solidFill>
+              <a:latin typeface="Courier New"/>
+            </a:endParaRPr>
           </a:p>
           <a:p>
             <a:pPr>
@@ -3467,7 +3474,7 @@
 </file>
 
 <file path=ppt/slides/slide11.xml><?xml version="1.0" encoding="utf-8"?>
-<p:sld xmlns:a="http://schemas.openxmlformats.org/drawingml/2006/main" xmlns:p="http://schemas.openxmlformats.org/presentationml/2006/main" xmlns:r="http://schemas.openxmlformats.org/officeDocument/2006/relationships">
+<p:sld xmlns:a="http://schemas.openxmlformats.org/drawingml/2006/main" xmlns:r="http://schemas.openxmlformats.org/officeDocument/2006/relationships" xmlns:p="http://schemas.openxmlformats.org/presentationml/2006/main">
   <p:cSld>
     <p:spTree>
       <p:nvGrpSpPr>
@@ -3475,7 +3482,14 @@
         <p:cNvGrpSpPr/>
         <p:nvPr/>
       </p:nvGrpSpPr>
-      <p:grpSpPr/>
+      <p:grpSpPr>
+        <a:xfrm>
+          <a:off x="0" y="0"/>
+          <a:ext cx="0" cy="0"/>
+          <a:chOff x="0" y="0"/>
+          <a:chExt cx="0" cy="0"/>
+        </a:xfrm>
+      </p:grpSpPr>
       <p:sp>
         <p:nvSpPr>
           <p:cNvPr id="2" name="TextBox 1"/>
@@ -3551,14 +3565,11 @@
                 <a:spcPts val="800"/>
               </a:spcAft>
             </a:pPr>
-            <a:r>
-              <a:rPr sz="2000">
-                <a:solidFill>
-                  <a:srgbClr val="212121"/>
-                </a:solidFill>
-              </a:rPr>
-              <a:t/>
-            </a:r>
+            <a:endParaRPr sz="2000">
+              <a:solidFill>
+                <a:srgbClr val="212121"/>
+              </a:solidFill>
+            </a:endParaRPr>
           </a:p>
           <a:p>
             <a:pPr>
@@ -3598,14 +3609,12 @@
                 <a:spcPts val="800"/>
               </a:spcAft>
             </a:pPr>
-            <a:r>
-              <a:rPr sz="2000">
-                <a:solidFill>
-                  <a:srgbClr val="212121"/>
-                </a:solidFill>
-              </a:rPr>
-              <a:t/>
-            </a:r>
+            <a:endParaRPr sz="1600">
+              <a:solidFill>
+                <a:srgbClr val="212121"/>
+              </a:solidFill>
+              <a:latin typeface="Courier New"/>
+            </a:endParaRPr>
           </a:p>
           <a:p>
             <a:pPr lvl="1">
@@ -3658,14 +3667,11 @@
                 <a:spcPts val="800"/>
               </a:spcAft>
             </a:pPr>
-            <a:r>
-              <a:rPr sz="2000">
-                <a:solidFill>
-                  <a:srgbClr val="212121"/>
-                </a:solidFill>
-              </a:rPr>
-              <a:t/>
-            </a:r>
+            <a:endParaRPr sz="1800">
+              <a:solidFill>
+                <a:srgbClr val="212121"/>
+              </a:solidFill>
+            </a:endParaRPr>
           </a:p>
           <a:p>
             <a:pPr>
@@ -3693,7 +3699,7 @@
 </file>
 
 <file path=ppt/slides/slide12.xml><?xml version="1.0" encoding="utf-8"?>
-<p:sld xmlns:a="http://schemas.openxmlformats.org/drawingml/2006/main" xmlns:p="http://schemas.openxmlformats.org/presentationml/2006/main" xmlns:r="http://schemas.openxmlformats.org/officeDocument/2006/relationships">
+<p:sld xmlns:a="http://schemas.openxmlformats.org/drawingml/2006/main" xmlns:r="http://schemas.openxmlformats.org/officeDocument/2006/relationships" xmlns:p="http://schemas.openxmlformats.org/presentationml/2006/main">
   <p:cSld>
     <p:spTree>
       <p:nvGrpSpPr>
@@ -3701,7 +3707,14 @@
         <p:cNvGrpSpPr/>
         <p:nvPr/>
       </p:nvGrpSpPr>
-      <p:grpSpPr/>
+      <p:grpSpPr>
+        <a:xfrm>
+          <a:off x="0" y="0"/>
+          <a:ext cx="0" cy="0"/>
+          <a:chOff x="0" y="0"/>
+          <a:chExt cx="0" cy="0"/>
+        </a:xfrm>
+      </p:grpSpPr>
       <p:sp>
         <p:nvSpPr>
           <p:cNvPr id="2" name="TextBox 1"/>
@@ -3822,27 +3835,24 @@
                 <a:spcPts val="800"/>
               </a:spcAft>
             </a:pPr>
+            <a:endParaRPr sz="2200">
+              <a:solidFill>
+                <a:srgbClr val="212121"/>
+              </a:solidFill>
+            </a:endParaRPr>
+          </a:p>
+          <a:p>
+            <a:pPr>
+              <a:spcAft>
+                <a:spcPts val="800"/>
+              </a:spcAft>
+            </a:pPr>
             <a:r>
               <a:rPr sz="2400">
                 <a:solidFill>
                   <a:srgbClr val="212121"/>
                 </a:solidFill>
               </a:rPr>
-              <a:t/>
-            </a:r>
-          </a:p>
-          <a:p>
-            <a:pPr>
-              <a:spcAft>
-                <a:spcPts val="800"/>
-              </a:spcAft>
-            </a:pPr>
-            <a:r>
-              <a:rPr sz="2400">
-                <a:solidFill>
-                  <a:srgbClr val="212121"/>
-                </a:solidFill>
-              </a:rPr>
               <a:t>Same verdict — two different questions answered (equivalence vs. a program is safe). If you can articulate the difference, you understand verification.</a:t>
             </a:r>
           </a:p>
@@ -3852,14 +3862,11 @@
                 <a:spcPts val="800"/>
               </a:spcAft>
             </a:pPr>
-            <a:r>
-              <a:rPr sz="2400">
-                <a:solidFill>
-                  <a:srgbClr val="212121"/>
-                </a:solidFill>
-              </a:rPr>
-              <a:t/>
-            </a:r>
+            <a:endParaRPr sz="2400">
+              <a:solidFill>
+                <a:srgbClr val="212121"/>
+              </a:solidFill>
+            </a:endParaRPr>
           </a:p>
           <a:p>
             <a:pPr lvl="1">
@@ -3887,7 +3894,7 @@
 </file>
 
 <file path=ppt/slides/slide13.xml><?xml version="1.0" encoding="utf-8"?>
-<p:sld xmlns:a="http://schemas.openxmlformats.org/drawingml/2006/main" xmlns:p="http://schemas.openxmlformats.org/presentationml/2006/main" xmlns:r="http://schemas.openxmlformats.org/officeDocument/2006/relationships">
+<p:sld xmlns:a="http://schemas.openxmlformats.org/drawingml/2006/main" xmlns:r="http://schemas.openxmlformats.org/officeDocument/2006/relationships" xmlns:p="http://schemas.openxmlformats.org/presentationml/2006/main">
   <p:cSld>
     <p:spTree>
       <p:nvGrpSpPr>
@@ -3895,7 +3902,14 @@
         <p:cNvGrpSpPr/>
         <p:nvPr/>
       </p:nvGrpSpPr>
-      <p:grpSpPr/>
+      <p:grpSpPr>
+        <a:xfrm>
+          <a:off x="0" y="0"/>
+          <a:ext cx="0" cy="0"/>
+          <a:chOff x="0" y="0"/>
+          <a:chExt cx="0" cy="0"/>
+        </a:xfrm>
+      </p:grpSpPr>
       <p:sp>
         <p:nvSpPr>
           <p:cNvPr id="2" name="TextBox 1"/>
@@ -3986,9 +4000,27 @@
                 <a:tableStyleId>{5C22544A-7EE6-4342-B048-85BDC9FD1C3A}</a:tableStyleId>
               </a:tblPr>
               <a:tblGrid>
-                <a:gridCol w="731520"/>
-                <a:gridCol w="4754880"/>
-                <a:gridCol w="2011680"/>
+                <a:gridCol w="731520">
+                  <a:extLst>
+                    <a:ext uri="{9D8B030D-6E8A-4147-A177-3AD203B41FA5}">
+                      <a16:colId xmlns:a16="http://schemas.microsoft.com/office/drawing/2014/main" val="20000"/>
+                    </a:ext>
+                  </a:extLst>
+                </a:gridCol>
+                <a:gridCol w="4754880">
+                  <a:extLst>
+                    <a:ext uri="{9D8B030D-6E8A-4147-A177-3AD203B41FA5}">
+                      <a16:colId xmlns:a16="http://schemas.microsoft.com/office/drawing/2014/main" val="20001"/>
+                    </a:ext>
+                  </a:extLst>
+                </a:gridCol>
+                <a:gridCol w="2011680">
+                  <a:extLst>
+                    <a:ext uri="{9D8B030D-6E8A-4147-A177-3AD203B41FA5}">
+                      <a16:colId xmlns:a16="http://schemas.microsoft.com/office/drawing/2014/main" val="20002"/>
+                    </a:ext>
+                  </a:extLst>
+                </a:gridCol>
               </a:tblGrid>
               <a:tr h="365760">
                 <a:tc>
@@ -4030,6 +4062,11 @@
                   </a:txBody>
                   <a:tcPr/>
                 </a:tc>
+                <a:extLst>
+                  <a:ext uri="{0D108BD9-81ED-4DB2-BD59-A6C34878D82A}">
+                    <a16:rowId xmlns:a16="http://schemas.microsoft.com/office/drawing/2014/main" val="10000"/>
+                  </a:ext>
+                </a:extLst>
               </a:tr>
               <a:tr h="365760">
                 <a:tc>
@@ -4071,6 +4108,11 @@
                   </a:txBody>
                   <a:tcPr/>
                 </a:tc>
+                <a:extLst>
+                  <a:ext uri="{0D108BD9-81ED-4DB2-BD59-A6C34878D82A}">
+                    <a16:rowId xmlns:a16="http://schemas.microsoft.com/office/drawing/2014/main" val="10001"/>
+                  </a:ext>
+                </a:extLst>
               </a:tr>
               <a:tr h="365760">
                 <a:tc>
@@ -4112,6 +4154,11 @@
                   </a:txBody>
                   <a:tcPr/>
                 </a:tc>
+                <a:extLst>
+                  <a:ext uri="{0D108BD9-81ED-4DB2-BD59-A6C34878D82A}">
+                    <a16:rowId xmlns:a16="http://schemas.microsoft.com/office/drawing/2014/main" val="10002"/>
+                  </a:ext>
+                </a:extLst>
               </a:tr>
               <a:tr h="365760">
                 <a:tc>
@@ -4153,6 +4200,11 @@
                   </a:txBody>
                   <a:tcPr/>
                 </a:tc>
+                <a:extLst>
+                  <a:ext uri="{0D108BD9-81ED-4DB2-BD59-A6C34878D82A}">
+                    <a16:rowId xmlns:a16="http://schemas.microsoft.com/office/drawing/2014/main" val="10003"/>
+                  </a:ext>
+                </a:extLst>
               </a:tr>
               <a:tr h="365760">
                 <a:tc>
@@ -4194,6 +4246,11 @@
                   </a:txBody>
                   <a:tcPr/>
                 </a:tc>
+                <a:extLst>
+                  <a:ext uri="{0D108BD9-81ED-4DB2-BD59-A6C34878D82A}">
+                    <a16:rowId xmlns:a16="http://schemas.microsoft.com/office/drawing/2014/main" val="10004"/>
+                  </a:ext>
+                </a:extLst>
               </a:tr>
             </a:tbl>
           </a:graphicData>
@@ -4277,7 +4334,7 @@
 </file>
 
 <file path=ppt/slides/slide14.xml><?xml version="1.0" encoding="utf-8"?>
-<p:sld xmlns:a="http://schemas.openxmlformats.org/drawingml/2006/main" xmlns:p="http://schemas.openxmlformats.org/presentationml/2006/main" xmlns:r="http://schemas.openxmlformats.org/officeDocument/2006/relationships">
+<p:sld xmlns:a="http://schemas.openxmlformats.org/drawingml/2006/main" xmlns:r="http://schemas.openxmlformats.org/officeDocument/2006/relationships" xmlns:p="http://schemas.openxmlformats.org/presentationml/2006/main">
   <p:cSld>
     <p:spTree>
       <p:nvGrpSpPr>
@@ -4285,7 +4342,14 @@
         <p:cNvGrpSpPr/>
         <p:nvPr/>
       </p:nvGrpSpPr>
-      <p:grpSpPr/>
+      <p:grpSpPr>
+        <a:xfrm>
+          <a:off x="0" y="0"/>
+          <a:ext cx="0" cy="0"/>
+          <a:chOff x="0" y="0"/>
+          <a:chExt cx="0" cy="0"/>
+        </a:xfrm>
+      </p:grpSpPr>
       <p:sp>
         <p:nvSpPr>
           <p:cNvPr id="2" name="TextBox 1"/>
@@ -4473,14 +4537,12 @@
                 <a:spcPts val="800"/>
               </a:spcAft>
             </a:pPr>
-            <a:r>
-              <a:rPr sz="2200">
-                <a:solidFill>
-                  <a:srgbClr val="212121"/>
-                </a:solidFill>
-              </a:rPr>
-              <a:t/>
-            </a:r>
+            <a:endParaRPr sz="1800">
+              <a:solidFill>
+                <a:srgbClr val="212121"/>
+              </a:solidFill>
+              <a:latin typeface="Courier New"/>
+            </a:endParaRPr>
           </a:p>
           <a:p>
             <a:pPr>
@@ -4508,7 +4570,7 @@
 </file>
 
 <file path=ppt/slides/slide15.xml><?xml version="1.0" encoding="utf-8"?>
-<p:sld xmlns:a="http://schemas.openxmlformats.org/drawingml/2006/main" xmlns:p="http://schemas.openxmlformats.org/presentationml/2006/main" xmlns:r="http://schemas.openxmlformats.org/officeDocument/2006/relationships">
+<p:sld xmlns:a="http://schemas.openxmlformats.org/drawingml/2006/main" xmlns:r="http://schemas.openxmlformats.org/officeDocument/2006/relationships" xmlns:p="http://schemas.openxmlformats.org/presentationml/2006/main">
   <p:cSld>
     <p:spTree>
       <p:nvGrpSpPr>
@@ -4516,7 +4578,14 @@
         <p:cNvGrpSpPr/>
         <p:nvPr/>
       </p:nvGrpSpPr>
-      <p:grpSpPr/>
+      <p:grpSpPr>
+        <a:xfrm>
+          <a:off x="0" y="0"/>
+          <a:ext cx="0" cy="0"/>
+          <a:chOff x="0" y="0"/>
+          <a:chExt cx="0" cy="0"/>
+        </a:xfrm>
+      </p:grpSpPr>
       <p:sp>
         <p:nvSpPr>
           <p:cNvPr id="2" name="TextBox 1"/>
@@ -4673,14 +4742,12 @@
                 <a:spcPts val="800"/>
               </a:spcAft>
             </a:pPr>
-            <a:r>
-              <a:rPr sz="2200">
-                <a:solidFill>
-                  <a:srgbClr val="212121"/>
-                </a:solidFill>
-              </a:rPr>
-              <a:t/>
-            </a:r>
+            <a:endParaRPr sz="1800">
+              <a:solidFill>
+                <a:srgbClr val="212121"/>
+              </a:solidFill>
+              <a:latin typeface="Courier New"/>
+            </a:endParaRPr>
           </a:p>
           <a:p>
             <a:pPr lvl="1">
@@ -4738,7 +4805,7 @@
 </file>
 
 <file path=ppt/slides/slide16.xml><?xml version="1.0" encoding="utf-8"?>
-<p:sld xmlns:a="http://schemas.openxmlformats.org/drawingml/2006/main" xmlns:p="http://schemas.openxmlformats.org/presentationml/2006/main" xmlns:r="http://schemas.openxmlformats.org/officeDocument/2006/relationships">
+<p:sld xmlns:a="http://schemas.openxmlformats.org/drawingml/2006/main" xmlns:r="http://schemas.openxmlformats.org/officeDocument/2006/relationships" xmlns:p="http://schemas.openxmlformats.org/presentationml/2006/main">
   <p:cSld>
     <p:spTree>
       <p:nvGrpSpPr>
@@ -4746,7 +4813,14 @@
         <p:cNvGrpSpPr/>
         <p:nvPr/>
       </p:nvGrpSpPr>
-      <p:grpSpPr/>
+      <p:grpSpPr>
+        <a:xfrm>
+          <a:off x="0" y="0"/>
+          <a:ext cx="0" cy="0"/>
+          <a:chOff x="0" y="0"/>
+          <a:chExt cx="0" cy="0"/>
+        </a:xfrm>
+      </p:grpSpPr>
       <p:sp>
         <p:nvSpPr>
           <p:cNvPr id="2" name="TextBox 1"/>
@@ -4915,14 +4989,11 @@
                 <a:spcPts val="800"/>
               </a:spcAft>
             </a:pPr>
-            <a:r>
-              <a:rPr sz="2200">
-                <a:solidFill>
-                  <a:srgbClr val="212121"/>
-                </a:solidFill>
-              </a:rPr>
-              <a:t/>
-            </a:r>
+            <a:endParaRPr sz="1800">
+              <a:solidFill>
+                <a:srgbClr val="212121"/>
+              </a:solidFill>
+            </a:endParaRPr>
           </a:p>
           <a:p>
             <a:pPr>
@@ -4965,7 +5036,7 @@
 </file>
 
 <file path=ppt/slides/slide17.xml><?xml version="1.0" encoding="utf-8"?>
-<p:sld xmlns:a="http://schemas.openxmlformats.org/drawingml/2006/main" xmlns:p="http://schemas.openxmlformats.org/presentationml/2006/main" xmlns:r="http://schemas.openxmlformats.org/officeDocument/2006/relationships">
+<p:sld xmlns:a="http://schemas.openxmlformats.org/drawingml/2006/main" xmlns:r="http://schemas.openxmlformats.org/officeDocument/2006/relationships" xmlns:p="http://schemas.openxmlformats.org/presentationml/2006/main">
   <p:cSld>
     <p:spTree>
       <p:nvGrpSpPr>
@@ -4973,7 +5044,14 @@
         <p:cNvGrpSpPr/>
         <p:nvPr/>
       </p:nvGrpSpPr>
-      <p:grpSpPr/>
+      <p:grpSpPr>
+        <a:xfrm>
+          <a:off x="0" y="0"/>
+          <a:ext cx="0" cy="0"/>
+          <a:chOff x="0" y="0"/>
+          <a:chExt cx="0" cy="0"/>
+        </a:xfrm>
+      </p:grpSpPr>
       <p:sp>
         <p:nvSpPr>
           <p:cNvPr id="2" name="TextBox 1"/>
@@ -5016,7 +5094,7 @@
 </file>
 
 <file path=ppt/slides/slide18.xml><?xml version="1.0" encoding="utf-8"?>
-<p:sld xmlns:a="http://schemas.openxmlformats.org/drawingml/2006/main" xmlns:p="http://schemas.openxmlformats.org/presentationml/2006/main" xmlns:r="http://schemas.openxmlformats.org/officeDocument/2006/relationships">
+<p:sld xmlns:a="http://schemas.openxmlformats.org/drawingml/2006/main" xmlns:r="http://schemas.openxmlformats.org/officeDocument/2006/relationships" xmlns:p="http://schemas.openxmlformats.org/presentationml/2006/main">
   <p:cSld>
     <p:spTree>
       <p:nvGrpSpPr>
@@ -5024,7 +5102,14 @@
         <p:cNvGrpSpPr/>
         <p:nvPr/>
       </p:nvGrpSpPr>
-      <p:grpSpPr/>
+      <p:grpSpPr>
+        <a:xfrm>
+          <a:off x="0" y="0"/>
+          <a:ext cx="0" cy="0"/>
+          <a:chOff x="0" y="0"/>
+          <a:chExt cx="0" cy="0"/>
+        </a:xfrm>
+      </p:grpSpPr>
       <p:sp>
         <p:nvSpPr>
           <p:cNvPr id="2" name="TextBox 1"/>
@@ -5130,14 +5215,11 @@
                 <a:spcPts val="800"/>
               </a:spcAft>
             </a:pPr>
-            <a:r>
-              <a:rPr sz="2800">
-                <a:solidFill>
-                  <a:srgbClr val="212121"/>
-                </a:solidFill>
-              </a:rPr>
-              <a:t/>
-            </a:r>
+            <a:endParaRPr sz="2800">
+              <a:solidFill>
+                <a:srgbClr val="212121"/>
+              </a:solidFill>
+            </a:endParaRPr>
           </a:p>
           <a:p>
             <a:pPr>
@@ -5165,7 +5247,7 @@
 </file>
 
 <file path=ppt/slides/slide19.xml><?xml version="1.0" encoding="utf-8"?>
-<p:sld xmlns:a="http://schemas.openxmlformats.org/drawingml/2006/main" xmlns:p="http://schemas.openxmlformats.org/presentationml/2006/main" xmlns:r="http://schemas.openxmlformats.org/officeDocument/2006/relationships">
+<p:sld xmlns:a="http://schemas.openxmlformats.org/drawingml/2006/main" xmlns:r="http://schemas.openxmlformats.org/officeDocument/2006/relationships" xmlns:p="http://schemas.openxmlformats.org/presentationml/2006/main">
   <p:cSld>
     <p:spTree>
       <p:nvGrpSpPr>
@@ -5173,7 +5255,14 @@
         <p:cNvGrpSpPr/>
         <p:nvPr/>
       </p:nvGrpSpPr>
-      <p:grpSpPr/>
+      <p:grpSpPr>
+        <a:xfrm>
+          <a:off x="0" y="0"/>
+          <a:ext cx="0" cy="0"/>
+          <a:chOff x="0" y="0"/>
+          <a:chExt cx="0" cy="0"/>
+        </a:xfrm>
+      </p:grpSpPr>
       <p:sp>
         <p:nvSpPr>
           <p:cNvPr id="2" name="TextBox 1"/>
@@ -5266,6 +5355,19 @@
                 <a:spcPts val="0"/>
               </a:spcAft>
             </a:pPr>
+            <a:endParaRPr sz="1800">
+              <a:solidFill>
+                <a:srgbClr val="212121"/>
+              </a:solidFill>
+              <a:latin typeface="Courier New"/>
+            </a:endParaRPr>
+          </a:p>
+          <a:p>
+            <a:pPr>
+              <a:spcAft>
+                <a:spcPts val="0"/>
+              </a:spcAft>
+            </a:pPr>
             <a:r>
               <a:rPr sz="1800">
                 <a:solidFill>
@@ -5273,7 +5375,7 @@
                 </a:solidFill>
                 <a:latin typeface="Courier New"/>
               </a:rPr>
-              <a:t/>
+              <a:t>int x = nondet_int();              /* every value at once */</a:t>
             </a:r>
           </a:p>
           <a:p>
@@ -5289,7 +5391,7 @@
                 </a:solidFill>
                 <a:latin typeface="Courier New"/>
               </a:rPr>
-              <a:t>int x = nondet_int();              /* every value at once */</a:t>
+              <a:t>__ESBMC_assume(x &gt; 0 &amp;&amp; x &lt; 100);  /* now: every value in 1..99 */</a:t>
             </a:r>
           </a:p>
           <a:p>
@@ -5305,22 +5407,6 @@
                 </a:solidFill>
                 <a:latin typeface="Courier New"/>
               </a:rPr>
-              <a:t>__ESBMC_assume(x &gt; 0 &amp;&amp; x &lt; 100);  /* now: every value in 1..99 */</a:t>
-            </a:r>
-          </a:p>
-          <a:p>
-            <a:pPr>
-              <a:spcAft>
-                <a:spcPts val="0"/>
-              </a:spcAft>
-            </a:pPr>
-            <a:r>
-              <a:rPr sz="1800">
-                <a:solidFill>
-                  <a:srgbClr val="212121"/>
-                </a:solidFill>
-                <a:latin typeface="Courier New"/>
-              </a:rPr>
               <a:t>assert(property(x));               /* must hold for ALL of them */</a:t>
             </a:r>
           </a:p>
@@ -5330,14 +5416,12 @@
                 <a:spcPts val="800"/>
               </a:spcAft>
             </a:pPr>
-            <a:r>
-              <a:rPr sz="2200">
-                <a:solidFill>
-                  <a:srgbClr val="212121"/>
-                </a:solidFill>
-              </a:rPr>
-              <a:t/>
-            </a:r>
+            <a:endParaRPr sz="1800">
+              <a:solidFill>
+                <a:srgbClr val="212121"/>
+              </a:solidFill>
+              <a:latin typeface="Courier New"/>
+            </a:endParaRPr>
           </a:p>
           <a:p>
             <a:pPr>
@@ -5365,7 +5449,7 @@
 </file>
 
 <file path=ppt/slides/slide2.xml><?xml version="1.0" encoding="utf-8"?>
-<p:sld xmlns:a="http://schemas.openxmlformats.org/drawingml/2006/main" xmlns:p="http://schemas.openxmlformats.org/presentationml/2006/main" xmlns:r="http://schemas.openxmlformats.org/officeDocument/2006/relationships">
+<p:sld xmlns:a="http://schemas.openxmlformats.org/drawingml/2006/main" xmlns:r="http://schemas.openxmlformats.org/officeDocument/2006/relationships" xmlns:p="http://schemas.openxmlformats.org/presentationml/2006/main">
   <p:cSld>
     <p:spTree>
       <p:nvGrpSpPr>
@@ -5373,7 +5457,14 @@
         <p:cNvGrpSpPr/>
         <p:nvPr/>
       </p:nvGrpSpPr>
-      <p:grpSpPr/>
+      <p:grpSpPr>
+        <a:xfrm>
+          <a:off x="0" y="0"/>
+          <a:ext cx="0" cy="0"/>
+          <a:chOff x="0" y="0"/>
+          <a:chExt cx="0" cy="0"/>
+        </a:xfrm>
+      </p:grpSpPr>
       <p:sp>
         <p:nvSpPr>
           <p:cNvPr id="2" name="TextBox 1"/>
@@ -5479,14 +5570,11 @@
                 <a:spcPts val="800"/>
               </a:spcAft>
             </a:pPr>
-            <a:r>
-              <a:rPr sz="2400">
-                <a:solidFill>
-                  <a:srgbClr val="212121"/>
-                </a:solidFill>
-              </a:rPr>
-              <a:t/>
-            </a:r>
+            <a:endParaRPr sz="2400">
+              <a:solidFill>
+                <a:srgbClr val="212121"/>
+              </a:solidFill>
+            </a:endParaRPr>
           </a:p>
           <a:p>
             <a:pPr>
@@ -5545,7 +5633,7 @@
 </file>
 
 <file path=ppt/slides/slide20.xml><?xml version="1.0" encoding="utf-8"?>
-<p:sld xmlns:a="http://schemas.openxmlformats.org/drawingml/2006/main" xmlns:p="http://schemas.openxmlformats.org/presentationml/2006/main" xmlns:r="http://schemas.openxmlformats.org/officeDocument/2006/relationships">
+<p:sld xmlns:a="http://schemas.openxmlformats.org/drawingml/2006/main" xmlns:r="http://schemas.openxmlformats.org/officeDocument/2006/relationships" xmlns:p="http://schemas.openxmlformats.org/presentationml/2006/main">
   <p:cSld>
     <p:spTree>
       <p:nvGrpSpPr>
@@ -5553,7 +5641,14 @@
         <p:cNvGrpSpPr/>
         <p:nvPr/>
       </p:nvGrpSpPr>
-      <p:grpSpPr/>
+      <p:grpSpPr>
+        <a:xfrm>
+          <a:off x="0" y="0"/>
+          <a:ext cx="0" cy="0"/>
+          <a:chOff x="0" y="0"/>
+          <a:chExt cx="0" cy="0"/>
+        </a:xfrm>
+      </p:grpSpPr>
       <p:sp>
         <p:nvSpPr>
           <p:cNvPr id="2" name="TextBox 1"/>
@@ -5678,14 +5773,12 @@
                 <a:spcPts val="800"/>
               </a:spcAft>
             </a:pPr>
-            <a:r>
-              <a:rPr sz="1800">
-                <a:solidFill>
-                  <a:srgbClr val="212121"/>
-                </a:solidFill>
-              </a:rPr>
-              <a:t/>
-            </a:r>
+            <a:endParaRPr sz="1400">
+              <a:solidFill>
+                <a:srgbClr val="212121"/>
+              </a:solidFill>
+              <a:latin typeface="Courier New"/>
+            </a:endParaRPr>
           </a:p>
           <a:p>
             <a:pPr lvl="1">
@@ -5753,14 +5846,11 @@
                 <a:spcPts val="800"/>
               </a:spcAft>
             </a:pPr>
-            <a:r>
-              <a:rPr sz="1800">
-                <a:solidFill>
-                  <a:srgbClr val="212121"/>
-                </a:solidFill>
-              </a:rPr>
-              <a:t/>
-            </a:r>
+            <a:endParaRPr sz="1600">
+              <a:solidFill>
+                <a:srgbClr val="212121"/>
+              </a:solidFill>
+            </a:endParaRPr>
           </a:p>
           <a:p>
             <a:pPr>
@@ -5788,7 +5878,7 @@
 </file>
 
 <file path=ppt/slides/slide21.xml><?xml version="1.0" encoding="utf-8"?>
-<p:sld xmlns:a="http://schemas.openxmlformats.org/drawingml/2006/main" xmlns:p="http://schemas.openxmlformats.org/presentationml/2006/main" xmlns:r="http://schemas.openxmlformats.org/officeDocument/2006/relationships">
+<p:sld xmlns:a="http://schemas.openxmlformats.org/drawingml/2006/main" xmlns:r="http://schemas.openxmlformats.org/officeDocument/2006/relationships" xmlns:p="http://schemas.openxmlformats.org/presentationml/2006/main">
   <p:cSld>
     <p:spTree>
       <p:nvGrpSpPr>
@@ -5796,7 +5886,14 @@
         <p:cNvGrpSpPr/>
         <p:nvPr/>
       </p:nvGrpSpPr>
-      <p:grpSpPr/>
+      <p:grpSpPr>
+        <a:xfrm>
+          <a:off x="0" y="0"/>
+          <a:ext cx="0" cy="0"/>
+          <a:chOff x="0" y="0"/>
+          <a:chExt cx="0" cy="0"/>
+        </a:xfrm>
+      </p:grpSpPr>
       <p:sp>
         <p:nvSpPr>
           <p:cNvPr id="2" name="TextBox 1"/>
@@ -5905,14 +6002,12 @@
                 <a:spcPts val="800"/>
               </a:spcAft>
             </a:pPr>
-            <a:r>
-              <a:rPr sz="2200">
-                <a:solidFill>
-                  <a:srgbClr val="212121"/>
-                </a:solidFill>
-              </a:rPr>
-              <a:t/>
-            </a:r>
+            <a:endParaRPr sz="1800">
+              <a:solidFill>
+                <a:srgbClr val="212121"/>
+              </a:solidFill>
+              <a:latin typeface="Courier New"/>
+            </a:endParaRPr>
           </a:p>
           <a:p>
             <a:pPr>
@@ -5970,7 +6065,7 @@
 </file>
 
 <file path=ppt/slides/slide22.xml><?xml version="1.0" encoding="utf-8"?>
-<p:sld xmlns:a="http://schemas.openxmlformats.org/drawingml/2006/main" xmlns:p="http://schemas.openxmlformats.org/presentationml/2006/main" xmlns:r="http://schemas.openxmlformats.org/officeDocument/2006/relationships">
+<p:sld xmlns:a="http://schemas.openxmlformats.org/drawingml/2006/main" xmlns:r="http://schemas.openxmlformats.org/officeDocument/2006/relationships" xmlns:p="http://schemas.openxmlformats.org/presentationml/2006/main">
   <p:cSld>
     <p:spTree>
       <p:nvGrpSpPr>
@@ -5978,7 +6073,14 @@
         <p:cNvGrpSpPr/>
         <p:nvPr/>
       </p:nvGrpSpPr>
-      <p:grpSpPr/>
+      <p:grpSpPr>
+        <a:xfrm>
+          <a:off x="0" y="0"/>
+          <a:ext cx="0" cy="0"/>
+          <a:chOff x="0" y="0"/>
+          <a:chExt cx="0" cy="0"/>
+        </a:xfrm>
+      </p:grpSpPr>
       <p:sp>
         <p:nvSpPr>
           <p:cNvPr id="2" name="TextBox 1"/>
@@ -6084,14 +6186,11 @@
                 <a:spcPts val="800"/>
               </a:spcAft>
             </a:pPr>
-            <a:r>
-              <a:rPr sz="2200">
-                <a:solidFill>
-                  <a:srgbClr val="212121"/>
-                </a:solidFill>
-              </a:rPr>
-              <a:t/>
-            </a:r>
+            <a:endParaRPr sz="2000">
+              <a:solidFill>
+                <a:srgbClr val="212121"/>
+              </a:solidFill>
+            </a:endParaRPr>
           </a:p>
           <a:p>
             <a:pPr>
@@ -6150,7 +6249,7 @@
 </file>
 
 <file path=ppt/slides/slide23.xml><?xml version="1.0" encoding="utf-8"?>
-<p:sld xmlns:a="http://schemas.openxmlformats.org/drawingml/2006/main" xmlns:p="http://schemas.openxmlformats.org/presentationml/2006/main" xmlns:r="http://schemas.openxmlformats.org/officeDocument/2006/relationships">
+<p:sld xmlns:a="http://schemas.openxmlformats.org/drawingml/2006/main" xmlns:r="http://schemas.openxmlformats.org/officeDocument/2006/relationships" xmlns:p="http://schemas.openxmlformats.org/presentationml/2006/main">
   <p:cSld>
     <p:spTree>
       <p:nvGrpSpPr>
@@ -6158,7 +6257,14 @@
         <p:cNvGrpSpPr/>
         <p:nvPr/>
       </p:nvGrpSpPr>
-      <p:grpSpPr/>
+      <p:grpSpPr>
+        <a:xfrm>
+          <a:off x="0" y="0"/>
+          <a:ext cx="0" cy="0"/>
+          <a:chOff x="0" y="0"/>
+          <a:chExt cx="0" cy="0"/>
+        </a:xfrm>
+      </p:grpSpPr>
       <p:sp>
         <p:nvSpPr>
           <p:cNvPr id="2" name="TextBox 1"/>
@@ -6201,7 +6307,7 @@
         <p:spPr>
           <a:xfrm>
             <a:off x="731520" y="1463040"/>
-            <a:ext cx="10789920" cy="5120640"/>
+            <a:ext cx="10789920" cy="2872581"/>
           </a:xfrm>
           <a:prstGeom prst="rect">
             <a:avLst/>
@@ -6220,67 +6326,128 @@
               </a:spcAft>
             </a:pPr>
             <a:r>
-              <a:rPr sz="2200">
-                <a:solidFill>
-                  <a:srgbClr val="212121"/>
-                </a:solidFill>
-              </a:rPr>
-              <a:t>Sequentially, race.c is bulletproof — run it a million times, the bug may never show.</a:t>
-            </a:r>
-          </a:p>
-          <a:p>
-            <a:pPr>
-              <a:spcAft>
-                <a:spcPts val="800"/>
-              </a:spcAft>
-            </a:pPr>
-            <a:r>
-              <a:rPr sz="2200">
-                <a:solidFill>
-                  <a:srgbClr val="212121"/>
-                </a:solidFill>
-              </a:rPr>
-              <a:t>Two threads of just 2 and 1 statements already have 3 interleavings; real code has billions.</a:t>
-            </a:r>
-          </a:p>
-          <a:p>
-            <a:pPr>
-              <a:spcAft>
-                <a:spcPts val="800"/>
-              </a:spcAft>
-            </a:pPr>
-            <a:r>
-              <a:rPr sz="2200">
-                <a:solidFill>
-                  <a:srgbClr val="212121"/>
-                </a:solidFill>
-              </a:rPr>
-              <a:t>The model checker enumerates every interleaving up to the context bound — including the one that kills the assertion.</a:t>
-            </a:r>
-          </a:p>
-          <a:p>
-            <a:pPr>
-              <a:spcAft>
-                <a:spcPts val="800"/>
-              </a:spcAft>
-            </a:pPr>
-            <a:r>
-              <a:rPr sz="2200">
-                <a:solidFill>
-                  <a:srgbClr val="212121"/>
-                </a:solidFill>
-              </a:rPr>
-              <a:t/>
-            </a:r>
-          </a:p>
-          <a:p>
-            <a:pPr>
-              <a:spcAft>
-                <a:spcPts val="800"/>
-              </a:spcAft>
-            </a:pPr>
-            <a:r>
-              <a:rPr sz="2200">
+              <a:rPr sz="2200" dirty="0">
+                <a:solidFill>
+                  <a:srgbClr val="212121"/>
+                </a:solidFill>
+              </a:rPr>
+              <a:t>Sequentially, </a:t>
+            </a:r>
+            <a:r>
+              <a:rPr sz="2200" dirty="0" err="1">
+                <a:solidFill>
+                  <a:srgbClr val="212121"/>
+                </a:solidFill>
+              </a:rPr>
+              <a:t>race.c</a:t>
+            </a:r>
+            <a:r>
+              <a:rPr sz="2200" dirty="0">
+                <a:solidFill>
+                  <a:srgbClr val="212121"/>
+                </a:solidFill>
+              </a:rPr>
+              <a:t> is bulletproof — run it a million times, the bug may never show.</a:t>
+            </a:r>
+          </a:p>
+          <a:p>
+            <a:pPr>
+              <a:spcAft>
+                <a:spcPts val="800"/>
+              </a:spcAft>
+            </a:pPr>
+            <a:r>
+              <a:rPr sz="2200" dirty="0">
+                <a:solidFill>
+                  <a:srgbClr val="212121"/>
+                </a:solidFill>
+              </a:rPr>
+              <a:t>Two threads of just 2 statements already have </a:t>
+            </a:r>
+            <a:r>
+              <a:rPr lang="en-GB" sz="2200" dirty="0">
+                <a:solidFill>
+                  <a:srgbClr val="212121"/>
+                </a:solidFill>
+              </a:rPr>
+              <a:t>6</a:t>
+            </a:r>
+            <a:r>
+              <a:rPr sz="2200" dirty="0">
+                <a:solidFill>
+                  <a:srgbClr val="212121"/>
+                </a:solidFill>
+              </a:rPr>
+              <a:t> </a:t>
+            </a:r>
+            <a:r>
+              <a:rPr sz="2200" dirty="0" err="1">
+                <a:solidFill>
+                  <a:srgbClr val="212121"/>
+                </a:solidFill>
+              </a:rPr>
+              <a:t>interleavings</a:t>
+            </a:r>
+            <a:r>
+              <a:rPr sz="2200" dirty="0">
+                <a:solidFill>
+                  <a:srgbClr val="212121"/>
+                </a:solidFill>
+              </a:rPr>
+              <a:t>; real code has billions.</a:t>
+            </a:r>
+          </a:p>
+          <a:p>
+            <a:pPr>
+              <a:spcAft>
+                <a:spcPts val="800"/>
+              </a:spcAft>
+            </a:pPr>
+            <a:r>
+              <a:rPr sz="2200" dirty="0">
+                <a:solidFill>
+                  <a:srgbClr val="212121"/>
+                </a:solidFill>
+              </a:rPr>
+              <a:t>The model checker enumerates every interleaving up to the context bound</a:t>
+            </a:r>
+            <a:r>
+              <a:rPr lang="en-GB" sz="2200" dirty="0">
+                <a:solidFill>
+                  <a:srgbClr val="212121"/>
+                </a:solidFill>
+              </a:rPr>
+              <a:t>,</a:t>
+            </a:r>
+            <a:r>
+              <a:rPr sz="2200" dirty="0">
+                <a:solidFill>
+                  <a:srgbClr val="212121"/>
+                </a:solidFill>
+              </a:rPr>
+              <a:t> including the one that kills the assertion.</a:t>
+            </a:r>
+          </a:p>
+          <a:p>
+            <a:pPr>
+              <a:spcAft>
+                <a:spcPts val="800"/>
+              </a:spcAft>
+            </a:pPr>
+            <a:endParaRPr sz="2200" dirty="0">
+              <a:solidFill>
+                <a:srgbClr val="212121"/>
+              </a:solidFill>
+            </a:endParaRPr>
+          </a:p>
+          <a:p>
+            <a:pPr>
+              <a:spcAft>
+                <a:spcPts val="800"/>
+              </a:spcAft>
+            </a:pPr>
+            <a:r>
+              <a:rPr sz="2200" dirty="0">
                 <a:solidFill>
                   <a:srgbClr val="212121"/>
                 </a:solidFill>
@@ -6299,7 +6466,7 @@
 </file>
 
 <file path=ppt/slides/slide24.xml><?xml version="1.0" encoding="utf-8"?>
-<p:sld xmlns:a="http://schemas.openxmlformats.org/drawingml/2006/main" xmlns:p="http://schemas.openxmlformats.org/presentationml/2006/main" xmlns:r="http://schemas.openxmlformats.org/officeDocument/2006/relationships">
+<p:sld xmlns:a="http://schemas.openxmlformats.org/drawingml/2006/main" xmlns:r="http://schemas.openxmlformats.org/officeDocument/2006/relationships" xmlns:p="http://schemas.openxmlformats.org/presentationml/2006/main">
   <p:cSld>
     <p:spTree>
       <p:nvGrpSpPr>
@@ -6307,7 +6474,14 @@
         <p:cNvGrpSpPr/>
         <p:nvPr/>
       </p:nvGrpSpPr>
-      <p:grpSpPr/>
+      <p:grpSpPr>
+        <a:xfrm>
+          <a:off x="0" y="0"/>
+          <a:ext cx="0" cy="0"/>
+          <a:chOff x="0" y="0"/>
+          <a:chExt cx="0" cy="0"/>
+        </a:xfrm>
+      </p:grpSpPr>
       <p:sp>
         <p:nvSpPr>
           <p:cNvPr id="2" name="TextBox 1"/>
@@ -6398,27 +6572,24 @@
                 <a:spcPts val="800"/>
               </a:spcAft>
             </a:pPr>
+            <a:endParaRPr sz="2200">
+              <a:solidFill>
+                <a:srgbClr val="212121"/>
+              </a:solidFill>
+            </a:endParaRPr>
+          </a:p>
+          <a:p>
+            <a:pPr>
+              <a:spcAft>
+                <a:spcPts val="800"/>
+              </a:spcAft>
+            </a:pPr>
             <a:r>
               <a:rPr sz="2200">
                 <a:solidFill>
                   <a:srgbClr val="212121"/>
                 </a:solidFill>
               </a:rPr>
-              <a:t/>
-            </a:r>
-          </a:p>
-          <a:p>
-            <a:pPr>
-              <a:spcAft>
-                <a:spcPts val="800"/>
-              </a:spcAft>
-            </a:pPr>
-            <a:r>
-              <a:rPr sz="2200">
-                <a:solidFill>
-                  <a:srgbClr val="212121"/>
-                </a:solidFill>
-              </a:rPr>
               <a:t>Where next:</a:t>
             </a:r>
           </a:p>
@@ -6488,14 +6659,11 @@
                 <a:spcPts val="800"/>
               </a:spcAft>
             </a:pPr>
-            <a:r>
-              <a:rPr sz="2200">
-                <a:solidFill>
-                  <a:srgbClr val="212121"/>
-                </a:solidFill>
-              </a:rPr>
-              <a:t/>
-            </a:r>
+            <a:endParaRPr sz="2000">
+              <a:solidFill>
+                <a:srgbClr val="212121"/>
+              </a:solidFill>
+            </a:endParaRPr>
           </a:p>
           <a:p>
             <a:pPr>
@@ -6523,7 +6691,7 @@
 </file>
 
 <file path=ppt/slides/slide3.xml><?xml version="1.0" encoding="utf-8"?>
-<p:sld xmlns:a="http://schemas.openxmlformats.org/drawingml/2006/main" xmlns:p="http://schemas.openxmlformats.org/presentationml/2006/main" xmlns:r="http://schemas.openxmlformats.org/officeDocument/2006/relationships">
+<p:sld xmlns:a="http://schemas.openxmlformats.org/drawingml/2006/main" xmlns:r="http://schemas.openxmlformats.org/officeDocument/2006/relationships" xmlns:p="http://schemas.openxmlformats.org/presentationml/2006/main">
   <p:cSld>
     <p:spTree>
       <p:nvGrpSpPr>
@@ -6531,7 +6699,14 @@
         <p:cNvGrpSpPr/>
         <p:nvPr/>
       </p:nvGrpSpPr>
-      <p:grpSpPr/>
+      <p:grpSpPr>
+        <a:xfrm>
+          <a:off x="0" y="0"/>
+          <a:ext cx="0" cy="0"/>
+          <a:chOff x="0" y="0"/>
+          <a:chExt cx="0" cy="0"/>
+        </a:xfrm>
+      </p:grpSpPr>
       <p:sp>
         <p:nvSpPr>
           <p:cNvPr id="2" name="TextBox 1"/>
@@ -6575,7 +6750,7 @@
         </p:nvGraphicFramePr>
         <p:xfrm>
           <a:off x="731520" y="1463040"/>
-          <a:ext cx="10698480" cy="2194560"/>
+          <a:ext cx="10698480" cy="2377440"/>
         </p:xfrm>
         <a:graphic>
           <a:graphicData uri="http://schemas.openxmlformats.org/drawingml/2006/table">
@@ -6584,9 +6759,27 @@
                 <a:tableStyleId>{5C22544A-7EE6-4342-B048-85BDC9FD1C3A}</a:tableStyleId>
               </a:tblPr>
               <a:tblGrid>
-                <a:gridCol w="1463040"/>
-                <a:gridCol w="1645920"/>
-                <a:gridCol w="7589520"/>
+                <a:gridCol w="1463040">
+                  <a:extLst>
+                    <a:ext uri="{9D8B030D-6E8A-4147-A177-3AD203B41FA5}">
+                      <a16:colId xmlns:a16="http://schemas.microsoft.com/office/drawing/2014/main" val="20000"/>
+                    </a:ext>
+                  </a:extLst>
+                </a:gridCol>
+                <a:gridCol w="1645920">
+                  <a:extLst>
+                    <a:ext uri="{9D8B030D-6E8A-4147-A177-3AD203B41FA5}">
+                      <a16:colId xmlns:a16="http://schemas.microsoft.com/office/drawing/2014/main" val="20001"/>
+                    </a:ext>
+                  </a:extLst>
+                </a:gridCol>
+                <a:gridCol w="7589520">
+                  <a:extLst>
+                    <a:ext uri="{9D8B030D-6E8A-4147-A177-3AD203B41FA5}">
+                      <a16:colId xmlns:a16="http://schemas.microsoft.com/office/drawing/2014/main" val="20002"/>
+                    </a:ext>
+                  </a:extLst>
+                </a:gridCol>
               </a:tblGrid>
               <a:tr h="365760">
                 <a:tc>
@@ -6628,6 +6821,11 @@
                   </a:txBody>
                   <a:tcPr/>
                 </a:tc>
+                <a:extLst>
+                  <a:ext uri="{0D108BD9-81ED-4DB2-BD59-A6C34878D82A}">
+                    <a16:rowId xmlns:a16="http://schemas.microsoft.com/office/drawing/2014/main" val="10000"/>
+                  </a:ext>
+                </a:extLst>
               </a:tr>
               <a:tr h="365760">
                 <a:tc>
@@ -6669,6 +6867,11 @@
                   </a:txBody>
                   <a:tcPr/>
                 </a:tc>
+                <a:extLst>
+                  <a:ext uri="{0D108BD9-81ED-4DB2-BD59-A6C34878D82A}">
+                    <a16:rowId xmlns:a16="http://schemas.microsoft.com/office/drawing/2014/main" val="10001"/>
+                  </a:ext>
+                </a:extLst>
               </a:tr>
               <a:tr h="365760">
                 <a:tc>
@@ -6701,10 +6904,17 @@
                   <a:txBody>
                     <a:bodyPr/>
                     <a:lstStyle/>
-                    <a:p/>
+                    <a:p>
+                      <a:endParaRPr/>
+                    </a:p>
                   </a:txBody>
                   <a:tcPr/>
                 </a:tc>
+                <a:extLst>
+                  <a:ext uri="{0D108BD9-81ED-4DB2-BD59-A6C34878D82A}">
+                    <a16:rowId xmlns:a16="http://schemas.microsoft.com/office/drawing/2014/main" val="10002"/>
+                  </a:ext>
+                </a:extLst>
               </a:tr>
               <a:tr h="365760">
                 <a:tc>
@@ -6746,6 +6956,11 @@
                   </a:txBody>
                   <a:tcPr/>
                 </a:tc>
+                <a:extLst>
+                  <a:ext uri="{0D108BD9-81ED-4DB2-BD59-A6C34878D82A}">
+                    <a16:rowId xmlns:a16="http://schemas.microsoft.com/office/drawing/2014/main" val="10003"/>
+                  </a:ext>
+                </a:extLst>
               </a:tr>
               <a:tr h="365760">
                 <a:tc>
@@ -6787,6 +7002,11 @@
                   </a:txBody>
                   <a:tcPr/>
                 </a:tc>
+                <a:extLst>
+                  <a:ext uri="{0D108BD9-81ED-4DB2-BD59-A6C34878D82A}">
+                    <a16:rowId xmlns:a16="http://schemas.microsoft.com/office/drawing/2014/main" val="10004"/>
+                  </a:ext>
+                </a:extLst>
               </a:tr>
               <a:tr h="365760">
                 <a:tc>
@@ -6806,7 +7026,9 @@
                   <a:txBody>
                     <a:bodyPr/>
                     <a:lstStyle/>
-                    <a:p/>
+                    <a:p>
+                      <a:endParaRPr/>
+                    </a:p>
                   </a:txBody>
                   <a:tcPr/>
                 </a:tc>
@@ -6823,6 +7045,11 @@
                   </a:txBody>
                   <a:tcPr/>
                 </a:tc>
+                <a:extLst>
+                  <a:ext uri="{0D108BD9-81ED-4DB2-BD59-A6C34878D82A}">
+                    <a16:rowId xmlns:a16="http://schemas.microsoft.com/office/drawing/2014/main" val="10005"/>
+                  </a:ext>
+                </a:extLst>
               </a:tr>
             </a:tbl>
           </a:graphicData>
@@ -6875,7 +7102,7 @@
 </file>
 
 <file path=ppt/slides/slide4.xml><?xml version="1.0" encoding="utf-8"?>
-<p:sld xmlns:a="http://schemas.openxmlformats.org/drawingml/2006/main" xmlns:p="http://schemas.openxmlformats.org/presentationml/2006/main" xmlns:r="http://schemas.openxmlformats.org/officeDocument/2006/relationships">
+<p:sld xmlns:a="http://schemas.openxmlformats.org/drawingml/2006/main" xmlns:r="http://schemas.openxmlformats.org/officeDocument/2006/relationships" xmlns:p="http://schemas.openxmlformats.org/presentationml/2006/main">
   <p:cSld>
     <p:spTree>
       <p:nvGrpSpPr>
@@ -6883,7 +7110,14 @@
         <p:cNvGrpSpPr/>
         <p:nvPr/>
       </p:nvGrpSpPr>
-      <p:grpSpPr/>
+      <p:grpSpPr>
+        <a:xfrm>
+          <a:off x="0" y="0"/>
+          <a:ext cx="0" cy="0"/>
+          <a:chOff x="0" y="0"/>
+          <a:chExt cx="0" cy="0"/>
+        </a:xfrm>
+      </p:grpSpPr>
       <p:sp>
         <p:nvSpPr>
           <p:cNvPr id="2" name="TextBox 1"/>
@@ -6989,14 +7223,11 @@
                 <a:spcPts val="800"/>
               </a:spcAft>
             </a:pPr>
-            <a:r>
-              <a:rPr sz="2600">
-                <a:solidFill>
-                  <a:srgbClr val="212121"/>
-                </a:solidFill>
-              </a:rPr>
-              <a:t/>
-            </a:r>
+            <a:endParaRPr sz="2400">
+              <a:solidFill>
+                <a:srgbClr val="212121"/>
+              </a:solidFill>
+            </a:endParaRPr>
           </a:p>
           <a:p>
             <a:pPr>
@@ -7024,7 +7255,7 @@
 </file>
 
 <file path=ppt/slides/slide5.xml><?xml version="1.0" encoding="utf-8"?>
-<p:sld xmlns:a="http://schemas.openxmlformats.org/drawingml/2006/main" xmlns:p="http://schemas.openxmlformats.org/presentationml/2006/main" xmlns:r="http://schemas.openxmlformats.org/officeDocument/2006/relationships">
+<p:sld xmlns:a="http://schemas.openxmlformats.org/drawingml/2006/main" xmlns:r="http://schemas.openxmlformats.org/officeDocument/2006/relationships" xmlns:p="http://schemas.openxmlformats.org/presentationml/2006/main">
   <p:cSld>
     <p:spTree>
       <p:nvGrpSpPr>
@@ -7032,7 +7263,14 @@
         <p:cNvGrpSpPr/>
         <p:nvPr/>
       </p:nvGrpSpPr>
-      <p:grpSpPr/>
+      <p:grpSpPr>
+        <a:xfrm>
+          <a:off x="0" y="0"/>
+          <a:ext cx="0" cy="0"/>
+          <a:chOff x="0" y="0"/>
+          <a:chExt cx="0" cy="0"/>
+        </a:xfrm>
+      </p:grpSpPr>
       <p:sp>
         <p:nvSpPr>
           <p:cNvPr id="2" name="TextBox 1"/>
@@ -7108,14 +7346,11 @@
                 <a:spcPts val="800"/>
               </a:spcAft>
             </a:pPr>
-            <a:r>
-              <a:rPr sz="2400">
-                <a:solidFill>
-                  <a:srgbClr val="212121"/>
-                </a:solidFill>
-              </a:rPr>
-              <a:t/>
-            </a:r>
+            <a:endParaRPr sz="2400">
+              <a:solidFill>
+                <a:srgbClr val="212121"/>
+              </a:solidFill>
+            </a:endParaRPr>
           </a:p>
           <a:p>
             <a:pPr lvl="1">
@@ -7211,7 +7446,7 @@
 </file>
 
 <file path=ppt/slides/slide6.xml><?xml version="1.0" encoding="utf-8"?>
-<p:sld xmlns:a="http://schemas.openxmlformats.org/drawingml/2006/main" xmlns:p="http://schemas.openxmlformats.org/presentationml/2006/main" xmlns:r="http://schemas.openxmlformats.org/officeDocument/2006/relationships">
+<p:sld xmlns:a="http://schemas.openxmlformats.org/drawingml/2006/main" xmlns:r="http://schemas.openxmlformats.org/officeDocument/2006/relationships" xmlns:p="http://schemas.openxmlformats.org/presentationml/2006/main">
   <p:cSld>
     <p:spTree>
       <p:nvGrpSpPr>
@@ -7219,7 +7454,14 @@
         <p:cNvGrpSpPr/>
         <p:nvPr/>
       </p:nvGrpSpPr>
-      <p:grpSpPr/>
+      <p:grpSpPr>
+        <a:xfrm>
+          <a:off x="0" y="0"/>
+          <a:ext cx="0" cy="0"/>
+          <a:chOff x="0" y="0"/>
+          <a:chExt cx="0" cy="0"/>
+        </a:xfrm>
+      </p:grpSpPr>
       <p:sp>
         <p:nvSpPr>
           <p:cNvPr id="2" name="TextBox 1"/>
@@ -7340,14 +7582,11 @@
                 <a:spcPts val="800"/>
               </a:spcAft>
             </a:pPr>
-            <a:r>
-              <a:rPr sz="2200">
-                <a:solidFill>
-                  <a:srgbClr val="212121"/>
-                </a:solidFill>
-              </a:rPr>
-              <a:t/>
-            </a:r>
+            <a:endParaRPr sz="2000">
+              <a:solidFill>
+                <a:srgbClr val="212121"/>
+              </a:solidFill>
+            </a:endParaRPr>
           </a:p>
           <a:p>
             <a:pPr>
@@ -7390,7 +7629,7 @@
 </file>
 
 <file path=ppt/slides/slide7.xml><?xml version="1.0" encoding="utf-8"?>
-<p:sld xmlns:a="http://schemas.openxmlformats.org/drawingml/2006/main" xmlns:p="http://schemas.openxmlformats.org/presentationml/2006/main" xmlns:r="http://schemas.openxmlformats.org/officeDocument/2006/relationships">
+<p:sld xmlns:a="http://schemas.openxmlformats.org/drawingml/2006/main" xmlns:r="http://schemas.openxmlformats.org/officeDocument/2006/relationships" xmlns:p="http://schemas.openxmlformats.org/presentationml/2006/main">
   <p:cSld>
     <p:spTree>
       <p:nvGrpSpPr>
@@ -7398,7 +7637,14 @@
         <p:cNvGrpSpPr/>
         <p:nvPr/>
       </p:nvGrpSpPr>
-      <p:grpSpPr/>
+      <p:grpSpPr>
+        <a:xfrm>
+          <a:off x="0" y="0"/>
+          <a:ext cx="0" cy="0"/>
+          <a:chOff x="0" y="0"/>
+          <a:chExt cx="0" cy="0"/>
+        </a:xfrm>
+      </p:grpSpPr>
       <p:sp>
         <p:nvSpPr>
           <p:cNvPr id="2" name="TextBox 1"/>
@@ -7507,6 +7753,19 @@
                 <a:spcPts val="0"/>
               </a:spcAft>
             </a:pPr>
+            <a:endParaRPr sz="1800">
+              <a:solidFill>
+                <a:srgbClr val="212121"/>
+              </a:solidFill>
+              <a:latin typeface="Courier New"/>
+            </a:endParaRPr>
+          </a:p>
+          <a:p>
+            <a:pPr>
+              <a:spcAft>
+                <a:spcPts val="0"/>
+              </a:spcAft>
+            </a:pPr>
             <a:r>
               <a:rPr sz="1800">
                 <a:solidFill>
@@ -7514,7 +7773,7 @@
                 </a:solidFill>
                 <a:latin typeface="Courier New"/>
               </a:rPr>
-              <a:t/>
+              <a:t>s = Solver()</a:t>
             </a:r>
           </a:p>
           <a:p>
@@ -7530,7 +7789,7 @@
                 </a:solidFill>
                 <a:latin typeface="Courier New"/>
               </a:rPr>
-              <a:t>s = Solver()</a:t>
+              <a:t>s.add(formula)           # constrain</a:t>
             </a:r>
           </a:p>
           <a:p>
@@ -7546,7 +7805,7 @@
                 </a:solidFill>
                 <a:latin typeface="Courier New"/>
               </a:rPr>
-              <a:t>s.add(formula)           # constrain</a:t>
+              <a:t>s.check()                # -&gt; sat or unsat</a:t>
             </a:r>
           </a:p>
           <a:p>
@@ -7562,22 +7821,6 @@
                 </a:solidFill>
                 <a:latin typeface="Courier New"/>
               </a:rPr>
-              <a:t>s.check()                # -&gt; sat or unsat</a:t>
-            </a:r>
-          </a:p>
-          <a:p>
-            <a:pPr>
-              <a:spcAft>
-                <a:spcPts val="0"/>
-              </a:spcAft>
-            </a:pPr>
-            <a:r>
-              <a:rPr sz="1800">
-                <a:solidFill>
-                  <a:srgbClr val="212121"/>
-                </a:solidFill>
-                <a:latin typeface="Courier New"/>
-              </a:rPr>
               <a:t>s.model()                # the witness, when sat</a:t>
             </a:r>
           </a:p>
@@ -7587,14 +7830,12 @@
                 <a:spcPts val="800"/>
               </a:spcAft>
             </a:pPr>
-            <a:r>
-              <a:rPr sz="2200">
-                <a:solidFill>
-                  <a:srgbClr val="212121"/>
-                </a:solidFill>
-              </a:rPr>
-              <a:t/>
-            </a:r>
+            <a:endParaRPr sz="1800">
+              <a:solidFill>
+                <a:srgbClr val="212121"/>
+              </a:solidFill>
+              <a:latin typeface="Courier New"/>
+            </a:endParaRPr>
           </a:p>
           <a:p>
             <a:pPr>
@@ -7622,7 +7863,7 @@
 </file>
 
 <file path=ppt/slides/slide8.xml><?xml version="1.0" encoding="utf-8"?>
-<p:sld xmlns:a="http://schemas.openxmlformats.org/drawingml/2006/main" xmlns:p="http://schemas.openxmlformats.org/presentationml/2006/main" xmlns:r="http://schemas.openxmlformats.org/officeDocument/2006/relationships">
+<p:sld xmlns:a="http://schemas.openxmlformats.org/drawingml/2006/main" xmlns:r="http://schemas.openxmlformats.org/officeDocument/2006/relationships" xmlns:p="http://schemas.openxmlformats.org/presentationml/2006/main">
   <p:cSld>
     <p:spTree>
       <p:nvGrpSpPr>
@@ -7630,7 +7871,14 @@
         <p:cNvGrpSpPr/>
         <p:nvPr/>
       </p:nvGrpSpPr>
-      <p:grpSpPr/>
+      <p:grpSpPr>
+        <a:xfrm>
+          <a:off x="0" y="0"/>
+          <a:ext cx="0" cy="0"/>
+          <a:chOff x="0" y="0"/>
+          <a:chExt cx="0" cy="0"/>
+        </a:xfrm>
+      </p:grpSpPr>
       <p:sp>
         <p:nvSpPr>
           <p:cNvPr id="2" name="TextBox 1"/>
@@ -7803,14 +8051,12 @@
                 <a:spcPts val="800"/>
               </a:spcAft>
             </a:pPr>
-            <a:r>
-              <a:rPr sz="2200">
-                <a:solidFill>
-                  <a:srgbClr val="212121"/>
-                </a:solidFill>
-              </a:rPr>
-              <a:t/>
-            </a:r>
+            <a:endParaRPr sz="1800">
+              <a:solidFill>
+                <a:srgbClr val="212121"/>
+              </a:solidFill>
+              <a:latin typeface="Courier New"/>
+            </a:endParaRPr>
           </a:p>
           <a:p>
             <a:pPr lvl="1">
@@ -7869,7 +8115,7 @@
 </file>
 
 <file path=ppt/slides/slide9.xml><?xml version="1.0" encoding="utf-8"?>
-<p:sld xmlns:a="http://schemas.openxmlformats.org/drawingml/2006/main" xmlns:p="http://schemas.openxmlformats.org/presentationml/2006/main" xmlns:r="http://schemas.openxmlformats.org/officeDocument/2006/relationships">
+<p:sld xmlns:a="http://schemas.openxmlformats.org/drawingml/2006/main" xmlns:r="http://schemas.openxmlformats.org/officeDocument/2006/relationships" xmlns:p="http://schemas.openxmlformats.org/presentationml/2006/main">
   <p:cSld>
     <p:spTree>
       <p:nvGrpSpPr>
@@ -7877,7 +8123,14 @@
         <p:cNvGrpSpPr/>
         <p:nvPr/>
       </p:nvGrpSpPr>
-      <p:grpSpPr/>
+      <p:grpSpPr>
+        <a:xfrm>
+          <a:off x="0" y="0"/>
+          <a:ext cx="0" cy="0"/>
+          <a:chOff x="0" y="0"/>
+          <a:chExt cx="0" cy="0"/>
+        </a:xfrm>
+      </p:grpSpPr>
       <p:sp>
         <p:nvSpPr>
           <p:cNvPr id="2" name="TextBox 1"/>
@@ -8002,58 +8255,56 @@
                 <a:spcPts val="800"/>
               </a:spcAft>
             </a:pPr>
+            <a:endParaRPr sz="1800">
+              <a:solidFill>
+                <a:srgbClr val="212121"/>
+              </a:solidFill>
+              <a:latin typeface="Courier New"/>
+            </a:endParaRPr>
+          </a:p>
+          <a:p>
+            <a:pPr>
+              <a:spcAft>
+                <a:spcPts val="0"/>
+              </a:spcAft>
+            </a:pPr>
+            <a:r>
+              <a:rPr sz="1800">
+                <a:solidFill>
+                  <a:srgbClr val="212121"/>
+                </a:solidFill>
+                <a:latin typeface="Courier New"/>
+              </a:rPr>
+              <a:t>sat — counterexample e.g. x = 1073741824 (= 2^30)</a:t>
+            </a:r>
+          </a:p>
+          <a:p>
+            <a:pPr lvl="1">
+              <a:spcAft>
+                <a:spcPts val="800"/>
+              </a:spcAft>
+            </a:pPr>
+            <a:r>
+              <a:rPr sz="2000">
+                <a:solidFill>
+                  <a:srgbClr val="212121"/>
+                </a:solidFill>
+              </a:rPr>
+              <a:t>y * 2 overflows the 32-bit range: z comes out negative.</a:t>
+            </a:r>
+          </a:p>
+          <a:p>
+            <a:pPr>
+              <a:spcAft>
+                <a:spcPts val="800"/>
+              </a:spcAft>
+            </a:pPr>
             <a:r>
               <a:rPr sz="2200">
                 <a:solidFill>
                   <a:srgbClr val="212121"/>
                 </a:solidFill>
               </a:rPr>
-              <a:t/>
-            </a:r>
-          </a:p>
-          <a:p>
-            <a:pPr>
-              <a:spcAft>
-                <a:spcPts val="0"/>
-              </a:spcAft>
-            </a:pPr>
-            <a:r>
-              <a:rPr sz="1800">
-                <a:solidFill>
-                  <a:srgbClr val="212121"/>
-                </a:solidFill>
-                <a:latin typeface="Courier New"/>
-              </a:rPr>
-              <a:t>sat — counterexample e.g. x = 1073741824 (= 2^30)</a:t>
-            </a:r>
-          </a:p>
-          <a:p>
-            <a:pPr lvl="1">
-              <a:spcAft>
-                <a:spcPts val="800"/>
-              </a:spcAft>
-            </a:pPr>
-            <a:r>
-              <a:rPr sz="2000">
-                <a:solidFill>
-                  <a:srgbClr val="212121"/>
-                </a:solidFill>
-              </a:rPr>
-              <a:t>y * 2 overflows the 32-bit range: z comes out negative.</a:t>
-            </a:r>
-          </a:p>
-          <a:p>
-            <a:pPr>
-              <a:spcAft>
-                <a:spcPts val="800"/>
-              </a:spcAft>
-            </a:pPr>
-            <a:r>
-              <a:rPr sz="2200">
-                <a:solidFill>
-                  <a:srgbClr val="212121"/>
-                </a:solidFill>
-              </a:rPr>
               <a:t>Would your test suite have tried 1073741824?</a:t>
             </a:r>
           </a:p>
@@ -8063,14 +8314,11 @@
                 <a:spcPts val="800"/>
               </a:spcAft>
             </a:pPr>
-            <a:r>
-              <a:rPr sz="2200">
-                <a:solidFill>
-                  <a:srgbClr val="212121"/>
-                </a:solidFill>
-              </a:rPr>
-              <a:t/>
-            </a:r>
+            <a:endParaRPr sz="2200">
+              <a:solidFill>
+                <a:srgbClr val="212121"/>
+              </a:solidFill>
+            </a:endParaRPr>
           </a:p>
           <a:p>
             <a:pPr>

</xml_diff>